<commit_message>
Document ASR metrics and align lecturer demo seed
</commit_message>
<xml_diff>
--- a/docs/INES_Digital_Library_Defense_Presentation_IRUMVA_Style.pptx
+++ b/docs/INES_Digital_Library_Defense_Presentation_IRUMVA_Style.pptx
@@ -2,27 +2,27 @@
 <file path=ppt/presentation.xml><?xml version="1.0" encoding="utf-8"?>
 <p:presentation xmlns:p="http://schemas.openxmlformats.org/presentationml/2006/main">
   <p:sldMasterIdLst>
-    <p:sldMasterId xmlns:r="http://schemas.openxmlformats.org/officeDocument/2006/relationships" id="2147483648" r:id="R6d067df8836042c1"/>
+    <p:sldMasterId xmlns:r="http://schemas.openxmlformats.org/officeDocument/2006/relationships" id="2147483648" r:id="R72e97d12647d4c07"/>
   </p:sldMasterIdLst>
   <p:notesMasterIdLst>
-    <p:notesMasterId xmlns:r="http://schemas.openxmlformats.org/officeDocument/2006/relationships" r:id="Rb7cd229f504f440c"/>
+    <p:notesMasterId xmlns:r="http://schemas.openxmlformats.org/officeDocument/2006/relationships" r:id="Rd5bbdecb6d6a41fd"/>
   </p:notesMasterIdLst>
   <p:sldIdLst>
-    <p:sldId xmlns:r="http://schemas.openxmlformats.org/officeDocument/2006/relationships" id="256" r:id="R35ee21d12e964cf9"/>
-    <p:sldId xmlns:r="http://schemas.openxmlformats.org/officeDocument/2006/relationships" id="257" r:id="R534a18a229104085"/>
-    <p:sldId xmlns:r="http://schemas.openxmlformats.org/officeDocument/2006/relationships" id="258" r:id="Re96cfcdb12cd4413"/>
-    <p:sldId xmlns:r="http://schemas.openxmlformats.org/officeDocument/2006/relationships" id="259" r:id="Rb4ba14448e8d4e05"/>
-    <p:sldId xmlns:r="http://schemas.openxmlformats.org/officeDocument/2006/relationships" id="260" r:id="Re064d7169d464d1f"/>
-    <p:sldId xmlns:r="http://schemas.openxmlformats.org/officeDocument/2006/relationships" id="261" r:id="R1750ff48039643e9"/>
-    <p:sldId xmlns:r="http://schemas.openxmlformats.org/officeDocument/2006/relationships" id="262" r:id="R94e9d645e30f45ac"/>
-    <p:sldId xmlns:r="http://schemas.openxmlformats.org/officeDocument/2006/relationships" id="263" r:id="R9c67120bbc364f18"/>
-    <p:sldId xmlns:r="http://schemas.openxmlformats.org/officeDocument/2006/relationships" id="264" r:id="Rcf4e7d64497b4cf7"/>
-    <p:sldId xmlns:r="http://schemas.openxmlformats.org/officeDocument/2006/relationships" id="265" r:id="Rcc895c7e942848bc"/>
-    <p:sldId xmlns:r="http://schemas.openxmlformats.org/officeDocument/2006/relationships" id="266" r:id="Rcb2963bd4daf464f"/>
-    <p:sldId xmlns:r="http://schemas.openxmlformats.org/officeDocument/2006/relationships" id="267" r:id="R167d768e6f304c1e"/>
-    <p:sldId xmlns:r="http://schemas.openxmlformats.org/officeDocument/2006/relationships" id="268" r:id="Re7174f180e9249e4"/>
-    <p:sldId xmlns:r="http://schemas.openxmlformats.org/officeDocument/2006/relationships" id="269" r:id="R65cde4503d51494e"/>
-    <p:sldId xmlns:r="http://schemas.openxmlformats.org/officeDocument/2006/relationships" id="270" r:id="R6148f09d1f9b4715"/>
+    <p:sldId xmlns:r="http://schemas.openxmlformats.org/officeDocument/2006/relationships" id="256" r:id="R7bb8d71acafe4591"/>
+    <p:sldId xmlns:r="http://schemas.openxmlformats.org/officeDocument/2006/relationships" id="257" r:id="R2fbe91ec487c4211"/>
+    <p:sldId xmlns:r="http://schemas.openxmlformats.org/officeDocument/2006/relationships" id="258" r:id="R81dd40873ca041fe"/>
+    <p:sldId xmlns:r="http://schemas.openxmlformats.org/officeDocument/2006/relationships" id="259" r:id="R320263fe5e8f4baa"/>
+    <p:sldId xmlns:r="http://schemas.openxmlformats.org/officeDocument/2006/relationships" id="260" r:id="R4f8b8ce9c4c14c9c"/>
+    <p:sldId xmlns:r="http://schemas.openxmlformats.org/officeDocument/2006/relationships" id="261" r:id="R45e26fa337cf4977"/>
+    <p:sldId xmlns:r="http://schemas.openxmlformats.org/officeDocument/2006/relationships" id="262" r:id="R20b09498bf4844ee"/>
+    <p:sldId xmlns:r="http://schemas.openxmlformats.org/officeDocument/2006/relationships" id="263" r:id="R925bf5b1405b461a"/>
+    <p:sldId xmlns:r="http://schemas.openxmlformats.org/officeDocument/2006/relationships" id="264" r:id="R46083f3028294029"/>
+    <p:sldId xmlns:r="http://schemas.openxmlformats.org/officeDocument/2006/relationships" id="265" r:id="R029579132f1041a1"/>
+    <p:sldId xmlns:r="http://schemas.openxmlformats.org/officeDocument/2006/relationships" id="266" r:id="R5545245c175e4df2"/>
+    <p:sldId xmlns:r="http://schemas.openxmlformats.org/officeDocument/2006/relationships" id="267" r:id="R070458412d344229"/>
+    <p:sldId xmlns:r="http://schemas.openxmlformats.org/officeDocument/2006/relationships" id="268" r:id="R2c8c6247b232441e"/>
+    <p:sldId xmlns:r="http://schemas.openxmlformats.org/officeDocument/2006/relationships" id="269" r:id="R45dda8a1e0c64117"/>
+    <p:sldId xmlns:r="http://schemas.openxmlformats.org/officeDocument/2006/relationships" id="270" r:id="Rbee8630a7f8c4945"/>
   </p:sldIdLst>
   <p:sldSz cx="12192000" cy="6858000"/>
   <p:notesSz cx="6858000" cy="9144000"/>
@@ -1599,7 +1599,7 @@
   </p:cSld>
   <p:clrMap bg1="lt1" tx1="dk1" bg2="lt2" tx2="dk2" accent1="accent1" accent2="accent2" accent3="accent3" accent4="accent4" accent5="accent5" accent6="accent6" hlink="hlink" folHlink="folHlink"/>
   <p:sldLayoutIdLst>
-    <p:sldLayoutId xmlns:r="http://schemas.openxmlformats.org/officeDocument/2006/relationships" id="2147483649" r:id="Rfa81e6a5b12d483d"/>
+    <p:sldLayoutId xmlns:r="http://schemas.openxmlformats.org/officeDocument/2006/relationships" id="2147483649" r:id="R65e4fdaae6914b4c"/>
   </p:sldLayoutIdLst>
   <p:txStyles>
     <p:titleStyle>
@@ -2150,7 +2150,7 @@
           <p:cNvPr id="1" name="">
             <a:extLst xmlns:a="http://schemas.openxmlformats.org/drawingml/2006/main">
               <a:ext uri="{FF2B5EF4-FFF2-40B4-BE49-F238E27FC236}">
-                <a16:creationId xmlns:a16="http://schemas.microsoft.com/office/drawing/2014/main" id="{849195A9-B720-4187-B549-4FFC81ABF5D4}"/>
+                <a16:creationId xmlns:a16="http://schemas.microsoft.com/office/drawing/2014/main" id="{29EB49DD-9CC1-4E69-A210-4265CB21D5E8}"/>
               </a:ext>
             </a:extLst>
           </p:cNvPr>
@@ -2187,7 +2187,7 @@
           <p:nvPr/>
         </p:nvPicPr>
         <p:blipFill>
-          <a:blip xmlns:r="http://schemas.openxmlformats.org/officeDocument/2006/relationships" xmlns:a="http://schemas.openxmlformats.org/drawingml/2006/main" r:embed="Reec68a5277e144b5"/>
+          <a:blip xmlns:r="http://schemas.openxmlformats.org/officeDocument/2006/relationships" xmlns:a="http://schemas.openxmlformats.org/drawingml/2006/main" r:embed="R95fad524588247ea"/>
           <a:stretch xmlns:a="http://schemas.openxmlformats.org/drawingml/2006/main"/>
         </p:blipFill>
         <p:spPr>
@@ -2205,7 +2205,7 @@
           <p:cNvPr id="3" name="">
             <a:extLst xmlns:a="http://schemas.openxmlformats.org/drawingml/2006/main">
               <a:ext uri="{FF2B5EF4-FFF2-40B4-BE49-F238E27FC236}">
-                <a16:creationId xmlns:a16="http://schemas.microsoft.com/office/drawing/2014/main" id="{121F627A-4DB8-4605-AB54-4EAED9815413}"/>
+                <a16:creationId xmlns:a16="http://schemas.microsoft.com/office/drawing/2014/main" id="{95FF469B-1ED8-4DBC-B855-A5D9417CA947}"/>
               </a:ext>
             </a:extLst>
           </p:cNvPr>
@@ -2255,7 +2255,7 @@
           <p:cNvPr id="4" name="">
             <a:extLst xmlns:a="http://schemas.openxmlformats.org/drawingml/2006/main">
               <a:ext uri="{FF2B5EF4-FFF2-40B4-BE49-F238E27FC236}">
-                <a16:creationId xmlns:a16="http://schemas.microsoft.com/office/drawing/2014/main" id="{9ACD8C51-2831-4549-8C59-AC66027998ED}"/>
+                <a16:creationId xmlns:a16="http://schemas.microsoft.com/office/drawing/2014/main" id="{F86EFD86-18FB-4494-8E53-E83AAEADE107}"/>
               </a:ext>
             </a:extLst>
           </p:cNvPr>
@@ -2305,7 +2305,7 @@
           <p:cNvPr id="5" name="">
             <a:extLst xmlns:a="http://schemas.openxmlformats.org/drawingml/2006/main">
               <a:ext uri="{FF2B5EF4-FFF2-40B4-BE49-F238E27FC236}">
-                <a16:creationId xmlns:a16="http://schemas.microsoft.com/office/drawing/2014/main" id="{0D195794-A959-4404-89B1-00BD2716CE19}"/>
+                <a16:creationId xmlns:a16="http://schemas.microsoft.com/office/drawing/2014/main" id="{AFD85A17-9988-4F6D-BE76-70CDBDCC6ECC}"/>
               </a:ext>
             </a:extLst>
           </p:cNvPr>
@@ -2340,7 +2340,7 @@
           <p:cNvPr id="6" name="">
             <a:extLst xmlns:a="http://schemas.openxmlformats.org/drawingml/2006/main">
               <a:ext uri="{FF2B5EF4-FFF2-40B4-BE49-F238E27FC236}">
-                <a16:creationId xmlns:a16="http://schemas.microsoft.com/office/drawing/2014/main" id="{33BA60BD-11F8-49CB-9C24-AA626841CFE7}"/>
+                <a16:creationId xmlns:a16="http://schemas.microsoft.com/office/drawing/2014/main" id="{D714BA41-3A6C-4ACB-A2AC-C18F49C13451}"/>
               </a:ext>
             </a:extLst>
           </p:cNvPr>
@@ -2390,7 +2390,7 @@
           <p:cNvPr id="7" name="">
             <a:extLst xmlns:a="http://schemas.openxmlformats.org/drawingml/2006/main">
               <a:ext uri="{FF2B5EF4-FFF2-40B4-BE49-F238E27FC236}">
-                <a16:creationId xmlns:a16="http://schemas.microsoft.com/office/drawing/2014/main" id="{B4C9664F-619B-46C0-B502-7DD426BF93B6}"/>
+                <a16:creationId xmlns:a16="http://schemas.microsoft.com/office/drawing/2014/main" id="{E84C3209-3E3B-4DB3-BBCA-4B55F6F48DB8}"/>
               </a:ext>
             </a:extLst>
           </p:cNvPr>
@@ -2440,7 +2440,7 @@
           <p:cNvPr id="8" name="">
             <a:extLst xmlns:a="http://schemas.openxmlformats.org/drawingml/2006/main">
               <a:ext uri="{FF2B5EF4-FFF2-40B4-BE49-F238E27FC236}">
-                <a16:creationId xmlns:a16="http://schemas.microsoft.com/office/drawing/2014/main" id="{B1507181-A018-47F6-9965-26712AFDFDF6}"/>
+                <a16:creationId xmlns:a16="http://schemas.microsoft.com/office/drawing/2014/main" id="{C5EF3FB6-26FA-40A8-8D9E-147B8EE0C021}"/>
               </a:ext>
             </a:extLst>
           </p:cNvPr>
@@ -2505,7 +2505,7 @@
     </p:spTree>
     <p:extLst>
       <p:ext uri="{BB962C8B-B14F-4D97-AF65-F5344CB8AC3E}">
-        <p14:creationId xmlns:p14="http://schemas.microsoft.com/office/powerpoint/2010/main" val="1112975325"/>
+        <p14:creationId xmlns:p14="http://schemas.microsoft.com/office/powerpoint/2010/main" val="48687895"/>
       </p:ext>
     </p:extLst>
   </p:cSld>
@@ -2536,7 +2536,7 @@
           <p:cNvPr id="1" name="">
             <a:extLst xmlns:a="http://schemas.openxmlformats.org/drawingml/2006/main">
               <a:ext uri="{FF2B5EF4-FFF2-40B4-BE49-F238E27FC236}">
-                <a16:creationId xmlns:a16="http://schemas.microsoft.com/office/drawing/2014/main" id="{27F56120-D446-44C0-9388-528DA19903C2}"/>
+                <a16:creationId xmlns:a16="http://schemas.microsoft.com/office/drawing/2014/main" id="{B9529D04-BCE9-4A43-ADBC-724B4AF0BD77}"/>
               </a:ext>
             </a:extLst>
           </p:cNvPr>
@@ -2569,7 +2569,7 @@
           <p:cNvPr id="2" name="">
             <a:extLst xmlns:a="http://schemas.openxmlformats.org/drawingml/2006/main">
               <a:ext uri="{FF2B5EF4-FFF2-40B4-BE49-F238E27FC236}">
-                <a16:creationId xmlns:a16="http://schemas.microsoft.com/office/drawing/2014/main" id="{A5FE96C7-5E61-40D3-A0D8-70B35002CEAE}"/>
+                <a16:creationId xmlns:a16="http://schemas.microsoft.com/office/drawing/2014/main" id="{A51A3EF2-05B8-4245-A362-5BF16BEED7AC}"/>
               </a:ext>
             </a:extLst>
           </p:cNvPr>
@@ -2602,7 +2602,7 @@
           <p:cNvPr id="3" name="">
             <a:extLst xmlns:a="http://schemas.openxmlformats.org/drawingml/2006/main">
               <a:ext uri="{FF2B5EF4-FFF2-40B4-BE49-F238E27FC236}">
-                <a16:creationId xmlns:a16="http://schemas.microsoft.com/office/drawing/2014/main" id="{F4D7903E-98AC-40F0-90EA-923A8C74E88E}"/>
+                <a16:creationId xmlns:a16="http://schemas.microsoft.com/office/drawing/2014/main" id="{584CB043-39AB-45C5-A165-AB23ADA0826C}"/>
               </a:ext>
             </a:extLst>
           </p:cNvPr>
@@ -2652,7 +2652,7 @@
           <p:cNvPr id="4" name="">
             <a:extLst xmlns:a="http://schemas.openxmlformats.org/drawingml/2006/main">
               <a:ext uri="{FF2B5EF4-FFF2-40B4-BE49-F238E27FC236}">
-                <a16:creationId xmlns:a16="http://schemas.microsoft.com/office/drawing/2014/main" id="{69FBCD30-B724-46EB-BF68-D19FEEF01FF2}"/>
+                <a16:creationId xmlns:a16="http://schemas.microsoft.com/office/drawing/2014/main" id="{76A72F8B-1C34-406E-900B-72312C079DE4}"/>
               </a:ext>
             </a:extLst>
           </p:cNvPr>
@@ -2702,7 +2702,7 @@
           <p:cNvPr id="5" name="">
             <a:extLst xmlns:a="http://schemas.openxmlformats.org/drawingml/2006/main">
               <a:ext uri="{FF2B5EF4-FFF2-40B4-BE49-F238E27FC236}">
-                <a16:creationId xmlns:a16="http://schemas.microsoft.com/office/drawing/2014/main" id="{137B4435-2319-42D1-9438-72924D91865B}"/>
+                <a16:creationId xmlns:a16="http://schemas.microsoft.com/office/drawing/2014/main" id="{005E19DE-5191-4A11-9213-061E40ACA193}"/>
               </a:ext>
             </a:extLst>
           </p:cNvPr>
@@ -2737,7 +2737,7 @@
           <p:nvPr/>
         </p:nvPicPr>
         <p:blipFill>
-          <a:blip xmlns:r="http://schemas.openxmlformats.org/officeDocument/2006/relationships" xmlns:a="http://schemas.openxmlformats.org/drawingml/2006/main" r:embed="R90862ede8f764759"/>
+          <a:blip xmlns:r="http://schemas.openxmlformats.org/officeDocument/2006/relationships" xmlns:a="http://schemas.openxmlformats.org/drawingml/2006/main" r:embed="R3ba3de3c705344af"/>
           <a:stretch xmlns:a="http://schemas.openxmlformats.org/drawingml/2006/main"/>
         </p:blipFill>
         <p:spPr>
@@ -2755,7 +2755,7 @@
           <p:cNvPr id="7" name="">
             <a:extLst xmlns:a="http://schemas.openxmlformats.org/drawingml/2006/main">
               <a:ext uri="{FF2B5EF4-FFF2-40B4-BE49-F238E27FC236}">
-                <a16:creationId xmlns:a16="http://schemas.microsoft.com/office/drawing/2014/main" id="{9F8366B7-07E2-47E5-80A0-186C8C91ECD4}"/>
+                <a16:creationId xmlns:a16="http://schemas.microsoft.com/office/drawing/2014/main" id="{1A93F1A3-8CE1-4FBE-AE6D-1F06EFB7E19E}"/>
               </a:ext>
             </a:extLst>
           </p:cNvPr>
@@ -2790,7 +2790,7 @@
           <p:cNvPr id="8" name="">
             <a:extLst xmlns:a="http://schemas.openxmlformats.org/drawingml/2006/main">
               <a:ext uri="{FF2B5EF4-FFF2-40B4-BE49-F238E27FC236}">
-                <a16:creationId xmlns:a16="http://schemas.microsoft.com/office/drawing/2014/main" id="{BC1C9F79-437E-4673-A083-F3DCBDFE4AE9}"/>
+                <a16:creationId xmlns:a16="http://schemas.microsoft.com/office/drawing/2014/main" id="{BC51146C-678F-4758-9D84-CFC109DFD0BC}"/>
               </a:ext>
             </a:extLst>
           </p:cNvPr>
@@ -2840,7 +2840,7 @@
           <p:cNvPr id="9" name="">
             <a:extLst xmlns:a="http://schemas.openxmlformats.org/drawingml/2006/main">
               <a:ext uri="{FF2B5EF4-FFF2-40B4-BE49-F238E27FC236}">
-                <a16:creationId xmlns:a16="http://schemas.microsoft.com/office/drawing/2014/main" id="{CCE6B808-2EB2-4E60-9DD3-962D9E2CD6D7}"/>
+                <a16:creationId xmlns:a16="http://schemas.microsoft.com/office/drawing/2014/main" id="{8260D5C5-18C8-4A41-8E88-5293FD567326}"/>
               </a:ext>
             </a:extLst>
           </p:cNvPr>
@@ -2890,7 +2890,7 @@
           <p:cNvPr id="10" name="">
             <a:extLst xmlns:a="http://schemas.openxmlformats.org/drawingml/2006/main">
               <a:ext uri="{FF2B5EF4-FFF2-40B4-BE49-F238E27FC236}">
-                <a16:creationId xmlns:a16="http://schemas.microsoft.com/office/drawing/2014/main" id="{67E36CFF-72BB-4D4E-B5D6-3F74F94979C3}"/>
+                <a16:creationId xmlns:a16="http://schemas.microsoft.com/office/drawing/2014/main" id="{CB2B03B7-5D05-431C-A0F0-AA0214457719}"/>
               </a:ext>
             </a:extLst>
           </p:cNvPr>
@@ -2925,7 +2925,7 @@
           <p:cNvPr id="11" name="">
             <a:extLst xmlns:a="http://schemas.openxmlformats.org/drawingml/2006/main">
               <a:ext uri="{FF2B5EF4-FFF2-40B4-BE49-F238E27FC236}">
-                <a16:creationId xmlns:a16="http://schemas.microsoft.com/office/drawing/2014/main" id="{1DB7AFB8-DA4A-439B-A978-49F8FA54EC9C}"/>
+                <a16:creationId xmlns:a16="http://schemas.microsoft.com/office/drawing/2014/main" id="{D61DBD1C-ADCA-46C2-A311-71BAC533CF1F}"/>
               </a:ext>
             </a:extLst>
           </p:cNvPr>
@@ -2975,7 +2975,7 @@
           <p:cNvPr id="12" name="">
             <a:extLst xmlns:a="http://schemas.openxmlformats.org/drawingml/2006/main">
               <a:ext uri="{FF2B5EF4-FFF2-40B4-BE49-F238E27FC236}">
-                <a16:creationId xmlns:a16="http://schemas.microsoft.com/office/drawing/2014/main" id="{7E5C05E9-C446-43B9-8485-9A817F5E1A7C}"/>
+                <a16:creationId xmlns:a16="http://schemas.microsoft.com/office/drawing/2014/main" id="{77AEF68B-31AB-47E3-BAF5-46797B29F01D}"/>
               </a:ext>
             </a:extLst>
           </p:cNvPr>
@@ -3025,7 +3025,7 @@
           <p:cNvPr id="13" name="">
             <a:extLst xmlns:a="http://schemas.openxmlformats.org/drawingml/2006/main">
               <a:ext uri="{FF2B5EF4-FFF2-40B4-BE49-F238E27FC236}">
-                <a16:creationId xmlns:a16="http://schemas.microsoft.com/office/drawing/2014/main" id="{45B37A2B-466C-4E5F-AD31-E2B4026F9FEC}"/>
+                <a16:creationId xmlns:a16="http://schemas.microsoft.com/office/drawing/2014/main" id="{22FCD1B9-307C-4FB5-B210-08D7443AEC4A}"/>
               </a:ext>
             </a:extLst>
           </p:cNvPr>
@@ -3060,7 +3060,7 @@
           <p:cNvPr id="14" name="">
             <a:extLst xmlns:a="http://schemas.openxmlformats.org/drawingml/2006/main">
               <a:ext uri="{FF2B5EF4-FFF2-40B4-BE49-F238E27FC236}">
-                <a16:creationId xmlns:a16="http://schemas.microsoft.com/office/drawing/2014/main" id="{8E290D04-A812-4B45-BCE5-77A84F4FFC72}"/>
+                <a16:creationId xmlns:a16="http://schemas.microsoft.com/office/drawing/2014/main" id="{58DEFB1B-AC88-4DA5-BE4A-16586F08B9E3}"/>
               </a:ext>
             </a:extLst>
           </p:cNvPr>
@@ -3110,7 +3110,7 @@
           <p:cNvPr id="15" name="">
             <a:extLst xmlns:a="http://schemas.openxmlformats.org/drawingml/2006/main">
               <a:ext uri="{FF2B5EF4-FFF2-40B4-BE49-F238E27FC236}">
-                <a16:creationId xmlns:a16="http://schemas.microsoft.com/office/drawing/2014/main" id="{E62E8D4D-22BE-46D7-8D52-E5F90818191E}"/>
+                <a16:creationId xmlns:a16="http://schemas.microsoft.com/office/drawing/2014/main" id="{B0EDDBB3-59B2-4932-B2D4-2A3CA648C219}"/>
               </a:ext>
             </a:extLst>
           </p:cNvPr>
@@ -3160,7 +3160,7 @@
           <p:cNvPr id="16" name="">
             <a:extLst xmlns:a="http://schemas.openxmlformats.org/drawingml/2006/main">
               <a:ext uri="{FF2B5EF4-FFF2-40B4-BE49-F238E27FC236}">
-                <a16:creationId xmlns:a16="http://schemas.microsoft.com/office/drawing/2014/main" id="{B2E68CB3-9AA0-4538-B107-D234C7DBF509}"/>
+                <a16:creationId xmlns:a16="http://schemas.microsoft.com/office/drawing/2014/main" id="{45CA0BFD-1CEB-4C3D-B2B0-7B94497DDF10}"/>
               </a:ext>
             </a:extLst>
           </p:cNvPr>
@@ -3195,7 +3195,7 @@
           <p:cNvPr id="17" name="">
             <a:extLst xmlns:a="http://schemas.openxmlformats.org/drawingml/2006/main">
               <a:ext uri="{FF2B5EF4-FFF2-40B4-BE49-F238E27FC236}">
-                <a16:creationId xmlns:a16="http://schemas.microsoft.com/office/drawing/2014/main" id="{08D08284-3106-462A-AD54-AE4F4D611C0A}"/>
+                <a16:creationId xmlns:a16="http://schemas.microsoft.com/office/drawing/2014/main" id="{45D702FA-6AEC-4716-A9F8-2C4DB7CF9BF0}"/>
               </a:ext>
             </a:extLst>
           </p:cNvPr>
@@ -3245,7 +3245,7 @@
           <p:cNvPr id="18" name="">
             <a:extLst xmlns:a="http://schemas.openxmlformats.org/drawingml/2006/main">
               <a:ext uri="{FF2B5EF4-FFF2-40B4-BE49-F238E27FC236}">
-                <a16:creationId xmlns:a16="http://schemas.microsoft.com/office/drawing/2014/main" id="{95C90D69-533A-4253-BF8F-EE580C15F6D2}"/>
+                <a16:creationId xmlns:a16="http://schemas.microsoft.com/office/drawing/2014/main" id="{91B2E687-3B10-40DB-9EDE-8EA903FB5FEC}"/>
               </a:ext>
             </a:extLst>
           </p:cNvPr>
@@ -3295,7 +3295,7 @@
           <p:cNvPr id="19" name="">
             <a:extLst xmlns:a="http://schemas.openxmlformats.org/drawingml/2006/main">
               <a:ext uri="{FF2B5EF4-FFF2-40B4-BE49-F238E27FC236}">
-                <a16:creationId xmlns:a16="http://schemas.microsoft.com/office/drawing/2014/main" id="{83E4FC28-E6AA-4419-A40D-1ADE2465D7E3}"/>
+                <a16:creationId xmlns:a16="http://schemas.microsoft.com/office/drawing/2014/main" id="{7BACB9C2-A4D8-4557-82E0-24700A6E2BF7}"/>
               </a:ext>
             </a:extLst>
           </p:cNvPr>
@@ -3330,7 +3330,7 @@
           <p:cNvPr id="20" name="">
             <a:extLst xmlns:a="http://schemas.openxmlformats.org/drawingml/2006/main">
               <a:ext uri="{FF2B5EF4-FFF2-40B4-BE49-F238E27FC236}">
-                <a16:creationId xmlns:a16="http://schemas.microsoft.com/office/drawing/2014/main" id="{A8E287F9-9200-44C7-915E-5EAA5621A540}"/>
+                <a16:creationId xmlns:a16="http://schemas.microsoft.com/office/drawing/2014/main" id="{82194E8C-AEBE-46FB-9AB4-674DBBF09A13}"/>
               </a:ext>
             </a:extLst>
           </p:cNvPr>
@@ -3380,7 +3380,7 @@
           <p:cNvPr id="21" name="">
             <a:extLst xmlns:a="http://schemas.openxmlformats.org/drawingml/2006/main">
               <a:ext uri="{FF2B5EF4-FFF2-40B4-BE49-F238E27FC236}">
-                <a16:creationId xmlns:a16="http://schemas.microsoft.com/office/drawing/2014/main" id="{D83F4A9C-FB67-40A7-A40A-06BAB05CF6CC}"/>
+                <a16:creationId xmlns:a16="http://schemas.microsoft.com/office/drawing/2014/main" id="{3DF1FAD3-DA26-44D2-B567-099717592EE1}"/>
               </a:ext>
             </a:extLst>
           </p:cNvPr>
@@ -3428,7 +3428,7 @@
     </p:spTree>
     <p:extLst>
       <p:ext uri="{BB962C8B-B14F-4D97-AF65-F5344CB8AC3E}">
-        <p14:creationId xmlns:p14="http://schemas.microsoft.com/office/powerpoint/2010/main" val="1324149597"/>
+        <p14:creationId xmlns:p14="http://schemas.microsoft.com/office/powerpoint/2010/main" val="1939564908"/>
       </p:ext>
     </p:extLst>
   </p:cSld>
@@ -3459,7 +3459,7 @@
           <p:cNvPr id="1" name="">
             <a:extLst xmlns:a="http://schemas.openxmlformats.org/drawingml/2006/main">
               <a:ext uri="{FF2B5EF4-FFF2-40B4-BE49-F238E27FC236}">
-                <a16:creationId xmlns:a16="http://schemas.microsoft.com/office/drawing/2014/main" id="{89F9F3D1-F820-42F1-8321-CC02B4B76EF2}"/>
+                <a16:creationId xmlns:a16="http://schemas.microsoft.com/office/drawing/2014/main" id="{A1EE48A6-A172-4EB5-99D4-8902CE63ECC7}"/>
               </a:ext>
             </a:extLst>
           </p:cNvPr>
@@ -3492,7 +3492,7 @@
           <p:cNvPr id="2" name="">
             <a:extLst xmlns:a="http://schemas.openxmlformats.org/drawingml/2006/main">
               <a:ext uri="{FF2B5EF4-FFF2-40B4-BE49-F238E27FC236}">
-                <a16:creationId xmlns:a16="http://schemas.microsoft.com/office/drawing/2014/main" id="{A4E6D27C-6CCE-4EBF-BF65-422281FDBF36}"/>
+                <a16:creationId xmlns:a16="http://schemas.microsoft.com/office/drawing/2014/main" id="{E7476F39-65E9-4E9C-B5A6-8E8DC6B5ECD5}"/>
               </a:ext>
             </a:extLst>
           </p:cNvPr>
@@ -3525,7 +3525,7 @@
           <p:cNvPr id="3" name="">
             <a:extLst xmlns:a="http://schemas.openxmlformats.org/drawingml/2006/main">
               <a:ext uri="{FF2B5EF4-FFF2-40B4-BE49-F238E27FC236}">
-                <a16:creationId xmlns:a16="http://schemas.microsoft.com/office/drawing/2014/main" id="{C5F72E28-0E26-4C99-87B0-0096E798A609}"/>
+                <a16:creationId xmlns:a16="http://schemas.microsoft.com/office/drawing/2014/main" id="{1405DBE0-5DB4-4287-ABC6-DB3A4D0D4EB0}"/>
               </a:ext>
             </a:extLst>
           </p:cNvPr>
@@ -3575,7 +3575,7 @@
           <p:cNvPr id="4" name="">
             <a:extLst xmlns:a="http://schemas.openxmlformats.org/drawingml/2006/main">
               <a:ext uri="{FF2B5EF4-FFF2-40B4-BE49-F238E27FC236}">
-                <a16:creationId xmlns:a16="http://schemas.microsoft.com/office/drawing/2014/main" id="{E220FA68-1DA7-490E-9426-65D245A1529C}"/>
+                <a16:creationId xmlns:a16="http://schemas.microsoft.com/office/drawing/2014/main" id="{E4ADC822-1E22-4640-B7B3-A129B8568C02}"/>
               </a:ext>
             </a:extLst>
           </p:cNvPr>
@@ -3625,7 +3625,7 @@
           <p:cNvPr id="5" name="">
             <a:extLst xmlns:a="http://schemas.openxmlformats.org/drawingml/2006/main">
               <a:ext uri="{FF2B5EF4-FFF2-40B4-BE49-F238E27FC236}">
-                <a16:creationId xmlns:a16="http://schemas.microsoft.com/office/drawing/2014/main" id="{CF5DF177-80EA-4393-92C0-BCD07993F6E6}"/>
+                <a16:creationId xmlns:a16="http://schemas.microsoft.com/office/drawing/2014/main" id="{502262FA-3E4F-413F-BA41-E5D7DE9B5350}"/>
               </a:ext>
             </a:extLst>
           </p:cNvPr>
@@ -3660,7 +3660,7 @@
           <p:nvPr/>
         </p:nvPicPr>
         <p:blipFill>
-          <a:blip xmlns:r="http://schemas.openxmlformats.org/officeDocument/2006/relationships" xmlns:a="http://schemas.openxmlformats.org/drawingml/2006/main" r:embed="Rb83dd0b221714cf3"/>
+          <a:blip xmlns:r="http://schemas.openxmlformats.org/officeDocument/2006/relationships" xmlns:a="http://schemas.openxmlformats.org/drawingml/2006/main" r:embed="Re4f6b1da48cf4805"/>
           <a:stretch xmlns:a="http://schemas.openxmlformats.org/drawingml/2006/main"/>
         </p:blipFill>
         <p:spPr>
@@ -3678,7 +3678,7 @@
           <p:cNvPr id="7" name="">
             <a:extLst xmlns:a="http://schemas.openxmlformats.org/drawingml/2006/main">
               <a:ext uri="{FF2B5EF4-FFF2-40B4-BE49-F238E27FC236}">
-                <a16:creationId xmlns:a16="http://schemas.microsoft.com/office/drawing/2014/main" id="{FED9D53D-E8B3-4567-8C3D-93CC0FD1C93F}"/>
+                <a16:creationId xmlns:a16="http://schemas.microsoft.com/office/drawing/2014/main" id="{AE50ACFA-FE13-4F3E-B3A4-1E958608775F}"/>
               </a:ext>
             </a:extLst>
           </p:cNvPr>
@@ -3713,7 +3713,7 @@
           <p:cNvPr id="8" name="">
             <a:extLst xmlns:a="http://schemas.openxmlformats.org/drawingml/2006/main">
               <a:ext uri="{FF2B5EF4-FFF2-40B4-BE49-F238E27FC236}">
-                <a16:creationId xmlns:a16="http://schemas.microsoft.com/office/drawing/2014/main" id="{FF35F278-2641-48DF-A226-A0FBD8B38822}"/>
+                <a16:creationId xmlns:a16="http://schemas.microsoft.com/office/drawing/2014/main" id="{00AAF173-BC79-4E74-8349-FE6806A66E49}"/>
               </a:ext>
             </a:extLst>
           </p:cNvPr>
@@ -3763,7 +3763,7 @@
           <p:cNvPr id="9" name="">
             <a:extLst xmlns:a="http://schemas.openxmlformats.org/drawingml/2006/main">
               <a:ext uri="{FF2B5EF4-FFF2-40B4-BE49-F238E27FC236}">
-                <a16:creationId xmlns:a16="http://schemas.microsoft.com/office/drawing/2014/main" id="{6518F8C2-1886-470A-9AF5-BFDE219C7276}"/>
+                <a16:creationId xmlns:a16="http://schemas.microsoft.com/office/drawing/2014/main" id="{0894B7E4-798C-43E1-8440-AF2DFF2310BD}"/>
               </a:ext>
             </a:extLst>
           </p:cNvPr>
@@ -3813,7 +3813,7 @@
           <p:cNvPr id="10" name="">
             <a:extLst xmlns:a="http://schemas.openxmlformats.org/drawingml/2006/main">
               <a:ext uri="{FF2B5EF4-FFF2-40B4-BE49-F238E27FC236}">
-                <a16:creationId xmlns:a16="http://schemas.microsoft.com/office/drawing/2014/main" id="{66907450-16E1-4C9A-9723-575C6175F486}"/>
+                <a16:creationId xmlns:a16="http://schemas.microsoft.com/office/drawing/2014/main" id="{C4DCF23E-A973-46FA-9194-F471E209E6CD}"/>
               </a:ext>
             </a:extLst>
           </p:cNvPr>
@@ -3848,7 +3848,7 @@
           <p:cNvPr id="11" name="">
             <a:extLst xmlns:a="http://schemas.openxmlformats.org/drawingml/2006/main">
               <a:ext uri="{FF2B5EF4-FFF2-40B4-BE49-F238E27FC236}">
-                <a16:creationId xmlns:a16="http://schemas.microsoft.com/office/drawing/2014/main" id="{22D650DA-8B68-46B7-A954-0E96DF69FACF}"/>
+                <a16:creationId xmlns:a16="http://schemas.microsoft.com/office/drawing/2014/main" id="{4A6A6A4B-EE0F-41F1-8A75-F925DDA21799}"/>
               </a:ext>
             </a:extLst>
           </p:cNvPr>
@@ -3898,7 +3898,7 @@
           <p:cNvPr id="12" name="">
             <a:extLst xmlns:a="http://schemas.openxmlformats.org/drawingml/2006/main">
               <a:ext uri="{FF2B5EF4-FFF2-40B4-BE49-F238E27FC236}">
-                <a16:creationId xmlns:a16="http://schemas.microsoft.com/office/drawing/2014/main" id="{F3FB22E7-9218-43BA-96A7-12DAA5CD46E6}"/>
+                <a16:creationId xmlns:a16="http://schemas.microsoft.com/office/drawing/2014/main" id="{23DAE736-6F16-4A70-8A7B-6B9FF314DAAD}"/>
               </a:ext>
             </a:extLst>
           </p:cNvPr>
@@ -3948,7 +3948,7 @@
           <p:cNvPr id="13" name="">
             <a:extLst xmlns:a="http://schemas.openxmlformats.org/drawingml/2006/main">
               <a:ext uri="{FF2B5EF4-FFF2-40B4-BE49-F238E27FC236}">
-                <a16:creationId xmlns:a16="http://schemas.microsoft.com/office/drawing/2014/main" id="{EC628E15-D194-4E34-B72C-22F3FB8211F1}"/>
+                <a16:creationId xmlns:a16="http://schemas.microsoft.com/office/drawing/2014/main" id="{27D026FC-E37B-4E5E-9760-730CFA62B235}"/>
               </a:ext>
             </a:extLst>
           </p:cNvPr>
@@ -3983,7 +3983,7 @@
           <p:cNvPr id="14" name="">
             <a:extLst xmlns:a="http://schemas.openxmlformats.org/drawingml/2006/main">
               <a:ext uri="{FF2B5EF4-FFF2-40B4-BE49-F238E27FC236}">
-                <a16:creationId xmlns:a16="http://schemas.microsoft.com/office/drawing/2014/main" id="{E767505A-29E4-4C83-A644-5C3F37796B29}"/>
+                <a16:creationId xmlns:a16="http://schemas.microsoft.com/office/drawing/2014/main" id="{5DA17C16-A455-4EBC-84C5-2FF7AC37D4B1}"/>
               </a:ext>
             </a:extLst>
           </p:cNvPr>
@@ -4033,7 +4033,7 @@
           <p:cNvPr id="15" name="">
             <a:extLst xmlns:a="http://schemas.openxmlformats.org/drawingml/2006/main">
               <a:ext uri="{FF2B5EF4-FFF2-40B4-BE49-F238E27FC236}">
-                <a16:creationId xmlns:a16="http://schemas.microsoft.com/office/drawing/2014/main" id="{C4B0CA58-7581-414E-8498-49691A47F7C4}"/>
+                <a16:creationId xmlns:a16="http://schemas.microsoft.com/office/drawing/2014/main" id="{C53D543D-8AAB-420C-ACBE-3AAD04380974}"/>
               </a:ext>
             </a:extLst>
           </p:cNvPr>
@@ -4083,7 +4083,7 @@
           <p:cNvPr id="16" name="">
             <a:extLst xmlns:a="http://schemas.openxmlformats.org/drawingml/2006/main">
               <a:ext uri="{FF2B5EF4-FFF2-40B4-BE49-F238E27FC236}">
-                <a16:creationId xmlns:a16="http://schemas.microsoft.com/office/drawing/2014/main" id="{DACB8986-00AF-4DB5-AA69-190D3E82C431}"/>
+                <a16:creationId xmlns:a16="http://schemas.microsoft.com/office/drawing/2014/main" id="{6897C433-0B9B-4486-95A8-1E9F2212BDC9}"/>
               </a:ext>
             </a:extLst>
           </p:cNvPr>
@@ -4118,7 +4118,7 @@
           <p:cNvPr id="17" name="">
             <a:extLst xmlns:a="http://schemas.openxmlformats.org/drawingml/2006/main">
               <a:ext uri="{FF2B5EF4-FFF2-40B4-BE49-F238E27FC236}">
-                <a16:creationId xmlns:a16="http://schemas.microsoft.com/office/drawing/2014/main" id="{CF7EBF38-43B6-4CEF-9BDC-A1CB4216C868}"/>
+                <a16:creationId xmlns:a16="http://schemas.microsoft.com/office/drawing/2014/main" id="{F3012887-2EC5-47C5-BE25-18FD194D2171}"/>
               </a:ext>
             </a:extLst>
           </p:cNvPr>
@@ -4168,7 +4168,7 @@
           <p:cNvPr id="18" name="">
             <a:extLst xmlns:a="http://schemas.openxmlformats.org/drawingml/2006/main">
               <a:ext uri="{FF2B5EF4-FFF2-40B4-BE49-F238E27FC236}">
-                <a16:creationId xmlns:a16="http://schemas.microsoft.com/office/drawing/2014/main" id="{334A0AE0-B6FC-4E05-B643-AD295E8925B0}"/>
+                <a16:creationId xmlns:a16="http://schemas.microsoft.com/office/drawing/2014/main" id="{51661181-6882-48F6-8262-79D4926D77EF}"/>
               </a:ext>
             </a:extLst>
           </p:cNvPr>
@@ -4218,7 +4218,7 @@
           <p:cNvPr id="19" name="">
             <a:extLst xmlns:a="http://schemas.openxmlformats.org/drawingml/2006/main">
               <a:ext uri="{FF2B5EF4-FFF2-40B4-BE49-F238E27FC236}">
-                <a16:creationId xmlns:a16="http://schemas.microsoft.com/office/drawing/2014/main" id="{E7AD0A98-6004-4DCF-865F-CE80933A55BE}"/>
+                <a16:creationId xmlns:a16="http://schemas.microsoft.com/office/drawing/2014/main" id="{1983FD78-C8A1-452E-9005-D5F99A77F542}"/>
               </a:ext>
             </a:extLst>
           </p:cNvPr>
@@ -4253,7 +4253,7 @@
           <p:cNvPr id="20" name="">
             <a:extLst xmlns:a="http://schemas.openxmlformats.org/drawingml/2006/main">
               <a:ext uri="{FF2B5EF4-FFF2-40B4-BE49-F238E27FC236}">
-                <a16:creationId xmlns:a16="http://schemas.microsoft.com/office/drawing/2014/main" id="{1AFED6D3-5081-4B5A-811B-63584F3475FE}"/>
+                <a16:creationId xmlns:a16="http://schemas.microsoft.com/office/drawing/2014/main" id="{C304143F-F9CC-4184-B405-6FD45E46D8E8}"/>
               </a:ext>
             </a:extLst>
           </p:cNvPr>
@@ -4303,7 +4303,7 @@
           <p:cNvPr id="21" name="">
             <a:extLst xmlns:a="http://schemas.openxmlformats.org/drawingml/2006/main">
               <a:ext uri="{FF2B5EF4-FFF2-40B4-BE49-F238E27FC236}">
-                <a16:creationId xmlns:a16="http://schemas.microsoft.com/office/drawing/2014/main" id="{A4EC5314-9F23-4999-873C-DA4C106ED2CF}"/>
+                <a16:creationId xmlns:a16="http://schemas.microsoft.com/office/drawing/2014/main" id="{FE8D839B-F189-4A62-B3DB-0E59FD5EA016}"/>
               </a:ext>
             </a:extLst>
           </p:cNvPr>
@@ -4353,7 +4353,7 @@
           <p:cNvPr id="22" name="">
             <a:extLst xmlns:a="http://schemas.openxmlformats.org/drawingml/2006/main">
               <a:ext uri="{FF2B5EF4-FFF2-40B4-BE49-F238E27FC236}">
-                <a16:creationId xmlns:a16="http://schemas.microsoft.com/office/drawing/2014/main" id="{A4E01F45-4C23-45B0-83F2-517F94F5B6F4}"/>
+                <a16:creationId xmlns:a16="http://schemas.microsoft.com/office/drawing/2014/main" id="{49162D19-439F-46FC-ADEC-F56D40D42F07}"/>
               </a:ext>
             </a:extLst>
           </p:cNvPr>
@@ -4388,7 +4388,7 @@
           <p:cNvPr id="23" name="">
             <a:extLst xmlns:a="http://schemas.openxmlformats.org/drawingml/2006/main">
               <a:ext uri="{FF2B5EF4-FFF2-40B4-BE49-F238E27FC236}">
-                <a16:creationId xmlns:a16="http://schemas.microsoft.com/office/drawing/2014/main" id="{6A4E36B3-A763-44E7-AD7E-B0C163247070}"/>
+                <a16:creationId xmlns:a16="http://schemas.microsoft.com/office/drawing/2014/main" id="{7D53431F-118B-4AB5-B567-EF73494452E1}"/>
               </a:ext>
             </a:extLst>
           </p:cNvPr>
@@ -4438,7 +4438,7 @@
           <p:cNvPr id="24" name="">
             <a:extLst xmlns:a="http://schemas.openxmlformats.org/drawingml/2006/main">
               <a:ext uri="{FF2B5EF4-FFF2-40B4-BE49-F238E27FC236}">
-                <a16:creationId xmlns:a16="http://schemas.microsoft.com/office/drawing/2014/main" id="{D49BFDC6-DA68-42B5-BD85-16CA5FA453AD}"/>
+                <a16:creationId xmlns:a16="http://schemas.microsoft.com/office/drawing/2014/main" id="{BC775F9A-1E35-4619-8E49-1DA0083F2BF7}"/>
               </a:ext>
             </a:extLst>
           </p:cNvPr>
@@ -4486,7 +4486,7 @@
     </p:spTree>
     <p:extLst>
       <p:ext uri="{BB962C8B-B14F-4D97-AF65-F5344CB8AC3E}">
-        <p14:creationId xmlns:p14="http://schemas.microsoft.com/office/powerpoint/2010/main" val="97002258"/>
+        <p14:creationId xmlns:p14="http://schemas.microsoft.com/office/powerpoint/2010/main" val="1255002873"/>
       </p:ext>
     </p:extLst>
   </p:cSld>
@@ -4517,7 +4517,7 @@
           <p:cNvPr id="1" name="">
             <a:extLst xmlns:a="http://schemas.openxmlformats.org/drawingml/2006/main">
               <a:ext uri="{FF2B5EF4-FFF2-40B4-BE49-F238E27FC236}">
-                <a16:creationId xmlns:a16="http://schemas.microsoft.com/office/drawing/2014/main" id="{83B3CFAF-40D2-41BC-902B-910931B0706B}"/>
+                <a16:creationId xmlns:a16="http://schemas.microsoft.com/office/drawing/2014/main" id="{4841E682-C0BD-40A9-873A-9BDE5D96C973}"/>
               </a:ext>
             </a:extLst>
           </p:cNvPr>
@@ -4550,7 +4550,7 @@
           <p:cNvPr id="2" name="">
             <a:extLst xmlns:a="http://schemas.openxmlformats.org/drawingml/2006/main">
               <a:ext uri="{FF2B5EF4-FFF2-40B4-BE49-F238E27FC236}">
-                <a16:creationId xmlns:a16="http://schemas.microsoft.com/office/drawing/2014/main" id="{EBC0376A-331B-43C7-817C-E83F4BBE86A0}"/>
+                <a16:creationId xmlns:a16="http://schemas.microsoft.com/office/drawing/2014/main" id="{B0B01ECE-E217-4D16-B009-6C83836D5BC6}"/>
               </a:ext>
             </a:extLst>
           </p:cNvPr>
@@ -4583,7 +4583,7 @@
           <p:cNvPr id="3" name="">
             <a:extLst xmlns:a="http://schemas.openxmlformats.org/drawingml/2006/main">
               <a:ext uri="{FF2B5EF4-FFF2-40B4-BE49-F238E27FC236}">
-                <a16:creationId xmlns:a16="http://schemas.microsoft.com/office/drawing/2014/main" id="{46758EF1-AC5B-48D1-90EA-AB91A8DE4546}"/>
+                <a16:creationId xmlns:a16="http://schemas.microsoft.com/office/drawing/2014/main" id="{DAC6B9E5-BD32-4BCA-B3E4-321B564FA58D}"/>
               </a:ext>
             </a:extLst>
           </p:cNvPr>
@@ -4633,7 +4633,7 @@
           <p:cNvPr id="4" name="">
             <a:extLst xmlns:a="http://schemas.openxmlformats.org/drawingml/2006/main">
               <a:ext uri="{FF2B5EF4-FFF2-40B4-BE49-F238E27FC236}">
-                <a16:creationId xmlns:a16="http://schemas.microsoft.com/office/drawing/2014/main" id="{7696AAFE-4F76-486D-9B30-F2CFAB7C8AB6}"/>
+                <a16:creationId xmlns:a16="http://schemas.microsoft.com/office/drawing/2014/main" id="{F3E40BCA-9E5A-46E4-97E0-B40A48B35A7A}"/>
               </a:ext>
             </a:extLst>
           </p:cNvPr>
@@ -4683,7 +4683,7 @@
           <p:cNvPr id="5" name="">
             <a:extLst xmlns:a="http://schemas.openxmlformats.org/drawingml/2006/main">
               <a:ext uri="{FF2B5EF4-FFF2-40B4-BE49-F238E27FC236}">
-                <a16:creationId xmlns:a16="http://schemas.microsoft.com/office/drawing/2014/main" id="{89CCFB70-6A28-485A-9122-E59DB6D513B5}"/>
+                <a16:creationId xmlns:a16="http://schemas.microsoft.com/office/drawing/2014/main" id="{6C6D3145-3242-42BB-B84C-743EF27F81BB}"/>
               </a:ext>
             </a:extLst>
           </p:cNvPr>
@@ -4718,7 +4718,7 @@
           <p:nvPr/>
         </p:nvPicPr>
         <p:blipFill>
-          <a:blip xmlns:r="http://schemas.openxmlformats.org/officeDocument/2006/relationships" xmlns:a="http://schemas.openxmlformats.org/drawingml/2006/main" r:embed="R80a1514b6efa4a3a"/>
+          <a:blip xmlns:r="http://schemas.openxmlformats.org/officeDocument/2006/relationships" xmlns:a="http://schemas.openxmlformats.org/drawingml/2006/main" r:embed="Rb8f86f257094407c"/>
           <a:stretch xmlns:a="http://schemas.openxmlformats.org/drawingml/2006/main"/>
         </p:blipFill>
         <p:spPr>
@@ -4736,7 +4736,7 @@
           <p:cNvPr id="7" name="">
             <a:extLst xmlns:a="http://schemas.openxmlformats.org/drawingml/2006/main">
               <a:ext uri="{FF2B5EF4-FFF2-40B4-BE49-F238E27FC236}">
-                <a16:creationId xmlns:a16="http://schemas.microsoft.com/office/drawing/2014/main" id="{1F4C3D1B-2AEC-418C-A5E8-6F4D1FF841D4}"/>
+                <a16:creationId xmlns:a16="http://schemas.microsoft.com/office/drawing/2014/main" id="{20E5E69F-AE40-4EFD-9050-4DC400DE1B4E}"/>
               </a:ext>
             </a:extLst>
           </p:cNvPr>
@@ -4771,7 +4771,7 @@
           <p:cNvPr id="8" name="">
             <a:extLst xmlns:a="http://schemas.openxmlformats.org/drawingml/2006/main">
               <a:ext uri="{FF2B5EF4-FFF2-40B4-BE49-F238E27FC236}">
-                <a16:creationId xmlns:a16="http://schemas.microsoft.com/office/drawing/2014/main" id="{792A0C08-BCE2-4742-A499-2358CBBCEE61}"/>
+                <a16:creationId xmlns:a16="http://schemas.microsoft.com/office/drawing/2014/main" id="{D7DEC7F7-ECD4-4682-AA35-04BD8E56F55C}"/>
               </a:ext>
             </a:extLst>
           </p:cNvPr>
@@ -4821,7 +4821,7 @@
           <p:cNvPr id="9" name="">
             <a:extLst xmlns:a="http://schemas.openxmlformats.org/drawingml/2006/main">
               <a:ext uri="{FF2B5EF4-FFF2-40B4-BE49-F238E27FC236}">
-                <a16:creationId xmlns:a16="http://schemas.microsoft.com/office/drawing/2014/main" id="{BB7530E9-9643-4C50-BBF8-5E57C52D2CA9}"/>
+                <a16:creationId xmlns:a16="http://schemas.microsoft.com/office/drawing/2014/main" id="{F63EAA64-4AE4-404A-908F-4C95479A2CDB}"/>
               </a:ext>
             </a:extLst>
           </p:cNvPr>
@@ -4871,7 +4871,7 @@
           <p:cNvPr id="10" name="">
             <a:extLst xmlns:a="http://schemas.openxmlformats.org/drawingml/2006/main">
               <a:ext uri="{FF2B5EF4-FFF2-40B4-BE49-F238E27FC236}">
-                <a16:creationId xmlns:a16="http://schemas.microsoft.com/office/drawing/2014/main" id="{9BE9CA07-DF5D-40D1-BFC0-3087A8A50CCE}"/>
+                <a16:creationId xmlns:a16="http://schemas.microsoft.com/office/drawing/2014/main" id="{6FA841E1-7D6B-4CCD-921C-115153A6D9DC}"/>
               </a:ext>
             </a:extLst>
           </p:cNvPr>
@@ -4906,7 +4906,7 @@
           <p:cNvPr id="11" name="">
             <a:extLst xmlns:a="http://schemas.openxmlformats.org/drawingml/2006/main">
               <a:ext uri="{FF2B5EF4-FFF2-40B4-BE49-F238E27FC236}">
-                <a16:creationId xmlns:a16="http://schemas.microsoft.com/office/drawing/2014/main" id="{CB47F956-51E0-40E7-B4AA-35E59532883F}"/>
+                <a16:creationId xmlns:a16="http://schemas.microsoft.com/office/drawing/2014/main" id="{3E6A72F3-DAD1-455F-B746-40A12BAD5782}"/>
               </a:ext>
             </a:extLst>
           </p:cNvPr>
@@ -4956,7 +4956,7 @@
           <p:cNvPr id="12" name="">
             <a:extLst xmlns:a="http://schemas.openxmlformats.org/drawingml/2006/main">
               <a:ext uri="{FF2B5EF4-FFF2-40B4-BE49-F238E27FC236}">
-                <a16:creationId xmlns:a16="http://schemas.microsoft.com/office/drawing/2014/main" id="{C12F78C1-998C-4A1E-AD54-C46465C6EBD9}"/>
+                <a16:creationId xmlns:a16="http://schemas.microsoft.com/office/drawing/2014/main" id="{EBE72000-F1C5-4171-A54E-D9653D5AD735}"/>
               </a:ext>
             </a:extLst>
           </p:cNvPr>
@@ -5006,7 +5006,7 @@
           <p:cNvPr id="13" name="">
             <a:extLst xmlns:a="http://schemas.openxmlformats.org/drawingml/2006/main">
               <a:ext uri="{FF2B5EF4-FFF2-40B4-BE49-F238E27FC236}">
-                <a16:creationId xmlns:a16="http://schemas.microsoft.com/office/drawing/2014/main" id="{98A3AAF5-AFB8-4C0E-BA72-2F7E572AE8BC}"/>
+                <a16:creationId xmlns:a16="http://schemas.microsoft.com/office/drawing/2014/main" id="{92B04A82-27C8-487C-BA2A-CFC0FFA68B72}"/>
               </a:ext>
             </a:extLst>
           </p:cNvPr>
@@ -5041,7 +5041,7 @@
           <p:cNvPr id="14" name="">
             <a:extLst xmlns:a="http://schemas.openxmlformats.org/drawingml/2006/main">
               <a:ext uri="{FF2B5EF4-FFF2-40B4-BE49-F238E27FC236}">
-                <a16:creationId xmlns:a16="http://schemas.microsoft.com/office/drawing/2014/main" id="{9A10278B-95AA-4196-AF93-5C9F265CCA8F}"/>
+                <a16:creationId xmlns:a16="http://schemas.microsoft.com/office/drawing/2014/main" id="{EB09A8F8-6B98-4F29-B830-A484C5A72A3D}"/>
               </a:ext>
             </a:extLst>
           </p:cNvPr>
@@ -5091,7 +5091,7 @@
           <p:cNvPr id="15" name="">
             <a:extLst xmlns:a="http://schemas.openxmlformats.org/drawingml/2006/main">
               <a:ext uri="{FF2B5EF4-FFF2-40B4-BE49-F238E27FC236}">
-                <a16:creationId xmlns:a16="http://schemas.microsoft.com/office/drawing/2014/main" id="{A52DA34C-E192-415A-99E1-54093367D51E}"/>
+                <a16:creationId xmlns:a16="http://schemas.microsoft.com/office/drawing/2014/main" id="{35A84C74-B135-478A-A077-2E5B596E90B8}"/>
               </a:ext>
             </a:extLst>
           </p:cNvPr>
@@ -5141,7 +5141,7 @@
           <p:cNvPr id="16" name="">
             <a:extLst xmlns:a="http://schemas.openxmlformats.org/drawingml/2006/main">
               <a:ext uri="{FF2B5EF4-FFF2-40B4-BE49-F238E27FC236}">
-                <a16:creationId xmlns:a16="http://schemas.microsoft.com/office/drawing/2014/main" id="{3B618B47-FA4E-4C69-B19F-2CA980419C60}"/>
+                <a16:creationId xmlns:a16="http://schemas.microsoft.com/office/drawing/2014/main" id="{25E4D1F4-AA59-4DAE-8DE9-2387DA0098A6}"/>
               </a:ext>
             </a:extLst>
           </p:cNvPr>
@@ -5176,7 +5176,7 @@
           <p:cNvPr id="17" name="">
             <a:extLst xmlns:a="http://schemas.openxmlformats.org/drawingml/2006/main">
               <a:ext uri="{FF2B5EF4-FFF2-40B4-BE49-F238E27FC236}">
-                <a16:creationId xmlns:a16="http://schemas.microsoft.com/office/drawing/2014/main" id="{1162B781-246F-4FD3-A500-13CD733500A2}"/>
+                <a16:creationId xmlns:a16="http://schemas.microsoft.com/office/drawing/2014/main" id="{DCB785B4-99AA-4E03-9112-EC3AD7B2BBD7}"/>
               </a:ext>
             </a:extLst>
           </p:cNvPr>
@@ -5226,7 +5226,7 @@
           <p:cNvPr id="18" name="">
             <a:extLst xmlns:a="http://schemas.openxmlformats.org/drawingml/2006/main">
               <a:ext uri="{FF2B5EF4-FFF2-40B4-BE49-F238E27FC236}">
-                <a16:creationId xmlns:a16="http://schemas.microsoft.com/office/drawing/2014/main" id="{D6A67E6F-E6A9-430E-B75E-2FCFBAA31118}"/>
+                <a16:creationId xmlns:a16="http://schemas.microsoft.com/office/drawing/2014/main" id="{274713E8-837C-4139-918D-0F333718BCDF}"/>
               </a:ext>
             </a:extLst>
           </p:cNvPr>
@@ -5276,7 +5276,7 @@
           <p:cNvPr id="19" name="">
             <a:extLst xmlns:a="http://schemas.openxmlformats.org/drawingml/2006/main">
               <a:ext uri="{FF2B5EF4-FFF2-40B4-BE49-F238E27FC236}">
-                <a16:creationId xmlns:a16="http://schemas.microsoft.com/office/drawing/2014/main" id="{D96918F2-99B9-4DE3-9921-9A9DB1A2CECD}"/>
+                <a16:creationId xmlns:a16="http://schemas.microsoft.com/office/drawing/2014/main" id="{EB016FE8-534F-42BA-BC56-3136618ABD65}"/>
               </a:ext>
             </a:extLst>
           </p:cNvPr>
@@ -5311,7 +5311,7 @@
           <p:cNvPr id="20" name="">
             <a:extLst xmlns:a="http://schemas.openxmlformats.org/drawingml/2006/main">
               <a:ext uri="{FF2B5EF4-FFF2-40B4-BE49-F238E27FC236}">
-                <a16:creationId xmlns:a16="http://schemas.microsoft.com/office/drawing/2014/main" id="{C1B3704A-A83F-4109-9E27-900EB2271720}"/>
+                <a16:creationId xmlns:a16="http://schemas.microsoft.com/office/drawing/2014/main" id="{67AA7AA1-7FBF-41A4-ADE3-BEE806538EF4}"/>
               </a:ext>
             </a:extLst>
           </p:cNvPr>
@@ -5361,7 +5361,7 @@
           <p:cNvPr id="21" name="">
             <a:extLst xmlns:a="http://schemas.openxmlformats.org/drawingml/2006/main">
               <a:ext uri="{FF2B5EF4-FFF2-40B4-BE49-F238E27FC236}">
-                <a16:creationId xmlns:a16="http://schemas.microsoft.com/office/drawing/2014/main" id="{E84ED489-49CA-43EA-96EF-3E1934331521}"/>
+                <a16:creationId xmlns:a16="http://schemas.microsoft.com/office/drawing/2014/main" id="{56119A48-D918-4671-87CF-5714CA52CDFE}"/>
               </a:ext>
             </a:extLst>
           </p:cNvPr>
@@ -5411,7 +5411,7 @@
           <p:cNvPr id="22" name="">
             <a:extLst xmlns:a="http://schemas.openxmlformats.org/drawingml/2006/main">
               <a:ext uri="{FF2B5EF4-FFF2-40B4-BE49-F238E27FC236}">
-                <a16:creationId xmlns:a16="http://schemas.microsoft.com/office/drawing/2014/main" id="{C9CFADB6-DD53-4C24-89DD-C67EB10A92FC}"/>
+                <a16:creationId xmlns:a16="http://schemas.microsoft.com/office/drawing/2014/main" id="{FA9C4C82-D5E3-4F3B-AAAF-34413C9A5E28}"/>
               </a:ext>
             </a:extLst>
           </p:cNvPr>
@@ -5446,7 +5446,7 @@
           <p:cNvPr id="23" name="">
             <a:extLst xmlns:a="http://schemas.openxmlformats.org/drawingml/2006/main">
               <a:ext uri="{FF2B5EF4-FFF2-40B4-BE49-F238E27FC236}">
-                <a16:creationId xmlns:a16="http://schemas.microsoft.com/office/drawing/2014/main" id="{95FD1912-C2D6-43EC-AEEB-5E2C2C522020}"/>
+                <a16:creationId xmlns:a16="http://schemas.microsoft.com/office/drawing/2014/main" id="{BEF70702-9C7C-472C-B60E-DFA42B1A4EE0}"/>
               </a:ext>
             </a:extLst>
           </p:cNvPr>
@@ -5496,7 +5496,7 @@
           <p:cNvPr id="24" name="">
             <a:extLst xmlns:a="http://schemas.openxmlformats.org/drawingml/2006/main">
               <a:ext uri="{FF2B5EF4-FFF2-40B4-BE49-F238E27FC236}">
-                <a16:creationId xmlns:a16="http://schemas.microsoft.com/office/drawing/2014/main" id="{6D05A61E-0D99-4DDE-8614-6FE6CAB27EDF}"/>
+                <a16:creationId xmlns:a16="http://schemas.microsoft.com/office/drawing/2014/main" id="{93A40D71-BF6D-479F-81EF-8204334722ED}"/>
               </a:ext>
             </a:extLst>
           </p:cNvPr>
@@ -5546,7 +5546,7 @@
           <p:cNvPr id="25" name="">
             <a:extLst xmlns:a="http://schemas.openxmlformats.org/drawingml/2006/main">
               <a:ext uri="{FF2B5EF4-FFF2-40B4-BE49-F238E27FC236}">
-                <a16:creationId xmlns:a16="http://schemas.microsoft.com/office/drawing/2014/main" id="{56F777A6-440C-4609-8908-22C368AB1BFE}"/>
+                <a16:creationId xmlns:a16="http://schemas.microsoft.com/office/drawing/2014/main" id="{B7A62E28-5571-48AB-852C-6538A7079E67}"/>
               </a:ext>
             </a:extLst>
           </p:cNvPr>
@@ -5594,7 +5594,7 @@
     </p:spTree>
     <p:extLst>
       <p:ext uri="{BB962C8B-B14F-4D97-AF65-F5344CB8AC3E}">
-        <p14:creationId xmlns:p14="http://schemas.microsoft.com/office/powerpoint/2010/main" val="1059369447"/>
+        <p14:creationId xmlns:p14="http://schemas.microsoft.com/office/powerpoint/2010/main" val="624618808"/>
       </p:ext>
     </p:extLst>
   </p:cSld>
@@ -5625,7 +5625,7 @@
           <p:cNvPr id="1" name="">
             <a:extLst xmlns:a="http://schemas.openxmlformats.org/drawingml/2006/main">
               <a:ext uri="{FF2B5EF4-FFF2-40B4-BE49-F238E27FC236}">
-                <a16:creationId xmlns:a16="http://schemas.microsoft.com/office/drawing/2014/main" id="{121084FF-D6AF-48D0-BFB5-63C02C9CEB1B}"/>
+                <a16:creationId xmlns:a16="http://schemas.microsoft.com/office/drawing/2014/main" id="{1DECBF84-BD6E-4977-BF82-09FE619B97C6}"/>
               </a:ext>
             </a:extLst>
           </p:cNvPr>
@@ -5658,7 +5658,7 @@
           <p:cNvPr id="2" name="">
             <a:extLst xmlns:a="http://schemas.openxmlformats.org/drawingml/2006/main">
               <a:ext uri="{FF2B5EF4-FFF2-40B4-BE49-F238E27FC236}">
-                <a16:creationId xmlns:a16="http://schemas.microsoft.com/office/drawing/2014/main" id="{607E2600-69D5-4B89-9D93-77501ECE8032}"/>
+                <a16:creationId xmlns:a16="http://schemas.microsoft.com/office/drawing/2014/main" id="{E6FA67EF-AAA9-47B3-8CFB-D30B329094BB}"/>
               </a:ext>
             </a:extLst>
           </p:cNvPr>
@@ -5691,7 +5691,7 @@
           <p:cNvPr id="3" name="">
             <a:extLst xmlns:a="http://schemas.openxmlformats.org/drawingml/2006/main">
               <a:ext uri="{FF2B5EF4-FFF2-40B4-BE49-F238E27FC236}">
-                <a16:creationId xmlns:a16="http://schemas.microsoft.com/office/drawing/2014/main" id="{18159A43-C7FF-4C9F-93C1-E6A5E6A48BCB}"/>
+                <a16:creationId xmlns:a16="http://schemas.microsoft.com/office/drawing/2014/main" id="{F9A19DCB-BF66-4443-83E7-C595D25A9458}"/>
               </a:ext>
             </a:extLst>
           </p:cNvPr>
@@ -5741,7 +5741,7 @@
           <p:cNvPr id="4" name="">
             <a:extLst xmlns:a="http://schemas.openxmlformats.org/drawingml/2006/main">
               <a:ext uri="{FF2B5EF4-FFF2-40B4-BE49-F238E27FC236}">
-                <a16:creationId xmlns:a16="http://schemas.microsoft.com/office/drawing/2014/main" id="{C086A2A7-265A-43D5-B082-3449A2A4E5B0}"/>
+                <a16:creationId xmlns:a16="http://schemas.microsoft.com/office/drawing/2014/main" id="{0557F73B-3747-4F96-B267-2332C1565577}"/>
               </a:ext>
             </a:extLst>
           </p:cNvPr>
@@ -5791,7 +5791,7 @@
           <p:cNvPr id="5" name="">
             <a:extLst xmlns:a="http://schemas.openxmlformats.org/drawingml/2006/main">
               <a:ext uri="{FF2B5EF4-FFF2-40B4-BE49-F238E27FC236}">
-                <a16:creationId xmlns:a16="http://schemas.microsoft.com/office/drawing/2014/main" id="{A7AE93B5-4975-4B99-A310-14702F77B10F}"/>
+                <a16:creationId xmlns:a16="http://schemas.microsoft.com/office/drawing/2014/main" id="{10BD786A-3219-4F45-8242-CFAAC439D555}"/>
               </a:ext>
             </a:extLst>
           </p:cNvPr>
@@ -5826,7 +5826,7 @@
           <p:nvPr/>
         </p:nvPicPr>
         <p:blipFill>
-          <a:blip xmlns:r="http://schemas.openxmlformats.org/officeDocument/2006/relationships" xmlns:a="http://schemas.openxmlformats.org/drawingml/2006/main" r:embed="Rc8333213268c461f"/>
+          <a:blip xmlns:r="http://schemas.openxmlformats.org/officeDocument/2006/relationships" xmlns:a="http://schemas.openxmlformats.org/drawingml/2006/main" r:embed="R63adadf5902a4262"/>
           <a:stretch xmlns:a="http://schemas.openxmlformats.org/drawingml/2006/main"/>
         </p:blipFill>
         <p:spPr>
@@ -5844,7 +5844,7 @@
           <p:cNvPr id="7" name="">
             <a:extLst xmlns:a="http://schemas.openxmlformats.org/drawingml/2006/main">
               <a:ext uri="{FF2B5EF4-FFF2-40B4-BE49-F238E27FC236}">
-                <a16:creationId xmlns:a16="http://schemas.microsoft.com/office/drawing/2014/main" id="{EF1DEBFD-77B1-4E53-83F6-47BB6F0B0F2F}"/>
+                <a16:creationId xmlns:a16="http://schemas.microsoft.com/office/drawing/2014/main" id="{1FC5A228-ACE2-4320-8190-5ADDA78882C0}"/>
               </a:ext>
             </a:extLst>
           </p:cNvPr>
@@ -5877,7 +5877,7 @@
           <p:cNvPr id="8" name="">
             <a:extLst xmlns:a="http://schemas.openxmlformats.org/drawingml/2006/main">
               <a:ext uri="{FF2B5EF4-FFF2-40B4-BE49-F238E27FC236}">
-                <a16:creationId xmlns:a16="http://schemas.microsoft.com/office/drawing/2014/main" id="{43940D91-79AB-4704-91F0-8C110E1403ED}"/>
+                <a16:creationId xmlns:a16="http://schemas.microsoft.com/office/drawing/2014/main" id="{21534F97-303D-40F0-88F5-D4BE8A483BC7}"/>
               </a:ext>
             </a:extLst>
           </p:cNvPr>
@@ -5927,7 +5927,7 @@
           <p:cNvPr id="9" name="">
             <a:extLst xmlns:a="http://schemas.openxmlformats.org/drawingml/2006/main">
               <a:ext uri="{FF2B5EF4-FFF2-40B4-BE49-F238E27FC236}">
-                <a16:creationId xmlns:a16="http://schemas.microsoft.com/office/drawing/2014/main" id="{6BF79DBA-A83A-4D1A-BEED-DDF866B2C4D1}"/>
+                <a16:creationId xmlns:a16="http://schemas.microsoft.com/office/drawing/2014/main" id="{05C43641-B5C9-4586-B056-0AFB710E8C52}"/>
               </a:ext>
             </a:extLst>
           </p:cNvPr>
@@ -5960,7 +5960,7 @@
           <p:cNvPr id="10" name="">
             <a:extLst xmlns:a="http://schemas.openxmlformats.org/drawingml/2006/main">
               <a:ext uri="{FF2B5EF4-FFF2-40B4-BE49-F238E27FC236}">
-                <a16:creationId xmlns:a16="http://schemas.microsoft.com/office/drawing/2014/main" id="{587CF783-E14F-4C0F-A65B-E6C4121F7D2B}"/>
+                <a16:creationId xmlns:a16="http://schemas.microsoft.com/office/drawing/2014/main" id="{67524B52-8DF5-4AC9-88CE-7A18F5503E78}"/>
               </a:ext>
             </a:extLst>
           </p:cNvPr>
@@ -6010,7 +6010,7 @@
           <p:cNvPr id="11" name="">
             <a:extLst xmlns:a="http://schemas.openxmlformats.org/drawingml/2006/main">
               <a:ext uri="{FF2B5EF4-FFF2-40B4-BE49-F238E27FC236}">
-                <a16:creationId xmlns:a16="http://schemas.microsoft.com/office/drawing/2014/main" id="{6DCBE2EC-A29F-4A67-8FF7-928777016030}"/>
+                <a16:creationId xmlns:a16="http://schemas.microsoft.com/office/drawing/2014/main" id="{64E4E534-A26C-4D11-BA84-76C18CED1543}"/>
               </a:ext>
             </a:extLst>
           </p:cNvPr>
@@ -6043,7 +6043,7 @@
           <p:cNvPr id="12" name="">
             <a:extLst xmlns:a="http://schemas.openxmlformats.org/drawingml/2006/main">
               <a:ext uri="{FF2B5EF4-FFF2-40B4-BE49-F238E27FC236}">
-                <a16:creationId xmlns:a16="http://schemas.microsoft.com/office/drawing/2014/main" id="{EADE1DAA-74AC-4E9D-B772-028C6C2A0761}"/>
+                <a16:creationId xmlns:a16="http://schemas.microsoft.com/office/drawing/2014/main" id="{76550B15-38A0-4117-885F-B7DF9C8E007E}"/>
               </a:ext>
             </a:extLst>
           </p:cNvPr>
@@ -6093,7 +6093,7 @@
           <p:cNvPr id="13" name="">
             <a:extLst xmlns:a="http://schemas.openxmlformats.org/drawingml/2006/main">
               <a:ext uri="{FF2B5EF4-FFF2-40B4-BE49-F238E27FC236}">
-                <a16:creationId xmlns:a16="http://schemas.microsoft.com/office/drawing/2014/main" id="{71E6D1E6-99D3-4664-A154-1BD0C52CC8E7}"/>
+                <a16:creationId xmlns:a16="http://schemas.microsoft.com/office/drawing/2014/main" id="{A1B31734-645C-40FD-B948-F1A7A81D77CA}"/>
               </a:ext>
             </a:extLst>
           </p:cNvPr>
@@ -6126,7 +6126,7 @@
           <p:cNvPr id="14" name="">
             <a:extLst xmlns:a="http://schemas.openxmlformats.org/drawingml/2006/main">
               <a:ext uri="{FF2B5EF4-FFF2-40B4-BE49-F238E27FC236}">
-                <a16:creationId xmlns:a16="http://schemas.microsoft.com/office/drawing/2014/main" id="{3557E6AF-E5B7-41D6-95D4-9C485A57E374}"/>
+                <a16:creationId xmlns:a16="http://schemas.microsoft.com/office/drawing/2014/main" id="{BB1A1DD4-82EA-424E-A5CD-94924F03FF65}"/>
               </a:ext>
             </a:extLst>
           </p:cNvPr>
@@ -6174,7 +6174,7 @@
     </p:spTree>
     <p:extLst>
       <p:ext uri="{BB962C8B-B14F-4D97-AF65-F5344CB8AC3E}">
-        <p14:creationId xmlns:p14="http://schemas.microsoft.com/office/powerpoint/2010/main" val="348907356"/>
+        <p14:creationId xmlns:p14="http://schemas.microsoft.com/office/powerpoint/2010/main" val="1425554037"/>
       </p:ext>
     </p:extLst>
   </p:cSld>
@@ -6205,7 +6205,7 @@
           <p:cNvPr id="1" name="">
             <a:extLst xmlns:a="http://schemas.openxmlformats.org/drawingml/2006/main">
               <a:ext uri="{FF2B5EF4-FFF2-40B4-BE49-F238E27FC236}">
-                <a16:creationId xmlns:a16="http://schemas.microsoft.com/office/drawing/2014/main" id="{626B5F9F-4A11-43A1-9E03-B0D3F777CEE5}"/>
+                <a16:creationId xmlns:a16="http://schemas.microsoft.com/office/drawing/2014/main" id="{8803D380-D527-418D-969F-CC7DA89CA665}"/>
               </a:ext>
             </a:extLst>
           </p:cNvPr>
@@ -6238,7 +6238,7 @@
           <p:cNvPr id="2" name="">
             <a:extLst xmlns:a="http://schemas.openxmlformats.org/drawingml/2006/main">
               <a:ext uri="{FF2B5EF4-FFF2-40B4-BE49-F238E27FC236}">
-                <a16:creationId xmlns:a16="http://schemas.microsoft.com/office/drawing/2014/main" id="{B27E5FEF-13DA-4936-97C1-574DB44AA340}"/>
+                <a16:creationId xmlns:a16="http://schemas.microsoft.com/office/drawing/2014/main" id="{5320C18F-992B-4B52-9974-D36AC3698649}"/>
               </a:ext>
             </a:extLst>
           </p:cNvPr>
@@ -6271,7 +6271,7 @@
           <p:cNvPr id="3" name="">
             <a:extLst xmlns:a="http://schemas.openxmlformats.org/drawingml/2006/main">
               <a:ext uri="{FF2B5EF4-FFF2-40B4-BE49-F238E27FC236}">
-                <a16:creationId xmlns:a16="http://schemas.microsoft.com/office/drawing/2014/main" id="{EC19D8D7-8E9E-41A6-9F0E-BE5F2E821E47}"/>
+                <a16:creationId xmlns:a16="http://schemas.microsoft.com/office/drawing/2014/main" id="{247F3A47-4854-41EE-A921-52CA54E4D8FF}"/>
               </a:ext>
             </a:extLst>
           </p:cNvPr>
@@ -6321,7 +6321,7 @@
           <p:cNvPr id="4" name="">
             <a:extLst xmlns:a="http://schemas.openxmlformats.org/drawingml/2006/main">
               <a:ext uri="{FF2B5EF4-FFF2-40B4-BE49-F238E27FC236}">
-                <a16:creationId xmlns:a16="http://schemas.microsoft.com/office/drawing/2014/main" id="{D4AB2CC4-3521-4E1E-A171-5F27E1169884}"/>
+                <a16:creationId xmlns:a16="http://schemas.microsoft.com/office/drawing/2014/main" id="{5612EFC1-28E0-49CC-96AC-2E0629647271}"/>
               </a:ext>
             </a:extLst>
           </p:cNvPr>
@@ -6371,7 +6371,7 @@
           <p:cNvPr id="5" name="">
             <a:extLst xmlns:a="http://schemas.openxmlformats.org/drawingml/2006/main">
               <a:ext uri="{FF2B5EF4-FFF2-40B4-BE49-F238E27FC236}">
-                <a16:creationId xmlns:a16="http://schemas.microsoft.com/office/drawing/2014/main" id="{2435CF68-6D57-4D8F-841A-004AED2A2D25}"/>
+                <a16:creationId xmlns:a16="http://schemas.microsoft.com/office/drawing/2014/main" id="{16D01649-036B-402A-AC7B-B48515B5D084}"/>
               </a:ext>
             </a:extLst>
           </p:cNvPr>
@@ -6406,7 +6406,7 @@
           <p:nvPr/>
         </p:nvPicPr>
         <p:blipFill>
-          <a:blip xmlns:r="http://schemas.openxmlformats.org/officeDocument/2006/relationships" xmlns:a="http://schemas.openxmlformats.org/drawingml/2006/main" r:embed="R2af8329074c34854"/>
+          <a:blip xmlns:r="http://schemas.openxmlformats.org/officeDocument/2006/relationships" xmlns:a="http://schemas.openxmlformats.org/drawingml/2006/main" r:embed="Rfb4daaecf0df446f"/>
           <a:stretch xmlns:a="http://schemas.openxmlformats.org/drawingml/2006/main"/>
         </p:blipFill>
         <p:spPr>
@@ -6424,7 +6424,7 @@
           <p:cNvPr id="7" name="">
             <a:extLst xmlns:a="http://schemas.openxmlformats.org/drawingml/2006/main">
               <a:ext uri="{FF2B5EF4-FFF2-40B4-BE49-F238E27FC236}">
-                <a16:creationId xmlns:a16="http://schemas.microsoft.com/office/drawing/2014/main" id="{8E28CB1D-1ACA-442B-AEF1-FB86447127AA}"/>
+                <a16:creationId xmlns:a16="http://schemas.microsoft.com/office/drawing/2014/main" id="{823C9F48-7D69-4229-9260-EEC3D333D38D}"/>
               </a:ext>
             </a:extLst>
           </p:cNvPr>
@@ -6457,7 +6457,7 @@
           <p:cNvPr id="8" name="">
             <a:extLst xmlns:a="http://schemas.openxmlformats.org/drawingml/2006/main">
               <a:ext uri="{FF2B5EF4-FFF2-40B4-BE49-F238E27FC236}">
-                <a16:creationId xmlns:a16="http://schemas.microsoft.com/office/drawing/2014/main" id="{D698FD49-47B9-4569-A6AD-768B116765B7}"/>
+                <a16:creationId xmlns:a16="http://schemas.microsoft.com/office/drawing/2014/main" id="{4808BAEC-25AA-4896-9A68-231C5A09A2B4}"/>
               </a:ext>
             </a:extLst>
           </p:cNvPr>
@@ -6507,7 +6507,7 @@
           <p:cNvPr id="9" name="">
             <a:extLst xmlns:a="http://schemas.openxmlformats.org/drawingml/2006/main">
               <a:ext uri="{FF2B5EF4-FFF2-40B4-BE49-F238E27FC236}">
-                <a16:creationId xmlns:a16="http://schemas.microsoft.com/office/drawing/2014/main" id="{788674B6-9C12-444D-A115-E0AB9AC0CB68}"/>
+                <a16:creationId xmlns:a16="http://schemas.microsoft.com/office/drawing/2014/main" id="{B60B2B31-1CF1-4E6D-BD33-9E7590142FC6}"/>
               </a:ext>
             </a:extLst>
           </p:cNvPr>
@@ -6540,7 +6540,7 @@
           <p:cNvPr id="10" name="">
             <a:extLst xmlns:a="http://schemas.openxmlformats.org/drawingml/2006/main">
               <a:ext uri="{FF2B5EF4-FFF2-40B4-BE49-F238E27FC236}">
-                <a16:creationId xmlns:a16="http://schemas.microsoft.com/office/drawing/2014/main" id="{7E676B88-2A1B-45FC-A44E-836BE993164D}"/>
+                <a16:creationId xmlns:a16="http://schemas.microsoft.com/office/drawing/2014/main" id="{EEE1DBA6-6A53-462E-832C-CF744BC410DD}"/>
               </a:ext>
             </a:extLst>
           </p:cNvPr>
@@ -6590,7 +6590,7 @@
           <p:cNvPr id="11" name="">
             <a:extLst xmlns:a="http://schemas.openxmlformats.org/drawingml/2006/main">
               <a:ext uri="{FF2B5EF4-FFF2-40B4-BE49-F238E27FC236}">
-                <a16:creationId xmlns:a16="http://schemas.microsoft.com/office/drawing/2014/main" id="{63CB5131-66DD-405B-82F4-70846687D333}"/>
+                <a16:creationId xmlns:a16="http://schemas.microsoft.com/office/drawing/2014/main" id="{8949968A-A741-45B5-A193-40FE9D4812BC}"/>
               </a:ext>
             </a:extLst>
           </p:cNvPr>
@@ -6623,7 +6623,7 @@
           <p:cNvPr id="12" name="">
             <a:extLst xmlns:a="http://schemas.openxmlformats.org/drawingml/2006/main">
               <a:ext uri="{FF2B5EF4-FFF2-40B4-BE49-F238E27FC236}">
-                <a16:creationId xmlns:a16="http://schemas.microsoft.com/office/drawing/2014/main" id="{2F32BBD5-C927-42E6-BC65-2B20F870800E}"/>
+                <a16:creationId xmlns:a16="http://schemas.microsoft.com/office/drawing/2014/main" id="{F357A218-6D3E-40E0-A2C4-CE82828D97CF}"/>
               </a:ext>
             </a:extLst>
           </p:cNvPr>
@@ -6673,7 +6673,7 @@
           <p:cNvPr id="13" name="">
             <a:extLst xmlns:a="http://schemas.openxmlformats.org/drawingml/2006/main">
               <a:ext uri="{FF2B5EF4-FFF2-40B4-BE49-F238E27FC236}">
-                <a16:creationId xmlns:a16="http://schemas.microsoft.com/office/drawing/2014/main" id="{64AA1B2E-476C-4AF9-AC43-9C7EF7EF5FAB}"/>
+                <a16:creationId xmlns:a16="http://schemas.microsoft.com/office/drawing/2014/main" id="{6602F1B6-DA52-4480-8048-D6097B4CC7B4}"/>
               </a:ext>
             </a:extLst>
           </p:cNvPr>
@@ -6706,7 +6706,7 @@
           <p:cNvPr id="14" name="">
             <a:extLst xmlns:a="http://schemas.openxmlformats.org/drawingml/2006/main">
               <a:ext uri="{FF2B5EF4-FFF2-40B4-BE49-F238E27FC236}">
-                <a16:creationId xmlns:a16="http://schemas.microsoft.com/office/drawing/2014/main" id="{FD95C641-8CC7-424E-988C-7569A55D0E48}"/>
+                <a16:creationId xmlns:a16="http://schemas.microsoft.com/office/drawing/2014/main" id="{2FA53D22-7B0C-4BC5-8C2C-22F58FEE423B}"/>
               </a:ext>
             </a:extLst>
           </p:cNvPr>
@@ -6754,7 +6754,7 @@
     </p:spTree>
     <p:extLst>
       <p:ext uri="{BB962C8B-B14F-4D97-AF65-F5344CB8AC3E}">
-        <p14:creationId xmlns:p14="http://schemas.microsoft.com/office/powerpoint/2010/main" val="1384504050"/>
+        <p14:creationId xmlns:p14="http://schemas.microsoft.com/office/powerpoint/2010/main" val="1915428358"/>
       </p:ext>
     </p:extLst>
   </p:cSld>
@@ -6785,7 +6785,7 @@
           <p:cNvPr id="1" name="">
             <a:extLst xmlns:a="http://schemas.openxmlformats.org/drawingml/2006/main">
               <a:ext uri="{FF2B5EF4-FFF2-40B4-BE49-F238E27FC236}">
-                <a16:creationId xmlns:a16="http://schemas.microsoft.com/office/drawing/2014/main" id="{AD2CBA10-A887-484C-A5AF-C5612A9C188F}"/>
+                <a16:creationId xmlns:a16="http://schemas.microsoft.com/office/drawing/2014/main" id="{FFE7BBA3-EE54-4DC1-BE1D-9C163EAD563D}"/>
               </a:ext>
             </a:extLst>
           </p:cNvPr>
@@ -6822,7 +6822,7 @@
           <p:nvPr/>
         </p:nvPicPr>
         <p:blipFill>
-          <a:blip xmlns:r="http://schemas.openxmlformats.org/officeDocument/2006/relationships" xmlns:a="http://schemas.openxmlformats.org/drawingml/2006/main" r:embed="R228d535dfd934bd1"/>
+          <a:blip xmlns:r="http://schemas.openxmlformats.org/officeDocument/2006/relationships" xmlns:a="http://schemas.openxmlformats.org/drawingml/2006/main" r:embed="Rc30cef73c9a1432f"/>
           <a:stretch xmlns:a="http://schemas.openxmlformats.org/drawingml/2006/main"/>
         </p:blipFill>
         <p:spPr>
@@ -6840,7 +6840,7 @@
           <p:cNvPr id="3" name="">
             <a:extLst xmlns:a="http://schemas.openxmlformats.org/drawingml/2006/main">
               <a:ext uri="{FF2B5EF4-FFF2-40B4-BE49-F238E27FC236}">
-                <a16:creationId xmlns:a16="http://schemas.microsoft.com/office/drawing/2014/main" id="{54305FFE-380B-4241-8164-055096ABF0BA}"/>
+                <a16:creationId xmlns:a16="http://schemas.microsoft.com/office/drawing/2014/main" id="{A72529D7-DFB6-4D8B-A310-9A9BE4C160E1}"/>
               </a:ext>
             </a:extLst>
           </p:cNvPr>
@@ -6890,7 +6890,7 @@
           <p:cNvPr id="4" name="">
             <a:extLst xmlns:a="http://schemas.openxmlformats.org/drawingml/2006/main">
               <a:ext uri="{FF2B5EF4-FFF2-40B4-BE49-F238E27FC236}">
-                <a16:creationId xmlns:a16="http://schemas.microsoft.com/office/drawing/2014/main" id="{F9361602-1333-49C6-A064-0E69F6C14271}"/>
+                <a16:creationId xmlns:a16="http://schemas.microsoft.com/office/drawing/2014/main" id="{0FB6DBF5-37B8-4781-9B98-959748F46032}"/>
               </a:ext>
             </a:extLst>
           </p:cNvPr>
@@ -6940,7 +6940,7 @@
           <p:cNvPr id="5" name="">
             <a:extLst xmlns:a="http://schemas.openxmlformats.org/drawingml/2006/main">
               <a:ext uri="{FF2B5EF4-FFF2-40B4-BE49-F238E27FC236}">
-                <a16:creationId xmlns:a16="http://schemas.microsoft.com/office/drawing/2014/main" id="{750B252C-4A72-4453-9A44-3E74C00D1324}"/>
+                <a16:creationId xmlns:a16="http://schemas.microsoft.com/office/drawing/2014/main" id="{B85BA887-B0DE-4391-9523-9A2E01AB5E0D}"/>
               </a:ext>
             </a:extLst>
           </p:cNvPr>
@@ -6975,7 +6975,7 @@
           <p:cNvPr id="6" name="">
             <a:extLst xmlns:a="http://schemas.openxmlformats.org/drawingml/2006/main">
               <a:ext uri="{FF2B5EF4-FFF2-40B4-BE49-F238E27FC236}">
-                <a16:creationId xmlns:a16="http://schemas.microsoft.com/office/drawing/2014/main" id="{5A4735C2-9854-421E-8A97-EE306CC38BB9}"/>
+                <a16:creationId xmlns:a16="http://schemas.microsoft.com/office/drawing/2014/main" id="{CE674A94-A661-4F9D-80E7-2BABDBBA9509}"/>
               </a:ext>
             </a:extLst>
           </p:cNvPr>
@@ -7025,7 +7025,7 @@
           <p:cNvPr id="7" name="">
             <a:extLst xmlns:a="http://schemas.openxmlformats.org/drawingml/2006/main">
               <a:ext uri="{FF2B5EF4-FFF2-40B4-BE49-F238E27FC236}">
-                <a16:creationId xmlns:a16="http://schemas.microsoft.com/office/drawing/2014/main" id="{550EF330-C2E3-4285-B1F9-564AC308C5EF}"/>
+                <a16:creationId xmlns:a16="http://schemas.microsoft.com/office/drawing/2014/main" id="{8272B286-A9B9-4EBC-B0B8-17B4BB2C2433}"/>
               </a:ext>
             </a:extLst>
           </p:cNvPr>
@@ -7073,7 +7073,7 @@
     </p:spTree>
     <p:extLst>
       <p:ext uri="{BB962C8B-B14F-4D97-AF65-F5344CB8AC3E}">
-        <p14:creationId xmlns:p14="http://schemas.microsoft.com/office/powerpoint/2010/main" val="888525797"/>
+        <p14:creationId xmlns:p14="http://schemas.microsoft.com/office/powerpoint/2010/main" val="584275463"/>
       </p:ext>
     </p:extLst>
   </p:cSld>
@@ -7104,7 +7104,7 @@
           <p:cNvPr id="1" name="">
             <a:extLst xmlns:a="http://schemas.openxmlformats.org/drawingml/2006/main">
               <a:ext uri="{FF2B5EF4-FFF2-40B4-BE49-F238E27FC236}">
-                <a16:creationId xmlns:a16="http://schemas.microsoft.com/office/drawing/2014/main" id="{DC93378F-5E9B-4019-9C40-BB1AD1CDBA52}"/>
+                <a16:creationId xmlns:a16="http://schemas.microsoft.com/office/drawing/2014/main" id="{B54B0C1C-B5DD-4AC9-B2D1-37B8437E8A22}"/>
               </a:ext>
             </a:extLst>
           </p:cNvPr>
@@ -7137,7 +7137,7 @@
           <p:cNvPr id="2" name="">
             <a:extLst xmlns:a="http://schemas.openxmlformats.org/drawingml/2006/main">
               <a:ext uri="{FF2B5EF4-FFF2-40B4-BE49-F238E27FC236}">
-                <a16:creationId xmlns:a16="http://schemas.microsoft.com/office/drawing/2014/main" id="{AEFAF5C1-406D-4064-8784-544BC862FEBC}"/>
+                <a16:creationId xmlns:a16="http://schemas.microsoft.com/office/drawing/2014/main" id="{54E63E59-0415-4959-9F43-0AA033AB5C7C}"/>
               </a:ext>
             </a:extLst>
           </p:cNvPr>
@@ -7170,7 +7170,7 @@
           <p:cNvPr id="3" name="">
             <a:extLst xmlns:a="http://schemas.openxmlformats.org/drawingml/2006/main">
               <a:ext uri="{FF2B5EF4-FFF2-40B4-BE49-F238E27FC236}">
-                <a16:creationId xmlns:a16="http://schemas.microsoft.com/office/drawing/2014/main" id="{84577662-47B9-46EC-8AFB-B89DF7EB7FEF}"/>
+                <a16:creationId xmlns:a16="http://schemas.microsoft.com/office/drawing/2014/main" id="{38AFB872-C1A3-4312-AF5C-AF171F4035E9}"/>
               </a:ext>
             </a:extLst>
           </p:cNvPr>
@@ -7220,7 +7220,7 @@
           <p:cNvPr id="4" name="">
             <a:extLst xmlns:a="http://schemas.openxmlformats.org/drawingml/2006/main">
               <a:ext uri="{FF2B5EF4-FFF2-40B4-BE49-F238E27FC236}">
-                <a16:creationId xmlns:a16="http://schemas.microsoft.com/office/drawing/2014/main" id="{D779039D-BAEB-4DD0-9D17-29C864B291A2}"/>
+                <a16:creationId xmlns:a16="http://schemas.microsoft.com/office/drawing/2014/main" id="{8B78CC29-05F6-422F-9139-77095048B73A}"/>
               </a:ext>
             </a:extLst>
           </p:cNvPr>
@@ -7270,7 +7270,7 @@
           <p:cNvPr id="5" name="">
             <a:extLst xmlns:a="http://schemas.openxmlformats.org/drawingml/2006/main">
               <a:ext uri="{FF2B5EF4-FFF2-40B4-BE49-F238E27FC236}">
-                <a16:creationId xmlns:a16="http://schemas.microsoft.com/office/drawing/2014/main" id="{4E28E07C-99B2-490E-94F4-6776DB620AA7}"/>
+                <a16:creationId xmlns:a16="http://schemas.microsoft.com/office/drawing/2014/main" id="{350697FB-F6DA-4741-AAA3-C0813205029F}"/>
               </a:ext>
             </a:extLst>
           </p:cNvPr>
@@ -7305,7 +7305,7 @@
           <p:nvPr/>
         </p:nvPicPr>
         <p:blipFill>
-          <a:blip xmlns:r="http://schemas.openxmlformats.org/officeDocument/2006/relationships" xmlns:a="http://schemas.openxmlformats.org/drawingml/2006/main" r:embed="Ra96fc661b9a540dd"/>
+          <a:blip xmlns:r="http://schemas.openxmlformats.org/officeDocument/2006/relationships" xmlns:a="http://schemas.openxmlformats.org/drawingml/2006/main" r:embed="Re597bb81b2f5492a"/>
           <a:stretch xmlns:a="http://schemas.openxmlformats.org/drawingml/2006/main"/>
         </p:blipFill>
         <p:spPr>
@@ -7323,7 +7323,7 @@
           <p:cNvPr id="7" name="">
             <a:extLst xmlns:a="http://schemas.openxmlformats.org/drawingml/2006/main">
               <a:ext uri="{FF2B5EF4-FFF2-40B4-BE49-F238E27FC236}">
-                <a16:creationId xmlns:a16="http://schemas.microsoft.com/office/drawing/2014/main" id="{D3B88B38-F542-498B-B6BC-CD3EAF526543}"/>
+                <a16:creationId xmlns:a16="http://schemas.microsoft.com/office/drawing/2014/main" id="{66B198BA-07D7-47F2-936D-A925AE060BBD}"/>
               </a:ext>
             </a:extLst>
           </p:cNvPr>
@@ -7358,7 +7358,7 @@
           <p:cNvPr id="8" name="">
             <a:extLst xmlns:a="http://schemas.openxmlformats.org/drawingml/2006/main">
               <a:ext uri="{FF2B5EF4-FFF2-40B4-BE49-F238E27FC236}">
-                <a16:creationId xmlns:a16="http://schemas.microsoft.com/office/drawing/2014/main" id="{6E796BC8-5DA7-4B43-A3A7-C82609DBB2AB}"/>
+                <a16:creationId xmlns:a16="http://schemas.microsoft.com/office/drawing/2014/main" id="{5F6B99DE-A9E0-4B52-8438-F40D2293984A}"/>
               </a:ext>
             </a:extLst>
           </p:cNvPr>
@@ -7393,7 +7393,7 @@
           <p:cNvPr id="9" name="">
             <a:extLst xmlns:a="http://schemas.openxmlformats.org/drawingml/2006/main">
               <a:ext uri="{FF2B5EF4-FFF2-40B4-BE49-F238E27FC236}">
-                <a16:creationId xmlns:a16="http://schemas.microsoft.com/office/drawing/2014/main" id="{131BFC4C-15D1-4E4B-A4B6-022516A59E74}"/>
+                <a16:creationId xmlns:a16="http://schemas.microsoft.com/office/drawing/2014/main" id="{B5B0CD21-7814-45B2-8B21-4889846063ED}"/>
               </a:ext>
             </a:extLst>
           </p:cNvPr>
@@ -7428,7 +7428,7 @@
           <p:cNvPr id="10" name="">
             <a:extLst xmlns:a="http://schemas.openxmlformats.org/drawingml/2006/main">
               <a:ext uri="{FF2B5EF4-FFF2-40B4-BE49-F238E27FC236}">
-                <a16:creationId xmlns:a16="http://schemas.microsoft.com/office/drawing/2014/main" id="{F555BB85-B5C2-4A7B-A3D1-CA0E824481DA}"/>
+                <a16:creationId xmlns:a16="http://schemas.microsoft.com/office/drawing/2014/main" id="{3D75C734-12EF-4A43-A19C-A5BDD5C0F1F6}"/>
               </a:ext>
             </a:extLst>
           </p:cNvPr>
@@ -7478,7 +7478,7 @@
           <p:cNvPr id="11" name="">
             <a:extLst xmlns:a="http://schemas.openxmlformats.org/drawingml/2006/main">
               <a:ext uri="{FF2B5EF4-FFF2-40B4-BE49-F238E27FC236}">
-                <a16:creationId xmlns:a16="http://schemas.microsoft.com/office/drawing/2014/main" id="{1C41174D-9F0C-49CA-955A-700F0157F5D1}"/>
+                <a16:creationId xmlns:a16="http://schemas.microsoft.com/office/drawing/2014/main" id="{9B9DC25F-BCE2-494E-AD09-A496404029EE}"/>
               </a:ext>
             </a:extLst>
           </p:cNvPr>
@@ -7528,7 +7528,7 @@
           <p:cNvPr id="12" name="">
             <a:extLst xmlns:a="http://schemas.openxmlformats.org/drawingml/2006/main">
               <a:ext uri="{FF2B5EF4-FFF2-40B4-BE49-F238E27FC236}">
-                <a16:creationId xmlns:a16="http://schemas.microsoft.com/office/drawing/2014/main" id="{17129FFC-09BC-43BC-BC8F-CB00B51F29AE}"/>
+                <a16:creationId xmlns:a16="http://schemas.microsoft.com/office/drawing/2014/main" id="{AC2B9DB3-4D6C-4ECB-AB25-2061A2F75C78}"/>
               </a:ext>
             </a:extLst>
           </p:cNvPr>
@@ -7578,7 +7578,7 @@
           <p:cNvPr id="13" name="">
             <a:extLst xmlns:a="http://schemas.openxmlformats.org/drawingml/2006/main">
               <a:ext uri="{FF2B5EF4-FFF2-40B4-BE49-F238E27FC236}">
-                <a16:creationId xmlns:a16="http://schemas.microsoft.com/office/drawing/2014/main" id="{94923F40-2015-40C5-B585-3A98FF612CAE}"/>
+                <a16:creationId xmlns:a16="http://schemas.microsoft.com/office/drawing/2014/main" id="{52B2D4E2-28C9-4A29-991C-76E17D394CE9}"/>
               </a:ext>
             </a:extLst>
           </p:cNvPr>
@@ -7628,7 +7628,7 @@
           <p:cNvPr id="14" name="">
             <a:extLst xmlns:a="http://schemas.openxmlformats.org/drawingml/2006/main">
               <a:ext uri="{FF2B5EF4-FFF2-40B4-BE49-F238E27FC236}">
-                <a16:creationId xmlns:a16="http://schemas.microsoft.com/office/drawing/2014/main" id="{D713E438-5467-4D3A-8044-A621EC037FDA}"/>
+                <a16:creationId xmlns:a16="http://schemas.microsoft.com/office/drawing/2014/main" id="{37ED3C90-E3DF-48EB-BC84-A8A4820B2577}"/>
               </a:ext>
             </a:extLst>
           </p:cNvPr>
@@ -7678,7 +7678,7 @@
           <p:cNvPr id="15" name="">
             <a:extLst xmlns:a="http://schemas.openxmlformats.org/drawingml/2006/main">
               <a:ext uri="{FF2B5EF4-FFF2-40B4-BE49-F238E27FC236}">
-                <a16:creationId xmlns:a16="http://schemas.microsoft.com/office/drawing/2014/main" id="{44146541-CAF4-413C-811D-0BAC4F8B3C6C}"/>
+                <a16:creationId xmlns:a16="http://schemas.microsoft.com/office/drawing/2014/main" id="{1B86F33E-7881-4907-9B99-2C08D8F99221}"/>
               </a:ext>
             </a:extLst>
           </p:cNvPr>
@@ -7728,7 +7728,7 @@
           <p:cNvPr id="16" name="">
             <a:extLst xmlns:a="http://schemas.openxmlformats.org/drawingml/2006/main">
               <a:ext uri="{FF2B5EF4-FFF2-40B4-BE49-F238E27FC236}">
-                <a16:creationId xmlns:a16="http://schemas.microsoft.com/office/drawing/2014/main" id="{4CEF07E1-6C20-491B-9CC7-F84867AC7BE6}"/>
+                <a16:creationId xmlns:a16="http://schemas.microsoft.com/office/drawing/2014/main" id="{0BB9FD1C-9DFC-43FB-A76B-36AC9BBFBA65}"/>
               </a:ext>
             </a:extLst>
           </p:cNvPr>
@@ -7776,7 +7776,7 @@
     </p:spTree>
     <p:extLst>
       <p:ext uri="{BB962C8B-B14F-4D97-AF65-F5344CB8AC3E}">
-        <p14:creationId xmlns:p14="http://schemas.microsoft.com/office/powerpoint/2010/main" val="2074361945"/>
+        <p14:creationId xmlns:p14="http://schemas.microsoft.com/office/powerpoint/2010/main" val="1345853493"/>
       </p:ext>
     </p:extLst>
   </p:cSld>
@@ -7807,7 +7807,7 @@
           <p:cNvPr id="1" name="">
             <a:extLst xmlns:a="http://schemas.openxmlformats.org/drawingml/2006/main">
               <a:ext uri="{FF2B5EF4-FFF2-40B4-BE49-F238E27FC236}">
-                <a16:creationId xmlns:a16="http://schemas.microsoft.com/office/drawing/2014/main" id="{AC86FD15-615D-4EEB-86A7-C7EDC38F9466}"/>
+                <a16:creationId xmlns:a16="http://schemas.microsoft.com/office/drawing/2014/main" id="{BA3246FD-2878-485F-A3F5-54124A54E2E7}"/>
               </a:ext>
             </a:extLst>
           </p:cNvPr>
@@ -7840,7 +7840,7 @@
           <p:cNvPr id="2" name="">
             <a:extLst xmlns:a="http://schemas.openxmlformats.org/drawingml/2006/main">
               <a:ext uri="{FF2B5EF4-FFF2-40B4-BE49-F238E27FC236}">
-                <a16:creationId xmlns:a16="http://schemas.microsoft.com/office/drawing/2014/main" id="{280B7487-2DB5-4AE7-8A59-95F0C0179501}"/>
+                <a16:creationId xmlns:a16="http://schemas.microsoft.com/office/drawing/2014/main" id="{55555A1F-0F5F-497F-B1DF-FA641628D875}"/>
               </a:ext>
             </a:extLst>
           </p:cNvPr>
@@ -7873,7 +7873,7 @@
           <p:cNvPr id="3" name="">
             <a:extLst xmlns:a="http://schemas.openxmlformats.org/drawingml/2006/main">
               <a:ext uri="{FF2B5EF4-FFF2-40B4-BE49-F238E27FC236}">
-                <a16:creationId xmlns:a16="http://schemas.microsoft.com/office/drawing/2014/main" id="{6D76998E-4742-4E8E-97C8-D7F2A6D5769E}"/>
+                <a16:creationId xmlns:a16="http://schemas.microsoft.com/office/drawing/2014/main" id="{2F8622A6-383C-4572-8EF4-497D8EA1F831}"/>
               </a:ext>
             </a:extLst>
           </p:cNvPr>
@@ -7923,7 +7923,7 @@
           <p:cNvPr id="4" name="">
             <a:extLst xmlns:a="http://schemas.openxmlformats.org/drawingml/2006/main">
               <a:ext uri="{FF2B5EF4-FFF2-40B4-BE49-F238E27FC236}">
-                <a16:creationId xmlns:a16="http://schemas.microsoft.com/office/drawing/2014/main" id="{5396A8EA-E633-48B6-A21E-0090B841231D}"/>
+                <a16:creationId xmlns:a16="http://schemas.microsoft.com/office/drawing/2014/main" id="{252C94F4-2575-45E0-B77D-DB074C4B692C}"/>
               </a:ext>
             </a:extLst>
           </p:cNvPr>
@@ -7973,7 +7973,7 @@
           <p:cNvPr id="5" name="">
             <a:extLst xmlns:a="http://schemas.openxmlformats.org/drawingml/2006/main">
               <a:ext uri="{FF2B5EF4-FFF2-40B4-BE49-F238E27FC236}">
-                <a16:creationId xmlns:a16="http://schemas.microsoft.com/office/drawing/2014/main" id="{138FA993-8ACF-4685-B759-4AF0D65838EC}"/>
+                <a16:creationId xmlns:a16="http://schemas.microsoft.com/office/drawing/2014/main" id="{18C5EA83-A449-4DDE-A191-A8A0172B66F0}"/>
               </a:ext>
             </a:extLst>
           </p:cNvPr>
@@ -8008,7 +8008,7 @@
           <p:nvPr/>
         </p:nvPicPr>
         <p:blipFill>
-          <a:blip xmlns:r="http://schemas.openxmlformats.org/officeDocument/2006/relationships" xmlns:a="http://schemas.openxmlformats.org/drawingml/2006/main" r:embed="R842eba8766324b67"/>
+          <a:blip xmlns:r="http://schemas.openxmlformats.org/officeDocument/2006/relationships" xmlns:a="http://schemas.openxmlformats.org/drawingml/2006/main" r:embed="Rb88e19ebd8c74f9e"/>
           <a:stretch xmlns:a="http://schemas.openxmlformats.org/drawingml/2006/main"/>
         </p:blipFill>
         <p:spPr>
@@ -8026,7 +8026,7 @@
           <p:cNvPr id="7" name="">
             <a:extLst xmlns:a="http://schemas.openxmlformats.org/drawingml/2006/main">
               <a:ext uri="{FF2B5EF4-FFF2-40B4-BE49-F238E27FC236}">
-                <a16:creationId xmlns:a16="http://schemas.microsoft.com/office/drawing/2014/main" id="{3B77A5B0-97BD-4F22-B11E-C5EC3745CDD6}"/>
+                <a16:creationId xmlns:a16="http://schemas.microsoft.com/office/drawing/2014/main" id="{C834E045-54E7-4768-8A34-5FA8F1AF59F1}"/>
               </a:ext>
             </a:extLst>
           </p:cNvPr>
@@ -8061,7 +8061,7 @@
           <p:cNvPr id="8" name="">
             <a:extLst xmlns:a="http://schemas.openxmlformats.org/drawingml/2006/main">
               <a:ext uri="{FF2B5EF4-FFF2-40B4-BE49-F238E27FC236}">
-                <a16:creationId xmlns:a16="http://schemas.microsoft.com/office/drawing/2014/main" id="{23FA3D0B-54D3-4F8F-B2D7-F9E80659F0D6}"/>
+                <a16:creationId xmlns:a16="http://schemas.microsoft.com/office/drawing/2014/main" id="{F6FC6E52-D024-4629-AB0C-9DD18CB86559}"/>
               </a:ext>
             </a:extLst>
           </p:cNvPr>
@@ -8111,7 +8111,7 @@
           <p:cNvPr id="9" name="">
             <a:extLst xmlns:a="http://schemas.openxmlformats.org/drawingml/2006/main">
               <a:ext uri="{FF2B5EF4-FFF2-40B4-BE49-F238E27FC236}">
-                <a16:creationId xmlns:a16="http://schemas.microsoft.com/office/drawing/2014/main" id="{21077E2C-DD38-4DD4-82E0-A290AF42F416}"/>
+                <a16:creationId xmlns:a16="http://schemas.microsoft.com/office/drawing/2014/main" id="{9C1EBC74-CBE7-4943-8047-FEA5F69490F3}"/>
               </a:ext>
             </a:extLst>
           </p:cNvPr>
@@ -8161,7 +8161,7 @@
           <p:cNvPr id="10" name="">
             <a:extLst xmlns:a="http://schemas.openxmlformats.org/drawingml/2006/main">
               <a:ext uri="{FF2B5EF4-FFF2-40B4-BE49-F238E27FC236}">
-                <a16:creationId xmlns:a16="http://schemas.microsoft.com/office/drawing/2014/main" id="{93BEEA05-4126-4A94-AB13-8D23BB01C710}"/>
+                <a16:creationId xmlns:a16="http://schemas.microsoft.com/office/drawing/2014/main" id="{5385A91C-67CB-4C92-BC39-A9A995CE0A46}"/>
               </a:ext>
             </a:extLst>
           </p:cNvPr>
@@ -8196,7 +8196,7 @@
           <p:cNvPr id="11" name="">
             <a:extLst xmlns:a="http://schemas.openxmlformats.org/drawingml/2006/main">
               <a:ext uri="{FF2B5EF4-FFF2-40B4-BE49-F238E27FC236}">
-                <a16:creationId xmlns:a16="http://schemas.microsoft.com/office/drawing/2014/main" id="{297C8F2B-C827-4D22-826C-2FD0CFF4A19F}"/>
+                <a16:creationId xmlns:a16="http://schemas.microsoft.com/office/drawing/2014/main" id="{BBF09CA4-6E51-45F2-A002-635BF3AC74E3}"/>
               </a:ext>
             </a:extLst>
           </p:cNvPr>
@@ -8246,7 +8246,7 @@
           <p:cNvPr id="12" name="">
             <a:extLst xmlns:a="http://schemas.openxmlformats.org/drawingml/2006/main">
               <a:ext uri="{FF2B5EF4-FFF2-40B4-BE49-F238E27FC236}">
-                <a16:creationId xmlns:a16="http://schemas.microsoft.com/office/drawing/2014/main" id="{71337BF7-5301-46D7-B63B-65B5A021D22E}"/>
+                <a16:creationId xmlns:a16="http://schemas.microsoft.com/office/drawing/2014/main" id="{4AFAAA4C-93CD-41AA-8B6B-9BF1EB344EA5}"/>
               </a:ext>
             </a:extLst>
           </p:cNvPr>
@@ -8296,7 +8296,7 @@
           <p:cNvPr id="13" name="">
             <a:extLst xmlns:a="http://schemas.openxmlformats.org/drawingml/2006/main">
               <a:ext uri="{FF2B5EF4-FFF2-40B4-BE49-F238E27FC236}">
-                <a16:creationId xmlns:a16="http://schemas.microsoft.com/office/drawing/2014/main" id="{4D07715D-4AE1-4B3A-8104-76BBD674554E}"/>
+                <a16:creationId xmlns:a16="http://schemas.microsoft.com/office/drawing/2014/main" id="{BE987406-68B9-45D4-9CB5-1903E46E14EC}"/>
               </a:ext>
             </a:extLst>
           </p:cNvPr>
@@ -8331,7 +8331,7 @@
           <p:cNvPr id="14" name="">
             <a:extLst xmlns:a="http://schemas.openxmlformats.org/drawingml/2006/main">
               <a:ext uri="{FF2B5EF4-FFF2-40B4-BE49-F238E27FC236}">
-                <a16:creationId xmlns:a16="http://schemas.microsoft.com/office/drawing/2014/main" id="{E765096F-07DB-4172-8376-726870FB35DF}"/>
+                <a16:creationId xmlns:a16="http://schemas.microsoft.com/office/drawing/2014/main" id="{81085F8B-19CE-46D4-9CA1-B6442D579B67}"/>
               </a:ext>
             </a:extLst>
           </p:cNvPr>
@@ -8381,7 +8381,7 @@
           <p:cNvPr id="15" name="">
             <a:extLst xmlns:a="http://schemas.openxmlformats.org/drawingml/2006/main">
               <a:ext uri="{FF2B5EF4-FFF2-40B4-BE49-F238E27FC236}">
-                <a16:creationId xmlns:a16="http://schemas.microsoft.com/office/drawing/2014/main" id="{E51C92CA-2E2E-41C2-AB94-4DB8A6E72BD2}"/>
+                <a16:creationId xmlns:a16="http://schemas.microsoft.com/office/drawing/2014/main" id="{F7FB87AA-D333-46BC-A986-9A16BB60AD15}"/>
               </a:ext>
             </a:extLst>
           </p:cNvPr>
@@ -8431,7 +8431,7 @@
           <p:cNvPr id="16" name="">
             <a:extLst xmlns:a="http://schemas.openxmlformats.org/drawingml/2006/main">
               <a:ext uri="{FF2B5EF4-FFF2-40B4-BE49-F238E27FC236}">
-                <a16:creationId xmlns:a16="http://schemas.microsoft.com/office/drawing/2014/main" id="{3B2D7887-E91D-462D-A2D6-DB0CC0CB4CD5}"/>
+                <a16:creationId xmlns:a16="http://schemas.microsoft.com/office/drawing/2014/main" id="{FEF2F3C4-8392-460D-9686-AFCD9B236343}"/>
               </a:ext>
             </a:extLst>
           </p:cNvPr>
@@ -8466,7 +8466,7 @@
           <p:cNvPr id="17" name="">
             <a:extLst xmlns:a="http://schemas.openxmlformats.org/drawingml/2006/main">
               <a:ext uri="{FF2B5EF4-FFF2-40B4-BE49-F238E27FC236}">
-                <a16:creationId xmlns:a16="http://schemas.microsoft.com/office/drawing/2014/main" id="{011A84E4-59B8-4F90-A925-7438CA2DF97D}"/>
+                <a16:creationId xmlns:a16="http://schemas.microsoft.com/office/drawing/2014/main" id="{F69AB1B5-B898-49E1-9551-D8BEE6446EF3}"/>
               </a:ext>
             </a:extLst>
           </p:cNvPr>
@@ -8516,7 +8516,7 @@
           <p:cNvPr id="18" name="">
             <a:extLst xmlns:a="http://schemas.openxmlformats.org/drawingml/2006/main">
               <a:ext uri="{FF2B5EF4-FFF2-40B4-BE49-F238E27FC236}">
-                <a16:creationId xmlns:a16="http://schemas.microsoft.com/office/drawing/2014/main" id="{E6207CC7-3F57-400C-ADB0-75FAFEB762D4}"/>
+                <a16:creationId xmlns:a16="http://schemas.microsoft.com/office/drawing/2014/main" id="{6FE86529-B647-4B2C-ABC1-55634DE66DF2}"/>
               </a:ext>
             </a:extLst>
           </p:cNvPr>
@@ -8564,7 +8564,7 @@
     </p:spTree>
     <p:extLst>
       <p:ext uri="{BB962C8B-B14F-4D97-AF65-F5344CB8AC3E}">
-        <p14:creationId xmlns:p14="http://schemas.microsoft.com/office/powerpoint/2010/main" val="1795862693"/>
+        <p14:creationId xmlns:p14="http://schemas.microsoft.com/office/powerpoint/2010/main" val="847338944"/>
       </p:ext>
     </p:extLst>
   </p:cSld>
@@ -8595,7 +8595,7 @@
           <p:cNvPr id="1" name="">
             <a:extLst xmlns:a="http://schemas.openxmlformats.org/drawingml/2006/main">
               <a:ext uri="{FF2B5EF4-FFF2-40B4-BE49-F238E27FC236}">
-                <a16:creationId xmlns:a16="http://schemas.microsoft.com/office/drawing/2014/main" id="{CF48A373-C867-4616-8D36-D29DC1926C01}"/>
+                <a16:creationId xmlns:a16="http://schemas.microsoft.com/office/drawing/2014/main" id="{6340C8DF-E1B6-45C2-A82A-35E3AF1EDFC3}"/>
               </a:ext>
             </a:extLst>
           </p:cNvPr>
@@ -8632,7 +8632,7 @@
           <p:nvPr/>
         </p:nvPicPr>
         <p:blipFill>
-          <a:blip xmlns:r="http://schemas.openxmlformats.org/officeDocument/2006/relationships" xmlns:a="http://schemas.openxmlformats.org/drawingml/2006/main" r:embed="R11462957faf34ba1"/>
+          <a:blip xmlns:r="http://schemas.openxmlformats.org/officeDocument/2006/relationships" xmlns:a="http://schemas.openxmlformats.org/drawingml/2006/main" r:embed="R99fced31756d4eb3"/>
           <a:stretch xmlns:a="http://schemas.openxmlformats.org/drawingml/2006/main"/>
         </p:blipFill>
         <p:spPr>
@@ -8650,7 +8650,7 @@
           <p:cNvPr id="3" name="">
             <a:extLst xmlns:a="http://schemas.openxmlformats.org/drawingml/2006/main">
               <a:ext uri="{FF2B5EF4-FFF2-40B4-BE49-F238E27FC236}">
-                <a16:creationId xmlns:a16="http://schemas.microsoft.com/office/drawing/2014/main" id="{66FF113B-F548-4BA0-9626-F68823E414F9}"/>
+                <a16:creationId xmlns:a16="http://schemas.microsoft.com/office/drawing/2014/main" id="{2F35754E-DB6E-4C26-8C2D-8ECDAF4A83D9}"/>
               </a:ext>
             </a:extLst>
           </p:cNvPr>
@@ -8700,7 +8700,7 @@
           <p:cNvPr id="4" name="">
             <a:extLst xmlns:a="http://schemas.openxmlformats.org/drawingml/2006/main">
               <a:ext uri="{FF2B5EF4-FFF2-40B4-BE49-F238E27FC236}">
-                <a16:creationId xmlns:a16="http://schemas.microsoft.com/office/drawing/2014/main" id="{522A54A6-D218-4EA9-9466-29F7C7627562}"/>
+                <a16:creationId xmlns:a16="http://schemas.microsoft.com/office/drawing/2014/main" id="{9AEA77FD-7ECC-4CAC-B594-C8FFDD7ADCA4}"/>
               </a:ext>
             </a:extLst>
           </p:cNvPr>
@@ -8748,7 +8748,7 @@
     </p:spTree>
     <p:extLst>
       <p:ext uri="{BB962C8B-B14F-4D97-AF65-F5344CB8AC3E}">
-        <p14:creationId xmlns:p14="http://schemas.microsoft.com/office/powerpoint/2010/main" val="1820728567"/>
+        <p14:creationId xmlns:p14="http://schemas.microsoft.com/office/powerpoint/2010/main" val="1090588486"/>
       </p:ext>
     </p:extLst>
   </p:cSld>
@@ -8779,7 +8779,7 @@
           <p:cNvPr id="1" name="">
             <a:extLst xmlns:a="http://schemas.openxmlformats.org/drawingml/2006/main">
               <a:ext uri="{FF2B5EF4-FFF2-40B4-BE49-F238E27FC236}">
-                <a16:creationId xmlns:a16="http://schemas.microsoft.com/office/drawing/2014/main" id="{02B98FD7-9EB0-40C8-BCE7-9137A27E98B4}"/>
+                <a16:creationId xmlns:a16="http://schemas.microsoft.com/office/drawing/2014/main" id="{3234C3B4-A79B-450A-9939-598BD736C044}"/>
               </a:ext>
             </a:extLst>
           </p:cNvPr>
@@ -8812,7 +8812,7 @@
           <p:cNvPr id="2" name="">
             <a:extLst xmlns:a="http://schemas.openxmlformats.org/drawingml/2006/main">
               <a:ext uri="{FF2B5EF4-FFF2-40B4-BE49-F238E27FC236}">
-                <a16:creationId xmlns:a16="http://schemas.microsoft.com/office/drawing/2014/main" id="{45CCF325-35B8-4BEB-BB42-C3A07B4FFEA8}"/>
+                <a16:creationId xmlns:a16="http://schemas.microsoft.com/office/drawing/2014/main" id="{107F5113-26F3-4501-BAB8-F12D97020EDA}"/>
               </a:ext>
             </a:extLst>
           </p:cNvPr>
@@ -8845,7 +8845,7 @@
           <p:cNvPr id="3" name="">
             <a:extLst xmlns:a="http://schemas.openxmlformats.org/drawingml/2006/main">
               <a:ext uri="{FF2B5EF4-FFF2-40B4-BE49-F238E27FC236}">
-                <a16:creationId xmlns:a16="http://schemas.microsoft.com/office/drawing/2014/main" id="{4ACB4E50-9D1D-4E27-8D2D-7B775A360000}"/>
+                <a16:creationId xmlns:a16="http://schemas.microsoft.com/office/drawing/2014/main" id="{755204F8-F0C9-4068-94F9-DC243297152D}"/>
               </a:ext>
             </a:extLst>
           </p:cNvPr>
@@ -8895,7 +8895,7 @@
           <p:cNvPr id="4" name="">
             <a:extLst xmlns:a="http://schemas.openxmlformats.org/drawingml/2006/main">
               <a:ext uri="{FF2B5EF4-FFF2-40B4-BE49-F238E27FC236}">
-                <a16:creationId xmlns:a16="http://schemas.microsoft.com/office/drawing/2014/main" id="{B148F8BD-88AB-4541-9542-BEBC504D855B}"/>
+                <a16:creationId xmlns:a16="http://schemas.microsoft.com/office/drawing/2014/main" id="{1B088408-0B23-4E56-8ED5-A4469F87ABD6}"/>
               </a:ext>
             </a:extLst>
           </p:cNvPr>
@@ -8945,7 +8945,7 @@
           <p:cNvPr id="5" name="">
             <a:extLst xmlns:a="http://schemas.openxmlformats.org/drawingml/2006/main">
               <a:ext uri="{FF2B5EF4-FFF2-40B4-BE49-F238E27FC236}">
-                <a16:creationId xmlns:a16="http://schemas.microsoft.com/office/drawing/2014/main" id="{56A66169-FDFA-4362-A128-B8A4FD32033D}"/>
+                <a16:creationId xmlns:a16="http://schemas.microsoft.com/office/drawing/2014/main" id="{BDE244DD-D80C-45E3-B117-5FF4903A8395}"/>
               </a:ext>
             </a:extLst>
           </p:cNvPr>
@@ -8980,7 +8980,7 @@
           <p:nvPr/>
         </p:nvPicPr>
         <p:blipFill>
-          <a:blip xmlns:r="http://schemas.openxmlformats.org/officeDocument/2006/relationships" xmlns:a="http://schemas.openxmlformats.org/drawingml/2006/main" r:embed="Ree951b098b32470b"/>
+          <a:blip xmlns:r="http://schemas.openxmlformats.org/officeDocument/2006/relationships" xmlns:a="http://schemas.openxmlformats.org/drawingml/2006/main" r:embed="R0ed44984667241ba"/>
           <a:stretch xmlns:a="http://schemas.openxmlformats.org/drawingml/2006/main"/>
         </p:blipFill>
         <p:spPr>
@@ -8998,7 +8998,7 @@
           <p:cNvPr id="7" name="">
             <a:extLst xmlns:a="http://schemas.openxmlformats.org/drawingml/2006/main">
               <a:ext uri="{FF2B5EF4-FFF2-40B4-BE49-F238E27FC236}">
-                <a16:creationId xmlns:a16="http://schemas.microsoft.com/office/drawing/2014/main" id="{6EBC64A7-BA07-489F-B9CF-700F37ADF39E}"/>
+                <a16:creationId xmlns:a16="http://schemas.microsoft.com/office/drawing/2014/main" id="{653CE123-9839-4DB1-9FB3-654E628A1834}"/>
               </a:ext>
             </a:extLst>
           </p:cNvPr>
@@ -9033,7 +9033,7 @@
           <p:cNvPr id="8" name="">
             <a:extLst xmlns:a="http://schemas.openxmlformats.org/drawingml/2006/main">
               <a:ext uri="{FF2B5EF4-FFF2-40B4-BE49-F238E27FC236}">
-                <a16:creationId xmlns:a16="http://schemas.microsoft.com/office/drawing/2014/main" id="{83A5F668-23BE-49E1-B98B-DA6FC8CFDAE0}"/>
+                <a16:creationId xmlns:a16="http://schemas.microsoft.com/office/drawing/2014/main" id="{AECAFE70-0C54-4FFE-8C14-206F14388A73}"/>
               </a:ext>
             </a:extLst>
           </p:cNvPr>
@@ -9083,7 +9083,7 @@
           <p:cNvPr id="9" name="">
             <a:extLst xmlns:a="http://schemas.openxmlformats.org/drawingml/2006/main">
               <a:ext uri="{FF2B5EF4-FFF2-40B4-BE49-F238E27FC236}">
-                <a16:creationId xmlns:a16="http://schemas.microsoft.com/office/drawing/2014/main" id="{07554516-290A-4891-92A1-A7DEB769CF8D}"/>
+                <a16:creationId xmlns:a16="http://schemas.microsoft.com/office/drawing/2014/main" id="{97C27F8E-2248-4545-9498-C7B5E2765A77}"/>
               </a:ext>
             </a:extLst>
           </p:cNvPr>
@@ -9133,7 +9133,7 @@
           <p:cNvPr id="10" name="">
             <a:extLst xmlns:a="http://schemas.openxmlformats.org/drawingml/2006/main">
               <a:ext uri="{FF2B5EF4-FFF2-40B4-BE49-F238E27FC236}">
-                <a16:creationId xmlns:a16="http://schemas.microsoft.com/office/drawing/2014/main" id="{50917B26-7C61-442D-9279-2C0C21A79831}"/>
+                <a16:creationId xmlns:a16="http://schemas.microsoft.com/office/drawing/2014/main" id="{C4502E40-7CE9-4118-AA23-60771127578F}"/>
               </a:ext>
             </a:extLst>
           </p:cNvPr>
@@ -9168,7 +9168,7 @@
           <p:cNvPr id="11" name="">
             <a:extLst xmlns:a="http://schemas.openxmlformats.org/drawingml/2006/main">
               <a:ext uri="{FF2B5EF4-FFF2-40B4-BE49-F238E27FC236}">
-                <a16:creationId xmlns:a16="http://schemas.microsoft.com/office/drawing/2014/main" id="{58788F41-09E8-424F-BA9E-38BCB7C47E34}"/>
+                <a16:creationId xmlns:a16="http://schemas.microsoft.com/office/drawing/2014/main" id="{1290352C-A3A0-4B1C-B1C1-BA5004110CBA}"/>
               </a:ext>
             </a:extLst>
           </p:cNvPr>
@@ -9218,7 +9218,7 @@
           <p:cNvPr id="12" name="">
             <a:extLst xmlns:a="http://schemas.openxmlformats.org/drawingml/2006/main">
               <a:ext uri="{FF2B5EF4-FFF2-40B4-BE49-F238E27FC236}">
-                <a16:creationId xmlns:a16="http://schemas.microsoft.com/office/drawing/2014/main" id="{6A931B76-5283-4C07-9F58-67EE960F3F0E}"/>
+                <a16:creationId xmlns:a16="http://schemas.microsoft.com/office/drawing/2014/main" id="{866CFFA8-F1C1-4C51-9F20-8DE55CAB7993}"/>
               </a:ext>
             </a:extLst>
           </p:cNvPr>
@@ -9268,7 +9268,7 @@
           <p:cNvPr id="13" name="">
             <a:extLst xmlns:a="http://schemas.openxmlformats.org/drawingml/2006/main">
               <a:ext uri="{FF2B5EF4-FFF2-40B4-BE49-F238E27FC236}">
-                <a16:creationId xmlns:a16="http://schemas.microsoft.com/office/drawing/2014/main" id="{635847CF-FECC-4980-8F3B-2D4F51D2FB58}"/>
+                <a16:creationId xmlns:a16="http://schemas.microsoft.com/office/drawing/2014/main" id="{9CB5178A-962E-4778-A0EE-2048AF60B3ED}"/>
               </a:ext>
             </a:extLst>
           </p:cNvPr>
@@ -9303,7 +9303,7 @@
           <p:cNvPr id="14" name="">
             <a:extLst xmlns:a="http://schemas.openxmlformats.org/drawingml/2006/main">
               <a:ext uri="{FF2B5EF4-FFF2-40B4-BE49-F238E27FC236}">
-                <a16:creationId xmlns:a16="http://schemas.microsoft.com/office/drawing/2014/main" id="{DC71C670-9C2C-403B-96F8-C68A9567E228}"/>
+                <a16:creationId xmlns:a16="http://schemas.microsoft.com/office/drawing/2014/main" id="{86F60D1D-B4D2-42F4-A135-C9C67CB5331B}"/>
               </a:ext>
             </a:extLst>
           </p:cNvPr>
@@ -9353,7 +9353,7 @@
           <p:cNvPr id="15" name="">
             <a:extLst xmlns:a="http://schemas.openxmlformats.org/drawingml/2006/main">
               <a:ext uri="{FF2B5EF4-FFF2-40B4-BE49-F238E27FC236}">
-                <a16:creationId xmlns:a16="http://schemas.microsoft.com/office/drawing/2014/main" id="{8406C8E3-940D-4A9F-9F73-006F8B70B1E1}"/>
+                <a16:creationId xmlns:a16="http://schemas.microsoft.com/office/drawing/2014/main" id="{EEFFC9C1-DF76-48D6-BF74-D4A808E83AAF}"/>
               </a:ext>
             </a:extLst>
           </p:cNvPr>
@@ -9403,7 +9403,7 @@
           <p:cNvPr id="16" name="">
             <a:extLst xmlns:a="http://schemas.openxmlformats.org/drawingml/2006/main">
               <a:ext uri="{FF2B5EF4-FFF2-40B4-BE49-F238E27FC236}">
-                <a16:creationId xmlns:a16="http://schemas.microsoft.com/office/drawing/2014/main" id="{B7AFDC05-E0CB-4FAA-8642-53E389EDED8F}"/>
+                <a16:creationId xmlns:a16="http://schemas.microsoft.com/office/drawing/2014/main" id="{1F165409-5CFC-4A51-B1EB-36FB13D324D7}"/>
               </a:ext>
             </a:extLst>
           </p:cNvPr>
@@ -9438,7 +9438,7 @@
           <p:cNvPr id="17" name="">
             <a:extLst xmlns:a="http://schemas.openxmlformats.org/drawingml/2006/main">
               <a:ext uri="{FF2B5EF4-FFF2-40B4-BE49-F238E27FC236}">
-                <a16:creationId xmlns:a16="http://schemas.microsoft.com/office/drawing/2014/main" id="{82736036-09E4-434A-9287-2804B0B25D9D}"/>
+                <a16:creationId xmlns:a16="http://schemas.microsoft.com/office/drawing/2014/main" id="{29657507-1E52-4DF9-A5F4-71866E585F90}"/>
               </a:ext>
             </a:extLst>
           </p:cNvPr>
@@ -9488,7 +9488,7 @@
           <p:cNvPr id="18" name="">
             <a:extLst xmlns:a="http://schemas.openxmlformats.org/drawingml/2006/main">
               <a:ext uri="{FF2B5EF4-FFF2-40B4-BE49-F238E27FC236}">
-                <a16:creationId xmlns:a16="http://schemas.microsoft.com/office/drawing/2014/main" id="{C849BE9A-A6BA-4C3F-92E9-68E641A7BD5B}"/>
+                <a16:creationId xmlns:a16="http://schemas.microsoft.com/office/drawing/2014/main" id="{9EB48349-F9FA-4719-A156-3968D5E347AC}"/>
               </a:ext>
             </a:extLst>
           </p:cNvPr>
@@ -9538,7 +9538,7 @@
           <p:cNvPr id="19" name="">
             <a:extLst xmlns:a="http://schemas.openxmlformats.org/drawingml/2006/main">
               <a:ext uri="{FF2B5EF4-FFF2-40B4-BE49-F238E27FC236}">
-                <a16:creationId xmlns:a16="http://schemas.microsoft.com/office/drawing/2014/main" id="{144CB224-8A1C-4579-BE59-D5E107610872}"/>
+                <a16:creationId xmlns:a16="http://schemas.microsoft.com/office/drawing/2014/main" id="{562A1B5A-6546-4DD3-A7BE-6D8CED11B456}"/>
               </a:ext>
             </a:extLst>
           </p:cNvPr>
@@ -9573,7 +9573,7 @@
           <p:cNvPr id="20" name="">
             <a:extLst xmlns:a="http://schemas.openxmlformats.org/drawingml/2006/main">
               <a:ext uri="{FF2B5EF4-FFF2-40B4-BE49-F238E27FC236}">
-                <a16:creationId xmlns:a16="http://schemas.microsoft.com/office/drawing/2014/main" id="{DAF3625D-4A7A-428D-8A87-D53549661765}"/>
+                <a16:creationId xmlns:a16="http://schemas.microsoft.com/office/drawing/2014/main" id="{7EF6CCA9-CE1C-4929-9B90-8A84576D47B6}"/>
               </a:ext>
             </a:extLst>
           </p:cNvPr>
@@ -9623,7 +9623,7 @@
           <p:cNvPr id="21" name="">
             <a:extLst xmlns:a="http://schemas.openxmlformats.org/drawingml/2006/main">
               <a:ext uri="{FF2B5EF4-FFF2-40B4-BE49-F238E27FC236}">
-                <a16:creationId xmlns:a16="http://schemas.microsoft.com/office/drawing/2014/main" id="{36BAB0DD-85DD-40C2-8404-6D52FF2B01C9}"/>
+                <a16:creationId xmlns:a16="http://schemas.microsoft.com/office/drawing/2014/main" id="{85E0EB84-3F9A-4930-AAC5-CF82EA3507A1}"/>
               </a:ext>
             </a:extLst>
           </p:cNvPr>
@@ -9673,7 +9673,7 @@
           <p:cNvPr id="22" name="">
             <a:extLst xmlns:a="http://schemas.openxmlformats.org/drawingml/2006/main">
               <a:ext uri="{FF2B5EF4-FFF2-40B4-BE49-F238E27FC236}">
-                <a16:creationId xmlns:a16="http://schemas.microsoft.com/office/drawing/2014/main" id="{51DE5A8A-DC45-4776-A3F2-D0CB225D502D}"/>
+                <a16:creationId xmlns:a16="http://schemas.microsoft.com/office/drawing/2014/main" id="{7FA1AD64-FFD6-4A9F-BE91-243C8D5C663D}"/>
               </a:ext>
             </a:extLst>
           </p:cNvPr>
@@ -9708,7 +9708,7 @@
           <p:cNvPr id="23" name="">
             <a:extLst xmlns:a="http://schemas.openxmlformats.org/drawingml/2006/main">
               <a:ext uri="{FF2B5EF4-FFF2-40B4-BE49-F238E27FC236}">
-                <a16:creationId xmlns:a16="http://schemas.microsoft.com/office/drawing/2014/main" id="{4DC3C218-8994-4925-8C9E-7066DE35D95E}"/>
+                <a16:creationId xmlns:a16="http://schemas.microsoft.com/office/drawing/2014/main" id="{45D1A29D-8963-47B1-817E-0D8FE957CA0A}"/>
               </a:ext>
             </a:extLst>
           </p:cNvPr>
@@ -9758,7 +9758,7 @@
           <p:cNvPr id="24" name="">
             <a:extLst xmlns:a="http://schemas.openxmlformats.org/drawingml/2006/main">
               <a:ext uri="{FF2B5EF4-FFF2-40B4-BE49-F238E27FC236}">
-                <a16:creationId xmlns:a16="http://schemas.microsoft.com/office/drawing/2014/main" id="{59DB9963-7FB7-4F87-956C-4761F0DD718A}"/>
+                <a16:creationId xmlns:a16="http://schemas.microsoft.com/office/drawing/2014/main" id="{09DC51BA-6E7D-4C91-892D-92774560AE91}"/>
               </a:ext>
             </a:extLst>
           </p:cNvPr>
@@ -9806,7 +9806,7 @@
     </p:spTree>
     <p:extLst>
       <p:ext uri="{BB962C8B-B14F-4D97-AF65-F5344CB8AC3E}">
-        <p14:creationId xmlns:p14="http://schemas.microsoft.com/office/powerpoint/2010/main" val="1418011557"/>
+        <p14:creationId xmlns:p14="http://schemas.microsoft.com/office/powerpoint/2010/main" val="1721983785"/>
       </p:ext>
     </p:extLst>
   </p:cSld>
@@ -9837,7 +9837,7 @@
           <p:cNvPr id="1" name="">
             <a:extLst xmlns:a="http://schemas.openxmlformats.org/drawingml/2006/main">
               <a:ext uri="{FF2B5EF4-FFF2-40B4-BE49-F238E27FC236}">
-                <a16:creationId xmlns:a16="http://schemas.microsoft.com/office/drawing/2014/main" id="{36221435-9430-4DC0-80F2-D2D2F16A94A9}"/>
+                <a16:creationId xmlns:a16="http://schemas.microsoft.com/office/drawing/2014/main" id="{5E6F2B9B-D6FC-4B1E-BFBF-A0A25B3FACB2}"/>
               </a:ext>
             </a:extLst>
           </p:cNvPr>
@@ -9870,7 +9870,7 @@
           <p:cNvPr id="2" name="">
             <a:extLst xmlns:a="http://schemas.openxmlformats.org/drawingml/2006/main">
               <a:ext uri="{FF2B5EF4-FFF2-40B4-BE49-F238E27FC236}">
-                <a16:creationId xmlns:a16="http://schemas.microsoft.com/office/drawing/2014/main" id="{B8A83FCE-33F7-430A-BFC9-D281375C9EE8}"/>
+                <a16:creationId xmlns:a16="http://schemas.microsoft.com/office/drawing/2014/main" id="{E15C223F-3E40-4EE9-ACA4-B4923DF78C19}"/>
               </a:ext>
             </a:extLst>
           </p:cNvPr>
@@ -9903,7 +9903,7 @@
           <p:cNvPr id="3" name="">
             <a:extLst xmlns:a="http://schemas.openxmlformats.org/drawingml/2006/main">
               <a:ext uri="{FF2B5EF4-FFF2-40B4-BE49-F238E27FC236}">
-                <a16:creationId xmlns:a16="http://schemas.microsoft.com/office/drawing/2014/main" id="{FDFF6425-FC8C-4EB8-8294-5A9F17044AAE}"/>
+                <a16:creationId xmlns:a16="http://schemas.microsoft.com/office/drawing/2014/main" id="{6FF54597-24E9-456A-99E9-4CF69F7029CF}"/>
               </a:ext>
             </a:extLst>
           </p:cNvPr>
@@ -9953,7 +9953,7 @@
           <p:cNvPr id="4" name="">
             <a:extLst xmlns:a="http://schemas.openxmlformats.org/drawingml/2006/main">
               <a:ext uri="{FF2B5EF4-FFF2-40B4-BE49-F238E27FC236}">
-                <a16:creationId xmlns:a16="http://schemas.microsoft.com/office/drawing/2014/main" id="{18D6BDC9-1094-4A69-A702-14EC342A6849}"/>
+                <a16:creationId xmlns:a16="http://schemas.microsoft.com/office/drawing/2014/main" id="{943DFA7D-C720-47FA-B11F-F30D678E8354}"/>
               </a:ext>
             </a:extLst>
           </p:cNvPr>
@@ -10003,7 +10003,7 @@
           <p:cNvPr id="5" name="">
             <a:extLst xmlns:a="http://schemas.openxmlformats.org/drawingml/2006/main">
               <a:ext uri="{FF2B5EF4-FFF2-40B4-BE49-F238E27FC236}">
-                <a16:creationId xmlns:a16="http://schemas.microsoft.com/office/drawing/2014/main" id="{E4728495-0498-4509-A784-AE08B0EAA2AB}"/>
+                <a16:creationId xmlns:a16="http://schemas.microsoft.com/office/drawing/2014/main" id="{39A54F34-CF5A-42F3-A0D6-BBC2D10D7796}"/>
               </a:ext>
             </a:extLst>
           </p:cNvPr>
@@ -10038,7 +10038,7 @@
           <p:nvPr/>
         </p:nvPicPr>
         <p:blipFill>
-          <a:blip xmlns:r="http://schemas.openxmlformats.org/officeDocument/2006/relationships" xmlns:a="http://schemas.openxmlformats.org/drawingml/2006/main" r:embed="Rda3900e42b144627"/>
+          <a:blip xmlns:r="http://schemas.openxmlformats.org/officeDocument/2006/relationships" xmlns:a="http://schemas.openxmlformats.org/drawingml/2006/main" r:embed="Re5ead1f723c04851"/>
           <a:stretch xmlns:a="http://schemas.openxmlformats.org/drawingml/2006/main"/>
         </p:blipFill>
         <p:spPr>
@@ -10056,7 +10056,7 @@
           <p:cNvPr id="7" name="">
             <a:extLst xmlns:a="http://schemas.openxmlformats.org/drawingml/2006/main">
               <a:ext uri="{FF2B5EF4-FFF2-40B4-BE49-F238E27FC236}">
-                <a16:creationId xmlns:a16="http://schemas.microsoft.com/office/drawing/2014/main" id="{AE469955-4B0C-47AF-9026-E7A661FA666E}"/>
+                <a16:creationId xmlns:a16="http://schemas.microsoft.com/office/drawing/2014/main" id="{7CC4E881-8A8E-4637-866D-0BE0A7438AE0}"/>
               </a:ext>
             </a:extLst>
           </p:cNvPr>
@@ -10106,7 +10106,7 @@
           <p:cNvPr id="8" name="">
             <a:extLst xmlns:a="http://schemas.openxmlformats.org/drawingml/2006/main">
               <a:ext uri="{FF2B5EF4-FFF2-40B4-BE49-F238E27FC236}">
-                <a16:creationId xmlns:a16="http://schemas.microsoft.com/office/drawing/2014/main" id="{4684B11E-85E3-4156-8D40-F505E9532413}"/>
+                <a16:creationId xmlns:a16="http://schemas.microsoft.com/office/drawing/2014/main" id="{BDEBE08E-24CB-4C5B-9CBE-96475D75887E}"/>
               </a:ext>
             </a:extLst>
           </p:cNvPr>
@@ -10156,7 +10156,7 @@
           <p:cNvPr id="9" name="">
             <a:extLst xmlns:a="http://schemas.openxmlformats.org/drawingml/2006/main">
               <a:ext uri="{FF2B5EF4-FFF2-40B4-BE49-F238E27FC236}">
-                <a16:creationId xmlns:a16="http://schemas.microsoft.com/office/drawing/2014/main" id="{37578AE7-052E-4D9A-8D7B-FBAD670205EB}"/>
+                <a16:creationId xmlns:a16="http://schemas.microsoft.com/office/drawing/2014/main" id="{AA4F093D-2AB9-4AC7-88AB-489B1D734F7F}"/>
               </a:ext>
             </a:extLst>
           </p:cNvPr>
@@ -10206,7 +10206,7 @@
           <p:cNvPr id="10" name="">
             <a:extLst xmlns:a="http://schemas.openxmlformats.org/drawingml/2006/main">
               <a:ext uri="{FF2B5EF4-FFF2-40B4-BE49-F238E27FC236}">
-                <a16:creationId xmlns:a16="http://schemas.microsoft.com/office/drawing/2014/main" id="{84019CFC-C307-4F7B-B6C3-E1FD8DA1E0AE}"/>
+                <a16:creationId xmlns:a16="http://schemas.microsoft.com/office/drawing/2014/main" id="{965A09B9-2702-4AA4-AAC4-9D0859C182F3}"/>
               </a:ext>
             </a:extLst>
           </p:cNvPr>
@@ -10239,7 +10239,7 @@
           <p:cNvPr id="11" name="">
             <a:extLst xmlns:a="http://schemas.openxmlformats.org/drawingml/2006/main">
               <a:ext uri="{FF2B5EF4-FFF2-40B4-BE49-F238E27FC236}">
-                <a16:creationId xmlns:a16="http://schemas.microsoft.com/office/drawing/2014/main" id="{D4571243-7FAF-4F3A-B4DC-F5C67742F73E}"/>
+                <a16:creationId xmlns:a16="http://schemas.microsoft.com/office/drawing/2014/main" id="{F70A290E-1E50-4D92-9C41-2884BD3C5027}"/>
               </a:ext>
             </a:extLst>
           </p:cNvPr>
@@ -10289,7 +10289,7 @@
           <p:cNvPr id="12" name="">
             <a:extLst xmlns:a="http://schemas.openxmlformats.org/drawingml/2006/main">
               <a:ext uri="{FF2B5EF4-FFF2-40B4-BE49-F238E27FC236}">
-                <a16:creationId xmlns:a16="http://schemas.microsoft.com/office/drawing/2014/main" id="{21256D6F-DA06-43AE-9893-F316040AE255}"/>
+                <a16:creationId xmlns:a16="http://schemas.microsoft.com/office/drawing/2014/main" id="{EA0D57BA-6E54-4496-8B00-2722760FBAF9}"/>
               </a:ext>
             </a:extLst>
           </p:cNvPr>
@@ -10322,7 +10322,7 @@
           <p:cNvPr id="13" name="">
             <a:extLst xmlns:a="http://schemas.openxmlformats.org/drawingml/2006/main">
               <a:ext uri="{FF2B5EF4-FFF2-40B4-BE49-F238E27FC236}">
-                <a16:creationId xmlns:a16="http://schemas.microsoft.com/office/drawing/2014/main" id="{E81F150F-D82E-4115-95F6-E607DB7109F0}"/>
+                <a16:creationId xmlns:a16="http://schemas.microsoft.com/office/drawing/2014/main" id="{82689965-4613-4E8C-B6F3-228FF81CFC05}"/>
               </a:ext>
             </a:extLst>
           </p:cNvPr>
@@ -10372,7 +10372,7 @@
           <p:cNvPr id="14" name="">
             <a:extLst xmlns:a="http://schemas.openxmlformats.org/drawingml/2006/main">
               <a:ext uri="{FF2B5EF4-FFF2-40B4-BE49-F238E27FC236}">
-                <a16:creationId xmlns:a16="http://schemas.microsoft.com/office/drawing/2014/main" id="{B4075E08-BF70-45E9-BBC9-4C80D317E407}"/>
+                <a16:creationId xmlns:a16="http://schemas.microsoft.com/office/drawing/2014/main" id="{767DF67A-5E1A-4B7D-AC71-2A2ED7818F15}"/>
               </a:ext>
             </a:extLst>
           </p:cNvPr>
@@ -10405,7 +10405,7 @@
           <p:cNvPr id="15" name="">
             <a:extLst xmlns:a="http://schemas.openxmlformats.org/drawingml/2006/main">
               <a:ext uri="{FF2B5EF4-FFF2-40B4-BE49-F238E27FC236}">
-                <a16:creationId xmlns:a16="http://schemas.microsoft.com/office/drawing/2014/main" id="{B7069194-5A55-4716-8CE7-D27EF0451093}"/>
+                <a16:creationId xmlns:a16="http://schemas.microsoft.com/office/drawing/2014/main" id="{29A900BE-CDAD-405B-97EB-D845EEB8ECD8}"/>
               </a:ext>
             </a:extLst>
           </p:cNvPr>
@@ -10455,7 +10455,7 @@
           <p:cNvPr id="16" name="">
             <a:extLst xmlns:a="http://schemas.openxmlformats.org/drawingml/2006/main">
               <a:ext uri="{FF2B5EF4-FFF2-40B4-BE49-F238E27FC236}">
-                <a16:creationId xmlns:a16="http://schemas.microsoft.com/office/drawing/2014/main" id="{32BD14EC-40D1-41E9-9506-C4EBD474BEDD}"/>
+                <a16:creationId xmlns:a16="http://schemas.microsoft.com/office/drawing/2014/main" id="{05546797-C95E-4B0E-B505-93F90DDFE807}"/>
               </a:ext>
             </a:extLst>
           </p:cNvPr>
@@ -10488,7 +10488,7 @@
           <p:cNvPr id="17" name="">
             <a:extLst xmlns:a="http://schemas.openxmlformats.org/drawingml/2006/main">
               <a:ext uri="{FF2B5EF4-FFF2-40B4-BE49-F238E27FC236}">
-                <a16:creationId xmlns:a16="http://schemas.microsoft.com/office/drawing/2014/main" id="{C14FCE28-2414-447F-88DF-3047C7FF7AAF}"/>
+                <a16:creationId xmlns:a16="http://schemas.microsoft.com/office/drawing/2014/main" id="{F7DF9538-2F3B-455A-A49B-82718CB6AE98}"/>
               </a:ext>
             </a:extLst>
           </p:cNvPr>
@@ -10536,7 +10536,7 @@
     </p:spTree>
     <p:extLst>
       <p:ext uri="{BB962C8B-B14F-4D97-AF65-F5344CB8AC3E}">
-        <p14:creationId xmlns:p14="http://schemas.microsoft.com/office/powerpoint/2010/main" val="1330142701"/>
+        <p14:creationId xmlns:p14="http://schemas.microsoft.com/office/powerpoint/2010/main" val="1036446004"/>
       </p:ext>
     </p:extLst>
   </p:cSld>
@@ -10567,7 +10567,7 @@
           <p:cNvPr id="1" name="">
             <a:extLst xmlns:a="http://schemas.openxmlformats.org/drawingml/2006/main">
               <a:ext uri="{FF2B5EF4-FFF2-40B4-BE49-F238E27FC236}">
-                <a16:creationId xmlns:a16="http://schemas.microsoft.com/office/drawing/2014/main" id="{8DA5A7C2-FB1C-4076-AF2E-ABF4D575C270}"/>
+                <a16:creationId xmlns:a16="http://schemas.microsoft.com/office/drawing/2014/main" id="{5E0FD171-A458-413F-AA48-A39824DC17BA}"/>
               </a:ext>
             </a:extLst>
           </p:cNvPr>
@@ -10600,7 +10600,7 @@
           <p:cNvPr id="2" name="">
             <a:extLst xmlns:a="http://schemas.openxmlformats.org/drawingml/2006/main">
               <a:ext uri="{FF2B5EF4-FFF2-40B4-BE49-F238E27FC236}">
-                <a16:creationId xmlns:a16="http://schemas.microsoft.com/office/drawing/2014/main" id="{23F2C2E7-090E-4497-B603-103842D0581A}"/>
+                <a16:creationId xmlns:a16="http://schemas.microsoft.com/office/drawing/2014/main" id="{0F76A65F-FE2F-4066-BB83-13442DE708BC}"/>
               </a:ext>
             </a:extLst>
           </p:cNvPr>
@@ -10633,7 +10633,7 @@
           <p:cNvPr id="3" name="">
             <a:extLst xmlns:a="http://schemas.openxmlformats.org/drawingml/2006/main">
               <a:ext uri="{FF2B5EF4-FFF2-40B4-BE49-F238E27FC236}">
-                <a16:creationId xmlns:a16="http://schemas.microsoft.com/office/drawing/2014/main" id="{0213C51A-3A94-4851-A425-2260C082068B}"/>
+                <a16:creationId xmlns:a16="http://schemas.microsoft.com/office/drawing/2014/main" id="{DDFD3F7A-2E77-44C8-A3D6-AA218F2BC7C3}"/>
               </a:ext>
             </a:extLst>
           </p:cNvPr>
@@ -10683,7 +10683,7 @@
           <p:cNvPr id="4" name="">
             <a:extLst xmlns:a="http://schemas.openxmlformats.org/drawingml/2006/main">
               <a:ext uri="{FF2B5EF4-FFF2-40B4-BE49-F238E27FC236}">
-                <a16:creationId xmlns:a16="http://schemas.microsoft.com/office/drawing/2014/main" id="{B426276A-8991-46A6-9EAE-0AE177DD10FC}"/>
+                <a16:creationId xmlns:a16="http://schemas.microsoft.com/office/drawing/2014/main" id="{C18FAD54-0537-4F34-A508-B72E32576E12}"/>
               </a:ext>
             </a:extLst>
           </p:cNvPr>
@@ -10733,7 +10733,7 @@
           <p:cNvPr id="5" name="">
             <a:extLst xmlns:a="http://schemas.openxmlformats.org/drawingml/2006/main">
               <a:ext uri="{FF2B5EF4-FFF2-40B4-BE49-F238E27FC236}">
-                <a16:creationId xmlns:a16="http://schemas.microsoft.com/office/drawing/2014/main" id="{672AE137-650D-4986-80FB-2857CCDB6C23}"/>
+                <a16:creationId xmlns:a16="http://schemas.microsoft.com/office/drawing/2014/main" id="{58A9FDEA-FB16-4A46-BC04-43B4BE2759D0}"/>
               </a:ext>
             </a:extLst>
           </p:cNvPr>
@@ -10768,7 +10768,7 @@
           <p:nvPr/>
         </p:nvPicPr>
         <p:blipFill>
-          <a:blip xmlns:r="http://schemas.openxmlformats.org/officeDocument/2006/relationships" xmlns:a="http://schemas.openxmlformats.org/drawingml/2006/main" r:embed="R51d92435c6ed4f77"/>
+          <a:blip xmlns:r="http://schemas.openxmlformats.org/officeDocument/2006/relationships" xmlns:a="http://schemas.openxmlformats.org/drawingml/2006/main" r:embed="R69e2d9f0778b4e57"/>
           <a:stretch xmlns:a="http://schemas.openxmlformats.org/drawingml/2006/main"/>
         </p:blipFill>
         <p:spPr>
@@ -10786,7 +10786,7 @@
           <p:cNvPr id="7" name="">
             <a:extLst xmlns:a="http://schemas.openxmlformats.org/drawingml/2006/main">
               <a:ext uri="{FF2B5EF4-FFF2-40B4-BE49-F238E27FC236}">
-                <a16:creationId xmlns:a16="http://schemas.microsoft.com/office/drawing/2014/main" id="{A4391D44-7B4C-465A-84FA-F1A1D2458B2F}"/>
+                <a16:creationId xmlns:a16="http://schemas.microsoft.com/office/drawing/2014/main" id="{AC062781-CBBD-4F1A-9B44-F1963BD4983D}"/>
               </a:ext>
             </a:extLst>
           </p:cNvPr>
@@ -10836,7 +10836,7 @@
           <p:cNvPr id="8" name="">
             <a:extLst xmlns:a="http://schemas.openxmlformats.org/drawingml/2006/main">
               <a:ext uri="{FF2B5EF4-FFF2-40B4-BE49-F238E27FC236}">
-                <a16:creationId xmlns:a16="http://schemas.microsoft.com/office/drawing/2014/main" id="{EB5510D9-9BA1-4CC6-A114-BB806BFD1BE2}"/>
+                <a16:creationId xmlns:a16="http://schemas.microsoft.com/office/drawing/2014/main" id="{961FB6E1-DB8E-4CF3-BD82-8A6A7FDE119B}"/>
               </a:ext>
             </a:extLst>
           </p:cNvPr>
@@ -10871,7 +10871,7 @@
           <p:cNvPr id="9" name="">
             <a:extLst xmlns:a="http://schemas.openxmlformats.org/drawingml/2006/main">
               <a:ext uri="{FF2B5EF4-FFF2-40B4-BE49-F238E27FC236}">
-                <a16:creationId xmlns:a16="http://schemas.microsoft.com/office/drawing/2014/main" id="{90BDEF0B-50CD-495C-B100-D104987D9B0D}"/>
+                <a16:creationId xmlns:a16="http://schemas.microsoft.com/office/drawing/2014/main" id="{A0FB8F0D-D978-4B65-9A8B-5D3029957C48}"/>
               </a:ext>
             </a:extLst>
           </p:cNvPr>
@@ -10921,7 +10921,7 @@
           <p:cNvPr id="10" name="">
             <a:extLst xmlns:a="http://schemas.openxmlformats.org/drawingml/2006/main">
               <a:ext uri="{FF2B5EF4-FFF2-40B4-BE49-F238E27FC236}">
-                <a16:creationId xmlns:a16="http://schemas.microsoft.com/office/drawing/2014/main" id="{CBF98CCC-F9A2-4CD6-BCFA-9BE9DBF41BAB}"/>
+                <a16:creationId xmlns:a16="http://schemas.microsoft.com/office/drawing/2014/main" id="{0D93E37D-063C-4C57-9ACD-BB4DE88E30FE}"/>
               </a:ext>
             </a:extLst>
           </p:cNvPr>
@@ -10971,7 +10971,7 @@
           <p:cNvPr id="11" name="">
             <a:extLst xmlns:a="http://schemas.openxmlformats.org/drawingml/2006/main">
               <a:ext uri="{FF2B5EF4-FFF2-40B4-BE49-F238E27FC236}">
-                <a16:creationId xmlns:a16="http://schemas.microsoft.com/office/drawing/2014/main" id="{D53B31D8-F177-4734-851A-D2A8D098FA3A}"/>
+                <a16:creationId xmlns:a16="http://schemas.microsoft.com/office/drawing/2014/main" id="{5CACC827-9DA5-4642-B152-258887D09D2E}"/>
               </a:ext>
             </a:extLst>
           </p:cNvPr>
@@ -11002,7 +11002,7 @@
           <p:cNvPr id="12" name="">
             <a:extLst xmlns:a="http://schemas.openxmlformats.org/drawingml/2006/main">
               <a:ext uri="{FF2B5EF4-FFF2-40B4-BE49-F238E27FC236}">
-                <a16:creationId xmlns:a16="http://schemas.microsoft.com/office/drawing/2014/main" id="{2C8D5B21-0A8C-41B7-8733-A72ADB542982}"/>
+                <a16:creationId xmlns:a16="http://schemas.microsoft.com/office/drawing/2014/main" id="{ED53651B-DE62-41FB-AA60-E61533A47295}"/>
               </a:ext>
             </a:extLst>
           </p:cNvPr>
@@ -11037,7 +11037,7 @@
           <p:cNvPr id="13" name="">
             <a:extLst xmlns:a="http://schemas.openxmlformats.org/drawingml/2006/main">
               <a:ext uri="{FF2B5EF4-FFF2-40B4-BE49-F238E27FC236}">
-                <a16:creationId xmlns:a16="http://schemas.microsoft.com/office/drawing/2014/main" id="{FF913F31-89DF-4F62-86AF-8D3EE3D7D67A}"/>
+                <a16:creationId xmlns:a16="http://schemas.microsoft.com/office/drawing/2014/main" id="{F91C2FCB-46B1-4F01-8609-875F5C199B89}"/>
               </a:ext>
             </a:extLst>
           </p:cNvPr>
@@ -11087,7 +11087,7 @@
           <p:cNvPr id="14" name="">
             <a:extLst xmlns:a="http://schemas.openxmlformats.org/drawingml/2006/main">
               <a:ext uri="{FF2B5EF4-FFF2-40B4-BE49-F238E27FC236}">
-                <a16:creationId xmlns:a16="http://schemas.microsoft.com/office/drawing/2014/main" id="{B164854F-17D4-41D5-843D-0AB8F1FE1DF6}"/>
+                <a16:creationId xmlns:a16="http://schemas.microsoft.com/office/drawing/2014/main" id="{FD430279-4D13-42A2-8FC4-6622FEF148EA}"/>
               </a:ext>
             </a:extLst>
           </p:cNvPr>
@@ -11137,7 +11137,7 @@
           <p:cNvPr id="15" name="">
             <a:extLst xmlns:a="http://schemas.openxmlformats.org/drawingml/2006/main">
               <a:ext uri="{FF2B5EF4-FFF2-40B4-BE49-F238E27FC236}">
-                <a16:creationId xmlns:a16="http://schemas.microsoft.com/office/drawing/2014/main" id="{1E31D654-9E73-4130-BF9E-027ED4BDA276}"/>
+                <a16:creationId xmlns:a16="http://schemas.microsoft.com/office/drawing/2014/main" id="{CED7EAA5-47F0-4F1A-B6A8-91254929424C}"/>
               </a:ext>
             </a:extLst>
           </p:cNvPr>
@@ -11168,7 +11168,7 @@
           <p:cNvPr id="16" name="">
             <a:extLst xmlns:a="http://schemas.openxmlformats.org/drawingml/2006/main">
               <a:ext uri="{FF2B5EF4-FFF2-40B4-BE49-F238E27FC236}">
-                <a16:creationId xmlns:a16="http://schemas.microsoft.com/office/drawing/2014/main" id="{694C451B-FBAA-468C-BB0C-0443F6F60D84}"/>
+                <a16:creationId xmlns:a16="http://schemas.microsoft.com/office/drawing/2014/main" id="{C31231BD-025E-4EE1-8C06-ECEE5BAE66CA}"/>
               </a:ext>
             </a:extLst>
           </p:cNvPr>
@@ -11203,7 +11203,7 @@
           <p:cNvPr id="17" name="">
             <a:extLst xmlns:a="http://schemas.openxmlformats.org/drawingml/2006/main">
               <a:ext uri="{FF2B5EF4-FFF2-40B4-BE49-F238E27FC236}">
-                <a16:creationId xmlns:a16="http://schemas.microsoft.com/office/drawing/2014/main" id="{1A2CD3BA-A424-4A9D-90E5-60B976915AA7}"/>
+                <a16:creationId xmlns:a16="http://schemas.microsoft.com/office/drawing/2014/main" id="{D88AAE40-E956-46E4-B57E-3696A73E87B0}"/>
               </a:ext>
             </a:extLst>
           </p:cNvPr>
@@ -11253,7 +11253,7 @@
           <p:cNvPr id="18" name="">
             <a:extLst xmlns:a="http://schemas.openxmlformats.org/drawingml/2006/main">
               <a:ext uri="{FF2B5EF4-FFF2-40B4-BE49-F238E27FC236}">
-                <a16:creationId xmlns:a16="http://schemas.microsoft.com/office/drawing/2014/main" id="{275D13DD-5054-4AD7-A75D-59B0DABC4E70}"/>
+                <a16:creationId xmlns:a16="http://schemas.microsoft.com/office/drawing/2014/main" id="{D1FF46B4-654D-4235-B756-D9025C2207E6}"/>
               </a:ext>
             </a:extLst>
           </p:cNvPr>
@@ -11303,7 +11303,7 @@
           <p:cNvPr id="19" name="">
             <a:extLst xmlns:a="http://schemas.openxmlformats.org/drawingml/2006/main">
               <a:ext uri="{FF2B5EF4-FFF2-40B4-BE49-F238E27FC236}">
-                <a16:creationId xmlns:a16="http://schemas.microsoft.com/office/drawing/2014/main" id="{6F317635-55B3-4F9D-B966-EC939CFC0271}"/>
+                <a16:creationId xmlns:a16="http://schemas.microsoft.com/office/drawing/2014/main" id="{A847A976-D751-4DF5-943D-8C2D360982E7}"/>
               </a:ext>
             </a:extLst>
           </p:cNvPr>
@@ -11334,7 +11334,7 @@
           <p:cNvPr id="20" name="">
             <a:extLst xmlns:a="http://schemas.openxmlformats.org/drawingml/2006/main">
               <a:ext uri="{FF2B5EF4-FFF2-40B4-BE49-F238E27FC236}">
-                <a16:creationId xmlns:a16="http://schemas.microsoft.com/office/drawing/2014/main" id="{53A334BA-6DC5-42C0-A2BD-3FCBF05DE5F0}"/>
+                <a16:creationId xmlns:a16="http://schemas.microsoft.com/office/drawing/2014/main" id="{8F349037-D63C-4174-8785-BF8202011C36}"/>
               </a:ext>
             </a:extLst>
           </p:cNvPr>
@@ -11369,7 +11369,7 @@
           <p:cNvPr id="21" name="">
             <a:extLst xmlns:a="http://schemas.openxmlformats.org/drawingml/2006/main">
               <a:ext uri="{FF2B5EF4-FFF2-40B4-BE49-F238E27FC236}">
-                <a16:creationId xmlns:a16="http://schemas.microsoft.com/office/drawing/2014/main" id="{ACEE8870-4ED1-4759-942D-DE39894F942E}"/>
+                <a16:creationId xmlns:a16="http://schemas.microsoft.com/office/drawing/2014/main" id="{EA6EB88B-C029-4DFA-9C9A-41EE74487705}"/>
               </a:ext>
             </a:extLst>
           </p:cNvPr>
@@ -11419,7 +11419,7 @@
           <p:cNvPr id="22" name="">
             <a:extLst xmlns:a="http://schemas.openxmlformats.org/drawingml/2006/main">
               <a:ext uri="{FF2B5EF4-FFF2-40B4-BE49-F238E27FC236}">
-                <a16:creationId xmlns:a16="http://schemas.microsoft.com/office/drawing/2014/main" id="{4BA3474A-B779-4E57-8EDD-86367D0F91B6}"/>
+                <a16:creationId xmlns:a16="http://schemas.microsoft.com/office/drawing/2014/main" id="{769CF140-5A4D-4632-B7E1-F2BF259B674B}"/>
               </a:ext>
             </a:extLst>
           </p:cNvPr>
@@ -11469,7 +11469,7 @@
           <p:cNvPr id="23" name="">
             <a:extLst xmlns:a="http://schemas.openxmlformats.org/drawingml/2006/main">
               <a:ext uri="{FF2B5EF4-FFF2-40B4-BE49-F238E27FC236}">
-                <a16:creationId xmlns:a16="http://schemas.microsoft.com/office/drawing/2014/main" id="{030B0DBE-EA4F-4E7E-92DE-D7878E0CAACB}"/>
+                <a16:creationId xmlns:a16="http://schemas.microsoft.com/office/drawing/2014/main" id="{8CE2E20F-D2AF-41CD-A994-2EC25B1FEE87}"/>
               </a:ext>
             </a:extLst>
           </p:cNvPr>
@@ -11500,7 +11500,7 @@
           <p:cNvPr id="24" name="">
             <a:extLst xmlns:a="http://schemas.openxmlformats.org/drawingml/2006/main">
               <a:ext uri="{FF2B5EF4-FFF2-40B4-BE49-F238E27FC236}">
-                <a16:creationId xmlns:a16="http://schemas.microsoft.com/office/drawing/2014/main" id="{143109E8-E166-4C2C-B96D-81CCD2EF7F22}"/>
+                <a16:creationId xmlns:a16="http://schemas.microsoft.com/office/drawing/2014/main" id="{11C8D66F-2160-4A87-AE82-749143390DB1}"/>
               </a:ext>
             </a:extLst>
           </p:cNvPr>
@@ -11535,7 +11535,7 @@
           <p:cNvPr id="25" name="">
             <a:extLst xmlns:a="http://schemas.openxmlformats.org/drawingml/2006/main">
               <a:ext uri="{FF2B5EF4-FFF2-40B4-BE49-F238E27FC236}">
-                <a16:creationId xmlns:a16="http://schemas.microsoft.com/office/drawing/2014/main" id="{4BAE1FAD-8D32-4155-B842-7CAB14E3AF22}"/>
+                <a16:creationId xmlns:a16="http://schemas.microsoft.com/office/drawing/2014/main" id="{8647A2FB-C285-4161-9F35-A2E8927B0583}"/>
               </a:ext>
             </a:extLst>
           </p:cNvPr>
@@ -11585,7 +11585,7 @@
           <p:cNvPr id="26" name="">
             <a:extLst xmlns:a="http://schemas.openxmlformats.org/drawingml/2006/main">
               <a:ext uri="{FF2B5EF4-FFF2-40B4-BE49-F238E27FC236}">
-                <a16:creationId xmlns:a16="http://schemas.microsoft.com/office/drawing/2014/main" id="{B466A466-D3EF-4A31-8ED0-924969DF0FFA}"/>
+                <a16:creationId xmlns:a16="http://schemas.microsoft.com/office/drawing/2014/main" id="{82F951BC-DC17-42B2-B810-80B725FF8FE7}"/>
               </a:ext>
             </a:extLst>
           </p:cNvPr>
@@ -11635,7 +11635,7 @@
           <p:cNvPr id="27" name="">
             <a:extLst xmlns:a="http://schemas.openxmlformats.org/drawingml/2006/main">
               <a:ext uri="{FF2B5EF4-FFF2-40B4-BE49-F238E27FC236}">
-                <a16:creationId xmlns:a16="http://schemas.microsoft.com/office/drawing/2014/main" id="{0AEB0BFA-D5D9-4D68-BD76-6F02D185D357}"/>
+                <a16:creationId xmlns:a16="http://schemas.microsoft.com/office/drawing/2014/main" id="{91BF9D92-F8DE-4582-B76C-B7F254DBF275}"/>
               </a:ext>
             </a:extLst>
           </p:cNvPr>
@@ -11685,7 +11685,7 @@
           <p:cNvPr id="28" name="">
             <a:extLst xmlns:a="http://schemas.openxmlformats.org/drawingml/2006/main">
               <a:ext uri="{FF2B5EF4-FFF2-40B4-BE49-F238E27FC236}">
-                <a16:creationId xmlns:a16="http://schemas.microsoft.com/office/drawing/2014/main" id="{406D5A6F-8A0C-4900-8835-5E3372786A11}"/>
+                <a16:creationId xmlns:a16="http://schemas.microsoft.com/office/drawing/2014/main" id="{6C450979-B913-40A2-BE61-4FB6F35B3A62}"/>
               </a:ext>
             </a:extLst>
           </p:cNvPr>
@@ -11733,7 +11733,7 @@
     </p:spTree>
     <p:extLst>
       <p:ext uri="{BB962C8B-B14F-4D97-AF65-F5344CB8AC3E}">
-        <p14:creationId xmlns:p14="http://schemas.microsoft.com/office/powerpoint/2010/main" val="1732699640"/>
+        <p14:creationId xmlns:p14="http://schemas.microsoft.com/office/powerpoint/2010/main" val="174009506"/>
       </p:ext>
     </p:extLst>
   </p:cSld>
@@ -11764,7 +11764,7 @@
           <p:cNvPr id="1" name="">
             <a:extLst xmlns:a="http://schemas.openxmlformats.org/drawingml/2006/main">
               <a:ext uri="{FF2B5EF4-FFF2-40B4-BE49-F238E27FC236}">
-                <a16:creationId xmlns:a16="http://schemas.microsoft.com/office/drawing/2014/main" id="{60283470-292B-49CD-9CFE-08A58B214D01}"/>
+                <a16:creationId xmlns:a16="http://schemas.microsoft.com/office/drawing/2014/main" id="{DA11C064-D715-42C5-A206-70E80E1E99B2}"/>
               </a:ext>
             </a:extLst>
           </p:cNvPr>
@@ -11797,7 +11797,7 @@
           <p:cNvPr id="2" name="">
             <a:extLst xmlns:a="http://schemas.openxmlformats.org/drawingml/2006/main">
               <a:ext uri="{FF2B5EF4-FFF2-40B4-BE49-F238E27FC236}">
-                <a16:creationId xmlns:a16="http://schemas.microsoft.com/office/drawing/2014/main" id="{709E2E98-CD9F-4E2D-B8AC-2F7078B28F3E}"/>
+                <a16:creationId xmlns:a16="http://schemas.microsoft.com/office/drawing/2014/main" id="{31F35BEF-E823-412C-ACF1-013E0AD8D802}"/>
               </a:ext>
             </a:extLst>
           </p:cNvPr>
@@ -11830,7 +11830,7 @@
           <p:cNvPr id="3" name="">
             <a:extLst xmlns:a="http://schemas.openxmlformats.org/drawingml/2006/main">
               <a:ext uri="{FF2B5EF4-FFF2-40B4-BE49-F238E27FC236}">
-                <a16:creationId xmlns:a16="http://schemas.microsoft.com/office/drawing/2014/main" id="{258F7EBE-0821-475A-9891-0B263CAD5E5B}"/>
+                <a16:creationId xmlns:a16="http://schemas.microsoft.com/office/drawing/2014/main" id="{0C989340-2A38-467F-BD61-9C0BC57BBC6F}"/>
               </a:ext>
             </a:extLst>
           </p:cNvPr>
@@ -11880,7 +11880,7 @@
           <p:cNvPr id="4" name="">
             <a:extLst xmlns:a="http://schemas.openxmlformats.org/drawingml/2006/main">
               <a:ext uri="{FF2B5EF4-FFF2-40B4-BE49-F238E27FC236}">
-                <a16:creationId xmlns:a16="http://schemas.microsoft.com/office/drawing/2014/main" id="{B528C6C0-BF13-4053-84D4-57970E542F0D}"/>
+                <a16:creationId xmlns:a16="http://schemas.microsoft.com/office/drawing/2014/main" id="{21A3DC5A-2F27-4762-9846-9F63815E9065}"/>
               </a:ext>
             </a:extLst>
           </p:cNvPr>
@@ -11930,7 +11930,7 @@
           <p:cNvPr id="5" name="">
             <a:extLst xmlns:a="http://schemas.openxmlformats.org/drawingml/2006/main">
               <a:ext uri="{FF2B5EF4-FFF2-40B4-BE49-F238E27FC236}">
-                <a16:creationId xmlns:a16="http://schemas.microsoft.com/office/drawing/2014/main" id="{A7D54B2F-E563-4BEB-AF32-21848E94BE63}"/>
+                <a16:creationId xmlns:a16="http://schemas.microsoft.com/office/drawing/2014/main" id="{416C480C-6C5D-4148-94D5-90676AA04C69}"/>
               </a:ext>
             </a:extLst>
           </p:cNvPr>
@@ -11965,7 +11965,7 @@
           <p:nvPr/>
         </p:nvPicPr>
         <p:blipFill>
-          <a:blip xmlns:r="http://schemas.openxmlformats.org/officeDocument/2006/relationships" xmlns:a="http://schemas.openxmlformats.org/drawingml/2006/main" r:embed="R86b89b5e135142dc"/>
+          <a:blip xmlns:r="http://schemas.openxmlformats.org/officeDocument/2006/relationships" xmlns:a="http://schemas.openxmlformats.org/drawingml/2006/main" r:embed="R280e0b96cb424a36"/>
           <a:stretch xmlns:a="http://schemas.openxmlformats.org/drawingml/2006/main"/>
         </p:blipFill>
         <p:spPr>
@@ -11983,7 +11983,7 @@
           <p:cNvPr id="7" name="">
             <a:extLst xmlns:a="http://schemas.openxmlformats.org/drawingml/2006/main">
               <a:ext uri="{FF2B5EF4-FFF2-40B4-BE49-F238E27FC236}">
-                <a16:creationId xmlns:a16="http://schemas.microsoft.com/office/drawing/2014/main" id="{38ED9347-45BC-4DFA-9C24-D71F83EC9A59}"/>
+                <a16:creationId xmlns:a16="http://schemas.microsoft.com/office/drawing/2014/main" id="{D5435E09-1113-41C8-8E40-4A72E8F25682}"/>
               </a:ext>
             </a:extLst>
           </p:cNvPr>
@@ -12016,7 +12016,7 @@
           <p:cNvPr id="8" name="">
             <a:extLst xmlns:a="http://schemas.openxmlformats.org/drawingml/2006/main">
               <a:ext uri="{FF2B5EF4-FFF2-40B4-BE49-F238E27FC236}">
-                <a16:creationId xmlns:a16="http://schemas.microsoft.com/office/drawing/2014/main" id="{CDF34749-66F8-46FD-8FDC-6C62206CCB3C}"/>
+                <a16:creationId xmlns:a16="http://schemas.microsoft.com/office/drawing/2014/main" id="{499A48D9-8B4A-4E76-B498-D7743F6DBA2C}"/>
               </a:ext>
             </a:extLst>
           </p:cNvPr>
@@ -12066,7 +12066,7 @@
           <p:cNvPr id="9" name="">
             <a:extLst xmlns:a="http://schemas.openxmlformats.org/drawingml/2006/main">
               <a:ext uri="{FF2B5EF4-FFF2-40B4-BE49-F238E27FC236}">
-                <a16:creationId xmlns:a16="http://schemas.microsoft.com/office/drawing/2014/main" id="{6E1161EC-A850-45D2-AC32-23025396254B}"/>
+                <a16:creationId xmlns:a16="http://schemas.microsoft.com/office/drawing/2014/main" id="{58AE3A95-3389-4CF5-B3B4-056681C2BE4B}"/>
               </a:ext>
             </a:extLst>
           </p:cNvPr>
@@ -12099,7 +12099,7 @@
           <p:cNvPr id="10" name="">
             <a:extLst xmlns:a="http://schemas.openxmlformats.org/drawingml/2006/main">
               <a:ext uri="{FF2B5EF4-FFF2-40B4-BE49-F238E27FC236}">
-                <a16:creationId xmlns:a16="http://schemas.microsoft.com/office/drawing/2014/main" id="{BC9B4D25-A6AA-4F59-BE52-494414900121}"/>
+                <a16:creationId xmlns:a16="http://schemas.microsoft.com/office/drawing/2014/main" id="{81095831-9628-4A01-8AA3-BCC42ECF0C50}"/>
               </a:ext>
             </a:extLst>
           </p:cNvPr>
@@ -12149,7 +12149,7 @@
           <p:cNvPr id="11" name="">
             <a:extLst xmlns:a="http://schemas.openxmlformats.org/drawingml/2006/main">
               <a:ext uri="{FF2B5EF4-FFF2-40B4-BE49-F238E27FC236}">
-                <a16:creationId xmlns:a16="http://schemas.microsoft.com/office/drawing/2014/main" id="{C3143351-0A98-4464-BBD5-8AAB114572E0}"/>
+                <a16:creationId xmlns:a16="http://schemas.microsoft.com/office/drawing/2014/main" id="{7FE1E453-EB7A-41F5-A024-1999C4711BB5}"/>
               </a:ext>
             </a:extLst>
           </p:cNvPr>
@@ -12182,7 +12182,7 @@
           <p:cNvPr id="12" name="">
             <a:extLst xmlns:a="http://schemas.openxmlformats.org/drawingml/2006/main">
               <a:ext uri="{FF2B5EF4-FFF2-40B4-BE49-F238E27FC236}">
-                <a16:creationId xmlns:a16="http://schemas.microsoft.com/office/drawing/2014/main" id="{0D0AE85E-1710-4E07-9746-7E265FB94AAE}"/>
+                <a16:creationId xmlns:a16="http://schemas.microsoft.com/office/drawing/2014/main" id="{62FB2D8E-B707-4F8F-939D-07628CD2B0AB}"/>
               </a:ext>
             </a:extLst>
           </p:cNvPr>
@@ -12232,7 +12232,7 @@
           <p:cNvPr id="13" name="">
             <a:extLst xmlns:a="http://schemas.openxmlformats.org/drawingml/2006/main">
               <a:ext uri="{FF2B5EF4-FFF2-40B4-BE49-F238E27FC236}">
-                <a16:creationId xmlns:a16="http://schemas.microsoft.com/office/drawing/2014/main" id="{C3129A9E-9C3D-46B5-B8F2-35FC88A0B157}"/>
+                <a16:creationId xmlns:a16="http://schemas.microsoft.com/office/drawing/2014/main" id="{66990577-3127-41E9-B74C-0484DB38DEAE}"/>
               </a:ext>
             </a:extLst>
           </p:cNvPr>
@@ -12265,7 +12265,7 @@
           <p:cNvPr id="14" name="">
             <a:extLst xmlns:a="http://schemas.openxmlformats.org/drawingml/2006/main">
               <a:ext uri="{FF2B5EF4-FFF2-40B4-BE49-F238E27FC236}">
-                <a16:creationId xmlns:a16="http://schemas.microsoft.com/office/drawing/2014/main" id="{1896AB25-9CED-4944-AA72-3763D2D6DC99}"/>
+                <a16:creationId xmlns:a16="http://schemas.microsoft.com/office/drawing/2014/main" id="{C5FD93AD-73DF-4360-9A56-94546C1EC2E8}"/>
               </a:ext>
             </a:extLst>
           </p:cNvPr>
@@ -12315,7 +12315,7 @@
           <p:cNvPr id="15" name="">
             <a:extLst xmlns:a="http://schemas.openxmlformats.org/drawingml/2006/main">
               <a:ext uri="{FF2B5EF4-FFF2-40B4-BE49-F238E27FC236}">
-                <a16:creationId xmlns:a16="http://schemas.microsoft.com/office/drawing/2014/main" id="{60223CE3-ACBB-4C36-8523-78E1DFECCED5}"/>
+                <a16:creationId xmlns:a16="http://schemas.microsoft.com/office/drawing/2014/main" id="{8D2753DB-928B-49F3-BCBD-99B0C3088FBF}"/>
               </a:ext>
             </a:extLst>
           </p:cNvPr>
@@ -12348,7 +12348,7 @@
           <p:cNvPr id="16" name="">
             <a:extLst xmlns:a="http://schemas.openxmlformats.org/drawingml/2006/main">
               <a:ext uri="{FF2B5EF4-FFF2-40B4-BE49-F238E27FC236}">
-                <a16:creationId xmlns:a16="http://schemas.microsoft.com/office/drawing/2014/main" id="{AEBB6A7E-B118-46EB-9EC4-1FDC566BB7D7}"/>
+                <a16:creationId xmlns:a16="http://schemas.microsoft.com/office/drawing/2014/main" id="{4918B13C-8862-4A04-90D3-42B4E86D7B63}"/>
               </a:ext>
             </a:extLst>
           </p:cNvPr>
@@ -12398,7 +12398,7 @@
           <p:cNvPr id="17" name="">
             <a:extLst xmlns:a="http://schemas.openxmlformats.org/drawingml/2006/main">
               <a:ext uri="{FF2B5EF4-FFF2-40B4-BE49-F238E27FC236}">
-                <a16:creationId xmlns:a16="http://schemas.microsoft.com/office/drawing/2014/main" id="{633A07FB-15DB-4DE6-BD7A-12FED557C968}"/>
+                <a16:creationId xmlns:a16="http://schemas.microsoft.com/office/drawing/2014/main" id="{E8C7BA56-A8DE-4788-A63F-630DCC9F3C2A}"/>
               </a:ext>
             </a:extLst>
           </p:cNvPr>
@@ -12433,7 +12433,7 @@
           <p:cNvPr id="18" name="">
             <a:extLst xmlns:a="http://schemas.openxmlformats.org/drawingml/2006/main">
               <a:ext uri="{FF2B5EF4-FFF2-40B4-BE49-F238E27FC236}">
-                <a16:creationId xmlns:a16="http://schemas.microsoft.com/office/drawing/2014/main" id="{53768027-A3E4-4225-B01B-2D70F4953E18}"/>
+                <a16:creationId xmlns:a16="http://schemas.microsoft.com/office/drawing/2014/main" id="{56E05323-0D81-42B9-BD11-14340A09B117}"/>
               </a:ext>
             </a:extLst>
           </p:cNvPr>
@@ -12483,7 +12483,7 @@
           <p:cNvPr id="19" name="">
             <a:extLst xmlns:a="http://schemas.openxmlformats.org/drawingml/2006/main">
               <a:ext uri="{FF2B5EF4-FFF2-40B4-BE49-F238E27FC236}">
-                <a16:creationId xmlns:a16="http://schemas.microsoft.com/office/drawing/2014/main" id="{BAFD1000-366C-415F-816B-E0F8096B6575}"/>
+                <a16:creationId xmlns:a16="http://schemas.microsoft.com/office/drawing/2014/main" id="{4EC21EF7-0F2C-4BC9-98C0-E810FF044592}"/>
               </a:ext>
             </a:extLst>
           </p:cNvPr>
@@ -12531,7 +12531,7 @@
     </p:spTree>
     <p:extLst>
       <p:ext uri="{BB962C8B-B14F-4D97-AF65-F5344CB8AC3E}">
-        <p14:creationId xmlns:p14="http://schemas.microsoft.com/office/powerpoint/2010/main" val="597662230"/>
+        <p14:creationId xmlns:p14="http://schemas.microsoft.com/office/powerpoint/2010/main" val="23015533"/>
       </p:ext>
     </p:extLst>
   </p:cSld>
@@ -12562,7 +12562,7 @@
           <p:cNvPr id="1" name="">
             <a:extLst xmlns:a="http://schemas.openxmlformats.org/drawingml/2006/main">
               <a:ext uri="{FF2B5EF4-FFF2-40B4-BE49-F238E27FC236}">
-                <a16:creationId xmlns:a16="http://schemas.microsoft.com/office/drawing/2014/main" id="{34ADFBB4-C902-4BA2-B506-72E7C6FE2FFF}"/>
+                <a16:creationId xmlns:a16="http://schemas.microsoft.com/office/drawing/2014/main" id="{8E485FAF-780D-480E-B747-4DF764ACDE28}"/>
               </a:ext>
             </a:extLst>
           </p:cNvPr>
@@ -12595,7 +12595,7 @@
           <p:cNvPr id="2" name="">
             <a:extLst xmlns:a="http://schemas.openxmlformats.org/drawingml/2006/main">
               <a:ext uri="{FF2B5EF4-FFF2-40B4-BE49-F238E27FC236}">
-                <a16:creationId xmlns:a16="http://schemas.microsoft.com/office/drawing/2014/main" id="{6F5F480F-1DFD-474A-906B-0DF08336B234}"/>
+                <a16:creationId xmlns:a16="http://schemas.microsoft.com/office/drawing/2014/main" id="{353CCD51-9E6E-4E50-AD49-468F38999F77}"/>
               </a:ext>
             </a:extLst>
           </p:cNvPr>
@@ -12628,7 +12628,7 @@
           <p:cNvPr id="3" name="">
             <a:extLst xmlns:a="http://schemas.openxmlformats.org/drawingml/2006/main">
               <a:ext uri="{FF2B5EF4-FFF2-40B4-BE49-F238E27FC236}">
-                <a16:creationId xmlns:a16="http://schemas.microsoft.com/office/drawing/2014/main" id="{25D11561-9383-42AD-B17D-FF0E1E09F894}"/>
+                <a16:creationId xmlns:a16="http://schemas.microsoft.com/office/drawing/2014/main" id="{5D6201A7-A131-440D-88EE-38C049430B6F}"/>
               </a:ext>
             </a:extLst>
           </p:cNvPr>
@@ -12678,7 +12678,7 @@
           <p:cNvPr id="4" name="">
             <a:extLst xmlns:a="http://schemas.openxmlformats.org/drawingml/2006/main">
               <a:ext uri="{FF2B5EF4-FFF2-40B4-BE49-F238E27FC236}">
-                <a16:creationId xmlns:a16="http://schemas.microsoft.com/office/drawing/2014/main" id="{E2FF3ECE-94EA-42D5-9410-109268E29107}"/>
+                <a16:creationId xmlns:a16="http://schemas.microsoft.com/office/drawing/2014/main" id="{58E06EDC-B27F-4428-9637-4EC3E9E768CC}"/>
               </a:ext>
             </a:extLst>
           </p:cNvPr>
@@ -12728,7 +12728,7 @@
           <p:cNvPr id="5" name="">
             <a:extLst xmlns:a="http://schemas.openxmlformats.org/drawingml/2006/main">
               <a:ext uri="{FF2B5EF4-FFF2-40B4-BE49-F238E27FC236}">
-                <a16:creationId xmlns:a16="http://schemas.microsoft.com/office/drawing/2014/main" id="{1E469240-2AE6-4F10-A31C-FD13FCFDF173}"/>
+                <a16:creationId xmlns:a16="http://schemas.microsoft.com/office/drawing/2014/main" id="{27A6D4FC-D682-4BD6-8B34-C69F96955296}"/>
               </a:ext>
             </a:extLst>
           </p:cNvPr>
@@ -12763,7 +12763,7 @@
           <p:nvPr/>
         </p:nvPicPr>
         <p:blipFill>
-          <a:blip xmlns:r="http://schemas.openxmlformats.org/officeDocument/2006/relationships" xmlns:a="http://schemas.openxmlformats.org/drawingml/2006/main" r:embed="Rb06d54a2c1254e6a"/>
+          <a:blip xmlns:r="http://schemas.openxmlformats.org/officeDocument/2006/relationships" xmlns:a="http://schemas.openxmlformats.org/drawingml/2006/main" r:embed="R026013f6129443ad"/>
           <a:stretch xmlns:a="http://schemas.openxmlformats.org/drawingml/2006/main"/>
         </p:blipFill>
         <p:spPr>
@@ -12781,7 +12781,7 @@
           <p:cNvPr id="7" name="">
             <a:extLst xmlns:a="http://schemas.openxmlformats.org/drawingml/2006/main">
               <a:ext uri="{FF2B5EF4-FFF2-40B4-BE49-F238E27FC236}">
-                <a16:creationId xmlns:a16="http://schemas.microsoft.com/office/drawing/2014/main" id="{E792E57A-103F-4620-924B-812412FCC43D}"/>
+                <a16:creationId xmlns:a16="http://schemas.microsoft.com/office/drawing/2014/main" id="{3500F6A5-ED30-4606-8327-C5A67BA0D340}"/>
               </a:ext>
             </a:extLst>
           </p:cNvPr>
@@ -12816,7 +12816,7 @@
           <p:cNvPr id="8" name="">
             <a:extLst xmlns:a="http://schemas.openxmlformats.org/drawingml/2006/main">
               <a:ext uri="{FF2B5EF4-FFF2-40B4-BE49-F238E27FC236}">
-                <a16:creationId xmlns:a16="http://schemas.microsoft.com/office/drawing/2014/main" id="{1576EA47-F7E8-47E9-A0F2-4BF253668A47}"/>
+                <a16:creationId xmlns:a16="http://schemas.microsoft.com/office/drawing/2014/main" id="{D6F9D275-4979-4001-91FB-05ABD33A51A6}"/>
               </a:ext>
             </a:extLst>
           </p:cNvPr>
@@ -12866,7 +12866,7 @@
           <p:cNvPr id="9" name="">
             <a:extLst xmlns:a="http://schemas.openxmlformats.org/drawingml/2006/main">
               <a:ext uri="{FF2B5EF4-FFF2-40B4-BE49-F238E27FC236}">
-                <a16:creationId xmlns:a16="http://schemas.microsoft.com/office/drawing/2014/main" id="{CF76EE43-34E5-4519-BCEE-484DFA9433E7}"/>
+                <a16:creationId xmlns:a16="http://schemas.microsoft.com/office/drawing/2014/main" id="{31F57949-D9E4-4A57-B354-09D72AD136E0}"/>
               </a:ext>
             </a:extLst>
           </p:cNvPr>
@@ -12916,7 +12916,7 @@
           <p:cNvPr id="10" name="">
             <a:extLst xmlns:a="http://schemas.openxmlformats.org/drawingml/2006/main">
               <a:ext uri="{FF2B5EF4-FFF2-40B4-BE49-F238E27FC236}">
-                <a16:creationId xmlns:a16="http://schemas.microsoft.com/office/drawing/2014/main" id="{FAAD6F53-CC75-4FB8-A1D0-A96F25693058}"/>
+                <a16:creationId xmlns:a16="http://schemas.microsoft.com/office/drawing/2014/main" id="{75A8178B-E988-400E-B1AC-0105FBA57426}"/>
               </a:ext>
             </a:extLst>
           </p:cNvPr>
@@ -12947,7 +12947,7 @@
           <p:cNvPr id="11" name="">
             <a:extLst xmlns:a="http://schemas.openxmlformats.org/drawingml/2006/main">
               <a:ext uri="{FF2B5EF4-FFF2-40B4-BE49-F238E27FC236}">
-                <a16:creationId xmlns:a16="http://schemas.microsoft.com/office/drawing/2014/main" id="{516C24AE-E1C9-4F31-B177-22080CE3C42A}"/>
+                <a16:creationId xmlns:a16="http://schemas.microsoft.com/office/drawing/2014/main" id="{69A20975-3CFF-47A8-B976-CEEC7F56D640}"/>
               </a:ext>
             </a:extLst>
           </p:cNvPr>
@@ -12982,7 +12982,7 @@
           <p:cNvPr id="12" name="">
             <a:extLst xmlns:a="http://schemas.openxmlformats.org/drawingml/2006/main">
               <a:ext uri="{FF2B5EF4-FFF2-40B4-BE49-F238E27FC236}">
-                <a16:creationId xmlns:a16="http://schemas.microsoft.com/office/drawing/2014/main" id="{1B2E6625-C132-4043-9302-88C840071F37}"/>
+                <a16:creationId xmlns:a16="http://schemas.microsoft.com/office/drawing/2014/main" id="{A8544DAA-4A0A-4622-A26D-29CD82254974}"/>
               </a:ext>
             </a:extLst>
           </p:cNvPr>
@@ -13032,7 +13032,7 @@
           <p:cNvPr id="13" name="">
             <a:extLst xmlns:a="http://schemas.openxmlformats.org/drawingml/2006/main">
               <a:ext uri="{FF2B5EF4-FFF2-40B4-BE49-F238E27FC236}">
-                <a16:creationId xmlns:a16="http://schemas.microsoft.com/office/drawing/2014/main" id="{4660FADD-9BB1-4CD0-BB15-569B1B9CC6E4}"/>
+                <a16:creationId xmlns:a16="http://schemas.microsoft.com/office/drawing/2014/main" id="{645FBFFE-F897-4846-9ACE-666053F6E2C2}"/>
               </a:ext>
             </a:extLst>
           </p:cNvPr>
@@ -13082,7 +13082,7 @@
           <p:cNvPr id="14" name="">
             <a:extLst xmlns:a="http://schemas.openxmlformats.org/drawingml/2006/main">
               <a:ext uri="{FF2B5EF4-FFF2-40B4-BE49-F238E27FC236}">
-                <a16:creationId xmlns:a16="http://schemas.microsoft.com/office/drawing/2014/main" id="{29C29CC3-3205-4F6D-8EC3-0E15AF348BFF}"/>
+                <a16:creationId xmlns:a16="http://schemas.microsoft.com/office/drawing/2014/main" id="{5A11F6E9-D500-4B34-BF5C-B0E9199933CD}"/>
               </a:ext>
             </a:extLst>
           </p:cNvPr>
@@ -13113,7 +13113,7 @@
           <p:cNvPr id="15" name="">
             <a:extLst xmlns:a="http://schemas.openxmlformats.org/drawingml/2006/main">
               <a:ext uri="{FF2B5EF4-FFF2-40B4-BE49-F238E27FC236}">
-                <a16:creationId xmlns:a16="http://schemas.microsoft.com/office/drawing/2014/main" id="{382DA622-9545-47C2-85FB-782F087C95B1}"/>
+                <a16:creationId xmlns:a16="http://schemas.microsoft.com/office/drawing/2014/main" id="{3C03D2CE-0C40-4AE8-A870-8F01150C1E74}"/>
               </a:ext>
             </a:extLst>
           </p:cNvPr>
@@ -13148,7 +13148,7 @@
           <p:cNvPr id="16" name="">
             <a:extLst xmlns:a="http://schemas.openxmlformats.org/drawingml/2006/main">
               <a:ext uri="{FF2B5EF4-FFF2-40B4-BE49-F238E27FC236}">
-                <a16:creationId xmlns:a16="http://schemas.microsoft.com/office/drawing/2014/main" id="{515560DC-FE87-42E4-AF97-29CF5324FC0C}"/>
+                <a16:creationId xmlns:a16="http://schemas.microsoft.com/office/drawing/2014/main" id="{8AC7C5C6-6175-4967-8CAA-FA28ADD0113B}"/>
               </a:ext>
             </a:extLst>
           </p:cNvPr>
@@ -13198,7 +13198,7 @@
           <p:cNvPr id="17" name="">
             <a:extLst xmlns:a="http://schemas.openxmlformats.org/drawingml/2006/main">
               <a:ext uri="{FF2B5EF4-FFF2-40B4-BE49-F238E27FC236}">
-                <a16:creationId xmlns:a16="http://schemas.microsoft.com/office/drawing/2014/main" id="{1F50BB66-F55E-41EB-B830-C70E602A3D76}"/>
+                <a16:creationId xmlns:a16="http://schemas.microsoft.com/office/drawing/2014/main" id="{AF5B467D-0A34-4061-AF7A-8C83B180C633}"/>
               </a:ext>
             </a:extLst>
           </p:cNvPr>
@@ -13248,7 +13248,7 @@
           <p:cNvPr id="18" name="">
             <a:extLst xmlns:a="http://schemas.openxmlformats.org/drawingml/2006/main">
               <a:ext uri="{FF2B5EF4-FFF2-40B4-BE49-F238E27FC236}">
-                <a16:creationId xmlns:a16="http://schemas.microsoft.com/office/drawing/2014/main" id="{9691F4B6-5E90-437C-8FE0-1FAC1AAC2F7F}"/>
+                <a16:creationId xmlns:a16="http://schemas.microsoft.com/office/drawing/2014/main" id="{453183F3-E23F-4259-9A2B-55FAC4FF0354}"/>
               </a:ext>
             </a:extLst>
           </p:cNvPr>
@@ -13279,7 +13279,7 @@
           <p:cNvPr id="19" name="">
             <a:extLst xmlns:a="http://schemas.openxmlformats.org/drawingml/2006/main">
               <a:ext uri="{FF2B5EF4-FFF2-40B4-BE49-F238E27FC236}">
-                <a16:creationId xmlns:a16="http://schemas.microsoft.com/office/drawing/2014/main" id="{FDB129BB-DA89-4C5B-BC09-C491AFE7460A}"/>
+                <a16:creationId xmlns:a16="http://schemas.microsoft.com/office/drawing/2014/main" id="{26115274-0603-4ACB-BBF0-782DC3BFC4EA}"/>
               </a:ext>
             </a:extLst>
           </p:cNvPr>
@@ -13314,7 +13314,7 @@
           <p:cNvPr id="20" name="">
             <a:extLst xmlns:a="http://schemas.openxmlformats.org/drawingml/2006/main">
               <a:ext uri="{FF2B5EF4-FFF2-40B4-BE49-F238E27FC236}">
-                <a16:creationId xmlns:a16="http://schemas.microsoft.com/office/drawing/2014/main" id="{9FFC3524-44F7-4D0B-AA7A-25EFA56B6CE5}"/>
+                <a16:creationId xmlns:a16="http://schemas.microsoft.com/office/drawing/2014/main" id="{5F6032B0-C216-4994-8881-43B084512660}"/>
               </a:ext>
             </a:extLst>
           </p:cNvPr>
@@ -13364,7 +13364,7 @@
           <p:cNvPr id="21" name="">
             <a:extLst xmlns:a="http://schemas.openxmlformats.org/drawingml/2006/main">
               <a:ext uri="{FF2B5EF4-FFF2-40B4-BE49-F238E27FC236}">
-                <a16:creationId xmlns:a16="http://schemas.microsoft.com/office/drawing/2014/main" id="{959C816B-8591-46C5-9E21-F61721130574}"/>
+                <a16:creationId xmlns:a16="http://schemas.microsoft.com/office/drawing/2014/main" id="{0321481D-EB22-44F8-B7F1-CF5A0A7A5495}"/>
               </a:ext>
             </a:extLst>
           </p:cNvPr>
@@ -13414,7 +13414,7 @@
           <p:cNvPr id="22" name="">
             <a:extLst xmlns:a="http://schemas.openxmlformats.org/drawingml/2006/main">
               <a:ext uri="{FF2B5EF4-FFF2-40B4-BE49-F238E27FC236}">
-                <a16:creationId xmlns:a16="http://schemas.microsoft.com/office/drawing/2014/main" id="{5286AA26-4709-4D27-8035-B8DB7B9AB52E}"/>
+                <a16:creationId xmlns:a16="http://schemas.microsoft.com/office/drawing/2014/main" id="{EFA724BF-055F-40DC-9C11-EDA45EFB5AC9}"/>
               </a:ext>
             </a:extLst>
           </p:cNvPr>
@@ -13445,7 +13445,7 @@
           <p:cNvPr id="23" name="">
             <a:extLst xmlns:a="http://schemas.openxmlformats.org/drawingml/2006/main">
               <a:ext uri="{FF2B5EF4-FFF2-40B4-BE49-F238E27FC236}">
-                <a16:creationId xmlns:a16="http://schemas.microsoft.com/office/drawing/2014/main" id="{0A17C8D0-1ECA-4C6D-ACBD-2B761BCB9C61}"/>
+                <a16:creationId xmlns:a16="http://schemas.microsoft.com/office/drawing/2014/main" id="{8287A5C1-6F27-47A4-93EA-8505A1280579}"/>
               </a:ext>
             </a:extLst>
           </p:cNvPr>
@@ -13480,7 +13480,7 @@
           <p:cNvPr id="24" name="">
             <a:extLst xmlns:a="http://schemas.openxmlformats.org/drawingml/2006/main">
               <a:ext uri="{FF2B5EF4-FFF2-40B4-BE49-F238E27FC236}">
-                <a16:creationId xmlns:a16="http://schemas.microsoft.com/office/drawing/2014/main" id="{D8FDDEFA-C47B-4F63-BD82-CFE3B44E0557}"/>
+                <a16:creationId xmlns:a16="http://schemas.microsoft.com/office/drawing/2014/main" id="{AE241D24-8369-46B9-AAB3-24B53BDA2E8F}"/>
               </a:ext>
             </a:extLst>
           </p:cNvPr>
@@ -13530,7 +13530,7 @@
           <p:cNvPr id="25" name="">
             <a:extLst xmlns:a="http://schemas.openxmlformats.org/drawingml/2006/main">
               <a:ext uri="{FF2B5EF4-FFF2-40B4-BE49-F238E27FC236}">
-                <a16:creationId xmlns:a16="http://schemas.microsoft.com/office/drawing/2014/main" id="{0E1EAD27-7703-4C8E-AD04-8743417DDEF9}"/>
+                <a16:creationId xmlns:a16="http://schemas.microsoft.com/office/drawing/2014/main" id="{0D189D02-D1BE-4168-A8CC-ED6EB21AC424}"/>
               </a:ext>
             </a:extLst>
           </p:cNvPr>
@@ -13580,7 +13580,7 @@
           <p:cNvPr id="26" name="">
             <a:extLst xmlns:a="http://schemas.openxmlformats.org/drawingml/2006/main">
               <a:ext uri="{FF2B5EF4-FFF2-40B4-BE49-F238E27FC236}">
-                <a16:creationId xmlns:a16="http://schemas.microsoft.com/office/drawing/2014/main" id="{7F729264-6E97-4F33-85D8-3AD465A1C010}"/>
+                <a16:creationId xmlns:a16="http://schemas.microsoft.com/office/drawing/2014/main" id="{A0F28009-F5DE-471A-A615-9E7F3D4A72CF}"/>
               </a:ext>
             </a:extLst>
           </p:cNvPr>
@@ -13628,7 +13628,7 @@
     </p:spTree>
     <p:extLst>
       <p:ext uri="{BB962C8B-B14F-4D97-AF65-F5344CB8AC3E}">
-        <p14:creationId xmlns:p14="http://schemas.microsoft.com/office/powerpoint/2010/main" val="1115139084"/>
+        <p14:creationId xmlns:p14="http://schemas.microsoft.com/office/powerpoint/2010/main" val="1148553630"/>
       </p:ext>
     </p:extLst>
   </p:cSld>

</xml_diff>

<commit_message>
Align defense presentation with final dissertation
</commit_message>
<xml_diff>
--- a/docs/INES_Digital_Library_Defense_Presentation_IRUMVA_Style.pptx
+++ b/docs/INES_Digital_Library_Defense_Presentation_IRUMVA_Style.pptx
@@ -2,27 +2,27 @@
 <file path=ppt/presentation.xml><?xml version="1.0" encoding="utf-8"?>
 <p:presentation xmlns:p="http://schemas.openxmlformats.org/presentationml/2006/main">
   <p:sldMasterIdLst>
-    <p:sldMasterId xmlns:r="http://schemas.openxmlformats.org/officeDocument/2006/relationships" id="2147483648" r:id="R72e97d12647d4c07"/>
+    <p:sldMasterId xmlns:r="http://schemas.openxmlformats.org/officeDocument/2006/relationships" id="2147483648" r:id="R4488944bfd2b4826"/>
   </p:sldMasterIdLst>
   <p:notesMasterIdLst>
-    <p:notesMasterId xmlns:r="http://schemas.openxmlformats.org/officeDocument/2006/relationships" r:id="Rd5bbdecb6d6a41fd"/>
+    <p:notesMasterId xmlns:r="http://schemas.openxmlformats.org/officeDocument/2006/relationships" r:id="R9cf9a515a8f34e3c"/>
   </p:notesMasterIdLst>
   <p:sldIdLst>
-    <p:sldId xmlns:r="http://schemas.openxmlformats.org/officeDocument/2006/relationships" id="256" r:id="R7bb8d71acafe4591"/>
-    <p:sldId xmlns:r="http://schemas.openxmlformats.org/officeDocument/2006/relationships" id="257" r:id="R2fbe91ec487c4211"/>
-    <p:sldId xmlns:r="http://schemas.openxmlformats.org/officeDocument/2006/relationships" id="258" r:id="R81dd40873ca041fe"/>
-    <p:sldId xmlns:r="http://schemas.openxmlformats.org/officeDocument/2006/relationships" id="259" r:id="R320263fe5e8f4baa"/>
-    <p:sldId xmlns:r="http://schemas.openxmlformats.org/officeDocument/2006/relationships" id="260" r:id="R4f8b8ce9c4c14c9c"/>
-    <p:sldId xmlns:r="http://schemas.openxmlformats.org/officeDocument/2006/relationships" id="261" r:id="R45e26fa337cf4977"/>
-    <p:sldId xmlns:r="http://schemas.openxmlformats.org/officeDocument/2006/relationships" id="262" r:id="R20b09498bf4844ee"/>
-    <p:sldId xmlns:r="http://schemas.openxmlformats.org/officeDocument/2006/relationships" id="263" r:id="R925bf5b1405b461a"/>
-    <p:sldId xmlns:r="http://schemas.openxmlformats.org/officeDocument/2006/relationships" id="264" r:id="R46083f3028294029"/>
-    <p:sldId xmlns:r="http://schemas.openxmlformats.org/officeDocument/2006/relationships" id="265" r:id="R029579132f1041a1"/>
-    <p:sldId xmlns:r="http://schemas.openxmlformats.org/officeDocument/2006/relationships" id="266" r:id="R5545245c175e4df2"/>
-    <p:sldId xmlns:r="http://schemas.openxmlformats.org/officeDocument/2006/relationships" id="267" r:id="R070458412d344229"/>
-    <p:sldId xmlns:r="http://schemas.openxmlformats.org/officeDocument/2006/relationships" id="268" r:id="R2c8c6247b232441e"/>
-    <p:sldId xmlns:r="http://schemas.openxmlformats.org/officeDocument/2006/relationships" id="269" r:id="R45dda8a1e0c64117"/>
-    <p:sldId xmlns:r="http://schemas.openxmlformats.org/officeDocument/2006/relationships" id="270" r:id="Rbee8630a7f8c4945"/>
+    <p:sldId xmlns:r="http://schemas.openxmlformats.org/officeDocument/2006/relationships" id="256" r:id="R2f638d1652fd47bb"/>
+    <p:sldId xmlns:r="http://schemas.openxmlformats.org/officeDocument/2006/relationships" id="257" r:id="R9b3e244f17644215"/>
+    <p:sldId xmlns:r="http://schemas.openxmlformats.org/officeDocument/2006/relationships" id="258" r:id="Rd3087dc366b94944"/>
+    <p:sldId xmlns:r="http://schemas.openxmlformats.org/officeDocument/2006/relationships" id="259" r:id="Rfc0e672dcc014823"/>
+    <p:sldId xmlns:r="http://schemas.openxmlformats.org/officeDocument/2006/relationships" id="260" r:id="R6fef9fd253f64541"/>
+    <p:sldId xmlns:r="http://schemas.openxmlformats.org/officeDocument/2006/relationships" id="261" r:id="R5371ba749f244469"/>
+    <p:sldId xmlns:r="http://schemas.openxmlformats.org/officeDocument/2006/relationships" id="262" r:id="Ra056dfa27b36449c"/>
+    <p:sldId xmlns:r="http://schemas.openxmlformats.org/officeDocument/2006/relationships" id="263" r:id="R68da02922c9b438d"/>
+    <p:sldId xmlns:r="http://schemas.openxmlformats.org/officeDocument/2006/relationships" id="264" r:id="Rd6bfdd3e2aaf4a6e"/>
+    <p:sldId xmlns:r="http://schemas.openxmlformats.org/officeDocument/2006/relationships" id="265" r:id="R2c95c362ac1140de"/>
+    <p:sldId xmlns:r="http://schemas.openxmlformats.org/officeDocument/2006/relationships" id="266" r:id="R3526c544a9674318"/>
+    <p:sldId xmlns:r="http://schemas.openxmlformats.org/officeDocument/2006/relationships" id="267" r:id="Rfa04bf772a5948aa"/>
+    <p:sldId xmlns:r="http://schemas.openxmlformats.org/officeDocument/2006/relationships" id="268" r:id="R8f9caaaa0b8d4890"/>
+    <p:sldId xmlns:r="http://schemas.openxmlformats.org/officeDocument/2006/relationships" id="269" r:id="R2edf3e5d29ea4816"/>
+    <p:sldId xmlns:r="http://schemas.openxmlformats.org/officeDocument/2006/relationships" id="270" r:id="Rc90d6145d5874afe"/>
   </p:sldIdLst>
   <p:sldSz cx="12192000" cy="6858000"/>
   <p:notesSz cx="6858000" cy="9144000"/>
@@ -761,7 +761,7 @@
           <a:lstStyle xmlns:a="http://schemas.openxmlformats.org/drawingml/2006/main"/>
           <a:p xmlns:a="http://schemas.openxmlformats.org/drawingml/2006/main">
             <a:r>
-              <a:t>Use this as the exact demonstration path. Keep it short and reliable.</a:t>
+              <a:t>Use this as the exact demonstration path. Show login, dashboards, reader, backend health, phpMyAdmin tables, voice search, and narration.</a:t>
             </a:r>
           </a:p>
         </p:txBody>
@@ -1391,7 +1391,7 @@
           <a:lstStyle xmlns:a="http://schemas.openxmlformats.org/drawingml/2006/main"/>
           <a:p xmlns:a="http://schemas.openxmlformats.org/drawingml/2006/main">
             <a:r>
-              <a:t>If the panel asks about research validation, be clear whether it is system testing, survey validation, or both.</a:t>
+              <a:t>Explain that data collection is part of methodology for understanding the problem and requirements. Chapter 4 should show implementation and testing results, not invented survey results.</a:t>
             </a:r>
           </a:p>
         </p:txBody>
@@ -1599,7 +1599,7 @@
   </p:cSld>
   <p:clrMap bg1="lt1" tx1="dk1" bg2="lt2" tx2="dk2" accent1="accent1" accent2="accent2" accent3="accent3" accent4="accent4" accent5="accent5" accent6="accent6" hlink="hlink" folHlink="folHlink"/>
   <p:sldLayoutIdLst>
-    <p:sldLayoutId xmlns:r="http://schemas.openxmlformats.org/officeDocument/2006/relationships" id="2147483649" r:id="R65e4fdaae6914b4c"/>
+    <p:sldLayoutId xmlns:r="http://schemas.openxmlformats.org/officeDocument/2006/relationships" id="2147483649" r:id="R9637334e1396443a"/>
   </p:sldLayoutIdLst>
   <p:txStyles>
     <p:titleStyle>
@@ -2150,7 +2150,7 @@
           <p:cNvPr id="1" name="">
             <a:extLst xmlns:a="http://schemas.openxmlformats.org/drawingml/2006/main">
               <a:ext uri="{FF2B5EF4-FFF2-40B4-BE49-F238E27FC236}">
-                <a16:creationId xmlns:a16="http://schemas.microsoft.com/office/drawing/2014/main" id="{29EB49DD-9CC1-4E69-A210-4265CB21D5E8}"/>
+                <a16:creationId xmlns:a16="http://schemas.microsoft.com/office/drawing/2014/main" id="{4C829B54-B765-465E-AB4D-5CA63EB964BE}"/>
               </a:ext>
             </a:extLst>
           </p:cNvPr>
@@ -2187,7 +2187,7 @@
           <p:nvPr/>
         </p:nvPicPr>
         <p:blipFill>
-          <a:blip xmlns:r="http://schemas.openxmlformats.org/officeDocument/2006/relationships" xmlns:a="http://schemas.openxmlformats.org/drawingml/2006/main" r:embed="R95fad524588247ea"/>
+          <a:blip xmlns:r="http://schemas.openxmlformats.org/officeDocument/2006/relationships" xmlns:a="http://schemas.openxmlformats.org/drawingml/2006/main" r:embed="R86b641511dde4f04"/>
           <a:stretch xmlns:a="http://schemas.openxmlformats.org/drawingml/2006/main"/>
         </p:blipFill>
         <p:spPr>
@@ -2205,7 +2205,7 @@
           <p:cNvPr id="3" name="">
             <a:extLst xmlns:a="http://schemas.openxmlformats.org/drawingml/2006/main">
               <a:ext uri="{FF2B5EF4-FFF2-40B4-BE49-F238E27FC236}">
-                <a16:creationId xmlns:a16="http://schemas.microsoft.com/office/drawing/2014/main" id="{95FF469B-1ED8-4DBC-B855-A5D9417CA947}"/>
+                <a16:creationId xmlns:a16="http://schemas.microsoft.com/office/drawing/2014/main" id="{DD1E4953-8CE6-4E46-86F3-75D417023662}"/>
               </a:ext>
             </a:extLst>
           </p:cNvPr>
@@ -2255,7 +2255,7 @@
           <p:cNvPr id="4" name="">
             <a:extLst xmlns:a="http://schemas.openxmlformats.org/drawingml/2006/main">
               <a:ext uri="{FF2B5EF4-FFF2-40B4-BE49-F238E27FC236}">
-                <a16:creationId xmlns:a16="http://schemas.microsoft.com/office/drawing/2014/main" id="{F86EFD86-18FB-4494-8E53-E83AAEADE107}"/>
+                <a16:creationId xmlns:a16="http://schemas.microsoft.com/office/drawing/2014/main" id="{401E0254-1202-4F21-8129-474AB08020CE}"/>
               </a:ext>
             </a:extLst>
           </p:cNvPr>
@@ -2305,7 +2305,7 @@
           <p:cNvPr id="5" name="">
             <a:extLst xmlns:a="http://schemas.openxmlformats.org/drawingml/2006/main">
               <a:ext uri="{FF2B5EF4-FFF2-40B4-BE49-F238E27FC236}">
-                <a16:creationId xmlns:a16="http://schemas.microsoft.com/office/drawing/2014/main" id="{AFD85A17-9988-4F6D-BE76-70CDBDCC6ECC}"/>
+                <a16:creationId xmlns:a16="http://schemas.microsoft.com/office/drawing/2014/main" id="{DDE03C5D-1318-4C9D-B632-3B829D6C40D7}"/>
               </a:ext>
             </a:extLst>
           </p:cNvPr>
@@ -2340,7 +2340,7 @@
           <p:cNvPr id="6" name="">
             <a:extLst xmlns:a="http://schemas.openxmlformats.org/drawingml/2006/main">
               <a:ext uri="{FF2B5EF4-FFF2-40B4-BE49-F238E27FC236}">
-                <a16:creationId xmlns:a16="http://schemas.microsoft.com/office/drawing/2014/main" id="{D714BA41-3A6C-4ACB-A2AC-C18F49C13451}"/>
+                <a16:creationId xmlns:a16="http://schemas.microsoft.com/office/drawing/2014/main" id="{8C1F3E3B-B1EE-47AE-9B07-E19CD0AEC749}"/>
               </a:ext>
             </a:extLst>
           </p:cNvPr>
@@ -2390,7 +2390,7 @@
           <p:cNvPr id="7" name="">
             <a:extLst xmlns:a="http://schemas.openxmlformats.org/drawingml/2006/main">
               <a:ext uri="{FF2B5EF4-FFF2-40B4-BE49-F238E27FC236}">
-                <a16:creationId xmlns:a16="http://schemas.microsoft.com/office/drawing/2014/main" id="{E84C3209-3E3B-4DB3-BBCA-4B55F6F48DB8}"/>
+                <a16:creationId xmlns:a16="http://schemas.microsoft.com/office/drawing/2014/main" id="{E6A6FE38-7A49-4AD1-862E-DB9FB445750A}"/>
               </a:ext>
             </a:extLst>
           </p:cNvPr>
@@ -2440,7 +2440,7 @@
           <p:cNvPr id="8" name="">
             <a:extLst xmlns:a="http://schemas.openxmlformats.org/drawingml/2006/main">
               <a:ext uri="{FF2B5EF4-FFF2-40B4-BE49-F238E27FC236}">
-                <a16:creationId xmlns:a16="http://schemas.microsoft.com/office/drawing/2014/main" id="{C5EF3FB6-26FA-40A8-8D9E-147B8EE0C021}"/>
+                <a16:creationId xmlns:a16="http://schemas.microsoft.com/office/drawing/2014/main" id="{289332C8-CBBB-4E2F-829F-DA59DDE41AE1}"/>
               </a:ext>
             </a:extLst>
           </p:cNvPr>
@@ -2505,7 +2505,7 @@
     </p:spTree>
     <p:extLst>
       <p:ext uri="{BB962C8B-B14F-4D97-AF65-F5344CB8AC3E}">
-        <p14:creationId xmlns:p14="http://schemas.microsoft.com/office/powerpoint/2010/main" val="48687895"/>
+        <p14:creationId xmlns:p14="http://schemas.microsoft.com/office/powerpoint/2010/main" val="785894561"/>
       </p:ext>
     </p:extLst>
   </p:cSld>
@@ -2536,7 +2536,7 @@
           <p:cNvPr id="1" name="">
             <a:extLst xmlns:a="http://schemas.openxmlformats.org/drawingml/2006/main">
               <a:ext uri="{FF2B5EF4-FFF2-40B4-BE49-F238E27FC236}">
-                <a16:creationId xmlns:a16="http://schemas.microsoft.com/office/drawing/2014/main" id="{B9529D04-BCE9-4A43-ADBC-724B4AF0BD77}"/>
+                <a16:creationId xmlns:a16="http://schemas.microsoft.com/office/drawing/2014/main" id="{411AE187-92E3-412D-8000-A76CD7C6D1A7}"/>
               </a:ext>
             </a:extLst>
           </p:cNvPr>
@@ -2569,7 +2569,7 @@
           <p:cNvPr id="2" name="">
             <a:extLst xmlns:a="http://schemas.openxmlformats.org/drawingml/2006/main">
               <a:ext uri="{FF2B5EF4-FFF2-40B4-BE49-F238E27FC236}">
-                <a16:creationId xmlns:a16="http://schemas.microsoft.com/office/drawing/2014/main" id="{A51A3EF2-05B8-4245-A362-5BF16BEED7AC}"/>
+                <a16:creationId xmlns:a16="http://schemas.microsoft.com/office/drawing/2014/main" id="{8D666798-3A9A-451A-92CF-560F78EC4566}"/>
               </a:ext>
             </a:extLst>
           </p:cNvPr>
@@ -2602,7 +2602,7 @@
           <p:cNvPr id="3" name="">
             <a:extLst xmlns:a="http://schemas.openxmlformats.org/drawingml/2006/main">
               <a:ext uri="{FF2B5EF4-FFF2-40B4-BE49-F238E27FC236}">
-                <a16:creationId xmlns:a16="http://schemas.microsoft.com/office/drawing/2014/main" id="{584CB043-39AB-45C5-A165-AB23ADA0826C}"/>
+                <a16:creationId xmlns:a16="http://schemas.microsoft.com/office/drawing/2014/main" id="{5328EB9F-D2EA-4E0D-9CC0-42730B89F00F}"/>
               </a:ext>
             </a:extLst>
           </p:cNvPr>
@@ -2652,7 +2652,7 @@
           <p:cNvPr id="4" name="">
             <a:extLst xmlns:a="http://schemas.openxmlformats.org/drawingml/2006/main">
               <a:ext uri="{FF2B5EF4-FFF2-40B4-BE49-F238E27FC236}">
-                <a16:creationId xmlns:a16="http://schemas.microsoft.com/office/drawing/2014/main" id="{76A72F8B-1C34-406E-900B-72312C079DE4}"/>
+                <a16:creationId xmlns:a16="http://schemas.microsoft.com/office/drawing/2014/main" id="{85BB3046-54E1-4D56-858E-7619A40D399A}"/>
               </a:ext>
             </a:extLst>
           </p:cNvPr>
@@ -2702,7 +2702,7 @@
           <p:cNvPr id="5" name="">
             <a:extLst xmlns:a="http://schemas.openxmlformats.org/drawingml/2006/main">
               <a:ext uri="{FF2B5EF4-FFF2-40B4-BE49-F238E27FC236}">
-                <a16:creationId xmlns:a16="http://schemas.microsoft.com/office/drawing/2014/main" id="{005E19DE-5191-4A11-9213-061E40ACA193}"/>
+                <a16:creationId xmlns:a16="http://schemas.microsoft.com/office/drawing/2014/main" id="{312DA9B0-AB20-44AE-801A-165E71A6FE5D}"/>
               </a:ext>
             </a:extLst>
           </p:cNvPr>
@@ -2737,7 +2737,7 @@
           <p:nvPr/>
         </p:nvPicPr>
         <p:blipFill>
-          <a:blip xmlns:r="http://schemas.openxmlformats.org/officeDocument/2006/relationships" xmlns:a="http://schemas.openxmlformats.org/drawingml/2006/main" r:embed="R3ba3de3c705344af"/>
+          <a:blip xmlns:r="http://schemas.openxmlformats.org/officeDocument/2006/relationships" xmlns:a="http://schemas.openxmlformats.org/drawingml/2006/main" r:embed="Rb475acaa16a0477a"/>
           <a:stretch xmlns:a="http://schemas.openxmlformats.org/drawingml/2006/main"/>
         </p:blipFill>
         <p:spPr>
@@ -2755,7 +2755,7 @@
           <p:cNvPr id="7" name="">
             <a:extLst xmlns:a="http://schemas.openxmlformats.org/drawingml/2006/main">
               <a:ext uri="{FF2B5EF4-FFF2-40B4-BE49-F238E27FC236}">
-                <a16:creationId xmlns:a16="http://schemas.microsoft.com/office/drawing/2014/main" id="{1A93F1A3-8CE1-4FBE-AE6D-1F06EFB7E19E}"/>
+                <a16:creationId xmlns:a16="http://schemas.microsoft.com/office/drawing/2014/main" id="{7625D79A-7050-45D1-A01D-FC033ECC27E7}"/>
               </a:ext>
             </a:extLst>
           </p:cNvPr>
@@ -2790,7 +2790,7 @@
           <p:cNvPr id="8" name="">
             <a:extLst xmlns:a="http://schemas.openxmlformats.org/drawingml/2006/main">
               <a:ext uri="{FF2B5EF4-FFF2-40B4-BE49-F238E27FC236}">
-                <a16:creationId xmlns:a16="http://schemas.microsoft.com/office/drawing/2014/main" id="{BC51146C-678F-4758-9D84-CFC109DFD0BC}"/>
+                <a16:creationId xmlns:a16="http://schemas.microsoft.com/office/drawing/2014/main" id="{378343F9-0339-429F-BFBD-512FDB307452}"/>
               </a:ext>
             </a:extLst>
           </p:cNvPr>
@@ -2840,7 +2840,7 @@
           <p:cNvPr id="9" name="">
             <a:extLst xmlns:a="http://schemas.openxmlformats.org/drawingml/2006/main">
               <a:ext uri="{FF2B5EF4-FFF2-40B4-BE49-F238E27FC236}">
-                <a16:creationId xmlns:a16="http://schemas.microsoft.com/office/drawing/2014/main" id="{8260D5C5-18C8-4A41-8E88-5293FD567326}"/>
+                <a16:creationId xmlns:a16="http://schemas.microsoft.com/office/drawing/2014/main" id="{188CE96F-F485-4D7D-8EC0-0E367881B824}"/>
               </a:ext>
             </a:extLst>
           </p:cNvPr>
@@ -2890,7 +2890,7 @@
           <p:cNvPr id="10" name="">
             <a:extLst xmlns:a="http://schemas.openxmlformats.org/drawingml/2006/main">
               <a:ext uri="{FF2B5EF4-FFF2-40B4-BE49-F238E27FC236}">
-                <a16:creationId xmlns:a16="http://schemas.microsoft.com/office/drawing/2014/main" id="{CB2B03B7-5D05-431C-A0F0-AA0214457719}"/>
+                <a16:creationId xmlns:a16="http://schemas.microsoft.com/office/drawing/2014/main" id="{A4D8D6B6-4C32-466D-BC79-CB1E674E61D5}"/>
               </a:ext>
             </a:extLst>
           </p:cNvPr>
@@ -2925,7 +2925,7 @@
           <p:cNvPr id="11" name="">
             <a:extLst xmlns:a="http://schemas.openxmlformats.org/drawingml/2006/main">
               <a:ext uri="{FF2B5EF4-FFF2-40B4-BE49-F238E27FC236}">
-                <a16:creationId xmlns:a16="http://schemas.microsoft.com/office/drawing/2014/main" id="{D61DBD1C-ADCA-46C2-A311-71BAC533CF1F}"/>
+                <a16:creationId xmlns:a16="http://schemas.microsoft.com/office/drawing/2014/main" id="{A710B58F-B48D-46CE-AF07-456C9789EADF}"/>
               </a:ext>
             </a:extLst>
           </p:cNvPr>
@@ -2975,7 +2975,7 @@
           <p:cNvPr id="12" name="">
             <a:extLst xmlns:a="http://schemas.openxmlformats.org/drawingml/2006/main">
               <a:ext uri="{FF2B5EF4-FFF2-40B4-BE49-F238E27FC236}">
-                <a16:creationId xmlns:a16="http://schemas.microsoft.com/office/drawing/2014/main" id="{77AEF68B-31AB-47E3-BAF5-46797B29F01D}"/>
+                <a16:creationId xmlns:a16="http://schemas.microsoft.com/office/drawing/2014/main" id="{A2FFD8B6-7BF3-4CDC-93B3-5CD9A5AA579F}"/>
               </a:ext>
             </a:extLst>
           </p:cNvPr>
@@ -3025,7 +3025,7 @@
           <p:cNvPr id="13" name="">
             <a:extLst xmlns:a="http://schemas.openxmlformats.org/drawingml/2006/main">
               <a:ext uri="{FF2B5EF4-FFF2-40B4-BE49-F238E27FC236}">
-                <a16:creationId xmlns:a16="http://schemas.microsoft.com/office/drawing/2014/main" id="{22FCD1B9-307C-4FB5-B210-08D7443AEC4A}"/>
+                <a16:creationId xmlns:a16="http://schemas.microsoft.com/office/drawing/2014/main" id="{0627A7B4-6D27-4EF1-A187-545E5F31253D}"/>
               </a:ext>
             </a:extLst>
           </p:cNvPr>
@@ -3060,7 +3060,7 @@
           <p:cNvPr id="14" name="">
             <a:extLst xmlns:a="http://schemas.openxmlformats.org/drawingml/2006/main">
               <a:ext uri="{FF2B5EF4-FFF2-40B4-BE49-F238E27FC236}">
-                <a16:creationId xmlns:a16="http://schemas.microsoft.com/office/drawing/2014/main" id="{58DEFB1B-AC88-4DA5-BE4A-16586F08B9E3}"/>
+                <a16:creationId xmlns:a16="http://schemas.microsoft.com/office/drawing/2014/main" id="{6E214F7A-5C99-4B07-996B-5DFE19FD4742}"/>
               </a:ext>
             </a:extLst>
           </p:cNvPr>
@@ -3110,7 +3110,7 @@
           <p:cNvPr id="15" name="">
             <a:extLst xmlns:a="http://schemas.openxmlformats.org/drawingml/2006/main">
               <a:ext uri="{FF2B5EF4-FFF2-40B4-BE49-F238E27FC236}">
-                <a16:creationId xmlns:a16="http://schemas.microsoft.com/office/drawing/2014/main" id="{B0EDDBB3-59B2-4932-B2D4-2A3CA648C219}"/>
+                <a16:creationId xmlns:a16="http://schemas.microsoft.com/office/drawing/2014/main" id="{12E560C6-2B93-43BA-8B94-4BD143678AB4}"/>
               </a:ext>
             </a:extLst>
           </p:cNvPr>
@@ -3160,7 +3160,7 @@
           <p:cNvPr id="16" name="">
             <a:extLst xmlns:a="http://schemas.openxmlformats.org/drawingml/2006/main">
               <a:ext uri="{FF2B5EF4-FFF2-40B4-BE49-F238E27FC236}">
-                <a16:creationId xmlns:a16="http://schemas.microsoft.com/office/drawing/2014/main" id="{45CA0BFD-1CEB-4C3D-B2B0-7B94497DDF10}"/>
+                <a16:creationId xmlns:a16="http://schemas.microsoft.com/office/drawing/2014/main" id="{1F8DBD7D-4E41-4BEF-A369-98B8DD016E84}"/>
               </a:ext>
             </a:extLst>
           </p:cNvPr>
@@ -3195,7 +3195,7 @@
           <p:cNvPr id="17" name="">
             <a:extLst xmlns:a="http://schemas.openxmlformats.org/drawingml/2006/main">
               <a:ext uri="{FF2B5EF4-FFF2-40B4-BE49-F238E27FC236}">
-                <a16:creationId xmlns:a16="http://schemas.microsoft.com/office/drawing/2014/main" id="{45D702FA-6AEC-4716-A9F8-2C4DB7CF9BF0}"/>
+                <a16:creationId xmlns:a16="http://schemas.microsoft.com/office/drawing/2014/main" id="{27AA6FC3-0813-4E85-AD1D-0880C8140A09}"/>
               </a:ext>
             </a:extLst>
           </p:cNvPr>
@@ -3245,7 +3245,7 @@
           <p:cNvPr id="18" name="">
             <a:extLst xmlns:a="http://schemas.openxmlformats.org/drawingml/2006/main">
               <a:ext uri="{FF2B5EF4-FFF2-40B4-BE49-F238E27FC236}">
-                <a16:creationId xmlns:a16="http://schemas.microsoft.com/office/drawing/2014/main" id="{91B2E687-3B10-40DB-9EDE-8EA903FB5FEC}"/>
+                <a16:creationId xmlns:a16="http://schemas.microsoft.com/office/drawing/2014/main" id="{B7A3A104-FF63-4117-A3BF-D47B26A0D378}"/>
               </a:ext>
             </a:extLst>
           </p:cNvPr>
@@ -3295,7 +3295,7 @@
           <p:cNvPr id="19" name="">
             <a:extLst xmlns:a="http://schemas.openxmlformats.org/drawingml/2006/main">
               <a:ext uri="{FF2B5EF4-FFF2-40B4-BE49-F238E27FC236}">
-                <a16:creationId xmlns:a16="http://schemas.microsoft.com/office/drawing/2014/main" id="{7BACB9C2-A4D8-4557-82E0-24700A6E2BF7}"/>
+                <a16:creationId xmlns:a16="http://schemas.microsoft.com/office/drawing/2014/main" id="{500742C2-EA71-4ED9-83D7-D5BBF9BBB2DF}"/>
               </a:ext>
             </a:extLst>
           </p:cNvPr>
@@ -3330,7 +3330,7 @@
           <p:cNvPr id="20" name="">
             <a:extLst xmlns:a="http://schemas.openxmlformats.org/drawingml/2006/main">
               <a:ext uri="{FF2B5EF4-FFF2-40B4-BE49-F238E27FC236}">
-                <a16:creationId xmlns:a16="http://schemas.microsoft.com/office/drawing/2014/main" id="{82194E8C-AEBE-46FB-9AB4-674DBBF09A13}"/>
+                <a16:creationId xmlns:a16="http://schemas.microsoft.com/office/drawing/2014/main" id="{273159A1-A864-43AD-90AE-F092FEA82EB1}"/>
               </a:ext>
             </a:extLst>
           </p:cNvPr>
@@ -3380,7 +3380,7 @@
           <p:cNvPr id="21" name="">
             <a:extLst xmlns:a="http://schemas.openxmlformats.org/drawingml/2006/main">
               <a:ext uri="{FF2B5EF4-FFF2-40B4-BE49-F238E27FC236}">
-                <a16:creationId xmlns:a16="http://schemas.microsoft.com/office/drawing/2014/main" id="{3DF1FAD3-DA26-44D2-B567-099717592EE1}"/>
+                <a16:creationId xmlns:a16="http://schemas.microsoft.com/office/drawing/2014/main" id="{3454C67A-51E7-4FCA-804C-41E7E9EECAE7}"/>
               </a:ext>
             </a:extLst>
           </p:cNvPr>
@@ -3428,7 +3428,7 @@
     </p:spTree>
     <p:extLst>
       <p:ext uri="{BB962C8B-B14F-4D97-AF65-F5344CB8AC3E}">
-        <p14:creationId xmlns:p14="http://schemas.microsoft.com/office/powerpoint/2010/main" val="1939564908"/>
+        <p14:creationId xmlns:p14="http://schemas.microsoft.com/office/powerpoint/2010/main" val="661705901"/>
       </p:ext>
     </p:extLst>
   </p:cSld>
@@ -3459,7 +3459,7 @@
           <p:cNvPr id="1" name="">
             <a:extLst xmlns:a="http://schemas.openxmlformats.org/drawingml/2006/main">
               <a:ext uri="{FF2B5EF4-FFF2-40B4-BE49-F238E27FC236}">
-                <a16:creationId xmlns:a16="http://schemas.microsoft.com/office/drawing/2014/main" id="{A1EE48A6-A172-4EB5-99D4-8902CE63ECC7}"/>
+                <a16:creationId xmlns:a16="http://schemas.microsoft.com/office/drawing/2014/main" id="{6EA9064E-005A-41CB-A236-944E4AD29136}"/>
               </a:ext>
             </a:extLst>
           </p:cNvPr>
@@ -3492,7 +3492,7 @@
           <p:cNvPr id="2" name="">
             <a:extLst xmlns:a="http://schemas.openxmlformats.org/drawingml/2006/main">
               <a:ext uri="{FF2B5EF4-FFF2-40B4-BE49-F238E27FC236}">
-                <a16:creationId xmlns:a16="http://schemas.microsoft.com/office/drawing/2014/main" id="{E7476F39-65E9-4E9C-B5A6-8E8DC6B5ECD5}"/>
+                <a16:creationId xmlns:a16="http://schemas.microsoft.com/office/drawing/2014/main" id="{15346BC8-9146-4670-8B4A-50D45E99ADC8}"/>
               </a:ext>
             </a:extLst>
           </p:cNvPr>
@@ -3525,7 +3525,7 @@
           <p:cNvPr id="3" name="">
             <a:extLst xmlns:a="http://schemas.openxmlformats.org/drawingml/2006/main">
               <a:ext uri="{FF2B5EF4-FFF2-40B4-BE49-F238E27FC236}">
-                <a16:creationId xmlns:a16="http://schemas.microsoft.com/office/drawing/2014/main" id="{1405DBE0-5DB4-4287-ABC6-DB3A4D0D4EB0}"/>
+                <a16:creationId xmlns:a16="http://schemas.microsoft.com/office/drawing/2014/main" id="{36BCA68C-4FA8-48CB-94A6-8B3AD8A7A565}"/>
               </a:ext>
             </a:extLst>
           </p:cNvPr>
@@ -3575,7 +3575,7 @@
           <p:cNvPr id="4" name="">
             <a:extLst xmlns:a="http://schemas.openxmlformats.org/drawingml/2006/main">
               <a:ext uri="{FF2B5EF4-FFF2-40B4-BE49-F238E27FC236}">
-                <a16:creationId xmlns:a16="http://schemas.microsoft.com/office/drawing/2014/main" id="{E4ADC822-1E22-4640-B7B3-A129B8568C02}"/>
+                <a16:creationId xmlns:a16="http://schemas.microsoft.com/office/drawing/2014/main" id="{D9E7DF51-ABC2-4C5F-8B30-0785D2EA63F5}"/>
               </a:ext>
             </a:extLst>
           </p:cNvPr>
@@ -3625,7 +3625,7 @@
           <p:cNvPr id="5" name="">
             <a:extLst xmlns:a="http://schemas.openxmlformats.org/drawingml/2006/main">
               <a:ext uri="{FF2B5EF4-FFF2-40B4-BE49-F238E27FC236}">
-                <a16:creationId xmlns:a16="http://schemas.microsoft.com/office/drawing/2014/main" id="{502262FA-3E4F-413F-BA41-E5D7DE9B5350}"/>
+                <a16:creationId xmlns:a16="http://schemas.microsoft.com/office/drawing/2014/main" id="{FE7094AE-C26D-4F37-9AF7-514DB2C94187}"/>
               </a:ext>
             </a:extLst>
           </p:cNvPr>
@@ -3660,7 +3660,7 @@
           <p:nvPr/>
         </p:nvPicPr>
         <p:blipFill>
-          <a:blip xmlns:r="http://schemas.openxmlformats.org/officeDocument/2006/relationships" xmlns:a="http://schemas.openxmlformats.org/drawingml/2006/main" r:embed="Re4f6b1da48cf4805"/>
+          <a:blip xmlns:r="http://schemas.openxmlformats.org/officeDocument/2006/relationships" xmlns:a="http://schemas.openxmlformats.org/drawingml/2006/main" r:embed="R80e59e0fcc9d4ed2"/>
           <a:stretch xmlns:a="http://schemas.openxmlformats.org/drawingml/2006/main"/>
         </p:blipFill>
         <p:spPr>
@@ -3678,7 +3678,7 @@
           <p:cNvPr id="7" name="">
             <a:extLst xmlns:a="http://schemas.openxmlformats.org/drawingml/2006/main">
               <a:ext uri="{FF2B5EF4-FFF2-40B4-BE49-F238E27FC236}">
-                <a16:creationId xmlns:a16="http://schemas.microsoft.com/office/drawing/2014/main" id="{AE50ACFA-FE13-4F3E-B3A4-1E958608775F}"/>
+                <a16:creationId xmlns:a16="http://schemas.microsoft.com/office/drawing/2014/main" id="{91717A0A-555A-4B27-B4C4-0F6A6A36D6C7}"/>
               </a:ext>
             </a:extLst>
           </p:cNvPr>
@@ -3713,7 +3713,7 @@
           <p:cNvPr id="8" name="">
             <a:extLst xmlns:a="http://schemas.openxmlformats.org/drawingml/2006/main">
               <a:ext uri="{FF2B5EF4-FFF2-40B4-BE49-F238E27FC236}">
-                <a16:creationId xmlns:a16="http://schemas.microsoft.com/office/drawing/2014/main" id="{00AAF173-BC79-4E74-8349-FE6806A66E49}"/>
+                <a16:creationId xmlns:a16="http://schemas.microsoft.com/office/drawing/2014/main" id="{8D81E522-AD9D-4792-A5DA-326BB6AF2A71}"/>
               </a:ext>
             </a:extLst>
           </p:cNvPr>
@@ -3763,7 +3763,7 @@
           <p:cNvPr id="9" name="">
             <a:extLst xmlns:a="http://schemas.openxmlformats.org/drawingml/2006/main">
               <a:ext uri="{FF2B5EF4-FFF2-40B4-BE49-F238E27FC236}">
-                <a16:creationId xmlns:a16="http://schemas.microsoft.com/office/drawing/2014/main" id="{0894B7E4-798C-43E1-8440-AF2DFF2310BD}"/>
+                <a16:creationId xmlns:a16="http://schemas.microsoft.com/office/drawing/2014/main" id="{E12852A6-E497-4DB7-ADA8-F0000E102427}"/>
               </a:ext>
             </a:extLst>
           </p:cNvPr>
@@ -3813,7 +3813,7 @@
           <p:cNvPr id="10" name="">
             <a:extLst xmlns:a="http://schemas.openxmlformats.org/drawingml/2006/main">
               <a:ext uri="{FF2B5EF4-FFF2-40B4-BE49-F238E27FC236}">
-                <a16:creationId xmlns:a16="http://schemas.microsoft.com/office/drawing/2014/main" id="{C4DCF23E-A973-46FA-9194-F471E209E6CD}"/>
+                <a16:creationId xmlns:a16="http://schemas.microsoft.com/office/drawing/2014/main" id="{9F957E88-CFC0-4AF2-99CE-344E27A5728B}"/>
               </a:ext>
             </a:extLst>
           </p:cNvPr>
@@ -3848,7 +3848,7 @@
           <p:cNvPr id="11" name="">
             <a:extLst xmlns:a="http://schemas.openxmlformats.org/drawingml/2006/main">
               <a:ext uri="{FF2B5EF4-FFF2-40B4-BE49-F238E27FC236}">
-                <a16:creationId xmlns:a16="http://schemas.microsoft.com/office/drawing/2014/main" id="{4A6A6A4B-EE0F-41F1-8A75-F925DDA21799}"/>
+                <a16:creationId xmlns:a16="http://schemas.microsoft.com/office/drawing/2014/main" id="{3024DC82-6C15-4D88-B344-D39AD7DF0347}"/>
               </a:ext>
             </a:extLst>
           </p:cNvPr>
@@ -3898,7 +3898,7 @@
           <p:cNvPr id="12" name="">
             <a:extLst xmlns:a="http://schemas.openxmlformats.org/drawingml/2006/main">
               <a:ext uri="{FF2B5EF4-FFF2-40B4-BE49-F238E27FC236}">
-                <a16:creationId xmlns:a16="http://schemas.microsoft.com/office/drawing/2014/main" id="{23DAE736-6F16-4A70-8A7B-6B9FF314DAAD}"/>
+                <a16:creationId xmlns:a16="http://schemas.microsoft.com/office/drawing/2014/main" id="{FC2DA0D3-E930-41F5-AF9D-84D6370A85BD}"/>
               </a:ext>
             </a:extLst>
           </p:cNvPr>
@@ -3948,7 +3948,7 @@
           <p:cNvPr id="13" name="">
             <a:extLst xmlns:a="http://schemas.openxmlformats.org/drawingml/2006/main">
               <a:ext uri="{FF2B5EF4-FFF2-40B4-BE49-F238E27FC236}">
-                <a16:creationId xmlns:a16="http://schemas.microsoft.com/office/drawing/2014/main" id="{27D026FC-E37B-4E5E-9760-730CFA62B235}"/>
+                <a16:creationId xmlns:a16="http://schemas.microsoft.com/office/drawing/2014/main" id="{F529F3CF-ED50-4EAF-9698-642B7F0B64F9}"/>
               </a:ext>
             </a:extLst>
           </p:cNvPr>
@@ -3983,7 +3983,7 @@
           <p:cNvPr id="14" name="">
             <a:extLst xmlns:a="http://schemas.openxmlformats.org/drawingml/2006/main">
               <a:ext uri="{FF2B5EF4-FFF2-40B4-BE49-F238E27FC236}">
-                <a16:creationId xmlns:a16="http://schemas.microsoft.com/office/drawing/2014/main" id="{5DA17C16-A455-4EBC-84C5-2FF7AC37D4B1}"/>
+                <a16:creationId xmlns:a16="http://schemas.microsoft.com/office/drawing/2014/main" id="{089FBEAA-887F-46DD-8E3C-675CB799296C}"/>
               </a:ext>
             </a:extLst>
           </p:cNvPr>
@@ -4033,7 +4033,7 @@
           <p:cNvPr id="15" name="">
             <a:extLst xmlns:a="http://schemas.openxmlformats.org/drawingml/2006/main">
               <a:ext uri="{FF2B5EF4-FFF2-40B4-BE49-F238E27FC236}">
-                <a16:creationId xmlns:a16="http://schemas.microsoft.com/office/drawing/2014/main" id="{C53D543D-8AAB-420C-ACBE-3AAD04380974}"/>
+                <a16:creationId xmlns:a16="http://schemas.microsoft.com/office/drawing/2014/main" id="{ADAC9C74-A35C-44B9-8FE3-9D2B767C3B9C}"/>
               </a:ext>
             </a:extLst>
           </p:cNvPr>
@@ -4083,7 +4083,7 @@
           <p:cNvPr id="16" name="">
             <a:extLst xmlns:a="http://schemas.openxmlformats.org/drawingml/2006/main">
               <a:ext uri="{FF2B5EF4-FFF2-40B4-BE49-F238E27FC236}">
-                <a16:creationId xmlns:a16="http://schemas.microsoft.com/office/drawing/2014/main" id="{6897C433-0B9B-4486-95A8-1E9F2212BDC9}"/>
+                <a16:creationId xmlns:a16="http://schemas.microsoft.com/office/drawing/2014/main" id="{896218E7-0158-4C54-85A7-A57197C51129}"/>
               </a:ext>
             </a:extLst>
           </p:cNvPr>
@@ -4118,7 +4118,7 @@
           <p:cNvPr id="17" name="">
             <a:extLst xmlns:a="http://schemas.openxmlformats.org/drawingml/2006/main">
               <a:ext uri="{FF2B5EF4-FFF2-40B4-BE49-F238E27FC236}">
-                <a16:creationId xmlns:a16="http://schemas.microsoft.com/office/drawing/2014/main" id="{F3012887-2EC5-47C5-BE25-18FD194D2171}"/>
+                <a16:creationId xmlns:a16="http://schemas.microsoft.com/office/drawing/2014/main" id="{734E7A88-1A73-47CA-A757-F9E3C6A5325E}"/>
               </a:ext>
             </a:extLst>
           </p:cNvPr>
@@ -4168,7 +4168,7 @@
           <p:cNvPr id="18" name="">
             <a:extLst xmlns:a="http://schemas.openxmlformats.org/drawingml/2006/main">
               <a:ext uri="{FF2B5EF4-FFF2-40B4-BE49-F238E27FC236}">
-                <a16:creationId xmlns:a16="http://schemas.microsoft.com/office/drawing/2014/main" id="{51661181-6882-48F6-8262-79D4926D77EF}"/>
+                <a16:creationId xmlns:a16="http://schemas.microsoft.com/office/drawing/2014/main" id="{07034B6E-3B2E-4862-9BAF-4AF5AA40C3BF}"/>
               </a:ext>
             </a:extLst>
           </p:cNvPr>
@@ -4218,7 +4218,7 @@
           <p:cNvPr id="19" name="">
             <a:extLst xmlns:a="http://schemas.openxmlformats.org/drawingml/2006/main">
               <a:ext uri="{FF2B5EF4-FFF2-40B4-BE49-F238E27FC236}">
-                <a16:creationId xmlns:a16="http://schemas.microsoft.com/office/drawing/2014/main" id="{1983FD78-C8A1-452E-9005-D5F99A77F542}"/>
+                <a16:creationId xmlns:a16="http://schemas.microsoft.com/office/drawing/2014/main" id="{739F336A-ED00-475A-B6B8-5B02D8123EDA}"/>
               </a:ext>
             </a:extLst>
           </p:cNvPr>
@@ -4253,7 +4253,7 @@
           <p:cNvPr id="20" name="">
             <a:extLst xmlns:a="http://schemas.openxmlformats.org/drawingml/2006/main">
               <a:ext uri="{FF2B5EF4-FFF2-40B4-BE49-F238E27FC236}">
-                <a16:creationId xmlns:a16="http://schemas.microsoft.com/office/drawing/2014/main" id="{C304143F-F9CC-4184-B405-6FD45E46D8E8}"/>
+                <a16:creationId xmlns:a16="http://schemas.microsoft.com/office/drawing/2014/main" id="{A5BEB3EF-D38B-4C63-B5BB-B4E317DB4FD6}"/>
               </a:ext>
             </a:extLst>
           </p:cNvPr>
@@ -4303,7 +4303,7 @@
           <p:cNvPr id="21" name="">
             <a:extLst xmlns:a="http://schemas.openxmlformats.org/drawingml/2006/main">
               <a:ext uri="{FF2B5EF4-FFF2-40B4-BE49-F238E27FC236}">
-                <a16:creationId xmlns:a16="http://schemas.microsoft.com/office/drawing/2014/main" id="{FE8D839B-F189-4A62-B3DB-0E59FD5EA016}"/>
+                <a16:creationId xmlns:a16="http://schemas.microsoft.com/office/drawing/2014/main" id="{8C7C3F0E-1BA6-48D3-8AFE-277C88B8975C}"/>
               </a:ext>
             </a:extLst>
           </p:cNvPr>
@@ -4353,7 +4353,7 @@
           <p:cNvPr id="22" name="">
             <a:extLst xmlns:a="http://schemas.openxmlformats.org/drawingml/2006/main">
               <a:ext uri="{FF2B5EF4-FFF2-40B4-BE49-F238E27FC236}">
-                <a16:creationId xmlns:a16="http://schemas.microsoft.com/office/drawing/2014/main" id="{49162D19-439F-46FC-ADEC-F56D40D42F07}"/>
+                <a16:creationId xmlns:a16="http://schemas.microsoft.com/office/drawing/2014/main" id="{E4F1F527-7EC8-4135-B539-5C297AFFF698}"/>
               </a:ext>
             </a:extLst>
           </p:cNvPr>
@@ -4388,7 +4388,7 @@
           <p:cNvPr id="23" name="">
             <a:extLst xmlns:a="http://schemas.openxmlformats.org/drawingml/2006/main">
               <a:ext uri="{FF2B5EF4-FFF2-40B4-BE49-F238E27FC236}">
-                <a16:creationId xmlns:a16="http://schemas.microsoft.com/office/drawing/2014/main" id="{7D53431F-118B-4AB5-B567-EF73494452E1}"/>
+                <a16:creationId xmlns:a16="http://schemas.microsoft.com/office/drawing/2014/main" id="{CEC5F08C-CB8F-4C6C-8525-6AD0D08096AB}"/>
               </a:ext>
             </a:extLst>
           </p:cNvPr>
@@ -4438,7 +4438,7 @@
           <p:cNvPr id="24" name="">
             <a:extLst xmlns:a="http://schemas.openxmlformats.org/drawingml/2006/main">
               <a:ext uri="{FF2B5EF4-FFF2-40B4-BE49-F238E27FC236}">
-                <a16:creationId xmlns:a16="http://schemas.microsoft.com/office/drawing/2014/main" id="{BC775F9A-1E35-4619-8E49-1DA0083F2BF7}"/>
+                <a16:creationId xmlns:a16="http://schemas.microsoft.com/office/drawing/2014/main" id="{E9B8A4EF-C1D4-48D8-B9E4-48E4DDD60574}"/>
               </a:ext>
             </a:extLst>
           </p:cNvPr>
@@ -4486,7 +4486,7 @@
     </p:spTree>
     <p:extLst>
       <p:ext uri="{BB962C8B-B14F-4D97-AF65-F5344CB8AC3E}">
-        <p14:creationId xmlns:p14="http://schemas.microsoft.com/office/powerpoint/2010/main" val="1255002873"/>
+        <p14:creationId xmlns:p14="http://schemas.microsoft.com/office/powerpoint/2010/main" val="2105475809"/>
       </p:ext>
     </p:extLst>
   </p:cSld>
@@ -4517,7 +4517,7 @@
           <p:cNvPr id="1" name="">
             <a:extLst xmlns:a="http://schemas.openxmlformats.org/drawingml/2006/main">
               <a:ext uri="{FF2B5EF4-FFF2-40B4-BE49-F238E27FC236}">
-                <a16:creationId xmlns:a16="http://schemas.microsoft.com/office/drawing/2014/main" id="{4841E682-C0BD-40A9-873A-9BDE5D96C973}"/>
+                <a16:creationId xmlns:a16="http://schemas.microsoft.com/office/drawing/2014/main" id="{7BBF19A1-6A5E-4461-8B3E-76812212E9E0}"/>
               </a:ext>
             </a:extLst>
           </p:cNvPr>
@@ -4550,7 +4550,7 @@
           <p:cNvPr id="2" name="">
             <a:extLst xmlns:a="http://schemas.openxmlformats.org/drawingml/2006/main">
               <a:ext uri="{FF2B5EF4-FFF2-40B4-BE49-F238E27FC236}">
-                <a16:creationId xmlns:a16="http://schemas.microsoft.com/office/drawing/2014/main" id="{B0B01ECE-E217-4D16-B009-6C83836D5BC6}"/>
+                <a16:creationId xmlns:a16="http://schemas.microsoft.com/office/drawing/2014/main" id="{CCA4D85F-63E6-4922-A4EF-1376A337CD19}"/>
               </a:ext>
             </a:extLst>
           </p:cNvPr>
@@ -4583,7 +4583,7 @@
           <p:cNvPr id="3" name="">
             <a:extLst xmlns:a="http://schemas.openxmlformats.org/drawingml/2006/main">
               <a:ext uri="{FF2B5EF4-FFF2-40B4-BE49-F238E27FC236}">
-                <a16:creationId xmlns:a16="http://schemas.microsoft.com/office/drawing/2014/main" id="{DAC6B9E5-BD32-4BCA-B3E4-321B564FA58D}"/>
+                <a16:creationId xmlns:a16="http://schemas.microsoft.com/office/drawing/2014/main" id="{57E515C5-96BB-48C5-869C-BE43A51DAEED}"/>
               </a:ext>
             </a:extLst>
           </p:cNvPr>
@@ -4633,7 +4633,7 @@
           <p:cNvPr id="4" name="">
             <a:extLst xmlns:a="http://schemas.openxmlformats.org/drawingml/2006/main">
               <a:ext uri="{FF2B5EF4-FFF2-40B4-BE49-F238E27FC236}">
-                <a16:creationId xmlns:a16="http://schemas.microsoft.com/office/drawing/2014/main" id="{F3E40BCA-9E5A-46E4-97E0-B40A48B35A7A}"/>
+                <a16:creationId xmlns:a16="http://schemas.microsoft.com/office/drawing/2014/main" id="{52ED7D1C-70CE-460E-98F5-90A329DECB1E}"/>
               </a:ext>
             </a:extLst>
           </p:cNvPr>
@@ -4683,7 +4683,7 @@
           <p:cNvPr id="5" name="">
             <a:extLst xmlns:a="http://schemas.openxmlformats.org/drawingml/2006/main">
               <a:ext uri="{FF2B5EF4-FFF2-40B4-BE49-F238E27FC236}">
-                <a16:creationId xmlns:a16="http://schemas.microsoft.com/office/drawing/2014/main" id="{6C6D3145-3242-42BB-B84C-743EF27F81BB}"/>
+                <a16:creationId xmlns:a16="http://schemas.microsoft.com/office/drawing/2014/main" id="{17F9C5A4-75C2-49CE-8A81-292BE48C4171}"/>
               </a:ext>
             </a:extLst>
           </p:cNvPr>
@@ -4718,7 +4718,7 @@
           <p:nvPr/>
         </p:nvPicPr>
         <p:blipFill>
-          <a:blip xmlns:r="http://schemas.openxmlformats.org/officeDocument/2006/relationships" xmlns:a="http://schemas.openxmlformats.org/drawingml/2006/main" r:embed="Rb8f86f257094407c"/>
+          <a:blip xmlns:r="http://schemas.openxmlformats.org/officeDocument/2006/relationships" xmlns:a="http://schemas.openxmlformats.org/drawingml/2006/main" r:embed="Rf5fad879474547a1"/>
           <a:stretch xmlns:a="http://schemas.openxmlformats.org/drawingml/2006/main"/>
         </p:blipFill>
         <p:spPr>
@@ -4736,7 +4736,7 @@
           <p:cNvPr id="7" name="">
             <a:extLst xmlns:a="http://schemas.openxmlformats.org/drawingml/2006/main">
               <a:ext uri="{FF2B5EF4-FFF2-40B4-BE49-F238E27FC236}">
-                <a16:creationId xmlns:a16="http://schemas.microsoft.com/office/drawing/2014/main" id="{20E5E69F-AE40-4EFD-9050-4DC400DE1B4E}"/>
+                <a16:creationId xmlns:a16="http://schemas.microsoft.com/office/drawing/2014/main" id="{BA22AD67-AF19-4977-B102-2EBA8D265CD0}"/>
               </a:ext>
             </a:extLst>
           </p:cNvPr>
@@ -4771,7 +4771,7 @@
           <p:cNvPr id="8" name="">
             <a:extLst xmlns:a="http://schemas.openxmlformats.org/drawingml/2006/main">
               <a:ext uri="{FF2B5EF4-FFF2-40B4-BE49-F238E27FC236}">
-                <a16:creationId xmlns:a16="http://schemas.microsoft.com/office/drawing/2014/main" id="{D7DEC7F7-ECD4-4682-AA35-04BD8E56F55C}"/>
+                <a16:creationId xmlns:a16="http://schemas.microsoft.com/office/drawing/2014/main" id="{4DD0A770-7B9C-4CB5-8BE0-A020F0C213D4}"/>
               </a:ext>
             </a:extLst>
           </p:cNvPr>
@@ -4821,7 +4821,7 @@
           <p:cNvPr id="9" name="">
             <a:extLst xmlns:a="http://schemas.openxmlformats.org/drawingml/2006/main">
               <a:ext uri="{FF2B5EF4-FFF2-40B4-BE49-F238E27FC236}">
-                <a16:creationId xmlns:a16="http://schemas.microsoft.com/office/drawing/2014/main" id="{F63EAA64-4AE4-404A-908F-4C95479A2CDB}"/>
+                <a16:creationId xmlns:a16="http://schemas.microsoft.com/office/drawing/2014/main" id="{C6B9D07C-676A-400A-AC3B-4F4F7C84E98E}"/>
               </a:ext>
             </a:extLst>
           </p:cNvPr>
@@ -4833,30 +4833,30 @@
         <p:spPr>
           <a:xfrm xmlns:a="http://schemas.openxmlformats.org/drawingml/2006/main">
             <a:off x="1466850" y="2114550"/>
-            <a:ext cx="1524000" cy="266700"/>
-          </a:xfrm>
-          <a:prstGeom xmlns:a="http://schemas.openxmlformats.org/drawingml/2006/main" prst="rect">
-            <a:avLst/>
-          </a:prstGeom>
-          <a:noFill xmlns:a="http://schemas.openxmlformats.org/drawingml/2006/main"/>
-          <a:ln xmlns:a="http://schemas.openxmlformats.org/drawingml/2006/main" w="0">
-            <a:noFill/>
-            <a:prstDash val="solid"/>
-          </a:ln>
-        </p:spPr>
-        <p:txBody>
-          <a:bodyPr xmlns:a="http://schemas.openxmlformats.org/drawingml/2006/main"/>
-          <a:lstStyle xmlns:a="http://schemas.openxmlformats.org/drawingml/2006/main"/>
-          <a:p xmlns:a="http://schemas.openxmlformats.org/drawingml/2006/main">
-            <a:pPr>
-              <a:defRPr sz="1575" b="1">
+            <a:ext cx="1619250" cy="266700"/>
+          </a:xfrm>
+          <a:prstGeom xmlns:a="http://schemas.openxmlformats.org/drawingml/2006/main" prst="rect">
+            <a:avLst/>
+          </a:prstGeom>
+          <a:noFill xmlns:a="http://schemas.openxmlformats.org/drawingml/2006/main"/>
+          <a:ln xmlns:a="http://schemas.openxmlformats.org/drawingml/2006/main" w="0">
+            <a:noFill/>
+            <a:prstDash val="solid"/>
+          </a:ln>
+        </p:spPr>
+        <p:txBody>
+          <a:bodyPr xmlns:a="http://schemas.openxmlformats.org/drawingml/2006/main"/>
+          <a:lstStyle xmlns:a="http://schemas.openxmlformats.org/drawingml/2006/main"/>
+          <a:p xmlns:a="http://schemas.openxmlformats.org/drawingml/2006/main">
+            <a:pPr>
+              <a:defRPr sz="1500" b="1">
                 <a:solidFill>
                   <a:srgbClr val="18211F"/>
                 </a:solidFill>
               </a:defRPr>
             </a:pPr>
             <a:r>
-              <a:rPr sz="1575" b="1">
+              <a:rPr sz="1500" b="1">
                 <a:solidFill>
                   <a:srgbClr val="18211F"/>
                 </a:solidFill>
@@ -4871,7 +4871,7 @@
           <p:cNvPr id="10" name="">
             <a:extLst xmlns:a="http://schemas.openxmlformats.org/drawingml/2006/main">
               <a:ext uri="{FF2B5EF4-FFF2-40B4-BE49-F238E27FC236}">
-                <a16:creationId xmlns:a16="http://schemas.microsoft.com/office/drawing/2014/main" id="{6FA841E1-7D6B-4CCD-921C-115153A6D9DC}"/>
+                <a16:creationId xmlns:a16="http://schemas.microsoft.com/office/drawing/2014/main" id="{D0874480-A41E-4C56-B019-6C08B0D23B06}"/>
               </a:ext>
             </a:extLst>
           </p:cNvPr>
@@ -4883,6 +4883,141 @@
         <p:spPr>
           <a:xfrm xmlns:a="http://schemas.openxmlformats.org/drawingml/2006/main">
             <a:off x="4048125" y="1790700"/>
+            <a:ext cx="2647950" cy="1066800"/>
+          </a:xfrm>
+          <a:prstGeom xmlns:a="http://schemas.openxmlformats.org/drawingml/2006/main" prst="roundRect">
+            <a:avLst>
+              <a:gd name="adj" fmla="val 7143"/>
+            </a:avLst>
+          </a:prstGeom>
+          <a:solidFill xmlns:a="http://schemas.openxmlformats.org/drawingml/2006/main">
+            <a:srgbClr val="0D3D2D"/>
+          </a:solidFill>
+          <a:ln xmlns:a="http://schemas.openxmlformats.org/drawingml/2006/main" w="9525">
+            <a:solidFill>
+              <a:srgbClr val="0D3D2D"/>
+            </a:solidFill>
+            <a:prstDash val="solid"/>
+          </a:ln>
+        </p:spPr>
+      </p:sp>
+      <p:sp>
+        <p:nvSpPr>
+          <p:cNvPr id="11" name="">
+            <a:extLst xmlns:a="http://schemas.openxmlformats.org/drawingml/2006/main">
+              <a:ext uri="{FF2B5EF4-FFF2-40B4-BE49-F238E27FC236}">
+                <a16:creationId xmlns:a16="http://schemas.microsoft.com/office/drawing/2014/main" id="{C8F6DC84-DFD0-43F3-95C3-D22F50C7353E}"/>
+              </a:ext>
+            </a:extLst>
+          </p:cNvPr>
+          <p:cNvSpPr>
+            <a:spLocks xmlns:a="http://schemas.openxmlformats.org/drawingml/2006/main" noGrp="1"/>
+          </p:cNvSpPr>
+          <p:nvPr/>
+        </p:nvSpPr>
+        <p:spPr>
+          <a:xfrm xmlns:a="http://schemas.openxmlformats.org/drawingml/2006/main">
+            <a:off x="4276725" y="2038350"/>
+            <a:ext cx="342900" cy="323850"/>
+          </a:xfrm>
+          <a:prstGeom xmlns:a="http://schemas.openxmlformats.org/drawingml/2006/main" prst="rect">
+            <a:avLst/>
+          </a:prstGeom>
+          <a:noFill xmlns:a="http://schemas.openxmlformats.org/drawingml/2006/main"/>
+          <a:ln xmlns:a="http://schemas.openxmlformats.org/drawingml/2006/main" w="0">
+            <a:noFill/>
+            <a:prstDash val="solid"/>
+          </a:ln>
+        </p:spPr>
+        <p:txBody>
+          <a:bodyPr xmlns:a="http://schemas.openxmlformats.org/drawingml/2006/main"/>
+          <a:lstStyle xmlns:a="http://schemas.openxmlformats.org/drawingml/2006/main"/>
+          <a:p xmlns:a="http://schemas.openxmlformats.org/drawingml/2006/main">
+            <a:pPr>
+              <a:defRPr sz="2250" b="1">
+                <a:solidFill>
+                  <a:srgbClr val="C7A044"/>
+                </a:solidFill>
+              </a:defRPr>
+            </a:pPr>
+            <a:r>
+              <a:rPr sz="2250" b="1">
+                <a:solidFill>
+                  <a:srgbClr val="C7A044"/>
+                </a:solidFill>
+              </a:rPr>
+              <a:t>2</a:t>
+            </a:r>
+          </a:p>
+        </p:txBody>
+      </p:sp>
+      <p:sp>
+        <p:nvSpPr>
+          <p:cNvPr id="12" name="">
+            <a:extLst xmlns:a="http://schemas.openxmlformats.org/drawingml/2006/main">
+              <a:ext uri="{FF2B5EF4-FFF2-40B4-BE49-F238E27FC236}">
+                <a16:creationId xmlns:a16="http://schemas.microsoft.com/office/drawing/2014/main" id="{1BD2E3E0-D34E-4CC8-806F-F29AB6266E8A}"/>
+              </a:ext>
+            </a:extLst>
+          </p:cNvPr>
+          <p:cNvSpPr>
+            <a:spLocks xmlns:a="http://schemas.openxmlformats.org/drawingml/2006/main" noGrp="1"/>
+          </p:cNvSpPr>
+          <p:nvPr/>
+        </p:nvSpPr>
+        <p:spPr>
+          <a:xfrm xmlns:a="http://schemas.openxmlformats.org/drawingml/2006/main">
+            <a:off x="4752975" y="2114550"/>
+            <a:ext cx="1619250" cy="266700"/>
+          </a:xfrm>
+          <a:prstGeom xmlns:a="http://schemas.openxmlformats.org/drawingml/2006/main" prst="rect">
+            <a:avLst/>
+          </a:prstGeom>
+          <a:noFill xmlns:a="http://schemas.openxmlformats.org/drawingml/2006/main"/>
+          <a:ln xmlns:a="http://schemas.openxmlformats.org/drawingml/2006/main" w="0">
+            <a:noFill/>
+            <a:prstDash val="solid"/>
+          </a:ln>
+        </p:spPr>
+        <p:txBody>
+          <a:bodyPr xmlns:a="http://schemas.openxmlformats.org/drawingml/2006/main"/>
+          <a:lstStyle xmlns:a="http://schemas.openxmlformats.org/drawingml/2006/main"/>
+          <a:p xmlns:a="http://schemas.openxmlformats.org/drawingml/2006/main">
+            <a:pPr>
+              <a:defRPr sz="1500" b="1">
+                <a:solidFill>
+                  <a:srgbClr val="FFFFFF"/>
+                </a:solidFill>
+              </a:defRPr>
+            </a:pPr>
+            <a:r>
+              <a:rPr sz="1500" b="1">
+                <a:solidFill>
+                  <a:srgbClr val="FFFFFF"/>
+                </a:solidFill>
+              </a:rPr>
+              <a:t>Frontend pages</a:t>
+            </a:r>
+          </a:p>
+        </p:txBody>
+      </p:sp>
+      <p:sp>
+        <p:nvSpPr>
+          <p:cNvPr id="13" name="">
+            <a:extLst xmlns:a="http://schemas.openxmlformats.org/drawingml/2006/main">
+              <a:ext uri="{FF2B5EF4-FFF2-40B4-BE49-F238E27FC236}">
+                <a16:creationId xmlns:a16="http://schemas.microsoft.com/office/drawing/2014/main" id="{19D5D81E-6C84-4B0F-BF75-87AADA8FD528}"/>
+              </a:ext>
+            </a:extLst>
+          </p:cNvPr>
+          <p:cNvSpPr>
+            <a:spLocks xmlns:a="http://schemas.openxmlformats.org/drawingml/2006/main" noGrp="1"/>
+          </p:cNvSpPr>
+          <p:nvPr/>
+        </p:nvSpPr>
+        <p:spPr>
+          <a:xfrm xmlns:a="http://schemas.openxmlformats.org/drawingml/2006/main">
+            <a:off x="7334250" y="1790700"/>
             <a:ext cx="2647950" cy="1066800"/>
           </a:xfrm>
           <a:prstGeom xmlns:a="http://schemas.openxmlformats.org/drawingml/2006/main" prst="roundRect">
@@ -4903,21 +5038,21 @@
       </p:sp>
       <p:sp>
         <p:nvSpPr>
-          <p:cNvPr id="11" name="">
-            <a:extLst xmlns:a="http://schemas.openxmlformats.org/drawingml/2006/main">
-              <a:ext uri="{FF2B5EF4-FFF2-40B4-BE49-F238E27FC236}">
-                <a16:creationId xmlns:a16="http://schemas.microsoft.com/office/drawing/2014/main" id="{3E6A72F3-DAD1-455F-B746-40A12BAD5782}"/>
-              </a:ext>
-            </a:extLst>
-          </p:cNvPr>
-          <p:cNvSpPr>
-            <a:spLocks xmlns:a="http://schemas.openxmlformats.org/drawingml/2006/main" noGrp="1"/>
-          </p:cNvSpPr>
-          <p:nvPr/>
-        </p:nvSpPr>
-        <p:spPr>
-          <a:xfrm xmlns:a="http://schemas.openxmlformats.org/drawingml/2006/main">
-            <a:off x="4276725" y="2038350"/>
+          <p:cNvPr id="14" name="">
+            <a:extLst xmlns:a="http://schemas.openxmlformats.org/drawingml/2006/main">
+              <a:ext uri="{FF2B5EF4-FFF2-40B4-BE49-F238E27FC236}">
+                <a16:creationId xmlns:a16="http://schemas.microsoft.com/office/drawing/2014/main" id="{76589C63-B9A0-46B6-BA27-BD3EB1930739}"/>
+              </a:ext>
+            </a:extLst>
+          </p:cNvPr>
+          <p:cNvSpPr>
+            <a:spLocks xmlns:a="http://schemas.openxmlformats.org/drawingml/2006/main" noGrp="1"/>
+          </p:cNvSpPr>
+          <p:nvPr/>
+        </p:nvSpPr>
+        <p:spPr>
+          <a:xfrm xmlns:a="http://schemas.openxmlformats.org/drawingml/2006/main">
+            <a:off x="7562850" y="2038350"/>
             <a:ext cx="342900" cy="323850"/>
           </a:xfrm>
           <a:prstGeom xmlns:a="http://schemas.openxmlformats.org/drawingml/2006/main" prst="rect">
@@ -4946,78 +5081,78 @@
                   <a:srgbClr val="0D3D2D"/>
                 </a:solidFill>
               </a:rPr>
-              <a:t>2</a:t>
-            </a:r>
-          </a:p>
-        </p:txBody>
-      </p:sp>
-      <p:sp>
-        <p:nvSpPr>
-          <p:cNvPr id="12" name="">
-            <a:extLst xmlns:a="http://schemas.openxmlformats.org/drawingml/2006/main">
-              <a:ext uri="{FF2B5EF4-FFF2-40B4-BE49-F238E27FC236}">
-                <a16:creationId xmlns:a16="http://schemas.microsoft.com/office/drawing/2014/main" id="{EBE72000-F1C5-4171-A54E-D9653D5AD735}"/>
-              </a:ext>
-            </a:extLst>
-          </p:cNvPr>
-          <p:cNvSpPr>
-            <a:spLocks xmlns:a="http://schemas.openxmlformats.org/drawingml/2006/main" noGrp="1"/>
-          </p:cNvSpPr>
-          <p:nvPr/>
-        </p:nvSpPr>
-        <p:spPr>
-          <a:xfrm xmlns:a="http://schemas.openxmlformats.org/drawingml/2006/main">
-            <a:off x="4752975" y="2114550"/>
-            <a:ext cx="1524000" cy="266700"/>
-          </a:xfrm>
-          <a:prstGeom xmlns:a="http://schemas.openxmlformats.org/drawingml/2006/main" prst="rect">
-            <a:avLst/>
-          </a:prstGeom>
-          <a:noFill xmlns:a="http://schemas.openxmlformats.org/drawingml/2006/main"/>
-          <a:ln xmlns:a="http://schemas.openxmlformats.org/drawingml/2006/main" w="0">
-            <a:noFill/>
-            <a:prstDash val="solid"/>
-          </a:ln>
-        </p:spPr>
-        <p:txBody>
-          <a:bodyPr xmlns:a="http://schemas.openxmlformats.org/drawingml/2006/main"/>
-          <a:lstStyle xmlns:a="http://schemas.openxmlformats.org/drawingml/2006/main"/>
-          <a:p xmlns:a="http://schemas.openxmlformats.org/drawingml/2006/main">
-            <a:pPr>
-              <a:defRPr sz="1575" b="1">
+              <a:t>3</a:t>
+            </a:r>
+          </a:p>
+        </p:txBody>
+      </p:sp>
+      <p:sp>
+        <p:nvSpPr>
+          <p:cNvPr id="15" name="">
+            <a:extLst xmlns:a="http://schemas.openxmlformats.org/drawingml/2006/main">
+              <a:ext uri="{FF2B5EF4-FFF2-40B4-BE49-F238E27FC236}">
+                <a16:creationId xmlns:a16="http://schemas.microsoft.com/office/drawing/2014/main" id="{7E9D8593-128A-41B1-9EC2-7D87B557EA42}"/>
+              </a:ext>
+            </a:extLst>
+          </p:cNvPr>
+          <p:cNvSpPr>
+            <a:spLocks xmlns:a="http://schemas.openxmlformats.org/drawingml/2006/main" noGrp="1"/>
+          </p:cNvSpPr>
+          <p:nvPr/>
+        </p:nvSpPr>
+        <p:spPr>
+          <a:xfrm xmlns:a="http://schemas.openxmlformats.org/drawingml/2006/main">
+            <a:off x="8039100" y="2114550"/>
+            <a:ext cx="1619250" cy="266700"/>
+          </a:xfrm>
+          <a:prstGeom xmlns:a="http://schemas.openxmlformats.org/drawingml/2006/main" prst="rect">
+            <a:avLst/>
+          </a:prstGeom>
+          <a:noFill xmlns:a="http://schemas.openxmlformats.org/drawingml/2006/main"/>
+          <a:ln xmlns:a="http://schemas.openxmlformats.org/drawingml/2006/main" w="0">
+            <a:noFill/>
+            <a:prstDash val="solid"/>
+          </a:ln>
+        </p:spPr>
+        <p:txBody>
+          <a:bodyPr xmlns:a="http://schemas.openxmlformats.org/drawingml/2006/main"/>
+          <a:lstStyle xmlns:a="http://schemas.openxmlformats.org/drawingml/2006/main"/>
+          <a:p xmlns:a="http://schemas.openxmlformats.org/drawingml/2006/main">
+            <a:pPr>
+              <a:defRPr sz="1500" b="1">
                 <a:solidFill>
                   <a:srgbClr val="18211F"/>
                 </a:solidFill>
               </a:defRPr>
             </a:pPr>
             <a:r>
-              <a:rPr sz="1575" b="1">
+              <a:rPr sz="1500" b="1">
                 <a:solidFill>
                   <a:srgbClr val="18211F"/>
                 </a:solidFill>
               </a:rPr>
-              <a:t>Open dashboard</a:t>
-            </a:r>
-          </a:p>
-        </p:txBody>
-      </p:sp>
-      <p:sp>
-        <p:nvSpPr>
-          <p:cNvPr id="13" name="">
-            <a:extLst xmlns:a="http://schemas.openxmlformats.org/drawingml/2006/main">
-              <a:ext uri="{FF2B5EF4-FFF2-40B4-BE49-F238E27FC236}">
-                <a16:creationId xmlns:a16="http://schemas.microsoft.com/office/drawing/2014/main" id="{92B04A82-27C8-487C-BA2A-CFC0FFA68B72}"/>
-              </a:ext>
-            </a:extLst>
-          </p:cNvPr>
-          <p:cNvSpPr>
-            <a:spLocks xmlns:a="http://schemas.openxmlformats.org/drawingml/2006/main" noGrp="1"/>
-          </p:cNvSpPr>
-          <p:nvPr/>
-        </p:nvSpPr>
-        <p:spPr>
-          <a:xfrm xmlns:a="http://schemas.openxmlformats.org/drawingml/2006/main">
-            <a:off x="7334250" y="1790700"/>
+              <a:t>Backend health</a:t>
+            </a:r>
+          </a:p>
+        </p:txBody>
+      </p:sp>
+      <p:sp>
+        <p:nvSpPr>
+          <p:cNvPr id="16" name="">
+            <a:extLst xmlns:a="http://schemas.openxmlformats.org/drawingml/2006/main">
+              <a:ext uri="{FF2B5EF4-FFF2-40B4-BE49-F238E27FC236}">
+                <a16:creationId xmlns:a16="http://schemas.microsoft.com/office/drawing/2014/main" id="{8E4C6D0D-82B3-42CE-87CE-B36997F2F8B7}"/>
+              </a:ext>
+            </a:extLst>
+          </p:cNvPr>
+          <p:cNvSpPr>
+            <a:spLocks xmlns:a="http://schemas.openxmlformats.org/drawingml/2006/main" noGrp="1"/>
+          </p:cNvSpPr>
+          <p:nvPr/>
+        </p:nvSpPr>
+        <p:spPr>
+          <a:xfrm xmlns:a="http://schemas.openxmlformats.org/drawingml/2006/main">
+            <a:off x="762000" y="3733800"/>
             <a:ext cx="2647950" cy="1066800"/>
           </a:xfrm>
           <a:prstGeom xmlns:a="http://schemas.openxmlformats.org/drawingml/2006/main" prst="roundRect">
@@ -5038,21 +5173,21 @@
       </p:sp>
       <p:sp>
         <p:nvSpPr>
-          <p:cNvPr id="14" name="">
-            <a:extLst xmlns:a="http://schemas.openxmlformats.org/drawingml/2006/main">
-              <a:ext uri="{FF2B5EF4-FFF2-40B4-BE49-F238E27FC236}">
-                <a16:creationId xmlns:a16="http://schemas.microsoft.com/office/drawing/2014/main" id="{EB09A8F8-6B98-4F29-B830-A484C5A72A3D}"/>
-              </a:ext>
-            </a:extLst>
-          </p:cNvPr>
-          <p:cNvSpPr>
-            <a:spLocks xmlns:a="http://schemas.openxmlformats.org/drawingml/2006/main" noGrp="1"/>
-          </p:cNvSpPr>
-          <p:nvPr/>
-        </p:nvSpPr>
-        <p:spPr>
-          <a:xfrm xmlns:a="http://schemas.openxmlformats.org/drawingml/2006/main">
-            <a:off x="7562850" y="2038350"/>
+          <p:cNvPr id="17" name="">
+            <a:extLst xmlns:a="http://schemas.openxmlformats.org/drawingml/2006/main">
+              <a:ext uri="{FF2B5EF4-FFF2-40B4-BE49-F238E27FC236}">
+                <a16:creationId xmlns:a16="http://schemas.microsoft.com/office/drawing/2014/main" id="{A01A4F27-F7D6-45BB-A41B-0588B3A96FC3}"/>
+              </a:ext>
+            </a:extLst>
+          </p:cNvPr>
+          <p:cNvSpPr>
+            <a:spLocks xmlns:a="http://schemas.openxmlformats.org/drawingml/2006/main" noGrp="1"/>
+          </p:cNvSpPr>
+          <p:nvPr/>
+        </p:nvSpPr>
+        <p:spPr>
+          <a:xfrm xmlns:a="http://schemas.openxmlformats.org/drawingml/2006/main">
+            <a:off x="990600" y="3981450"/>
             <a:ext cx="342900" cy="323850"/>
           </a:xfrm>
           <a:prstGeom xmlns:a="http://schemas.openxmlformats.org/drawingml/2006/main" prst="rect">
@@ -5081,78 +5216,78 @@
                   <a:srgbClr val="0D3D2D"/>
                 </a:solidFill>
               </a:rPr>
-              <a:t>3</a:t>
-            </a:r>
-          </a:p>
-        </p:txBody>
-      </p:sp>
-      <p:sp>
-        <p:nvSpPr>
-          <p:cNvPr id="15" name="">
-            <a:extLst xmlns:a="http://schemas.openxmlformats.org/drawingml/2006/main">
-              <a:ext uri="{FF2B5EF4-FFF2-40B4-BE49-F238E27FC236}">
-                <a16:creationId xmlns:a16="http://schemas.microsoft.com/office/drawing/2014/main" id="{35A84C74-B135-478A-A077-2E5B596E90B8}"/>
-              </a:ext>
-            </a:extLst>
-          </p:cNvPr>
-          <p:cNvSpPr>
-            <a:spLocks xmlns:a="http://schemas.openxmlformats.org/drawingml/2006/main" noGrp="1"/>
-          </p:cNvSpPr>
-          <p:nvPr/>
-        </p:nvSpPr>
-        <p:spPr>
-          <a:xfrm xmlns:a="http://schemas.openxmlformats.org/drawingml/2006/main">
-            <a:off x="8039100" y="2114550"/>
-            <a:ext cx="1524000" cy="266700"/>
-          </a:xfrm>
-          <a:prstGeom xmlns:a="http://schemas.openxmlformats.org/drawingml/2006/main" prst="rect">
-            <a:avLst/>
-          </a:prstGeom>
-          <a:noFill xmlns:a="http://schemas.openxmlformats.org/drawingml/2006/main"/>
-          <a:ln xmlns:a="http://schemas.openxmlformats.org/drawingml/2006/main" w="0">
-            <a:noFill/>
-            <a:prstDash val="solid"/>
-          </a:ln>
-        </p:spPr>
-        <p:txBody>
-          <a:bodyPr xmlns:a="http://schemas.openxmlformats.org/drawingml/2006/main"/>
-          <a:lstStyle xmlns:a="http://schemas.openxmlformats.org/drawingml/2006/main"/>
-          <a:p xmlns:a="http://schemas.openxmlformats.org/drawingml/2006/main">
-            <a:pPr>
-              <a:defRPr sz="1575" b="1">
+              <a:t>4</a:t>
+            </a:r>
+          </a:p>
+        </p:txBody>
+      </p:sp>
+      <p:sp>
+        <p:nvSpPr>
+          <p:cNvPr id="18" name="">
+            <a:extLst xmlns:a="http://schemas.openxmlformats.org/drawingml/2006/main">
+              <a:ext uri="{FF2B5EF4-FFF2-40B4-BE49-F238E27FC236}">
+                <a16:creationId xmlns:a16="http://schemas.microsoft.com/office/drawing/2014/main" id="{D0FF1F2F-F9D8-46E7-A8E8-E17FC95ED7F2}"/>
+              </a:ext>
+            </a:extLst>
+          </p:cNvPr>
+          <p:cNvSpPr>
+            <a:spLocks xmlns:a="http://schemas.openxmlformats.org/drawingml/2006/main" noGrp="1"/>
+          </p:cNvSpPr>
+          <p:nvPr/>
+        </p:nvSpPr>
+        <p:spPr>
+          <a:xfrm xmlns:a="http://schemas.openxmlformats.org/drawingml/2006/main">
+            <a:off x="1466850" y="4057650"/>
+            <a:ext cx="1619250" cy="266700"/>
+          </a:xfrm>
+          <a:prstGeom xmlns:a="http://schemas.openxmlformats.org/drawingml/2006/main" prst="rect">
+            <a:avLst/>
+          </a:prstGeom>
+          <a:noFill xmlns:a="http://schemas.openxmlformats.org/drawingml/2006/main"/>
+          <a:ln xmlns:a="http://schemas.openxmlformats.org/drawingml/2006/main" w="0">
+            <a:noFill/>
+            <a:prstDash val="solid"/>
+          </a:ln>
+        </p:spPr>
+        <p:txBody>
+          <a:bodyPr xmlns:a="http://schemas.openxmlformats.org/drawingml/2006/main"/>
+          <a:lstStyle xmlns:a="http://schemas.openxmlformats.org/drawingml/2006/main"/>
+          <a:p xmlns:a="http://schemas.openxmlformats.org/drawingml/2006/main">
+            <a:pPr>
+              <a:defRPr sz="1500" b="1">
                 <a:solidFill>
                   <a:srgbClr val="18211F"/>
                 </a:solidFill>
               </a:defRPr>
             </a:pPr>
             <a:r>
-              <a:rPr sz="1575" b="1">
+              <a:rPr sz="1500" b="1">
                 <a:solidFill>
                   <a:srgbClr val="18211F"/>
                 </a:solidFill>
               </a:rPr>
-              <a:t>Search book</a:t>
-            </a:r>
-          </a:p>
-        </p:txBody>
-      </p:sp>
-      <p:sp>
-        <p:nvSpPr>
-          <p:cNvPr id="16" name="">
-            <a:extLst xmlns:a="http://schemas.openxmlformats.org/drawingml/2006/main">
-              <a:ext uri="{FF2B5EF4-FFF2-40B4-BE49-F238E27FC236}">
-                <a16:creationId xmlns:a16="http://schemas.microsoft.com/office/drawing/2014/main" id="{25E4D1F4-AA59-4DAE-8DE9-2387DA0098A6}"/>
-              </a:ext>
-            </a:extLst>
-          </p:cNvPr>
-          <p:cNvSpPr>
-            <a:spLocks xmlns:a="http://schemas.openxmlformats.org/drawingml/2006/main" noGrp="1"/>
-          </p:cNvSpPr>
-          <p:nvPr/>
-        </p:nvSpPr>
-        <p:spPr>
-          <a:xfrm xmlns:a="http://schemas.openxmlformats.org/drawingml/2006/main">
-            <a:off x="762000" y="3733800"/>
+              <a:t>Database tables</a:t>
+            </a:r>
+          </a:p>
+        </p:txBody>
+      </p:sp>
+      <p:sp>
+        <p:nvSpPr>
+          <p:cNvPr id="19" name="">
+            <a:extLst xmlns:a="http://schemas.openxmlformats.org/drawingml/2006/main">
+              <a:ext uri="{FF2B5EF4-FFF2-40B4-BE49-F238E27FC236}">
+                <a16:creationId xmlns:a16="http://schemas.microsoft.com/office/drawing/2014/main" id="{D2759782-94F6-47A0-90CA-D4C81F587D29}"/>
+              </a:ext>
+            </a:extLst>
+          </p:cNvPr>
+          <p:cNvSpPr>
+            <a:spLocks xmlns:a="http://schemas.openxmlformats.org/drawingml/2006/main" noGrp="1"/>
+          </p:cNvSpPr>
+          <p:nvPr/>
+        </p:nvSpPr>
+        <p:spPr>
+          <a:xfrm xmlns:a="http://schemas.openxmlformats.org/drawingml/2006/main">
+            <a:off x="4048125" y="3733800"/>
             <a:ext cx="2647950" cy="1066800"/>
           </a:xfrm>
           <a:prstGeom xmlns:a="http://schemas.openxmlformats.org/drawingml/2006/main" prst="roundRect">
@@ -5173,145 +5308,10 @@
       </p:sp>
       <p:sp>
         <p:nvSpPr>
-          <p:cNvPr id="17" name="">
-            <a:extLst xmlns:a="http://schemas.openxmlformats.org/drawingml/2006/main">
-              <a:ext uri="{FF2B5EF4-FFF2-40B4-BE49-F238E27FC236}">
-                <a16:creationId xmlns:a16="http://schemas.microsoft.com/office/drawing/2014/main" id="{DCB785B4-99AA-4E03-9112-EC3AD7B2BBD7}"/>
-              </a:ext>
-            </a:extLst>
-          </p:cNvPr>
-          <p:cNvSpPr>
-            <a:spLocks xmlns:a="http://schemas.openxmlformats.org/drawingml/2006/main" noGrp="1"/>
-          </p:cNvSpPr>
-          <p:nvPr/>
-        </p:nvSpPr>
-        <p:spPr>
-          <a:xfrm xmlns:a="http://schemas.openxmlformats.org/drawingml/2006/main">
-            <a:off x="990600" y="3981450"/>
-            <a:ext cx="342900" cy="323850"/>
-          </a:xfrm>
-          <a:prstGeom xmlns:a="http://schemas.openxmlformats.org/drawingml/2006/main" prst="rect">
-            <a:avLst/>
-          </a:prstGeom>
-          <a:noFill xmlns:a="http://schemas.openxmlformats.org/drawingml/2006/main"/>
-          <a:ln xmlns:a="http://schemas.openxmlformats.org/drawingml/2006/main" w="0">
-            <a:noFill/>
-            <a:prstDash val="solid"/>
-          </a:ln>
-        </p:spPr>
-        <p:txBody>
-          <a:bodyPr xmlns:a="http://schemas.openxmlformats.org/drawingml/2006/main"/>
-          <a:lstStyle xmlns:a="http://schemas.openxmlformats.org/drawingml/2006/main"/>
-          <a:p xmlns:a="http://schemas.openxmlformats.org/drawingml/2006/main">
-            <a:pPr>
-              <a:defRPr sz="2250" b="1">
-                <a:solidFill>
-                  <a:srgbClr val="0D3D2D"/>
-                </a:solidFill>
-              </a:defRPr>
-            </a:pPr>
-            <a:r>
-              <a:rPr sz="2250" b="1">
-                <a:solidFill>
-                  <a:srgbClr val="0D3D2D"/>
-                </a:solidFill>
-              </a:rPr>
-              <a:t>4</a:t>
-            </a:r>
-          </a:p>
-        </p:txBody>
-      </p:sp>
-      <p:sp>
-        <p:nvSpPr>
-          <p:cNvPr id="18" name="">
-            <a:extLst xmlns:a="http://schemas.openxmlformats.org/drawingml/2006/main">
-              <a:ext uri="{FF2B5EF4-FFF2-40B4-BE49-F238E27FC236}">
-                <a16:creationId xmlns:a16="http://schemas.microsoft.com/office/drawing/2014/main" id="{274713E8-837C-4139-918D-0F333718BCDF}"/>
-              </a:ext>
-            </a:extLst>
-          </p:cNvPr>
-          <p:cNvSpPr>
-            <a:spLocks xmlns:a="http://schemas.openxmlformats.org/drawingml/2006/main" noGrp="1"/>
-          </p:cNvSpPr>
-          <p:nvPr/>
-        </p:nvSpPr>
-        <p:spPr>
-          <a:xfrm xmlns:a="http://schemas.openxmlformats.org/drawingml/2006/main">
-            <a:off x="1466850" y="4057650"/>
-            <a:ext cx="1524000" cy="266700"/>
-          </a:xfrm>
-          <a:prstGeom xmlns:a="http://schemas.openxmlformats.org/drawingml/2006/main" prst="rect">
-            <a:avLst/>
-          </a:prstGeom>
-          <a:noFill xmlns:a="http://schemas.openxmlformats.org/drawingml/2006/main"/>
-          <a:ln xmlns:a="http://schemas.openxmlformats.org/drawingml/2006/main" w="0">
-            <a:noFill/>
-            <a:prstDash val="solid"/>
-          </a:ln>
-        </p:spPr>
-        <p:txBody>
-          <a:bodyPr xmlns:a="http://schemas.openxmlformats.org/drawingml/2006/main"/>
-          <a:lstStyle xmlns:a="http://schemas.openxmlformats.org/drawingml/2006/main"/>
-          <a:p xmlns:a="http://schemas.openxmlformats.org/drawingml/2006/main">
-            <a:pPr>
-              <a:defRPr sz="1575" b="1">
-                <a:solidFill>
-                  <a:srgbClr val="18211F"/>
-                </a:solidFill>
-              </a:defRPr>
-            </a:pPr>
-            <a:r>
-              <a:rPr sz="1575" b="1">
-                <a:solidFill>
-                  <a:srgbClr val="18211F"/>
-                </a:solidFill>
-              </a:rPr>
-              <a:t>Voice search</a:t>
-            </a:r>
-          </a:p>
-        </p:txBody>
-      </p:sp>
-      <p:sp>
-        <p:nvSpPr>
-          <p:cNvPr id="19" name="">
-            <a:extLst xmlns:a="http://schemas.openxmlformats.org/drawingml/2006/main">
-              <a:ext uri="{FF2B5EF4-FFF2-40B4-BE49-F238E27FC236}">
-                <a16:creationId xmlns:a16="http://schemas.microsoft.com/office/drawing/2014/main" id="{EB016FE8-534F-42BA-BC56-3136618ABD65}"/>
-              </a:ext>
-            </a:extLst>
-          </p:cNvPr>
-          <p:cNvSpPr>
-            <a:spLocks xmlns:a="http://schemas.openxmlformats.org/drawingml/2006/main" noGrp="1"/>
-          </p:cNvSpPr>
-          <p:nvPr/>
-        </p:nvSpPr>
-        <p:spPr>
-          <a:xfrm xmlns:a="http://schemas.openxmlformats.org/drawingml/2006/main">
-            <a:off x="4048125" y="3733800"/>
-            <a:ext cx="2647950" cy="1066800"/>
-          </a:xfrm>
-          <a:prstGeom xmlns:a="http://schemas.openxmlformats.org/drawingml/2006/main" prst="roundRect">
-            <a:avLst>
-              <a:gd name="adj" fmla="val 7143"/>
-            </a:avLst>
-          </a:prstGeom>
-          <a:solidFill xmlns:a="http://schemas.openxmlformats.org/drawingml/2006/main">
-            <a:srgbClr val="0D3D2D"/>
-          </a:solidFill>
-          <a:ln xmlns:a="http://schemas.openxmlformats.org/drawingml/2006/main" w="9525">
-            <a:solidFill>
-              <a:srgbClr val="0D3D2D"/>
-            </a:solidFill>
-            <a:prstDash val="solid"/>
-          </a:ln>
-        </p:spPr>
-      </p:sp>
-      <p:sp>
-        <p:nvSpPr>
           <p:cNvPr id="20" name="">
             <a:extLst xmlns:a="http://schemas.openxmlformats.org/drawingml/2006/main">
               <a:ext uri="{FF2B5EF4-FFF2-40B4-BE49-F238E27FC236}">
-                <a16:creationId xmlns:a16="http://schemas.microsoft.com/office/drawing/2014/main" id="{67AA7AA1-7FBF-41A4-ADE3-BEE806538EF4}"/>
+                <a16:creationId xmlns:a16="http://schemas.microsoft.com/office/drawing/2014/main" id="{642EB99F-E7E3-457D-955B-05D296790CA2}"/>
               </a:ext>
             </a:extLst>
           </p:cNvPr>
@@ -5341,14 +5341,14 @@
             <a:pPr>
               <a:defRPr sz="2250" b="1">
                 <a:solidFill>
-                  <a:srgbClr val="C7A044"/>
+                  <a:srgbClr val="0D3D2D"/>
                 </a:solidFill>
               </a:defRPr>
             </a:pPr>
             <a:r>
               <a:rPr sz="2250" b="1">
                 <a:solidFill>
-                  <a:srgbClr val="C7A044"/>
+                  <a:srgbClr val="0D3D2D"/>
                 </a:solidFill>
               </a:rPr>
               <a:t>5</a:t>
@@ -5361,7 +5361,7 @@
           <p:cNvPr id="21" name="">
             <a:extLst xmlns:a="http://schemas.openxmlformats.org/drawingml/2006/main">
               <a:ext uri="{FF2B5EF4-FFF2-40B4-BE49-F238E27FC236}">
-                <a16:creationId xmlns:a16="http://schemas.microsoft.com/office/drawing/2014/main" id="{56119A48-D918-4671-87CF-5714CA52CDFE}"/>
+                <a16:creationId xmlns:a16="http://schemas.microsoft.com/office/drawing/2014/main" id="{58A83903-BA65-405E-AA69-1DB0623466A8}"/>
               </a:ext>
             </a:extLst>
           </p:cNvPr>
@@ -5373,35 +5373,35 @@
         <p:spPr>
           <a:xfrm xmlns:a="http://schemas.openxmlformats.org/drawingml/2006/main">
             <a:off x="4752975" y="4057650"/>
-            <a:ext cx="1524000" cy="266700"/>
-          </a:xfrm>
-          <a:prstGeom xmlns:a="http://schemas.openxmlformats.org/drawingml/2006/main" prst="rect">
-            <a:avLst/>
-          </a:prstGeom>
-          <a:noFill xmlns:a="http://schemas.openxmlformats.org/drawingml/2006/main"/>
-          <a:ln xmlns:a="http://schemas.openxmlformats.org/drawingml/2006/main" w="0">
-            <a:noFill/>
-            <a:prstDash val="solid"/>
-          </a:ln>
-        </p:spPr>
-        <p:txBody>
-          <a:bodyPr xmlns:a="http://schemas.openxmlformats.org/drawingml/2006/main"/>
-          <a:lstStyle xmlns:a="http://schemas.openxmlformats.org/drawingml/2006/main"/>
-          <a:p xmlns:a="http://schemas.openxmlformats.org/drawingml/2006/main">
-            <a:pPr>
-              <a:defRPr sz="1575" b="1">
-                <a:solidFill>
-                  <a:srgbClr val="FFFFFF"/>
-                </a:solidFill>
-              </a:defRPr>
-            </a:pPr>
-            <a:r>
-              <a:rPr sz="1575" b="1">
-                <a:solidFill>
-                  <a:srgbClr val="FFFFFF"/>
-                </a:solidFill>
-              </a:rPr>
-              <a:t>Play narration</a:t>
+            <a:ext cx="1619250" cy="266700"/>
+          </a:xfrm>
+          <a:prstGeom xmlns:a="http://schemas.openxmlformats.org/drawingml/2006/main" prst="rect">
+            <a:avLst/>
+          </a:prstGeom>
+          <a:noFill xmlns:a="http://schemas.openxmlformats.org/drawingml/2006/main"/>
+          <a:ln xmlns:a="http://schemas.openxmlformats.org/drawingml/2006/main" w="0">
+            <a:noFill/>
+            <a:prstDash val="solid"/>
+          </a:ln>
+        </p:spPr>
+        <p:txBody>
+          <a:bodyPr xmlns:a="http://schemas.openxmlformats.org/drawingml/2006/main"/>
+          <a:lstStyle xmlns:a="http://schemas.openxmlformats.org/drawingml/2006/main"/>
+          <a:p xmlns:a="http://schemas.openxmlformats.org/drawingml/2006/main">
+            <a:pPr>
+              <a:defRPr sz="1500" b="1">
+                <a:solidFill>
+                  <a:srgbClr val="18211F"/>
+                </a:solidFill>
+              </a:defRPr>
+            </a:pPr>
+            <a:r>
+              <a:rPr sz="1500" b="1">
+                <a:solidFill>
+                  <a:srgbClr val="18211F"/>
+                </a:solidFill>
+              </a:rPr>
+              <a:t>Voice search</a:t>
             </a:r>
           </a:p>
         </p:txBody>
@@ -5411,7 +5411,7 @@
           <p:cNvPr id="22" name="">
             <a:extLst xmlns:a="http://schemas.openxmlformats.org/drawingml/2006/main">
               <a:ext uri="{FF2B5EF4-FFF2-40B4-BE49-F238E27FC236}">
-                <a16:creationId xmlns:a16="http://schemas.microsoft.com/office/drawing/2014/main" id="{FA9C4C82-D5E3-4F3B-AAAF-34413C9A5E28}"/>
+                <a16:creationId xmlns:a16="http://schemas.microsoft.com/office/drawing/2014/main" id="{4B4ED0AC-BD6D-45AC-876C-B919411737DA}"/>
               </a:ext>
             </a:extLst>
           </p:cNvPr>
@@ -5446,7 +5446,7 @@
           <p:cNvPr id="23" name="">
             <a:extLst xmlns:a="http://schemas.openxmlformats.org/drawingml/2006/main">
               <a:ext uri="{FF2B5EF4-FFF2-40B4-BE49-F238E27FC236}">
-                <a16:creationId xmlns:a16="http://schemas.microsoft.com/office/drawing/2014/main" id="{BEF70702-9C7C-472C-B60E-DFA42B1A4EE0}"/>
+                <a16:creationId xmlns:a16="http://schemas.microsoft.com/office/drawing/2014/main" id="{F9C1CEF3-4729-427D-9C01-1011DD1EC06C}"/>
               </a:ext>
             </a:extLst>
           </p:cNvPr>
@@ -5496,7 +5496,7 @@
           <p:cNvPr id="24" name="">
             <a:extLst xmlns:a="http://schemas.openxmlformats.org/drawingml/2006/main">
               <a:ext uri="{FF2B5EF4-FFF2-40B4-BE49-F238E27FC236}">
-                <a16:creationId xmlns:a16="http://schemas.microsoft.com/office/drawing/2014/main" id="{93A40D71-BF6D-479F-81EF-8204334722ED}"/>
+                <a16:creationId xmlns:a16="http://schemas.microsoft.com/office/drawing/2014/main" id="{E0DA4E25-DFE7-452A-BB97-E3FAE5435605}"/>
               </a:ext>
             </a:extLst>
           </p:cNvPr>
@@ -5508,35 +5508,35 @@
         <p:spPr>
           <a:xfrm xmlns:a="http://schemas.openxmlformats.org/drawingml/2006/main">
             <a:off x="8039100" y="4057650"/>
-            <a:ext cx="1524000" cy="266700"/>
-          </a:xfrm>
-          <a:prstGeom xmlns:a="http://schemas.openxmlformats.org/drawingml/2006/main" prst="rect">
-            <a:avLst/>
-          </a:prstGeom>
-          <a:noFill xmlns:a="http://schemas.openxmlformats.org/drawingml/2006/main"/>
-          <a:ln xmlns:a="http://schemas.openxmlformats.org/drawingml/2006/main" w="0">
-            <a:noFill/>
-            <a:prstDash val="solid"/>
-          </a:ln>
-        </p:spPr>
-        <p:txBody>
-          <a:bodyPr xmlns:a="http://schemas.openxmlformats.org/drawingml/2006/main"/>
-          <a:lstStyle xmlns:a="http://schemas.openxmlformats.org/drawingml/2006/main"/>
-          <a:p xmlns:a="http://schemas.openxmlformats.org/drawingml/2006/main">
-            <a:pPr>
-              <a:defRPr sz="1575" b="1">
+            <a:ext cx="1619250" cy="266700"/>
+          </a:xfrm>
+          <a:prstGeom xmlns:a="http://schemas.openxmlformats.org/drawingml/2006/main" prst="rect">
+            <a:avLst/>
+          </a:prstGeom>
+          <a:noFill xmlns:a="http://schemas.openxmlformats.org/drawingml/2006/main"/>
+          <a:ln xmlns:a="http://schemas.openxmlformats.org/drawingml/2006/main" w="0">
+            <a:noFill/>
+            <a:prstDash val="solid"/>
+          </a:ln>
+        </p:spPr>
+        <p:txBody>
+          <a:bodyPr xmlns:a="http://schemas.openxmlformats.org/drawingml/2006/main"/>
+          <a:lstStyle xmlns:a="http://schemas.openxmlformats.org/drawingml/2006/main"/>
+          <a:p xmlns:a="http://schemas.openxmlformats.org/drawingml/2006/main">
+            <a:pPr>
+              <a:defRPr sz="1500" b="1">
                 <a:solidFill>
                   <a:srgbClr val="18211F"/>
                 </a:solidFill>
               </a:defRPr>
             </a:pPr>
             <a:r>
-              <a:rPr sz="1575" b="1">
+              <a:rPr sz="1500" b="1">
                 <a:solidFill>
                   <a:srgbClr val="18211F"/>
                 </a:solidFill>
               </a:rPr>
-              <a:t>Check admin/report</a:t>
+              <a:t>Play narration</a:t>
             </a:r>
           </a:p>
         </p:txBody>
@@ -5546,18 +5546,18 @@
           <p:cNvPr id="25" name="">
             <a:extLst xmlns:a="http://schemas.openxmlformats.org/drawingml/2006/main">
               <a:ext uri="{FF2B5EF4-FFF2-40B4-BE49-F238E27FC236}">
-                <a16:creationId xmlns:a16="http://schemas.microsoft.com/office/drawing/2014/main" id="{B7A62E28-5571-48AB-852C-6538A7079E67}"/>
-              </a:ext>
-            </a:extLst>
-          </p:cNvPr>
-          <p:cNvSpPr>
-            <a:spLocks xmlns:a="http://schemas.openxmlformats.org/drawingml/2006/main" noGrp="1"/>
-          </p:cNvSpPr>
-          <p:nvPr/>
-        </p:nvSpPr>
-        <p:spPr>
-          <a:xfrm xmlns:a="http://schemas.openxmlformats.org/drawingml/2006/main">
-            <a:off x="876300" y="5391150"/>
+                <a16:creationId xmlns:a16="http://schemas.microsoft.com/office/drawing/2014/main" id="{BA9147A0-12B2-4E45-861D-78F86EF2074F}"/>
+              </a:ext>
+            </a:extLst>
+          </p:cNvPr>
+          <p:cNvSpPr>
+            <a:spLocks xmlns:a="http://schemas.openxmlformats.org/drawingml/2006/main" noGrp="1"/>
+          </p:cNvSpPr>
+          <p:nvPr/>
+        </p:nvSpPr>
+        <p:spPr>
+          <a:xfrm xmlns:a="http://schemas.openxmlformats.org/drawingml/2006/main">
+            <a:off x="876300" y="5295900"/>
             <a:ext cx="8858250" cy="400050"/>
           </a:xfrm>
           <a:prstGeom xmlns:a="http://schemas.openxmlformats.org/drawingml/2006/main" prst="rect">
@@ -5586,7 +5586,7 @@
                   <a:srgbClr val="18211F"/>
                 </a:solidFill>
               </a:rPr>
-              <a:t>Before defense: start XAMPP, run backend checks, make sure Python speech services are ready, then open the React/Vite frontend.</a:t>
+              <a:t>Show frontend as the visible React/Vite pages, backend as the PHP health/API behavior, and database as MySQL tables in phpMyAdmin.</a:t>
             </a:r>
           </a:p>
         </p:txBody>
@@ -5594,7 +5594,7 @@
     </p:spTree>
     <p:extLst>
       <p:ext uri="{BB962C8B-B14F-4D97-AF65-F5344CB8AC3E}">
-        <p14:creationId xmlns:p14="http://schemas.microsoft.com/office/powerpoint/2010/main" val="624618808"/>
+        <p14:creationId xmlns:p14="http://schemas.microsoft.com/office/powerpoint/2010/main" val="1567660814"/>
       </p:ext>
     </p:extLst>
   </p:cSld>
@@ -5625,7 +5625,7 @@
           <p:cNvPr id="1" name="">
             <a:extLst xmlns:a="http://schemas.openxmlformats.org/drawingml/2006/main">
               <a:ext uri="{FF2B5EF4-FFF2-40B4-BE49-F238E27FC236}">
-                <a16:creationId xmlns:a16="http://schemas.microsoft.com/office/drawing/2014/main" id="{1DECBF84-BD6E-4977-BF82-09FE619B97C6}"/>
+                <a16:creationId xmlns:a16="http://schemas.microsoft.com/office/drawing/2014/main" id="{62FFC055-87D9-4D9B-9A30-32E36840D303}"/>
               </a:ext>
             </a:extLst>
           </p:cNvPr>
@@ -5658,7 +5658,7 @@
           <p:cNvPr id="2" name="">
             <a:extLst xmlns:a="http://schemas.openxmlformats.org/drawingml/2006/main">
               <a:ext uri="{FF2B5EF4-FFF2-40B4-BE49-F238E27FC236}">
-                <a16:creationId xmlns:a16="http://schemas.microsoft.com/office/drawing/2014/main" id="{E6FA67EF-AAA9-47B3-8CFB-D30B329094BB}"/>
+                <a16:creationId xmlns:a16="http://schemas.microsoft.com/office/drawing/2014/main" id="{675ECB7C-7FD0-49E9-B860-8C215B0A1860}"/>
               </a:ext>
             </a:extLst>
           </p:cNvPr>
@@ -5691,7 +5691,7 @@
           <p:cNvPr id="3" name="">
             <a:extLst xmlns:a="http://schemas.openxmlformats.org/drawingml/2006/main">
               <a:ext uri="{FF2B5EF4-FFF2-40B4-BE49-F238E27FC236}">
-                <a16:creationId xmlns:a16="http://schemas.microsoft.com/office/drawing/2014/main" id="{F9A19DCB-BF66-4443-83E7-C595D25A9458}"/>
+                <a16:creationId xmlns:a16="http://schemas.microsoft.com/office/drawing/2014/main" id="{9821D6C1-1CD8-4B0A-8332-162CC8B2966B}"/>
               </a:ext>
             </a:extLst>
           </p:cNvPr>
@@ -5741,7 +5741,7 @@
           <p:cNvPr id="4" name="">
             <a:extLst xmlns:a="http://schemas.openxmlformats.org/drawingml/2006/main">
               <a:ext uri="{FF2B5EF4-FFF2-40B4-BE49-F238E27FC236}">
-                <a16:creationId xmlns:a16="http://schemas.microsoft.com/office/drawing/2014/main" id="{0557F73B-3747-4F96-B267-2332C1565577}"/>
+                <a16:creationId xmlns:a16="http://schemas.microsoft.com/office/drawing/2014/main" id="{3A4DD8D4-21A1-467A-8260-7B9EEC15AB3A}"/>
               </a:ext>
             </a:extLst>
           </p:cNvPr>
@@ -5791,7 +5791,7 @@
           <p:cNvPr id="5" name="">
             <a:extLst xmlns:a="http://schemas.openxmlformats.org/drawingml/2006/main">
               <a:ext uri="{FF2B5EF4-FFF2-40B4-BE49-F238E27FC236}">
-                <a16:creationId xmlns:a16="http://schemas.microsoft.com/office/drawing/2014/main" id="{10BD786A-3219-4F45-8242-CFAAC439D555}"/>
+                <a16:creationId xmlns:a16="http://schemas.microsoft.com/office/drawing/2014/main" id="{8D7509D8-6A83-460A-901A-309C2FCB24CC}"/>
               </a:ext>
             </a:extLst>
           </p:cNvPr>
@@ -5826,7 +5826,7 @@
           <p:nvPr/>
         </p:nvPicPr>
         <p:blipFill>
-          <a:blip xmlns:r="http://schemas.openxmlformats.org/officeDocument/2006/relationships" xmlns:a="http://schemas.openxmlformats.org/drawingml/2006/main" r:embed="R63adadf5902a4262"/>
+          <a:blip xmlns:r="http://schemas.openxmlformats.org/officeDocument/2006/relationships" xmlns:a="http://schemas.openxmlformats.org/drawingml/2006/main" r:embed="Rd0fe11fa5dcd4ef4"/>
           <a:stretch xmlns:a="http://schemas.openxmlformats.org/drawingml/2006/main"/>
         </p:blipFill>
         <p:spPr>
@@ -5844,7 +5844,7 @@
           <p:cNvPr id="7" name="">
             <a:extLst xmlns:a="http://schemas.openxmlformats.org/drawingml/2006/main">
               <a:ext uri="{FF2B5EF4-FFF2-40B4-BE49-F238E27FC236}">
-                <a16:creationId xmlns:a16="http://schemas.microsoft.com/office/drawing/2014/main" id="{1FC5A228-ACE2-4320-8190-5ADDA78882C0}"/>
+                <a16:creationId xmlns:a16="http://schemas.microsoft.com/office/drawing/2014/main" id="{D298C67B-C010-442D-8725-0E0117690F2F}"/>
               </a:ext>
             </a:extLst>
           </p:cNvPr>
@@ -5877,7 +5877,7 @@
           <p:cNvPr id="8" name="">
             <a:extLst xmlns:a="http://schemas.openxmlformats.org/drawingml/2006/main">
               <a:ext uri="{FF2B5EF4-FFF2-40B4-BE49-F238E27FC236}">
-                <a16:creationId xmlns:a16="http://schemas.microsoft.com/office/drawing/2014/main" id="{21534F97-303D-40F0-88F5-D4BE8A483BC7}"/>
+                <a16:creationId xmlns:a16="http://schemas.microsoft.com/office/drawing/2014/main" id="{E24F8805-7D28-4DB3-ACC6-7759AA0B9463}"/>
               </a:ext>
             </a:extLst>
           </p:cNvPr>
@@ -5927,7 +5927,7 @@
           <p:cNvPr id="9" name="">
             <a:extLst xmlns:a="http://schemas.openxmlformats.org/drawingml/2006/main">
               <a:ext uri="{FF2B5EF4-FFF2-40B4-BE49-F238E27FC236}">
-                <a16:creationId xmlns:a16="http://schemas.microsoft.com/office/drawing/2014/main" id="{05C43641-B5C9-4586-B056-0AFB710E8C52}"/>
+                <a16:creationId xmlns:a16="http://schemas.microsoft.com/office/drawing/2014/main" id="{5A15D1AD-708D-4C1B-B57C-CD580BA5E1B5}"/>
               </a:ext>
             </a:extLst>
           </p:cNvPr>
@@ -5960,7 +5960,7 @@
           <p:cNvPr id="10" name="">
             <a:extLst xmlns:a="http://schemas.openxmlformats.org/drawingml/2006/main">
               <a:ext uri="{FF2B5EF4-FFF2-40B4-BE49-F238E27FC236}">
-                <a16:creationId xmlns:a16="http://schemas.microsoft.com/office/drawing/2014/main" id="{67524B52-8DF5-4AC9-88CE-7A18F5503E78}"/>
+                <a16:creationId xmlns:a16="http://schemas.microsoft.com/office/drawing/2014/main" id="{D622A700-09DE-4F0B-813D-92076DAE313C}"/>
               </a:ext>
             </a:extLst>
           </p:cNvPr>
@@ -6010,7 +6010,7 @@
           <p:cNvPr id="11" name="">
             <a:extLst xmlns:a="http://schemas.openxmlformats.org/drawingml/2006/main">
               <a:ext uri="{FF2B5EF4-FFF2-40B4-BE49-F238E27FC236}">
-                <a16:creationId xmlns:a16="http://schemas.microsoft.com/office/drawing/2014/main" id="{64E4E534-A26C-4D11-BA84-76C18CED1543}"/>
+                <a16:creationId xmlns:a16="http://schemas.microsoft.com/office/drawing/2014/main" id="{4FD22268-49E3-4138-AD34-F3D1A5EB1701}"/>
               </a:ext>
             </a:extLst>
           </p:cNvPr>
@@ -6043,7 +6043,7 @@
           <p:cNvPr id="12" name="">
             <a:extLst xmlns:a="http://schemas.openxmlformats.org/drawingml/2006/main">
               <a:ext uri="{FF2B5EF4-FFF2-40B4-BE49-F238E27FC236}">
-                <a16:creationId xmlns:a16="http://schemas.microsoft.com/office/drawing/2014/main" id="{76550B15-38A0-4117-885F-B7DF9C8E007E}"/>
+                <a16:creationId xmlns:a16="http://schemas.microsoft.com/office/drawing/2014/main" id="{12011F32-3DDF-450C-B47A-2F4BF823B275}"/>
               </a:ext>
             </a:extLst>
           </p:cNvPr>
@@ -6093,7 +6093,7 @@
           <p:cNvPr id="13" name="">
             <a:extLst xmlns:a="http://schemas.openxmlformats.org/drawingml/2006/main">
               <a:ext uri="{FF2B5EF4-FFF2-40B4-BE49-F238E27FC236}">
-                <a16:creationId xmlns:a16="http://schemas.microsoft.com/office/drawing/2014/main" id="{A1B31734-645C-40FD-B948-F1A7A81D77CA}"/>
+                <a16:creationId xmlns:a16="http://schemas.microsoft.com/office/drawing/2014/main" id="{21760ABE-0A00-4841-B5B2-51DAAB9DAE14}"/>
               </a:ext>
             </a:extLst>
           </p:cNvPr>
@@ -6126,7 +6126,7 @@
           <p:cNvPr id="14" name="">
             <a:extLst xmlns:a="http://schemas.openxmlformats.org/drawingml/2006/main">
               <a:ext uri="{FF2B5EF4-FFF2-40B4-BE49-F238E27FC236}">
-                <a16:creationId xmlns:a16="http://schemas.microsoft.com/office/drawing/2014/main" id="{BB1A1DD4-82EA-424E-A5CD-94924F03FF65}"/>
+                <a16:creationId xmlns:a16="http://schemas.microsoft.com/office/drawing/2014/main" id="{1AD8C65B-B327-4836-8D1E-7AEA86661574}"/>
               </a:ext>
             </a:extLst>
           </p:cNvPr>
@@ -6174,7 +6174,7 @@
     </p:spTree>
     <p:extLst>
       <p:ext uri="{BB962C8B-B14F-4D97-AF65-F5344CB8AC3E}">
-        <p14:creationId xmlns:p14="http://schemas.microsoft.com/office/powerpoint/2010/main" val="1425554037"/>
+        <p14:creationId xmlns:p14="http://schemas.microsoft.com/office/powerpoint/2010/main" val="1731394189"/>
       </p:ext>
     </p:extLst>
   </p:cSld>
@@ -6205,7 +6205,7 @@
           <p:cNvPr id="1" name="">
             <a:extLst xmlns:a="http://schemas.openxmlformats.org/drawingml/2006/main">
               <a:ext uri="{FF2B5EF4-FFF2-40B4-BE49-F238E27FC236}">
-                <a16:creationId xmlns:a16="http://schemas.microsoft.com/office/drawing/2014/main" id="{8803D380-D527-418D-969F-CC7DA89CA665}"/>
+                <a16:creationId xmlns:a16="http://schemas.microsoft.com/office/drawing/2014/main" id="{61B94051-6464-4EFC-9B64-191C86A6F9EC}"/>
               </a:ext>
             </a:extLst>
           </p:cNvPr>
@@ -6238,7 +6238,7 @@
           <p:cNvPr id="2" name="">
             <a:extLst xmlns:a="http://schemas.openxmlformats.org/drawingml/2006/main">
               <a:ext uri="{FF2B5EF4-FFF2-40B4-BE49-F238E27FC236}">
-                <a16:creationId xmlns:a16="http://schemas.microsoft.com/office/drawing/2014/main" id="{5320C18F-992B-4B52-9974-D36AC3698649}"/>
+                <a16:creationId xmlns:a16="http://schemas.microsoft.com/office/drawing/2014/main" id="{26EB8E10-B01C-4FE6-A159-8FD859BBC744}"/>
               </a:ext>
             </a:extLst>
           </p:cNvPr>
@@ -6271,7 +6271,7 @@
           <p:cNvPr id="3" name="">
             <a:extLst xmlns:a="http://schemas.openxmlformats.org/drawingml/2006/main">
               <a:ext uri="{FF2B5EF4-FFF2-40B4-BE49-F238E27FC236}">
-                <a16:creationId xmlns:a16="http://schemas.microsoft.com/office/drawing/2014/main" id="{247F3A47-4854-41EE-A921-52CA54E4D8FF}"/>
+                <a16:creationId xmlns:a16="http://schemas.microsoft.com/office/drawing/2014/main" id="{E161E251-8A35-4EDF-AA5E-A51A191A3A51}"/>
               </a:ext>
             </a:extLst>
           </p:cNvPr>
@@ -6321,7 +6321,7 @@
           <p:cNvPr id="4" name="">
             <a:extLst xmlns:a="http://schemas.openxmlformats.org/drawingml/2006/main">
               <a:ext uri="{FF2B5EF4-FFF2-40B4-BE49-F238E27FC236}">
-                <a16:creationId xmlns:a16="http://schemas.microsoft.com/office/drawing/2014/main" id="{5612EFC1-28E0-49CC-96AC-2E0629647271}"/>
+                <a16:creationId xmlns:a16="http://schemas.microsoft.com/office/drawing/2014/main" id="{ACE52C42-40C4-43D3-A001-D263BDF8EA1E}"/>
               </a:ext>
             </a:extLst>
           </p:cNvPr>
@@ -6371,7 +6371,7 @@
           <p:cNvPr id="5" name="">
             <a:extLst xmlns:a="http://schemas.openxmlformats.org/drawingml/2006/main">
               <a:ext uri="{FF2B5EF4-FFF2-40B4-BE49-F238E27FC236}">
-                <a16:creationId xmlns:a16="http://schemas.microsoft.com/office/drawing/2014/main" id="{16D01649-036B-402A-AC7B-B48515B5D084}"/>
+                <a16:creationId xmlns:a16="http://schemas.microsoft.com/office/drawing/2014/main" id="{5057FCDF-F143-40E6-B6E1-0A8FDF20459C}"/>
               </a:ext>
             </a:extLst>
           </p:cNvPr>
@@ -6406,7 +6406,7 @@
           <p:nvPr/>
         </p:nvPicPr>
         <p:blipFill>
-          <a:blip xmlns:r="http://schemas.openxmlformats.org/officeDocument/2006/relationships" xmlns:a="http://schemas.openxmlformats.org/drawingml/2006/main" r:embed="Rfb4daaecf0df446f"/>
+          <a:blip xmlns:r="http://schemas.openxmlformats.org/officeDocument/2006/relationships" xmlns:a="http://schemas.openxmlformats.org/drawingml/2006/main" r:embed="R433a7f00dd6c4038"/>
           <a:stretch xmlns:a="http://schemas.openxmlformats.org/drawingml/2006/main"/>
         </p:blipFill>
         <p:spPr>
@@ -6424,7 +6424,7 @@
           <p:cNvPr id="7" name="">
             <a:extLst xmlns:a="http://schemas.openxmlformats.org/drawingml/2006/main">
               <a:ext uri="{FF2B5EF4-FFF2-40B4-BE49-F238E27FC236}">
-                <a16:creationId xmlns:a16="http://schemas.microsoft.com/office/drawing/2014/main" id="{823C9F48-7D69-4229-9260-EEC3D333D38D}"/>
+                <a16:creationId xmlns:a16="http://schemas.microsoft.com/office/drawing/2014/main" id="{0B47302D-9925-4F1E-ABBF-D0D1BB540C05}"/>
               </a:ext>
             </a:extLst>
           </p:cNvPr>
@@ -6457,7 +6457,7 @@
           <p:cNvPr id="8" name="">
             <a:extLst xmlns:a="http://schemas.openxmlformats.org/drawingml/2006/main">
               <a:ext uri="{FF2B5EF4-FFF2-40B4-BE49-F238E27FC236}">
-                <a16:creationId xmlns:a16="http://schemas.microsoft.com/office/drawing/2014/main" id="{4808BAEC-25AA-4896-9A68-231C5A09A2B4}"/>
+                <a16:creationId xmlns:a16="http://schemas.microsoft.com/office/drawing/2014/main" id="{371C55E9-8DEC-47D5-A125-9EEA9BD29A42}"/>
               </a:ext>
             </a:extLst>
           </p:cNvPr>
@@ -6507,7 +6507,7 @@
           <p:cNvPr id="9" name="">
             <a:extLst xmlns:a="http://schemas.openxmlformats.org/drawingml/2006/main">
               <a:ext uri="{FF2B5EF4-FFF2-40B4-BE49-F238E27FC236}">
-                <a16:creationId xmlns:a16="http://schemas.microsoft.com/office/drawing/2014/main" id="{B60B2B31-1CF1-4E6D-BD33-9E7590142FC6}"/>
+                <a16:creationId xmlns:a16="http://schemas.microsoft.com/office/drawing/2014/main" id="{9D269DA1-82C0-4793-A6EC-29AB407073EE}"/>
               </a:ext>
             </a:extLst>
           </p:cNvPr>
@@ -6540,7 +6540,7 @@
           <p:cNvPr id="10" name="">
             <a:extLst xmlns:a="http://schemas.openxmlformats.org/drawingml/2006/main">
               <a:ext uri="{FF2B5EF4-FFF2-40B4-BE49-F238E27FC236}">
-                <a16:creationId xmlns:a16="http://schemas.microsoft.com/office/drawing/2014/main" id="{EEE1DBA6-6A53-462E-832C-CF744BC410DD}"/>
+                <a16:creationId xmlns:a16="http://schemas.microsoft.com/office/drawing/2014/main" id="{08474A2B-898B-4607-BBAB-EB61734EDC3C}"/>
               </a:ext>
             </a:extLst>
           </p:cNvPr>
@@ -6590,7 +6590,7 @@
           <p:cNvPr id="11" name="">
             <a:extLst xmlns:a="http://schemas.openxmlformats.org/drawingml/2006/main">
               <a:ext uri="{FF2B5EF4-FFF2-40B4-BE49-F238E27FC236}">
-                <a16:creationId xmlns:a16="http://schemas.microsoft.com/office/drawing/2014/main" id="{8949968A-A741-45B5-A193-40FE9D4812BC}"/>
+                <a16:creationId xmlns:a16="http://schemas.microsoft.com/office/drawing/2014/main" id="{9C3E874B-81C9-4846-A761-A2712C70C97E}"/>
               </a:ext>
             </a:extLst>
           </p:cNvPr>
@@ -6623,7 +6623,7 @@
           <p:cNvPr id="12" name="">
             <a:extLst xmlns:a="http://schemas.openxmlformats.org/drawingml/2006/main">
               <a:ext uri="{FF2B5EF4-FFF2-40B4-BE49-F238E27FC236}">
-                <a16:creationId xmlns:a16="http://schemas.microsoft.com/office/drawing/2014/main" id="{F357A218-6D3E-40E0-A2C4-CE82828D97CF}"/>
+                <a16:creationId xmlns:a16="http://schemas.microsoft.com/office/drawing/2014/main" id="{2A3F9887-E0D3-40E0-8A56-993B4CA4EF6F}"/>
               </a:ext>
             </a:extLst>
           </p:cNvPr>
@@ -6673,7 +6673,7 @@
           <p:cNvPr id="13" name="">
             <a:extLst xmlns:a="http://schemas.openxmlformats.org/drawingml/2006/main">
               <a:ext uri="{FF2B5EF4-FFF2-40B4-BE49-F238E27FC236}">
-                <a16:creationId xmlns:a16="http://schemas.microsoft.com/office/drawing/2014/main" id="{6602F1B6-DA52-4480-8048-D6097B4CC7B4}"/>
+                <a16:creationId xmlns:a16="http://schemas.microsoft.com/office/drawing/2014/main" id="{7F7B91D2-77BB-42E7-BC87-B910E91299AA}"/>
               </a:ext>
             </a:extLst>
           </p:cNvPr>
@@ -6706,7 +6706,7 @@
           <p:cNvPr id="14" name="">
             <a:extLst xmlns:a="http://schemas.openxmlformats.org/drawingml/2006/main">
               <a:ext uri="{FF2B5EF4-FFF2-40B4-BE49-F238E27FC236}">
-                <a16:creationId xmlns:a16="http://schemas.microsoft.com/office/drawing/2014/main" id="{2FA53D22-7B0C-4BC5-8C2C-22F58FEE423B}"/>
+                <a16:creationId xmlns:a16="http://schemas.microsoft.com/office/drawing/2014/main" id="{254CFD3E-97EA-4625-A135-D6B32C68E6B4}"/>
               </a:ext>
             </a:extLst>
           </p:cNvPr>
@@ -6754,7 +6754,7 @@
     </p:spTree>
     <p:extLst>
       <p:ext uri="{BB962C8B-B14F-4D97-AF65-F5344CB8AC3E}">
-        <p14:creationId xmlns:p14="http://schemas.microsoft.com/office/powerpoint/2010/main" val="1915428358"/>
+        <p14:creationId xmlns:p14="http://schemas.microsoft.com/office/powerpoint/2010/main" val="1440661214"/>
       </p:ext>
     </p:extLst>
   </p:cSld>
@@ -6785,7 +6785,7 @@
           <p:cNvPr id="1" name="">
             <a:extLst xmlns:a="http://schemas.openxmlformats.org/drawingml/2006/main">
               <a:ext uri="{FF2B5EF4-FFF2-40B4-BE49-F238E27FC236}">
-                <a16:creationId xmlns:a16="http://schemas.microsoft.com/office/drawing/2014/main" id="{FFE7BBA3-EE54-4DC1-BE1D-9C163EAD563D}"/>
+                <a16:creationId xmlns:a16="http://schemas.microsoft.com/office/drawing/2014/main" id="{094450A0-43CB-495D-9517-CE77095C1890}"/>
               </a:ext>
             </a:extLst>
           </p:cNvPr>
@@ -6822,7 +6822,7 @@
           <p:nvPr/>
         </p:nvPicPr>
         <p:blipFill>
-          <a:blip xmlns:r="http://schemas.openxmlformats.org/officeDocument/2006/relationships" xmlns:a="http://schemas.openxmlformats.org/drawingml/2006/main" r:embed="Rc30cef73c9a1432f"/>
+          <a:blip xmlns:r="http://schemas.openxmlformats.org/officeDocument/2006/relationships" xmlns:a="http://schemas.openxmlformats.org/drawingml/2006/main" r:embed="R67832de5ccc24d23"/>
           <a:stretch xmlns:a="http://schemas.openxmlformats.org/drawingml/2006/main"/>
         </p:blipFill>
         <p:spPr>
@@ -6840,7 +6840,7 @@
           <p:cNvPr id="3" name="">
             <a:extLst xmlns:a="http://schemas.openxmlformats.org/drawingml/2006/main">
               <a:ext uri="{FF2B5EF4-FFF2-40B4-BE49-F238E27FC236}">
-                <a16:creationId xmlns:a16="http://schemas.microsoft.com/office/drawing/2014/main" id="{A72529D7-DFB6-4D8B-A310-9A9BE4C160E1}"/>
+                <a16:creationId xmlns:a16="http://schemas.microsoft.com/office/drawing/2014/main" id="{74808002-9BA4-4319-8652-BCD6E9B062A6}"/>
               </a:ext>
             </a:extLst>
           </p:cNvPr>
@@ -6890,7 +6890,7 @@
           <p:cNvPr id="4" name="">
             <a:extLst xmlns:a="http://schemas.openxmlformats.org/drawingml/2006/main">
               <a:ext uri="{FF2B5EF4-FFF2-40B4-BE49-F238E27FC236}">
-                <a16:creationId xmlns:a16="http://schemas.microsoft.com/office/drawing/2014/main" id="{0FB6DBF5-37B8-4781-9B98-959748F46032}"/>
+                <a16:creationId xmlns:a16="http://schemas.microsoft.com/office/drawing/2014/main" id="{73369E1A-C5A8-4C8D-BB5F-A1725DCF4D91}"/>
               </a:ext>
             </a:extLst>
           </p:cNvPr>
@@ -6940,7 +6940,7 @@
           <p:cNvPr id="5" name="">
             <a:extLst xmlns:a="http://schemas.openxmlformats.org/drawingml/2006/main">
               <a:ext uri="{FF2B5EF4-FFF2-40B4-BE49-F238E27FC236}">
-                <a16:creationId xmlns:a16="http://schemas.microsoft.com/office/drawing/2014/main" id="{B85BA887-B0DE-4391-9523-9A2E01AB5E0D}"/>
+                <a16:creationId xmlns:a16="http://schemas.microsoft.com/office/drawing/2014/main" id="{38E02DF6-C10E-4D48-A1E4-07F960FA311C}"/>
               </a:ext>
             </a:extLst>
           </p:cNvPr>
@@ -6975,7 +6975,7 @@
           <p:cNvPr id="6" name="">
             <a:extLst xmlns:a="http://schemas.openxmlformats.org/drawingml/2006/main">
               <a:ext uri="{FF2B5EF4-FFF2-40B4-BE49-F238E27FC236}">
-                <a16:creationId xmlns:a16="http://schemas.microsoft.com/office/drawing/2014/main" id="{CE674A94-A661-4F9D-80E7-2BABDBBA9509}"/>
+                <a16:creationId xmlns:a16="http://schemas.microsoft.com/office/drawing/2014/main" id="{6CBE66F5-8E36-4A6A-8B48-CD70F53C52CB}"/>
               </a:ext>
             </a:extLst>
           </p:cNvPr>
@@ -7025,7 +7025,7 @@
           <p:cNvPr id="7" name="">
             <a:extLst xmlns:a="http://schemas.openxmlformats.org/drawingml/2006/main">
               <a:ext uri="{FF2B5EF4-FFF2-40B4-BE49-F238E27FC236}">
-                <a16:creationId xmlns:a16="http://schemas.microsoft.com/office/drawing/2014/main" id="{8272B286-A9B9-4EBC-B0B8-17B4BB2C2433}"/>
+                <a16:creationId xmlns:a16="http://schemas.microsoft.com/office/drawing/2014/main" id="{649D36D6-02F4-44C3-9092-28F682BC8F62}"/>
               </a:ext>
             </a:extLst>
           </p:cNvPr>
@@ -7073,7 +7073,7 @@
     </p:spTree>
     <p:extLst>
       <p:ext uri="{BB962C8B-B14F-4D97-AF65-F5344CB8AC3E}">
-        <p14:creationId xmlns:p14="http://schemas.microsoft.com/office/powerpoint/2010/main" val="584275463"/>
+        <p14:creationId xmlns:p14="http://schemas.microsoft.com/office/powerpoint/2010/main" val="267966330"/>
       </p:ext>
     </p:extLst>
   </p:cSld>
@@ -7104,7 +7104,7 @@
           <p:cNvPr id="1" name="">
             <a:extLst xmlns:a="http://schemas.openxmlformats.org/drawingml/2006/main">
               <a:ext uri="{FF2B5EF4-FFF2-40B4-BE49-F238E27FC236}">
-                <a16:creationId xmlns:a16="http://schemas.microsoft.com/office/drawing/2014/main" id="{B54B0C1C-B5DD-4AC9-B2D1-37B8437E8A22}"/>
+                <a16:creationId xmlns:a16="http://schemas.microsoft.com/office/drawing/2014/main" id="{540B47C0-5F12-4DBC-BE25-FBBB786AD819}"/>
               </a:ext>
             </a:extLst>
           </p:cNvPr>
@@ -7137,7 +7137,7 @@
           <p:cNvPr id="2" name="">
             <a:extLst xmlns:a="http://schemas.openxmlformats.org/drawingml/2006/main">
               <a:ext uri="{FF2B5EF4-FFF2-40B4-BE49-F238E27FC236}">
-                <a16:creationId xmlns:a16="http://schemas.microsoft.com/office/drawing/2014/main" id="{54E63E59-0415-4959-9F43-0AA033AB5C7C}"/>
+                <a16:creationId xmlns:a16="http://schemas.microsoft.com/office/drawing/2014/main" id="{B2303BC3-1248-47CF-B02A-FF770CB49C30}"/>
               </a:ext>
             </a:extLst>
           </p:cNvPr>
@@ -7170,7 +7170,7 @@
           <p:cNvPr id="3" name="">
             <a:extLst xmlns:a="http://schemas.openxmlformats.org/drawingml/2006/main">
               <a:ext uri="{FF2B5EF4-FFF2-40B4-BE49-F238E27FC236}">
-                <a16:creationId xmlns:a16="http://schemas.microsoft.com/office/drawing/2014/main" id="{38AFB872-C1A3-4312-AF5C-AF171F4035E9}"/>
+                <a16:creationId xmlns:a16="http://schemas.microsoft.com/office/drawing/2014/main" id="{6D73FE83-899A-478C-BFA4-72E0F93FAD84}"/>
               </a:ext>
             </a:extLst>
           </p:cNvPr>
@@ -7220,7 +7220,7 @@
           <p:cNvPr id="4" name="">
             <a:extLst xmlns:a="http://schemas.openxmlformats.org/drawingml/2006/main">
               <a:ext uri="{FF2B5EF4-FFF2-40B4-BE49-F238E27FC236}">
-                <a16:creationId xmlns:a16="http://schemas.microsoft.com/office/drawing/2014/main" id="{8B78CC29-05F6-422F-9139-77095048B73A}"/>
+                <a16:creationId xmlns:a16="http://schemas.microsoft.com/office/drawing/2014/main" id="{09EA90D7-B92D-4172-8BA5-929FB9DBC938}"/>
               </a:ext>
             </a:extLst>
           </p:cNvPr>
@@ -7270,7 +7270,7 @@
           <p:cNvPr id="5" name="">
             <a:extLst xmlns:a="http://schemas.openxmlformats.org/drawingml/2006/main">
               <a:ext uri="{FF2B5EF4-FFF2-40B4-BE49-F238E27FC236}">
-                <a16:creationId xmlns:a16="http://schemas.microsoft.com/office/drawing/2014/main" id="{350697FB-F6DA-4741-AAA3-C0813205029F}"/>
+                <a16:creationId xmlns:a16="http://schemas.microsoft.com/office/drawing/2014/main" id="{0DBBC2BA-BCBB-47D5-B913-7C2A62CB7153}"/>
               </a:ext>
             </a:extLst>
           </p:cNvPr>
@@ -7305,7 +7305,7 @@
           <p:nvPr/>
         </p:nvPicPr>
         <p:blipFill>
-          <a:blip xmlns:r="http://schemas.openxmlformats.org/officeDocument/2006/relationships" xmlns:a="http://schemas.openxmlformats.org/drawingml/2006/main" r:embed="Re597bb81b2f5492a"/>
+          <a:blip xmlns:r="http://schemas.openxmlformats.org/officeDocument/2006/relationships" xmlns:a="http://schemas.openxmlformats.org/drawingml/2006/main" r:embed="R69a25ef89fe64079"/>
           <a:stretch xmlns:a="http://schemas.openxmlformats.org/drawingml/2006/main"/>
         </p:blipFill>
         <p:spPr>
@@ -7323,7 +7323,7 @@
           <p:cNvPr id="7" name="">
             <a:extLst xmlns:a="http://schemas.openxmlformats.org/drawingml/2006/main">
               <a:ext uri="{FF2B5EF4-FFF2-40B4-BE49-F238E27FC236}">
-                <a16:creationId xmlns:a16="http://schemas.microsoft.com/office/drawing/2014/main" id="{66B198BA-07D7-47F2-936D-A925AE060BBD}"/>
+                <a16:creationId xmlns:a16="http://schemas.microsoft.com/office/drawing/2014/main" id="{19CABC6D-37DA-4DDF-A0DA-929F56A87D05}"/>
               </a:ext>
             </a:extLst>
           </p:cNvPr>
@@ -7358,7 +7358,7 @@
           <p:cNvPr id="8" name="">
             <a:extLst xmlns:a="http://schemas.openxmlformats.org/drawingml/2006/main">
               <a:ext uri="{FF2B5EF4-FFF2-40B4-BE49-F238E27FC236}">
-                <a16:creationId xmlns:a16="http://schemas.microsoft.com/office/drawing/2014/main" id="{5F6B99DE-A9E0-4B52-8438-F40D2293984A}"/>
+                <a16:creationId xmlns:a16="http://schemas.microsoft.com/office/drawing/2014/main" id="{A701350C-E23E-4417-B93E-27231F8CB608}"/>
               </a:ext>
             </a:extLst>
           </p:cNvPr>
@@ -7393,7 +7393,7 @@
           <p:cNvPr id="9" name="">
             <a:extLst xmlns:a="http://schemas.openxmlformats.org/drawingml/2006/main">
               <a:ext uri="{FF2B5EF4-FFF2-40B4-BE49-F238E27FC236}">
-                <a16:creationId xmlns:a16="http://schemas.microsoft.com/office/drawing/2014/main" id="{B5B0CD21-7814-45B2-8B21-4889846063ED}"/>
+                <a16:creationId xmlns:a16="http://schemas.microsoft.com/office/drawing/2014/main" id="{EB6867EA-ED68-47DC-BCC0-886E42BE4526}"/>
               </a:ext>
             </a:extLst>
           </p:cNvPr>
@@ -7428,7 +7428,7 @@
           <p:cNvPr id="10" name="">
             <a:extLst xmlns:a="http://schemas.openxmlformats.org/drawingml/2006/main">
               <a:ext uri="{FF2B5EF4-FFF2-40B4-BE49-F238E27FC236}">
-                <a16:creationId xmlns:a16="http://schemas.microsoft.com/office/drawing/2014/main" id="{3D75C734-12EF-4A43-A19C-A5BDD5C0F1F6}"/>
+                <a16:creationId xmlns:a16="http://schemas.microsoft.com/office/drawing/2014/main" id="{B2C36DE0-3D6C-42C1-B1AE-7908182E5FB7}"/>
               </a:ext>
             </a:extLst>
           </p:cNvPr>
@@ -7478,7 +7478,7 @@
           <p:cNvPr id="11" name="">
             <a:extLst xmlns:a="http://schemas.openxmlformats.org/drawingml/2006/main">
               <a:ext uri="{FF2B5EF4-FFF2-40B4-BE49-F238E27FC236}">
-                <a16:creationId xmlns:a16="http://schemas.microsoft.com/office/drawing/2014/main" id="{9B9DC25F-BCE2-494E-AD09-A496404029EE}"/>
+                <a16:creationId xmlns:a16="http://schemas.microsoft.com/office/drawing/2014/main" id="{67706C64-3264-4F27-B7B7-3BF20A1EC71E}"/>
               </a:ext>
             </a:extLst>
           </p:cNvPr>
@@ -7528,7 +7528,7 @@
           <p:cNvPr id="12" name="">
             <a:extLst xmlns:a="http://schemas.openxmlformats.org/drawingml/2006/main">
               <a:ext uri="{FF2B5EF4-FFF2-40B4-BE49-F238E27FC236}">
-                <a16:creationId xmlns:a16="http://schemas.microsoft.com/office/drawing/2014/main" id="{AC2B9DB3-4D6C-4ECB-AB25-2061A2F75C78}"/>
+                <a16:creationId xmlns:a16="http://schemas.microsoft.com/office/drawing/2014/main" id="{C32B1F5A-F61D-4507-8A38-3F82A442CA64}"/>
               </a:ext>
             </a:extLst>
           </p:cNvPr>
@@ -7578,7 +7578,7 @@
           <p:cNvPr id="13" name="">
             <a:extLst xmlns:a="http://schemas.openxmlformats.org/drawingml/2006/main">
               <a:ext uri="{FF2B5EF4-FFF2-40B4-BE49-F238E27FC236}">
-                <a16:creationId xmlns:a16="http://schemas.microsoft.com/office/drawing/2014/main" id="{52B2D4E2-28C9-4A29-991C-76E17D394CE9}"/>
+                <a16:creationId xmlns:a16="http://schemas.microsoft.com/office/drawing/2014/main" id="{ACED9A57-3F5D-4410-985F-CFB07CCF98F2}"/>
               </a:ext>
             </a:extLst>
           </p:cNvPr>
@@ -7628,7 +7628,7 @@
           <p:cNvPr id="14" name="">
             <a:extLst xmlns:a="http://schemas.openxmlformats.org/drawingml/2006/main">
               <a:ext uri="{FF2B5EF4-FFF2-40B4-BE49-F238E27FC236}">
-                <a16:creationId xmlns:a16="http://schemas.microsoft.com/office/drawing/2014/main" id="{37ED3C90-E3DF-48EB-BC84-A8A4820B2577}"/>
+                <a16:creationId xmlns:a16="http://schemas.microsoft.com/office/drawing/2014/main" id="{1CB316D5-067B-4073-908D-3B1C33314F4F}"/>
               </a:ext>
             </a:extLst>
           </p:cNvPr>
@@ -7678,7 +7678,7 @@
           <p:cNvPr id="15" name="">
             <a:extLst xmlns:a="http://schemas.openxmlformats.org/drawingml/2006/main">
               <a:ext uri="{FF2B5EF4-FFF2-40B4-BE49-F238E27FC236}">
-                <a16:creationId xmlns:a16="http://schemas.microsoft.com/office/drawing/2014/main" id="{1B86F33E-7881-4907-9B99-2C08D8F99221}"/>
+                <a16:creationId xmlns:a16="http://schemas.microsoft.com/office/drawing/2014/main" id="{64F1CDA4-9634-4D5D-8143-FEA8F326175F}"/>
               </a:ext>
             </a:extLst>
           </p:cNvPr>
@@ -7728,7 +7728,7 @@
           <p:cNvPr id="16" name="">
             <a:extLst xmlns:a="http://schemas.openxmlformats.org/drawingml/2006/main">
               <a:ext uri="{FF2B5EF4-FFF2-40B4-BE49-F238E27FC236}">
-                <a16:creationId xmlns:a16="http://schemas.microsoft.com/office/drawing/2014/main" id="{0BB9FD1C-9DFC-43FB-A76B-36AC9BBFBA65}"/>
+                <a16:creationId xmlns:a16="http://schemas.microsoft.com/office/drawing/2014/main" id="{1461805D-50B2-4D0B-95E1-A0B762E8DB40}"/>
               </a:ext>
             </a:extLst>
           </p:cNvPr>
@@ -7776,7 +7776,7 @@
     </p:spTree>
     <p:extLst>
       <p:ext uri="{BB962C8B-B14F-4D97-AF65-F5344CB8AC3E}">
-        <p14:creationId xmlns:p14="http://schemas.microsoft.com/office/powerpoint/2010/main" val="1345853493"/>
+        <p14:creationId xmlns:p14="http://schemas.microsoft.com/office/powerpoint/2010/main" val="701391234"/>
       </p:ext>
     </p:extLst>
   </p:cSld>
@@ -7807,7 +7807,7 @@
           <p:cNvPr id="1" name="">
             <a:extLst xmlns:a="http://schemas.openxmlformats.org/drawingml/2006/main">
               <a:ext uri="{FF2B5EF4-FFF2-40B4-BE49-F238E27FC236}">
-                <a16:creationId xmlns:a16="http://schemas.microsoft.com/office/drawing/2014/main" id="{BA3246FD-2878-485F-A3F5-54124A54E2E7}"/>
+                <a16:creationId xmlns:a16="http://schemas.microsoft.com/office/drawing/2014/main" id="{07D69B4C-0810-48C9-9CFA-064C3F2E68B0}"/>
               </a:ext>
             </a:extLst>
           </p:cNvPr>
@@ -7840,7 +7840,7 @@
           <p:cNvPr id="2" name="">
             <a:extLst xmlns:a="http://schemas.openxmlformats.org/drawingml/2006/main">
               <a:ext uri="{FF2B5EF4-FFF2-40B4-BE49-F238E27FC236}">
-                <a16:creationId xmlns:a16="http://schemas.microsoft.com/office/drawing/2014/main" id="{55555A1F-0F5F-497F-B1DF-FA641628D875}"/>
+                <a16:creationId xmlns:a16="http://schemas.microsoft.com/office/drawing/2014/main" id="{2B10234E-02B4-416F-8034-DE0EEA46D5FE}"/>
               </a:ext>
             </a:extLst>
           </p:cNvPr>
@@ -7873,7 +7873,7 @@
           <p:cNvPr id="3" name="">
             <a:extLst xmlns:a="http://schemas.openxmlformats.org/drawingml/2006/main">
               <a:ext uri="{FF2B5EF4-FFF2-40B4-BE49-F238E27FC236}">
-                <a16:creationId xmlns:a16="http://schemas.microsoft.com/office/drawing/2014/main" id="{2F8622A6-383C-4572-8EF4-497D8EA1F831}"/>
+                <a16:creationId xmlns:a16="http://schemas.microsoft.com/office/drawing/2014/main" id="{C5B83E01-8A0B-4274-9A4E-E7D109626598}"/>
               </a:ext>
             </a:extLst>
           </p:cNvPr>
@@ -7923,7 +7923,7 @@
           <p:cNvPr id="4" name="">
             <a:extLst xmlns:a="http://schemas.openxmlformats.org/drawingml/2006/main">
               <a:ext uri="{FF2B5EF4-FFF2-40B4-BE49-F238E27FC236}">
-                <a16:creationId xmlns:a16="http://schemas.microsoft.com/office/drawing/2014/main" id="{252C94F4-2575-45E0-B77D-DB074C4B692C}"/>
+                <a16:creationId xmlns:a16="http://schemas.microsoft.com/office/drawing/2014/main" id="{5F757532-4109-4B5E-AF71-5869739123F1}"/>
               </a:ext>
             </a:extLst>
           </p:cNvPr>
@@ -7973,7 +7973,7 @@
           <p:cNvPr id="5" name="">
             <a:extLst xmlns:a="http://schemas.openxmlformats.org/drawingml/2006/main">
               <a:ext uri="{FF2B5EF4-FFF2-40B4-BE49-F238E27FC236}">
-                <a16:creationId xmlns:a16="http://schemas.microsoft.com/office/drawing/2014/main" id="{18C5EA83-A449-4DDE-A191-A8A0172B66F0}"/>
+                <a16:creationId xmlns:a16="http://schemas.microsoft.com/office/drawing/2014/main" id="{69DEE6C0-5B56-410B-94B6-2BAB78F4D2EA}"/>
               </a:ext>
             </a:extLst>
           </p:cNvPr>
@@ -8008,7 +8008,7 @@
           <p:nvPr/>
         </p:nvPicPr>
         <p:blipFill>
-          <a:blip xmlns:r="http://schemas.openxmlformats.org/officeDocument/2006/relationships" xmlns:a="http://schemas.openxmlformats.org/drawingml/2006/main" r:embed="Rb88e19ebd8c74f9e"/>
+          <a:blip xmlns:r="http://schemas.openxmlformats.org/officeDocument/2006/relationships" xmlns:a="http://schemas.openxmlformats.org/drawingml/2006/main" r:embed="Rd15eae3eaaad4c56"/>
           <a:stretch xmlns:a="http://schemas.openxmlformats.org/drawingml/2006/main"/>
         </p:blipFill>
         <p:spPr>
@@ -8026,7 +8026,7 @@
           <p:cNvPr id="7" name="">
             <a:extLst xmlns:a="http://schemas.openxmlformats.org/drawingml/2006/main">
               <a:ext uri="{FF2B5EF4-FFF2-40B4-BE49-F238E27FC236}">
-                <a16:creationId xmlns:a16="http://schemas.microsoft.com/office/drawing/2014/main" id="{C834E045-54E7-4768-8A34-5FA8F1AF59F1}"/>
+                <a16:creationId xmlns:a16="http://schemas.microsoft.com/office/drawing/2014/main" id="{6F32BE93-B452-43B8-9F74-E478AD730987}"/>
               </a:ext>
             </a:extLst>
           </p:cNvPr>
@@ -8061,7 +8061,7 @@
           <p:cNvPr id="8" name="">
             <a:extLst xmlns:a="http://schemas.openxmlformats.org/drawingml/2006/main">
               <a:ext uri="{FF2B5EF4-FFF2-40B4-BE49-F238E27FC236}">
-                <a16:creationId xmlns:a16="http://schemas.microsoft.com/office/drawing/2014/main" id="{F6FC6E52-D024-4629-AB0C-9DD18CB86559}"/>
+                <a16:creationId xmlns:a16="http://schemas.microsoft.com/office/drawing/2014/main" id="{A352EC47-E550-479B-B9CF-0BDE92049360}"/>
               </a:ext>
             </a:extLst>
           </p:cNvPr>
@@ -8111,7 +8111,7 @@
           <p:cNvPr id="9" name="">
             <a:extLst xmlns:a="http://schemas.openxmlformats.org/drawingml/2006/main">
               <a:ext uri="{FF2B5EF4-FFF2-40B4-BE49-F238E27FC236}">
-                <a16:creationId xmlns:a16="http://schemas.microsoft.com/office/drawing/2014/main" id="{9C1EBC74-CBE7-4943-8047-FEA5F69490F3}"/>
+                <a16:creationId xmlns:a16="http://schemas.microsoft.com/office/drawing/2014/main" id="{D979A773-78CB-4EB3-BA6F-2A09777DB81B}"/>
               </a:ext>
             </a:extLst>
           </p:cNvPr>
@@ -8161,7 +8161,7 @@
           <p:cNvPr id="10" name="">
             <a:extLst xmlns:a="http://schemas.openxmlformats.org/drawingml/2006/main">
               <a:ext uri="{FF2B5EF4-FFF2-40B4-BE49-F238E27FC236}">
-                <a16:creationId xmlns:a16="http://schemas.microsoft.com/office/drawing/2014/main" id="{5385A91C-67CB-4C92-BC39-A9A995CE0A46}"/>
+                <a16:creationId xmlns:a16="http://schemas.microsoft.com/office/drawing/2014/main" id="{AD807BF1-EFAA-43CA-B5AA-D8F3A98E3AE2}"/>
               </a:ext>
             </a:extLst>
           </p:cNvPr>
@@ -8196,7 +8196,7 @@
           <p:cNvPr id="11" name="">
             <a:extLst xmlns:a="http://schemas.openxmlformats.org/drawingml/2006/main">
               <a:ext uri="{FF2B5EF4-FFF2-40B4-BE49-F238E27FC236}">
-                <a16:creationId xmlns:a16="http://schemas.microsoft.com/office/drawing/2014/main" id="{BBF09CA4-6E51-45F2-A002-635BF3AC74E3}"/>
+                <a16:creationId xmlns:a16="http://schemas.microsoft.com/office/drawing/2014/main" id="{9C29C35C-3B3D-495F-8F5E-FF359CB4E31E}"/>
               </a:ext>
             </a:extLst>
           </p:cNvPr>
@@ -8246,7 +8246,7 @@
           <p:cNvPr id="12" name="">
             <a:extLst xmlns:a="http://schemas.openxmlformats.org/drawingml/2006/main">
               <a:ext uri="{FF2B5EF4-FFF2-40B4-BE49-F238E27FC236}">
-                <a16:creationId xmlns:a16="http://schemas.microsoft.com/office/drawing/2014/main" id="{4AFAAA4C-93CD-41AA-8B6B-9BF1EB344EA5}"/>
+                <a16:creationId xmlns:a16="http://schemas.microsoft.com/office/drawing/2014/main" id="{BDE5E0EF-B7C9-4E58-A7F0-B732DE967DBC}"/>
               </a:ext>
             </a:extLst>
           </p:cNvPr>
@@ -8296,7 +8296,7 @@
           <p:cNvPr id="13" name="">
             <a:extLst xmlns:a="http://schemas.openxmlformats.org/drawingml/2006/main">
               <a:ext uri="{FF2B5EF4-FFF2-40B4-BE49-F238E27FC236}">
-                <a16:creationId xmlns:a16="http://schemas.microsoft.com/office/drawing/2014/main" id="{BE987406-68B9-45D4-9CB5-1903E46E14EC}"/>
+                <a16:creationId xmlns:a16="http://schemas.microsoft.com/office/drawing/2014/main" id="{1CBE0259-63E1-4F89-A748-12D947B36E01}"/>
               </a:ext>
             </a:extLst>
           </p:cNvPr>
@@ -8331,7 +8331,7 @@
           <p:cNvPr id="14" name="">
             <a:extLst xmlns:a="http://schemas.openxmlformats.org/drawingml/2006/main">
               <a:ext uri="{FF2B5EF4-FFF2-40B4-BE49-F238E27FC236}">
-                <a16:creationId xmlns:a16="http://schemas.microsoft.com/office/drawing/2014/main" id="{81085F8B-19CE-46D4-9CA1-B6442D579B67}"/>
+                <a16:creationId xmlns:a16="http://schemas.microsoft.com/office/drawing/2014/main" id="{D23E386A-3413-4CA3-B431-50E228F8F373}"/>
               </a:ext>
             </a:extLst>
           </p:cNvPr>
@@ -8381,7 +8381,7 @@
           <p:cNvPr id="15" name="">
             <a:extLst xmlns:a="http://schemas.openxmlformats.org/drawingml/2006/main">
               <a:ext uri="{FF2B5EF4-FFF2-40B4-BE49-F238E27FC236}">
-                <a16:creationId xmlns:a16="http://schemas.microsoft.com/office/drawing/2014/main" id="{F7FB87AA-D333-46BC-A986-9A16BB60AD15}"/>
+                <a16:creationId xmlns:a16="http://schemas.microsoft.com/office/drawing/2014/main" id="{DFBD9FC0-223D-4DCF-9E8A-96E32C14287B}"/>
               </a:ext>
             </a:extLst>
           </p:cNvPr>
@@ -8431,7 +8431,7 @@
           <p:cNvPr id="16" name="">
             <a:extLst xmlns:a="http://schemas.openxmlformats.org/drawingml/2006/main">
               <a:ext uri="{FF2B5EF4-FFF2-40B4-BE49-F238E27FC236}">
-                <a16:creationId xmlns:a16="http://schemas.microsoft.com/office/drawing/2014/main" id="{FEF2F3C4-8392-460D-9686-AFCD9B236343}"/>
+                <a16:creationId xmlns:a16="http://schemas.microsoft.com/office/drawing/2014/main" id="{034AD633-B053-45B5-9787-6CAF49E504DE}"/>
               </a:ext>
             </a:extLst>
           </p:cNvPr>
@@ -8466,7 +8466,7 @@
           <p:cNvPr id="17" name="">
             <a:extLst xmlns:a="http://schemas.openxmlformats.org/drawingml/2006/main">
               <a:ext uri="{FF2B5EF4-FFF2-40B4-BE49-F238E27FC236}">
-                <a16:creationId xmlns:a16="http://schemas.microsoft.com/office/drawing/2014/main" id="{F69AB1B5-B898-49E1-9551-D8BEE6446EF3}"/>
+                <a16:creationId xmlns:a16="http://schemas.microsoft.com/office/drawing/2014/main" id="{AFF253E6-B9FA-48C8-9F35-5CF62FB2D211}"/>
               </a:ext>
             </a:extLst>
           </p:cNvPr>
@@ -8516,7 +8516,7 @@
           <p:cNvPr id="18" name="">
             <a:extLst xmlns:a="http://schemas.openxmlformats.org/drawingml/2006/main">
               <a:ext uri="{FF2B5EF4-FFF2-40B4-BE49-F238E27FC236}">
-                <a16:creationId xmlns:a16="http://schemas.microsoft.com/office/drawing/2014/main" id="{6FE86529-B647-4B2C-ABC1-55634DE66DF2}"/>
+                <a16:creationId xmlns:a16="http://schemas.microsoft.com/office/drawing/2014/main" id="{7D6EF442-8624-4247-8117-5748A8FE159A}"/>
               </a:ext>
             </a:extLst>
           </p:cNvPr>
@@ -8564,7 +8564,7 @@
     </p:spTree>
     <p:extLst>
       <p:ext uri="{BB962C8B-B14F-4D97-AF65-F5344CB8AC3E}">
-        <p14:creationId xmlns:p14="http://schemas.microsoft.com/office/powerpoint/2010/main" val="847338944"/>
+        <p14:creationId xmlns:p14="http://schemas.microsoft.com/office/powerpoint/2010/main" val="918072930"/>
       </p:ext>
     </p:extLst>
   </p:cSld>
@@ -8595,7 +8595,7 @@
           <p:cNvPr id="1" name="">
             <a:extLst xmlns:a="http://schemas.openxmlformats.org/drawingml/2006/main">
               <a:ext uri="{FF2B5EF4-FFF2-40B4-BE49-F238E27FC236}">
-                <a16:creationId xmlns:a16="http://schemas.microsoft.com/office/drawing/2014/main" id="{6340C8DF-E1B6-45C2-A82A-35E3AF1EDFC3}"/>
+                <a16:creationId xmlns:a16="http://schemas.microsoft.com/office/drawing/2014/main" id="{D41B97B2-C6C4-4C7D-9503-79A32B95C72A}"/>
               </a:ext>
             </a:extLst>
           </p:cNvPr>
@@ -8632,7 +8632,7 @@
           <p:nvPr/>
         </p:nvPicPr>
         <p:blipFill>
-          <a:blip xmlns:r="http://schemas.openxmlformats.org/officeDocument/2006/relationships" xmlns:a="http://schemas.openxmlformats.org/drawingml/2006/main" r:embed="R99fced31756d4eb3"/>
+          <a:blip xmlns:r="http://schemas.openxmlformats.org/officeDocument/2006/relationships" xmlns:a="http://schemas.openxmlformats.org/drawingml/2006/main" r:embed="R739cfbc256074060"/>
           <a:stretch xmlns:a="http://schemas.openxmlformats.org/drawingml/2006/main"/>
         </p:blipFill>
         <p:spPr>
@@ -8650,7 +8650,7 @@
           <p:cNvPr id="3" name="">
             <a:extLst xmlns:a="http://schemas.openxmlformats.org/drawingml/2006/main">
               <a:ext uri="{FF2B5EF4-FFF2-40B4-BE49-F238E27FC236}">
-                <a16:creationId xmlns:a16="http://schemas.microsoft.com/office/drawing/2014/main" id="{2F35754E-DB6E-4C26-8C2D-8ECDAF4A83D9}"/>
+                <a16:creationId xmlns:a16="http://schemas.microsoft.com/office/drawing/2014/main" id="{DA1AB6AF-E092-4F9F-A048-09181CBDED0E}"/>
               </a:ext>
             </a:extLst>
           </p:cNvPr>
@@ -8700,7 +8700,7 @@
           <p:cNvPr id="4" name="">
             <a:extLst xmlns:a="http://schemas.openxmlformats.org/drawingml/2006/main">
               <a:ext uri="{FF2B5EF4-FFF2-40B4-BE49-F238E27FC236}">
-                <a16:creationId xmlns:a16="http://schemas.microsoft.com/office/drawing/2014/main" id="{9AEA77FD-7ECC-4CAC-B594-C8FFDD7ADCA4}"/>
+                <a16:creationId xmlns:a16="http://schemas.microsoft.com/office/drawing/2014/main" id="{3A0737A7-6E60-4C23-B227-FF032EEDFB19}"/>
               </a:ext>
             </a:extLst>
           </p:cNvPr>
@@ -8748,7 +8748,7 @@
     </p:spTree>
     <p:extLst>
       <p:ext uri="{BB962C8B-B14F-4D97-AF65-F5344CB8AC3E}">
-        <p14:creationId xmlns:p14="http://schemas.microsoft.com/office/powerpoint/2010/main" val="1090588486"/>
+        <p14:creationId xmlns:p14="http://schemas.microsoft.com/office/powerpoint/2010/main" val="8363582"/>
       </p:ext>
     </p:extLst>
   </p:cSld>
@@ -8779,7 +8779,7 @@
           <p:cNvPr id="1" name="">
             <a:extLst xmlns:a="http://schemas.openxmlformats.org/drawingml/2006/main">
               <a:ext uri="{FF2B5EF4-FFF2-40B4-BE49-F238E27FC236}">
-                <a16:creationId xmlns:a16="http://schemas.microsoft.com/office/drawing/2014/main" id="{3234C3B4-A79B-450A-9939-598BD736C044}"/>
+                <a16:creationId xmlns:a16="http://schemas.microsoft.com/office/drawing/2014/main" id="{D5981778-E97A-4C75-9C36-35A11DDACADE}"/>
               </a:ext>
             </a:extLst>
           </p:cNvPr>
@@ -8812,7 +8812,7 @@
           <p:cNvPr id="2" name="">
             <a:extLst xmlns:a="http://schemas.openxmlformats.org/drawingml/2006/main">
               <a:ext uri="{FF2B5EF4-FFF2-40B4-BE49-F238E27FC236}">
-                <a16:creationId xmlns:a16="http://schemas.microsoft.com/office/drawing/2014/main" id="{107F5113-26F3-4501-BAB8-F12D97020EDA}"/>
+                <a16:creationId xmlns:a16="http://schemas.microsoft.com/office/drawing/2014/main" id="{DF2DFDCD-ACD3-4510-AA2B-5D07DC05EF16}"/>
               </a:ext>
             </a:extLst>
           </p:cNvPr>
@@ -8845,7 +8845,7 @@
           <p:cNvPr id="3" name="">
             <a:extLst xmlns:a="http://schemas.openxmlformats.org/drawingml/2006/main">
               <a:ext uri="{FF2B5EF4-FFF2-40B4-BE49-F238E27FC236}">
-                <a16:creationId xmlns:a16="http://schemas.microsoft.com/office/drawing/2014/main" id="{755204F8-F0C9-4068-94F9-DC243297152D}"/>
+                <a16:creationId xmlns:a16="http://schemas.microsoft.com/office/drawing/2014/main" id="{926E36BA-D54E-4398-A0D2-C6E3BAC1C558}"/>
               </a:ext>
             </a:extLst>
           </p:cNvPr>
@@ -8895,7 +8895,7 @@
           <p:cNvPr id="4" name="">
             <a:extLst xmlns:a="http://schemas.openxmlformats.org/drawingml/2006/main">
               <a:ext uri="{FF2B5EF4-FFF2-40B4-BE49-F238E27FC236}">
-                <a16:creationId xmlns:a16="http://schemas.microsoft.com/office/drawing/2014/main" id="{1B088408-0B23-4E56-8ED5-A4469F87ABD6}"/>
+                <a16:creationId xmlns:a16="http://schemas.microsoft.com/office/drawing/2014/main" id="{171D5009-C3EC-4282-AC66-74C5AC69E339}"/>
               </a:ext>
             </a:extLst>
           </p:cNvPr>
@@ -8945,7 +8945,7 @@
           <p:cNvPr id="5" name="">
             <a:extLst xmlns:a="http://schemas.openxmlformats.org/drawingml/2006/main">
               <a:ext uri="{FF2B5EF4-FFF2-40B4-BE49-F238E27FC236}">
-                <a16:creationId xmlns:a16="http://schemas.microsoft.com/office/drawing/2014/main" id="{BDE244DD-D80C-45E3-B117-5FF4903A8395}"/>
+                <a16:creationId xmlns:a16="http://schemas.microsoft.com/office/drawing/2014/main" id="{4A5DF6D4-4645-41C0-BDA2-3B485701A9D8}"/>
               </a:ext>
             </a:extLst>
           </p:cNvPr>
@@ -8980,7 +8980,7 @@
           <p:nvPr/>
         </p:nvPicPr>
         <p:blipFill>
-          <a:blip xmlns:r="http://schemas.openxmlformats.org/officeDocument/2006/relationships" xmlns:a="http://schemas.openxmlformats.org/drawingml/2006/main" r:embed="R0ed44984667241ba"/>
+          <a:blip xmlns:r="http://schemas.openxmlformats.org/officeDocument/2006/relationships" xmlns:a="http://schemas.openxmlformats.org/drawingml/2006/main" r:embed="R4c3f566713c14f7e"/>
           <a:stretch xmlns:a="http://schemas.openxmlformats.org/drawingml/2006/main"/>
         </p:blipFill>
         <p:spPr>
@@ -8998,7 +8998,7 @@
           <p:cNvPr id="7" name="">
             <a:extLst xmlns:a="http://schemas.openxmlformats.org/drawingml/2006/main">
               <a:ext uri="{FF2B5EF4-FFF2-40B4-BE49-F238E27FC236}">
-                <a16:creationId xmlns:a16="http://schemas.microsoft.com/office/drawing/2014/main" id="{653CE123-9839-4DB1-9FB3-654E628A1834}"/>
+                <a16:creationId xmlns:a16="http://schemas.microsoft.com/office/drawing/2014/main" id="{E4C655AF-2825-47AB-A67B-B09D3518C192}"/>
               </a:ext>
             </a:extLst>
           </p:cNvPr>
@@ -9033,7 +9033,7 @@
           <p:cNvPr id="8" name="">
             <a:extLst xmlns:a="http://schemas.openxmlformats.org/drawingml/2006/main">
               <a:ext uri="{FF2B5EF4-FFF2-40B4-BE49-F238E27FC236}">
-                <a16:creationId xmlns:a16="http://schemas.microsoft.com/office/drawing/2014/main" id="{AECAFE70-0C54-4FFE-8C14-206F14388A73}"/>
+                <a16:creationId xmlns:a16="http://schemas.microsoft.com/office/drawing/2014/main" id="{1EE9A511-2308-4B3C-90C7-9AAC049D3964}"/>
               </a:ext>
             </a:extLst>
           </p:cNvPr>
@@ -9083,7 +9083,7 @@
           <p:cNvPr id="9" name="">
             <a:extLst xmlns:a="http://schemas.openxmlformats.org/drawingml/2006/main">
               <a:ext uri="{FF2B5EF4-FFF2-40B4-BE49-F238E27FC236}">
-                <a16:creationId xmlns:a16="http://schemas.microsoft.com/office/drawing/2014/main" id="{97C27F8E-2248-4545-9498-C7B5E2765A77}"/>
+                <a16:creationId xmlns:a16="http://schemas.microsoft.com/office/drawing/2014/main" id="{FC03210B-5889-4FEA-BF49-98D84AEFBFBA}"/>
               </a:ext>
             </a:extLst>
           </p:cNvPr>
@@ -9133,7 +9133,7 @@
           <p:cNvPr id="10" name="">
             <a:extLst xmlns:a="http://schemas.openxmlformats.org/drawingml/2006/main">
               <a:ext uri="{FF2B5EF4-FFF2-40B4-BE49-F238E27FC236}">
-                <a16:creationId xmlns:a16="http://schemas.microsoft.com/office/drawing/2014/main" id="{C4502E40-7CE9-4118-AA23-60771127578F}"/>
+                <a16:creationId xmlns:a16="http://schemas.microsoft.com/office/drawing/2014/main" id="{C14DE69C-F1C5-4A78-B3E9-BA46384A10AD}"/>
               </a:ext>
             </a:extLst>
           </p:cNvPr>
@@ -9168,7 +9168,7 @@
           <p:cNvPr id="11" name="">
             <a:extLst xmlns:a="http://schemas.openxmlformats.org/drawingml/2006/main">
               <a:ext uri="{FF2B5EF4-FFF2-40B4-BE49-F238E27FC236}">
-                <a16:creationId xmlns:a16="http://schemas.microsoft.com/office/drawing/2014/main" id="{1290352C-A3A0-4B1C-B1C1-BA5004110CBA}"/>
+                <a16:creationId xmlns:a16="http://schemas.microsoft.com/office/drawing/2014/main" id="{A2AF2C1F-4044-4AF2-AB45-5715551FDF34}"/>
               </a:ext>
             </a:extLst>
           </p:cNvPr>
@@ -9218,7 +9218,7 @@
           <p:cNvPr id="12" name="">
             <a:extLst xmlns:a="http://schemas.openxmlformats.org/drawingml/2006/main">
               <a:ext uri="{FF2B5EF4-FFF2-40B4-BE49-F238E27FC236}">
-                <a16:creationId xmlns:a16="http://schemas.microsoft.com/office/drawing/2014/main" id="{866CFFA8-F1C1-4C51-9F20-8DE55CAB7993}"/>
+                <a16:creationId xmlns:a16="http://schemas.microsoft.com/office/drawing/2014/main" id="{D746F0D4-02A0-407C-8815-9CD27046E814}"/>
               </a:ext>
             </a:extLst>
           </p:cNvPr>
@@ -9268,7 +9268,7 @@
           <p:cNvPr id="13" name="">
             <a:extLst xmlns:a="http://schemas.openxmlformats.org/drawingml/2006/main">
               <a:ext uri="{FF2B5EF4-FFF2-40B4-BE49-F238E27FC236}">
-                <a16:creationId xmlns:a16="http://schemas.microsoft.com/office/drawing/2014/main" id="{9CB5178A-962E-4778-A0EE-2048AF60B3ED}"/>
+                <a16:creationId xmlns:a16="http://schemas.microsoft.com/office/drawing/2014/main" id="{9E507F71-C1EA-457C-B7BE-51AAA3909F5B}"/>
               </a:ext>
             </a:extLst>
           </p:cNvPr>
@@ -9303,7 +9303,7 @@
           <p:cNvPr id="14" name="">
             <a:extLst xmlns:a="http://schemas.openxmlformats.org/drawingml/2006/main">
               <a:ext uri="{FF2B5EF4-FFF2-40B4-BE49-F238E27FC236}">
-                <a16:creationId xmlns:a16="http://schemas.microsoft.com/office/drawing/2014/main" id="{86F60D1D-B4D2-42F4-A135-C9C67CB5331B}"/>
+                <a16:creationId xmlns:a16="http://schemas.microsoft.com/office/drawing/2014/main" id="{43EF2283-4D32-4C85-8D8F-B8F65FDB8F57}"/>
               </a:ext>
             </a:extLst>
           </p:cNvPr>
@@ -9353,7 +9353,7 @@
           <p:cNvPr id="15" name="">
             <a:extLst xmlns:a="http://schemas.openxmlformats.org/drawingml/2006/main">
               <a:ext uri="{FF2B5EF4-FFF2-40B4-BE49-F238E27FC236}">
-                <a16:creationId xmlns:a16="http://schemas.microsoft.com/office/drawing/2014/main" id="{EEFFC9C1-DF76-48D6-BF74-D4A808E83AAF}"/>
+                <a16:creationId xmlns:a16="http://schemas.microsoft.com/office/drawing/2014/main" id="{661A2E8B-C533-4B33-9132-F1027B6D88C1}"/>
               </a:ext>
             </a:extLst>
           </p:cNvPr>
@@ -9403,7 +9403,7 @@
           <p:cNvPr id="16" name="">
             <a:extLst xmlns:a="http://schemas.openxmlformats.org/drawingml/2006/main">
               <a:ext uri="{FF2B5EF4-FFF2-40B4-BE49-F238E27FC236}">
-                <a16:creationId xmlns:a16="http://schemas.microsoft.com/office/drawing/2014/main" id="{1F165409-5CFC-4A51-B1EB-36FB13D324D7}"/>
+                <a16:creationId xmlns:a16="http://schemas.microsoft.com/office/drawing/2014/main" id="{BC93BB3F-C0CF-47BC-ACCC-DF7EFB129388}"/>
               </a:ext>
             </a:extLst>
           </p:cNvPr>
@@ -9438,7 +9438,7 @@
           <p:cNvPr id="17" name="">
             <a:extLst xmlns:a="http://schemas.openxmlformats.org/drawingml/2006/main">
               <a:ext uri="{FF2B5EF4-FFF2-40B4-BE49-F238E27FC236}">
-                <a16:creationId xmlns:a16="http://schemas.microsoft.com/office/drawing/2014/main" id="{29657507-1E52-4DF9-A5F4-71866E585F90}"/>
+                <a16:creationId xmlns:a16="http://schemas.microsoft.com/office/drawing/2014/main" id="{EE993462-1D83-41DC-A163-63B23D996CC1}"/>
               </a:ext>
             </a:extLst>
           </p:cNvPr>
@@ -9488,7 +9488,7 @@
           <p:cNvPr id="18" name="">
             <a:extLst xmlns:a="http://schemas.openxmlformats.org/drawingml/2006/main">
               <a:ext uri="{FF2B5EF4-FFF2-40B4-BE49-F238E27FC236}">
-                <a16:creationId xmlns:a16="http://schemas.microsoft.com/office/drawing/2014/main" id="{9EB48349-F9FA-4719-A156-3968D5E347AC}"/>
+                <a16:creationId xmlns:a16="http://schemas.microsoft.com/office/drawing/2014/main" id="{3E750C76-B0FB-4C87-B5EB-C97DA54442EA}"/>
               </a:ext>
             </a:extLst>
           </p:cNvPr>
@@ -9538,7 +9538,7 @@
           <p:cNvPr id="19" name="">
             <a:extLst xmlns:a="http://schemas.openxmlformats.org/drawingml/2006/main">
               <a:ext uri="{FF2B5EF4-FFF2-40B4-BE49-F238E27FC236}">
-                <a16:creationId xmlns:a16="http://schemas.microsoft.com/office/drawing/2014/main" id="{562A1B5A-6546-4DD3-A7BE-6D8CED11B456}"/>
+                <a16:creationId xmlns:a16="http://schemas.microsoft.com/office/drawing/2014/main" id="{6402B4D2-72B2-4528-A64A-6E8ADB1C070D}"/>
               </a:ext>
             </a:extLst>
           </p:cNvPr>
@@ -9573,7 +9573,7 @@
           <p:cNvPr id="20" name="">
             <a:extLst xmlns:a="http://schemas.openxmlformats.org/drawingml/2006/main">
               <a:ext uri="{FF2B5EF4-FFF2-40B4-BE49-F238E27FC236}">
-                <a16:creationId xmlns:a16="http://schemas.microsoft.com/office/drawing/2014/main" id="{7EF6CCA9-CE1C-4929-9B90-8A84576D47B6}"/>
+                <a16:creationId xmlns:a16="http://schemas.microsoft.com/office/drawing/2014/main" id="{0E9DC8E5-7BC7-4FFA-8F4C-01AE0B53CB02}"/>
               </a:ext>
             </a:extLst>
           </p:cNvPr>
@@ -9623,7 +9623,7 @@
           <p:cNvPr id="21" name="">
             <a:extLst xmlns:a="http://schemas.openxmlformats.org/drawingml/2006/main">
               <a:ext uri="{FF2B5EF4-FFF2-40B4-BE49-F238E27FC236}">
-                <a16:creationId xmlns:a16="http://schemas.microsoft.com/office/drawing/2014/main" id="{85E0EB84-3F9A-4930-AAC5-CF82EA3507A1}"/>
+                <a16:creationId xmlns:a16="http://schemas.microsoft.com/office/drawing/2014/main" id="{CA7A772A-80FF-48F6-A09C-090BA98B66E1}"/>
               </a:ext>
             </a:extLst>
           </p:cNvPr>
@@ -9673,7 +9673,7 @@
           <p:cNvPr id="22" name="">
             <a:extLst xmlns:a="http://schemas.openxmlformats.org/drawingml/2006/main">
               <a:ext uri="{FF2B5EF4-FFF2-40B4-BE49-F238E27FC236}">
-                <a16:creationId xmlns:a16="http://schemas.microsoft.com/office/drawing/2014/main" id="{7FA1AD64-FFD6-4A9F-BE91-243C8D5C663D}"/>
+                <a16:creationId xmlns:a16="http://schemas.microsoft.com/office/drawing/2014/main" id="{C9AE81C0-F7CE-45B7-AD57-81BDEA07AAED}"/>
               </a:ext>
             </a:extLst>
           </p:cNvPr>
@@ -9708,7 +9708,7 @@
           <p:cNvPr id="23" name="">
             <a:extLst xmlns:a="http://schemas.openxmlformats.org/drawingml/2006/main">
               <a:ext uri="{FF2B5EF4-FFF2-40B4-BE49-F238E27FC236}">
-                <a16:creationId xmlns:a16="http://schemas.microsoft.com/office/drawing/2014/main" id="{45D1A29D-8963-47B1-817E-0D8FE957CA0A}"/>
+                <a16:creationId xmlns:a16="http://schemas.microsoft.com/office/drawing/2014/main" id="{0EB78697-5DA2-4DE6-8F38-38ED7E9FBF68}"/>
               </a:ext>
             </a:extLst>
           </p:cNvPr>
@@ -9758,7 +9758,7 @@
           <p:cNvPr id="24" name="">
             <a:extLst xmlns:a="http://schemas.openxmlformats.org/drawingml/2006/main">
               <a:ext uri="{FF2B5EF4-FFF2-40B4-BE49-F238E27FC236}">
-                <a16:creationId xmlns:a16="http://schemas.microsoft.com/office/drawing/2014/main" id="{09DC51BA-6E7D-4C91-892D-92774560AE91}"/>
+                <a16:creationId xmlns:a16="http://schemas.microsoft.com/office/drawing/2014/main" id="{ED8B5AA2-28E3-4C32-AF9E-460C42E68D89}"/>
               </a:ext>
             </a:extLst>
           </p:cNvPr>
@@ -9806,7 +9806,7 @@
     </p:spTree>
     <p:extLst>
       <p:ext uri="{BB962C8B-B14F-4D97-AF65-F5344CB8AC3E}">
-        <p14:creationId xmlns:p14="http://schemas.microsoft.com/office/powerpoint/2010/main" val="1721983785"/>
+        <p14:creationId xmlns:p14="http://schemas.microsoft.com/office/powerpoint/2010/main" val="1194396131"/>
       </p:ext>
     </p:extLst>
   </p:cSld>
@@ -9837,7 +9837,7 @@
           <p:cNvPr id="1" name="">
             <a:extLst xmlns:a="http://schemas.openxmlformats.org/drawingml/2006/main">
               <a:ext uri="{FF2B5EF4-FFF2-40B4-BE49-F238E27FC236}">
-                <a16:creationId xmlns:a16="http://schemas.microsoft.com/office/drawing/2014/main" id="{5E6F2B9B-D6FC-4B1E-BFBF-A0A25B3FACB2}"/>
+                <a16:creationId xmlns:a16="http://schemas.microsoft.com/office/drawing/2014/main" id="{00BC8134-ED6D-42A7-B9B6-3C7876F3AD0D}"/>
               </a:ext>
             </a:extLst>
           </p:cNvPr>
@@ -9870,7 +9870,7 @@
           <p:cNvPr id="2" name="">
             <a:extLst xmlns:a="http://schemas.openxmlformats.org/drawingml/2006/main">
               <a:ext uri="{FF2B5EF4-FFF2-40B4-BE49-F238E27FC236}">
-                <a16:creationId xmlns:a16="http://schemas.microsoft.com/office/drawing/2014/main" id="{E15C223F-3E40-4EE9-ACA4-B4923DF78C19}"/>
+                <a16:creationId xmlns:a16="http://schemas.microsoft.com/office/drawing/2014/main" id="{938602D9-DA2C-4C06-916C-7AE9F6338D73}"/>
               </a:ext>
             </a:extLst>
           </p:cNvPr>
@@ -9903,7 +9903,7 @@
           <p:cNvPr id="3" name="">
             <a:extLst xmlns:a="http://schemas.openxmlformats.org/drawingml/2006/main">
               <a:ext uri="{FF2B5EF4-FFF2-40B4-BE49-F238E27FC236}">
-                <a16:creationId xmlns:a16="http://schemas.microsoft.com/office/drawing/2014/main" id="{6FF54597-24E9-456A-99E9-4CF69F7029CF}"/>
+                <a16:creationId xmlns:a16="http://schemas.microsoft.com/office/drawing/2014/main" id="{043543C5-31B4-409A-A798-D216F4CA0693}"/>
               </a:ext>
             </a:extLst>
           </p:cNvPr>
@@ -9953,7 +9953,7 @@
           <p:cNvPr id="4" name="">
             <a:extLst xmlns:a="http://schemas.openxmlformats.org/drawingml/2006/main">
               <a:ext uri="{FF2B5EF4-FFF2-40B4-BE49-F238E27FC236}">
-                <a16:creationId xmlns:a16="http://schemas.microsoft.com/office/drawing/2014/main" id="{943DFA7D-C720-47FA-B11F-F30D678E8354}"/>
+                <a16:creationId xmlns:a16="http://schemas.microsoft.com/office/drawing/2014/main" id="{3B1FF14E-860C-476F-88BD-7FE60D2FDFD2}"/>
               </a:ext>
             </a:extLst>
           </p:cNvPr>
@@ -10003,7 +10003,7 @@
           <p:cNvPr id="5" name="">
             <a:extLst xmlns:a="http://schemas.openxmlformats.org/drawingml/2006/main">
               <a:ext uri="{FF2B5EF4-FFF2-40B4-BE49-F238E27FC236}">
-                <a16:creationId xmlns:a16="http://schemas.microsoft.com/office/drawing/2014/main" id="{39A54F34-CF5A-42F3-A0D6-BBC2D10D7796}"/>
+                <a16:creationId xmlns:a16="http://schemas.microsoft.com/office/drawing/2014/main" id="{2CE773BD-3E02-41C1-8979-5EF2747F15B7}"/>
               </a:ext>
             </a:extLst>
           </p:cNvPr>
@@ -10038,7 +10038,7 @@
           <p:nvPr/>
         </p:nvPicPr>
         <p:blipFill>
-          <a:blip xmlns:r="http://schemas.openxmlformats.org/officeDocument/2006/relationships" xmlns:a="http://schemas.openxmlformats.org/drawingml/2006/main" r:embed="Re5ead1f723c04851"/>
+          <a:blip xmlns:r="http://schemas.openxmlformats.org/officeDocument/2006/relationships" xmlns:a="http://schemas.openxmlformats.org/drawingml/2006/main" r:embed="Rb3901886bf34402d"/>
           <a:stretch xmlns:a="http://schemas.openxmlformats.org/drawingml/2006/main"/>
         </p:blipFill>
         <p:spPr>
@@ -10056,7 +10056,7 @@
           <p:cNvPr id="7" name="">
             <a:extLst xmlns:a="http://schemas.openxmlformats.org/drawingml/2006/main">
               <a:ext uri="{FF2B5EF4-FFF2-40B4-BE49-F238E27FC236}">
-                <a16:creationId xmlns:a16="http://schemas.microsoft.com/office/drawing/2014/main" id="{7CC4E881-8A8E-4637-866D-0BE0A7438AE0}"/>
+                <a16:creationId xmlns:a16="http://schemas.microsoft.com/office/drawing/2014/main" id="{2CBDBD24-6716-44CC-9CC2-6C50B0BC04D1}"/>
               </a:ext>
             </a:extLst>
           </p:cNvPr>
@@ -10106,7 +10106,7 @@
           <p:cNvPr id="8" name="">
             <a:extLst xmlns:a="http://schemas.openxmlformats.org/drawingml/2006/main">
               <a:ext uri="{FF2B5EF4-FFF2-40B4-BE49-F238E27FC236}">
-                <a16:creationId xmlns:a16="http://schemas.microsoft.com/office/drawing/2014/main" id="{BDEBE08E-24CB-4C5B-9CBE-96475D75887E}"/>
+                <a16:creationId xmlns:a16="http://schemas.microsoft.com/office/drawing/2014/main" id="{9E992CEA-D4B6-4E19-9168-FD7C91902908}"/>
               </a:ext>
             </a:extLst>
           </p:cNvPr>
@@ -10156,7 +10156,7 @@
           <p:cNvPr id="9" name="">
             <a:extLst xmlns:a="http://schemas.openxmlformats.org/drawingml/2006/main">
               <a:ext uri="{FF2B5EF4-FFF2-40B4-BE49-F238E27FC236}">
-                <a16:creationId xmlns:a16="http://schemas.microsoft.com/office/drawing/2014/main" id="{AA4F093D-2AB9-4AC7-88AB-489B1D734F7F}"/>
+                <a16:creationId xmlns:a16="http://schemas.microsoft.com/office/drawing/2014/main" id="{72ED9AEF-F90B-4BDE-BC44-9C6409C8C362}"/>
               </a:ext>
             </a:extLst>
           </p:cNvPr>
@@ -10206,7 +10206,7 @@
           <p:cNvPr id="10" name="">
             <a:extLst xmlns:a="http://schemas.openxmlformats.org/drawingml/2006/main">
               <a:ext uri="{FF2B5EF4-FFF2-40B4-BE49-F238E27FC236}">
-                <a16:creationId xmlns:a16="http://schemas.microsoft.com/office/drawing/2014/main" id="{965A09B9-2702-4AA4-AAC4-9D0859C182F3}"/>
+                <a16:creationId xmlns:a16="http://schemas.microsoft.com/office/drawing/2014/main" id="{5731AE1B-0D3F-467D-8D36-042C9BB6A539}"/>
               </a:ext>
             </a:extLst>
           </p:cNvPr>
@@ -10239,7 +10239,7 @@
           <p:cNvPr id="11" name="">
             <a:extLst xmlns:a="http://schemas.openxmlformats.org/drawingml/2006/main">
               <a:ext uri="{FF2B5EF4-FFF2-40B4-BE49-F238E27FC236}">
-                <a16:creationId xmlns:a16="http://schemas.microsoft.com/office/drawing/2014/main" id="{F70A290E-1E50-4D92-9C41-2884BD3C5027}"/>
+                <a16:creationId xmlns:a16="http://schemas.microsoft.com/office/drawing/2014/main" id="{9E045A40-2EF4-45D0-A2F3-22ECFD08760B}"/>
               </a:ext>
             </a:extLst>
           </p:cNvPr>
@@ -10289,7 +10289,7 @@
           <p:cNvPr id="12" name="">
             <a:extLst xmlns:a="http://schemas.openxmlformats.org/drawingml/2006/main">
               <a:ext uri="{FF2B5EF4-FFF2-40B4-BE49-F238E27FC236}">
-                <a16:creationId xmlns:a16="http://schemas.microsoft.com/office/drawing/2014/main" id="{EA0D57BA-6E54-4496-8B00-2722760FBAF9}"/>
+                <a16:creationId xmlns:a16="http://schemas.microsoft.com/office/drawing/2014/main" id="{4E135673-E611-4FB6-8B38-31E4B5E9623E}"/>
               </a:ext>
             </a:extLst>
           </p:cNvPr>
@@ -10322,7 +10322,7 @@
           <p:cNvPr id="13" name="">
             <a:extLst xmlns:a="http://schemas.openxmlformats.org/drawingml/2006/main">
               <a:ext uri="{FF2B5EF4-FFF2-40B4-BE49-F238E27FC236}">
-                <a16:creationId xmlns:a16="http://schemas.microsoft.com/office/drawing/2014/main" id="{82689965-4613-4E8C-B6F3-228FF81CFC05}"/>
+                <a16:creationId xmlns:a16="http://schemas.microsoft.com/office/drawing/2014/main" id="{4ABDBEF9-C698-49BC-B4E4-F52DC95CA4CE}"/>
               </a:ext>
             </a:extLst>
           </p:cNvPr>
@@ -10372,7 +10372,7 @@
           <p:cNvPr id="14" name="">
             <a:extLst xmlns:a="http://schemas.openxmlformats.org/drawingml/2006/main">
               <a:ext uri="{FF2B5EF4-FFF2-40B4-BE49-F238E27FC236}">
-                <a16:creationId xmlns:a16="http://schemas.microsoft.com/office/drawing/2014/main" id="{767DF67A-5E1A-4B7D-AC71-2A2ED7818F15}"/>
+                <a16:creationId xmlns:a16="http://schemas.microsoft.com/office/drawing/2014/main" id="{E4AFC232-6355-4210-ACE9-1348991D4031}"/>
               </a:ext>
             </a:extLst>
           </p:cNvPr>
@@ -10405,7 +10405,7 @@
           <p:cNvPr id="15" name="">
             <a:extLst xmlns:a="http://schemas.openxmlformats.org/drawingml/2006/main">
               <a:ext uri="{FF2B5EF4-FFF2-40B4-BE49-F238E27FC236}">
-                <a16:creationId xmlns:a16="http://schemas.microsoft.com/office/drawing/2014/main" id="{29A900BE-CDAD-405B-97EB-D845EEB8ECD8}"/>
+                <a16:creationId xmlns:a16="http://schemas.microsoft.com/office/drawing/2014/main" id="{31074C2D-81B0-4A28-B0C8-4B4C0B3B093F}"/>
               </a:ext>
             </a:extLst>
           </p:cNvPr>
@@ -10455,7 +10455,7 @@
           <p:cNvPr id="16" name="">
             <a:extLst xmlns:a="http://schemas.openxmlformats.org/drawingml/2006/main">
               <a:ext uri="{FF2B5EF4-FFF2-40B4-BE49-F238E27FC236}">
-                <a16:creationId xmlns:a16="http://schemas.microsoft.com/office/drawing/2014/main" id="{05546797-C95E-4B0E-B505-93F90DDFE807}"/>
+                <a16:creationId xmlns:a16="http://schemas.microsoft.com/office/drawing/2014/main" id="{75EFC192-9043-4F05-9348-ACBCDF599B4C}"/>
               </a:ext>
             </a:extLst>
           </p:cNvPr>
@@ -10488,7 +10488,7 @@
           <p:cNvPr id="17" name="">
             <a:extLst xmlns:a="http://schemas.openxmlformats.org/drawingml/2006/main">
               <a:ext uri="{FF2B5EF4-FFF2-40B4-BE49-F238E27FC236}">
-                <a16:creationId xmlns:a16="http://schemas.microsoft.com/office/drawing/2014/main" id="{F7DF9538-2F3B-455A-A49B-82718CB6AE98}"/>
+                <a16:creationId xmlns:a16="http://schemas.microsoft.com/office/drawing/2014/main" id="{1AC36A98-4057-4708-83CA-5906B467AE1E}"/>
               </a:ext>
             </a:extLst>
           </p:cNvPr>
@@ -10536,7 +10536,7 @@
     </p:spTree>
     <p:extLst>
       <p:ext uri="{BB962C8B-B14F-4D97-AF65-F5344CB8AC3E}">
-        <p14:creationId xmlns:p14="http://schemas.microsoft.com/office/powerpoint/2010/main" val="1036446004"/>
+        <p14:creationId xmlns:p14="http://schemas.microsoft.com/office/powerpoint/2010/main" val="1538020153"/>
       </p:ext>
     </p:extLst>
   </p:cSld>
@@ -10567,7 +10567,7 @@
           <p:cNvPr id="1" name="">
             <a:extLst xmlns:a="http://schemas.openxmlformats.org/drawingml/2006/main">
               <a:ext uri="{FF2B5EF4-FFF2-40B4-BE49-F238E27FC236}">
-                <a16:creationId xmlns:a16="http://schemas.microsoft.com/office/drawing/2014/main" id="{5E0FD171-A458-413F-AA48-A39824DC17BA}"/>
+                <a16:creationId xmlns:a16="http://schemas.microsoft.com/office/drawing/2014/main" id="{3C7C06FD-12FD-48D6-882A-55446EEC9A9D}"/>
               </a:ext>
             </a:extLst>
           </p:cNvPr>
@@ -10600,7 +10600,7 @@
           <p:cNvPr id="2" name="">
             <a:extLst xmlns:a="http://schemas.openxmlformats.org/drawingml/2006/main">
               <a:ext uri="{FF2B5EF4-FFF2-40B4-BE49-F238E27FC236}">
-                <a16:creationId xmlns:a16="http://schemas.microsoft.com/office/drawing/2014/main" id="{0F76A65F-FE2F-4066-BB83-13442DE708BC}"/>
+                <a16:creationId xmlns:a16="http://schemas.microsoft.com/office/drawing/2014/main" id="{95D42B22-AB33-4839-A330-0ECA735C3B8C}"/>
               </a:ext>
             </a:extLst>
           </p:cNvPr>
@@ -10633,7 +10633,7 @@
           <p:cNvPr id="3" name="">
             <a:extLst xmlns:a="http://schemas.openxmlformats.org/drawingml/2006/main">
               <a:ext uri="{FF2B5EF4-FFF2-40B4-BE49-F238E27FC236}">
-                <a16:creationId xmlns:a16="http://schemas.microsoft.com/office/drawing/2014/main" id="{DDFD3F7A-2E77-44C8-A3D6-AA218F2BC7C3}"/>
+                <a16:creationId xmlns:a16="http://schemas.microsoft.com/office/drawing/2014/main" id="{B0E28AF5-1DBF-4978-AF59-32C80EBF1954}"/>
               </a:ext>
             </a:extLst>
           </p:cNvPr>
@@ -10683,7 +10683,7 @@
           <p:cNvPr id="4" name="">
             <a:extLst xmlns:a="http://schemas.openxmlformats.org/drawingml/2006/main">
               <a:ext uri="{FF2B5EF4-FFF2-40B4-BE49-F238E27FC236}">
-                <a16:creationId xmlns:a16="http://schemas.microsoft.com/office/drawing/2014/main" id="{C18FAD54-0537-4F34-A508-B72E32576E12}"/>
+                <a16:creationId xmlns:a16="http://schemas.microsoft.com/office/drawing/2014/main" id="{2E6F1560-7530-469D-8877-08AD6AD725F9}"/>
               </a:ext>
             </a:extLst>
           </p:cNvPr>
@@ -10733,7 +10733,7 @@
           <p:cNvPr id="5" name="">
             <a:extLst xmlns:a="http://schemas.openxmlformats.org/drawingml/2006/main">
               <a:ext uri="{FF2B5EF4-FFF2-40B4-BE49-F238E27FC236}">
-                <a16:creationId xmlns:a16="http://schemas.microsoft.com/office/drawing/2014/main" id="{58A9FDEA-FB16-4A46-BC04-43B4BE2759D0}"/>
+                <a16:creationId xmlns:a16="http://schemas.microsoft.com/office/drawing/2014/main" id="{FD7D5E93-73E6-40E3-A0C8-C2AAF1D57535}"/>
               </a:ext>
             </a:extLst>
           </p:cNvPr>
@@ -10761,14 +10761,14 @@
       </p:sp>
       <p:pic>
         <p:nvPicPr>
-          <p:cNvPr id="34" name=""/>
+          <p:cNvPr id="38" name=""/>
           <p:cNvPicPr>
             <a:picLocks xmlns:a="http://schemas.openxmlformats.org/drawingml/2006/main" noChangeAspect="1"/>
           </p:cNvPicPr>
           <p:nvPr/>
         </p:nvPicPr>
         <p:blipFill>
-          <a:blip xmlns:r="http://schemas.openxmlformats.org/officeDocument/2006/relationships" xmlns:a="http://schemas.openxmlformats.org/drawingml/2006/main" r:embed="R69e2d9f0778b4e57"/>
+          <a:blip xmlns:r="http://schemas.openxmlformats.org/officeDocument/2006/relationships" xmlns:a="http://schemas.openxmlformats.org/drawingml/2006/main" r:embed="R937b94541514469b"/>
           <a:stretch xmlns:a="http://schemas.openxmlformats.org/drawingml/2006/main"/>
         </p:blipFill>
         <p:spPr>
@@ -10786,18 +10786,18 @@
           <p:cNvPr id="7" name="">
             <a:extLst xmlns:a="http://schemas.openxmlformats.org/drawingml/2006/main">
               <a:ext uri="{FF2B5EF4-FFF2-40B4-BE49-F238E27FC236}">
-                <a16:creationId xmlns:a16="http://schemas.microsoft.com/office/drawing/2014/main" id="{AC062781-CBBD-4F1A-9B44-F1963BD4983D}"/>
-              </a:ext>
-            </a:extLst>
-          </p:cNvPr>
-          <p:cNvSpPr>
-            <a:spLocks xmlns:a="http://schemas.openxmlformats.org/drawingml/2006/main" noGrp="1"/>
-          </p:cNvSpPr>
-          <p:nvPr/>
-        </p:nvSpPr>
-        <p:spPr>
-          <a:xfrm xmlns:a="http://schemas.openxmlformats.org/drawingml/2006/main">
-            <a:off x="895350" y="1657350"/>
+                <a16:creationId xmlns:a16="http://schemas.microsoft.com/office/drawing/2014/main" id="{C64EC182-8D8E-4CA6-BF0F-79FA38FAE15E}"/>
+              </a:ext>
+            </a:extLst>
+          </p:cNvPr>
+          <p:cNvSpPr>
+            <a:spLocks xmlns:a="http://schemas.openxmlformats.org/drawingml/2006/main" noGrp="1"/>
+          </p:cNvSpPr>
+          <p:nvPr/>
+        </p:nvSpPr>
+        <p:spPr>
+          <a:xfrm xmlns:a="http://schemas.openxmlformats.org/drawingml/2006/main">
+            <a:off x="895350" y="1600200"/>
             <a:ext cx="3048000" cy="285750"/>
           </a:xfrm>
           <a:prstGeom xmlns:a="http://schemas.openxmlformats.org/drawingml/2006/main" prst="rect">
@@ -10836,23 +10836,189 @@
           <p:cNvPr id="8" name="">
             <a:extLst xmlns:a="http://schemas.openxmlformats.org/drawingml/2006/main">
               <a:ext uri="{FF2B5EF4-FFF2-40B4-BE49-F238E27FC236}">
-                <a16:creationId xmlns:a16="http://schemas.microsoft.com/office/drawing/2014/main" id="{961FB6E1-DB8E-4CF3-BD82-8A6A7FDE119B}"/>
-              </a:ext>
-            </a:extLst>
-          </p:cNvPr>
-          <p:cNvSpPr>
-            <a:spLocks xmlns:a="http://schemas.openxmlformats.org/drawingml/2006/main" noGrp="1"/>
-          </p:cNvSpPr>
-          <p:nvPr/>
-        </p:nvSpPr>
-        <p:spPr>
-          <a:xfrm xmlns:a="http://schemas.openxmlformats.org/drawingml/2006/main">
-            <a:off x="876300" y="2381250"/>
-            <a:ext cx="1428750" cy="1047750"/>
+                <a16:creationId xmlns:a16="http://schemas.microsoft.com/office/drawing/2014/main" id="{6F6F96D0-732F-4685-AE73-BB16A626EC2E}"/>
+              </a:ext>
+            </a:extLst>
+          </p:cNvPr>
+          <p:cNvSpPr>
+            <a:spLocks xmlns:a="http://schemas.openxmlformats.org/drawingml/2006/main" noGrp="1"/>
+          </p:cNvSpPr>
+          <p:nvPr/>
+        </p:nvSpPr>
+        <p:spPr>
+          <a:xfrm xmlns:a="http://schemas.openxmlformats.org/drawingml/2006/main">
+            <a:off x="876300" y="2152650"/>
+            <a:ext cx="1428750" cy="990600"/>
           </a:xfrm>
           <a:prstGeom xmlns:a="http://schemas.openxmlformats.org/drawingml/2006/main" prst="roundRect">
             <a:avLst>
-              <a:gd name="adj" fmla="val 7273"/>
+              <a:gd name="adj" fmla="val 7692"/>
+            </a:avLst>
+          </a:prstGeom>
+          <a:solidFill xmlns:a="http://schemas.openxmlformats.org/drawingml/2006/main">
+            <a:srgbClr val="0D3D2D"/>
+          </a:solidFill>
+          <a:ln xmlns:a="http://schemas.openxmlformats.org/drawingml/2006/main" w="9525">
+            <a:solidFill>
+              <a:srgbClr val="0D3D2D"/>
+            </a:solidFill>
+            <a:prstDash val="solid"/>
+          </a:ln>
+        </p:spPr>
+      </p:sp>
+      <p:sp>
+        <p:nvSpPr>
+          <p:cNvPr id="9" name="">
+            <a:extLst xmlns:a="http://schemas.openxmlformats.org/drawingml/2006/main">
+              <a:ext uri="{FF2B5EF4-FFF2-40B4-BE49-F238E27FC236}">
+                <a16:creationId xmlns:a16="http://schemas.microsoft.com/office/drawing/2014/main" id="{2093411D-1B89-4C81-8610-FC680C4F445E}"/>
+              </a:ext>
+            </a:extLst>
+          </p:cNvPr>
+          <p:cNvSpPr>
+            <a:spLocks xmlns:a="http://schemas.openxmlformats.org/drawingml/2006/main" noGrp="1"/>
+          </p:cNvSpPr>
+          <p:nvPr/>
+        </p:nvSpPr>
+        <p:spPr>
+          <a:xfrm xmlns:a="http://schemas.openxmlformats.org/drawingml/2006/main">
+            <a:off x="1085850" y="2343150"/>
+            <a:ext cx="342900" cy="323850"/>
+          </a:xfrm>
+          <a:prstGeom xmlns:a="http://schemas.openxmlformats.org/drawingml/2006/main" prst="rect">
+            <a:avLst/>
+          </a:prstGeom>
+          <a:noFill xmlns:a="http://schemas.openxmlformats.org/drawingml/2006/main"/>
+          <a:ln xmlns:a="http://schemas.openxmlformats.org/drawingml/2006/main" w="0">
+            <a:noFill/>
+            <a:prstDash val="solid"/>
+          </a:ln>
+        </p:spPr>
+        <p:txBody>
+          <a:bodyPr xmlns:a="http://schemas.openxmlformats.org/drawingml/2006/main"/>
+          <a:lstStyle xmlns:a="http://schemas.openxmlformats.org/drawingml/2006/main"/>
+          <a:p xmlns:a="http://schemas.openxmlformats.org/drawingml/2006/main">
+            <a:pPr>
+              <a:defRPr sz="2325" b="1">
+                <a:solidFill>
+                  <a:srgbClr val="C7A044"/>
+                </a:solidFill>
+              </a:defRPr>
+            </a:pPr>
+            <a:r>
+              <a:rPr sz="2325" b="1">
+                <a:solidFill>
+                  <a:srgbClr val="C7A044"/>
+                </a:solidFill>
+              </a:rPr>
+              <a:t>1</a:t>
+            </a:r>
+          </a:p>
+        </p:txBody>
+      </p:sp>
+      <p:sp>
+        <p:nvSpPr>
+          <p:cNvPr id="10" name="">
+            <a:extLst xmlns:a="http://schemas.openxmlformats.org/drawingml/2006/main">
+              <a:ext uri="{FF2B5EF4-FFF2-40B4-BE49-F238E27FC236}">
+                <a16:creationId xmlns:a16="http://schemas.microsoft.com/office/drawing/2014/main" id="{BB08D2BF-F358-40FC-95B9-7853D16E7157}"/>
+              </a:ext>
+            </a:extLst>
+          </p:cNvPr>
+          <p:cNvSpPr>
+            <a:spLocks xmlns:a="http://schemas.openxmlformats.org/drawingml/2006/main" noGrp="1"/>
+          </p:cNvSpPr>
+          <p:nvPr/>
+        </p:nvSpPr>
+        <p:spPr>
+          <a:xfrm xmlns:a="http://schemas.openxmlformats.org/drawingml/2006/main">
+            <a:off x="1085850" y="2781300"/>
+            <a:ext cx="952500" cy="247650"/>
+          </a:xfrm>
+          <a:prstGeom xmlns:a="http://schemas.openxmlformats.org/drawingml/2006/main" prst="rect">
+            <a:avLst/>
+          </a:prstGeom>
+          <a:noFill xmlns:a="http://schemas.openxmlformats.org/drawingml/2006/main"/>
+          <a:ln xmlns:a="http://schemas.openxmlformats.org/drawingml/2006/main" w="0">
+            <a:noFill/>
+            <a:prstDash val="solid"/>
+          </a:ln>
+        </p:spPr>
+        <p:txBody>
+          <a:bodyPr xmlns:a="http://schemas.openxmlformats.org/drawingml/2006/main"/>
+          <a:lstStyle xmlns:a="http://schemas.openxmlformats.org/drawingml/2006/main"/>
+          <a:p xmlns:a="http://schemas.openxmlformats.org/drawingml/2006/main">
+            <a:pPr>
+              <a:defRPr sz="1575" b="1">
+                <a:solidFill>
+                  <a:srgbClr val="FFFFFF"/>
+                </a:solidFill>
+              </a:defRPr>
+            </a:pPr>
+            <a:r>
+              <a:rPr sz="1575" b="1">
+                <a:solidFill>
+                  <a:srgbClr val="FFFFFF"/>
+                </a:solidFill>
+              </a:rPr>
+              <a:t>Collect</a:t>
+            </a:r>
+          </a:p>
+        </p:txBody>
+      </p:sp>
+      <p:sp>
+        <p:nvSpPr>
+          <p:cNvPr id="11" name="">
+            <a:extLst xmlns:a="http://schemas.openxmlformats.org/drawingml/2006/main">
+              <a:ext uri="{FF2B5EF4-FFF2-40B4-BE49-F238E27FC236}">
+                <a16:creationId xmlns:a16="http://schemas.microsoft.com/office/drawing/2014/main" id="{4C9E0B47-8058-4778-8DF2-4C847D2A6986}"/>
+              </a:ext>
+            </a:extLst>
+          </p:cNvPr>
+          <p:cNvSpPr>
+            <a:spLocks xmlns:a="http://schemas.openxmlformats.org/drawingml/2006/main" noGrp="1"/>
+          </p:cNvSpPr>
+          <p:nvPr/>
+        </p:nvSpPr>
+        <p:spPr>
+          <a:xfrm xmlns:a="http://schemas.openxmlformats.org/drawingml/2006/main">
+            <a:off x="2352675" y="2647950"/>
+            <a:ext cx="438150" cy="0"/>
+          </a:xfrm>
+          <a:prstGeom xmlns:a="http://schemas.openxmlformats.org/drawingml/2006/main" prst="line">
+            <a:avLst/>
+          </a:prstGeom>
+          <a:noFill xmlns:a="http://schemas.openxmlformats.org/drawingml/2006/main"/>
+          <a:ln xmlns:a="http://schemas.openxmlformats.org/drawingml/2006/main" w="28575">
+            <a:solidFill>
+              <a:srgbClr val="C7A044"/>
+            </a:solidFill>
+            <a:prstDash val="solid"/>
+          </a:ln>
+        </p:spPr>
+      </p:sp>
+      <p:sp>
+        <p:nvSpPr>
+          <p:cNvPr id="12" name="">
+            <a:extLst xmlns:a="http://schemas.openxmlformats.org/drawingml/2006/main">
+              <a:ext uri="{FF2B5EF4-FFF2-40B4-BE49-F238E27FC236}">
+                <a16:creationId xmlns:a16="http://schemas.microsoft.com/office/drawing/2014/main" id="{44F4156B-0584-4CA7-98B1-114EE3D10F67}"/>
+              </a:ext>
+            </a:extLst>
+          </p:cNvPr>
+          <p:cNvSpPr>
+            <a:spLocks xmlns:a="http://schemas.openxmlformats.org/drawingml/2006/main" noGrp="1"/>
+          </p:cNvSpPr>
+          <p:nvPr/>
+        </p:nvSpPr>
+        <p:spPr>
+          <a:xfrm xmlns:a="http://schemas.openxmlformats.org/drawingml/2006/main">
+            <a:off x="2828925" y="2152650"/>
+            <a:ext cx="1428750" cy="990600"/>
+          </a:xfrm>
+          <a:prstGeom xmlns:a="http://schemas.openxmlformats.org/drawingml/2006/main" prst="roundRect">
+            <a:avLst>
+              <a:gd name="adj" fmla="val 7692"/>
             </a:avLst>
           </a:prstGeom>
           <a:solidFill xmlns:a="http://schemas.openxmlformats.org/drawingml/2006/main">
@@ -10868,21 +11034,21 @@
       </p:sp>
       <p:sp>
         <p:nvSpPr>
-          <p:cNvPr id="9" name="">
-            <a:extLst xmlns:a="http://schemas.openxmlformats.org/drawingml/2006/main">
-              <a:ext uri="{FF2B5EF4-FFF2-40B4-BE49-F238E27FC236}">
-                <a16:creationId xmlns:a16="http://schemas.microsoft.com/office/drawing/2014/main" id="{A0FB8F0D-D978-4B65-9A8B-5D3029957C48}"/>
-              </a:ext>
-            </a:extLst>
-          </p:cNvPr>
-          <p:cNvSpPr>
-            <a:spLocks xmlns:a="http://schemas.openxmlformats.org/drawingml/2006/main" noGrp="1"/>
-          </p:cNvSpPr>
-          <p:nvPr/>
-        </p:nvSpPr>
-        <p:spPr>
-          <a:xfrm xmlns:a="http://schemas.openxmlformats.org/drawingml/2006/main">
-            <a:off x="1085850" y="2590800"/>
+          <p:cNvPr id="13" name="">
+            <a:extLst xmlns:a="http://schemas.openxmlformats.org/drawingml/2006/main">
+              <a:ext uri="{FF2B5EF4-FFF2-40B4-BE49-F238E27FC236}">
+                <a16:creationId xmlns:a16="http://schemas.microsoft.com/office/drawing/2014/main" id="{9430A848-5751-4C11-89C9-BB5AA213076E}"/>
+              </a:ext>
+            </a:extLst>
+          </p:cNvPr>
+          <p:cNvSpPr>
+            <a:spLocks xmlns:a="http://schemas.openxmlformats.org/drawingml/2006/main" noGrp="1"/>
+          </p:cNvSpPr>
+          <p:nvPr/>
+        </p:nvSpPr>
+        <p:spPr>
+          <a:xfrm xmlns:a="http://schemas.openxmlformats.org/drawingml/2006/main">
+            <a:off x="3038475" y="2343150"/>
             <a:ext cx="342900" cy="323850"/>
           </a:xfrm>
           <a:prstGeom xmlns:a="http://schemas.openxmlformats.org/drawingml/2006/main" prst="rect">
@@ -10911,28 +11077,28 @@
                   <a:srgbClr val="0D3D2D"/>
                 </a:solidFill>
               </a:rPr>
-              <a:t>1</a:t>
-            </a:r>
-          </a:p>
-        </p:txBody>
-      </p:sp>
-      <p:sp>
-        <p:nvSpPr>
-          <p:cNvPr id="10" name="">
-            <a:extLst xmlns:a="http://schemas.openxmlformats.org/drawingml/2006/main">
-              <a:ext uri="{FF2B5EF4-FFF2-40B4-BE49-F238E27FC236}">
-                <a16:creationId xmlns:a16="http://schemas.microsoft.com/office/drawing/2014/main" id="{0D93E37D-063C-4C57-9ACD-BB4DE88E30FE}"/>
-              </a:ext>
-            </a:extLst>
-          </p:cNvPr>
-          <p:cNvSpPr>
-            <a:spLocks xmlns:a="http://schemas.openxmlformats.org/drawingml/2006/main" noGrp="1"/>
-          </p:cNvSpPr>
-          <p:nvPr/>
-        </p:nvSpPr>
-        <p:spPr>
-          <a:xfrm xmlns:a="http://schemas.openxmlformats.org/drawingml/2006/main">
-            <a:off x="1085850" y="3028950"/>
+              <a:t>2</a:t>
+            </a:r>
+          </a:p>
+        </p:txBody>
+      </p:sp>
+      <p:sp>
+        <p:nvSpPr>
+          <p:cNvPr id="14" name="">
+            <a:extLst xmlns:a="http://schemas.openxmlformats.org/drawingml/2006/main">
+              <a:ext uri="{FF2B5EF4-FFF2-40B4-BE49-F238E27FC236}">
+                <a16:creationId xmlns:a16="http://schemas.microsoft.com/office/drawing/2014/main" id="{E19E915E-87BE-4050-9EB9-1A66672D8BA7}"/>
+              </a:ext>
+            </a:extLst>
+          </p:cNvPr>
+          <p:cNvSpPr>
+            <a:spLocks xmlns:a="http://schemas.openxmlformats.org/drawingml/2006/main" noGrp="1"/>
+          </p:cNvSpPr>
+          <p:nvPr/>
+        </p:nvSpPr>
+        <p:spPr>
+          <a:xfrm xmlns:a="http://schemas.openxmlformats.org/drawingml/2006/main">
+            <a:off x="3038475" y="2781300"/>
             <a:ext cx="952500" cy="247650"/>
           </a:xfrm>
           <a:prstGeom xmlns:a="http://schemas.openxmlformats.org/drawingml/2006/main" prst="rect">
@@ -10968,21 +11134,21 @@
       </p:sp>
       <p:sp>
         <p:nvSpPr>
-          <p:cNvPr id="11" name="">
-            <a:extLst xmlns:a="http://schemas.openxmlformats.org/drawingml/2006/main">
-              <a:ext uri="{FF2B5EF4-FFF2-40B4-BE49-F238E27FC236}">
-                <a16:creationId xmlns:a16="http://schemas.microsoft.com/office/drawing/2014/main" id="{5CACC827-9DA5-4642-B152-258887D09D2E}"/>
-              </a:ext>
-            </a:extLst>
-          </p:cNvPr>
-          <p:cNvSpPr>
-            <a:spLocks xmlns:a="http://schemas.openxmlformats.org/drawingml/2006/main" noGrp="1"/>
-          </p:cNvSpPr>
-          <p:nvPr/>
-        </p:nvSpPr>
-        <p:spPr>
-          <a:xfrm xmlns:a="http://schemas.openxmlformats.org/drawingml/2006/main">
-            <a:off x="2352675" y="2905125"/>
+          <p:cNvPr id="15" name="">
+            <a:extLst xmlns:a="http://schemas.openxmlformats.org/drawingml/2006/main">
+              <a:ext uri="{FF2B5EF4-FFF2-40B4-BE49-F238E27FC236}">
+                <a16:creationId xmlns:a16="http://schemas.microsoft.com/office/drawing/2014/main" id="{F75806BC-9934-44B5-89A4-814BE15F4006}"/>
+              </a:ext>
+            </a:extLst>
+          </p:cNvPr>
+          <p:cNvSpPr>
+            <a:spLocks xmlns:a="http://schemas.openxmlformats.org/drawingml/2006/main" noGrp="1"/>
+          </p:cNvSpPr>
+          <p:nvPr/>
+        </p:nvSpPr>
+        <p:spPr>
+          <a:xfrm xmlns:a="http://schemas.openxmlformats.org/drawingml/2006/main">
+            <a:off x="4305300" y="2647950"/>
             <a:ext cx="438150" cy="0"/>
           </a:xfrm>
           <a:prstGeom xmlns:a="http://schemas.openxmlformats.org/drawingml/2006/main" prst="line">
@@ -10999,26 +11165,26 @@
       </p:sp>
       <p:sp>
         <p:nvSpPr>
-          <p:cNvPr id="12" name="">
-            <a:extLst xmlns:a="http://schemas.openxmlformats.org/drawingml/2006/main">
-              <a:ext uri="{FF2B5EF4-FFF2-40B4-BE49-F238E27FC236}">
-                <a16:creationId xmlns:a16="http://schemas.microsoft.com/office/drawing/2014/main" id="{ED53651B-DE62-41FB-AA60-E61533A47295}"/>
-              </a:ext>
-            </a:extLst>
-          </p:cNvPr>
-          <p:cNvSpPr>
-            <a:spLocks xmlns:a="http://schemas.openxmlformats.org/drawingml/2006/main" noGrp="1"/>
-          </p:cNvSpPr>
-          <p:nvPr/>
-        </p:nvSpPr>
-        <p:spPr>
-          <a:xfrm xmlns:a="http://schemas.openxmlformats.org/drawingml/2006/main">
-            <a:off x="2828925" y="2381250"/>
-            <a:ext cx="1428750" cy="1047750"/>
+          <p:cNvPr id="16" name="">
+            <a:extLst xmlns:a="http://schemas.openxmlformats.org/drawingml/2006/main">
+              <a:ext uri="{FF2B5EF4-FFF2-40B4-BE49-F238E27FC236}">
+                <a16:creationId xmlns:a16="http://schemas.microsoft.com/office/drawing/2014/main" id="{BCEEEE57-A675-41B3-9929-ECE26BE87579}"/>
+              </a:ext>
+            </a:extLst>
+          </p:cNvPr>
+          <p:cNvSpPr>
+            <a:spLocks xmlns:a="http://schemas.openxmlformats.org/drawingml/2006/main" noGrp="1"/>
+          </p:cNvSpPr>
+          <p:nvPr/>
+        </p:nvSpPr>
+        <p:spPr>
+          <a:xfrm xmlns:a="http://schemas.openxmlformats.org/drawingml/2006/main">
+            <a:off x="4781550" y="2152650"/>
+            <a:ext cx="1428750" cy="990600"/>
           </a:xfrm>
           <a:prstGeom xmlns:a="http://schemas.openxmlformats.org/drawingml/2006/main" prst="roundRect">
             <a:avLst>
-              <a:gd name="adj" fmla="val 7273"/>
+              <a:gd name="adj" fmla="val 7692"/>
             </a:avLst>
           </a:prstGeom>
           <a:solidFill xmlns:a="http://schemas.openxmlformats.org/drawingml/2006/main">
@@ -11034,21 +11200,21 @@
       </p:sp>
       <p:sp>
         <p:nvSpPr>
-          <p:cNvPr id="13" name="">
-            <a:extLst xmlns:a="http://schemas.openxmlformats.org/drawingml/2006/main">
-              <a:ext uri="{FF2B5EF4-FFF2-40B4-BE49-F238E27FC236}">
-                <a16:creationId xmlns:a16="http://schemas.microsoft.com/office/drawing/2014/main" id="{F91C2FCB-46B1-4F01-8609-875F5C199B89}"/>
-              </a:ext>
-            </a:extLst>
-          </p:cNvPr>
-          <p:cNvSpPr>
-            <a:spLocks xmlns:a="http://schemas.openxmlformats.org/drawingml/2006/main" noGrp="1"/>
-          </p:cNvSpPr>
-          <p:nvPr/>
-        </p:nvSpPr>
-        <p:spPr>
-          <a:xfrm xmlns:a="http://schemas.openxmlformats.org/drawingml/2006/main">
-            <a:off x="3038475" y="2590800"/>
+          <p:cNvPr id="17" name="">
+            <a:extLst xmlns:a="http://schemas.openxmlformats.org/drawingml/2006/main">
+              <a:ext uri="{FF2B5EF4-FFF2-40B4-BE49-F238E27FC236}">
+                <a16:creationId xmlns:a16="http://schemas.microsoft.com/office/drawing/2014/main" id="{40531070-DD45-45F7-B25C-9C4D24796D5C}"/>
+              </a:ext>
+            </a:extLst>
+          </p:cNvPr>
+          <p:cNvSpPr>
+            <a:spLocks xmlns:a="http://schemas.openxmlformats.org/drawingml/2006/main" noGrp="1"/>
+          </p:cNvSpPr>
+          <p:nvPr/>
+        </p:nvSpPr>
+        <p:spPr>
+          <a:xfrm xmlns:a="http://schemas.openxmlformats.org/drawingml/2006/main">
+            <a:off x="4991100" y="2343150"/>
             <a:ext cx="342900" cy="323850"/>
           </a:xfrm>
           <a:prstGeom xmlns:a="http://schemas.openxmlformats.org/drawingml/2006/main" prst="rect">
@@ -11077,28 +11243,28 @@
                   <a:srgbClr val="0D3D2D"/>
                 </a:solidFill>
               </a:rPr>
-              <a:t>2</a:t>
-            </a:r>
-          </a:p>
-        </p:txBody>
-      </p:sp>
-      <p:sp>
-        <p:nvSpPr>
-          <p:cNvPr id="14" name="">
-            <a:extLst xmlns:a="http://schemas.openxmlformats.org/drawingml/2006/main">
-              <a:ext uri="{FF2B5EF4-FFF2-40B4-BE49-F238E27FC236}">
-                <a16:creationId xmlns:a16="http://schemas.microsoft.com/office/drawing/2014/main" id="{FD430279-4D13-42A2-8FC4-6622FEF148EA}"/>
-              </a:ext>
-            </a:extLst>
-          </p:cNvPr>
-          <p:cNvSpPr>
-            <a:spLocks xmlns:a="http://schemas.openxmlformats.org/drawingml/2006/main" noGrp="1"/>
-          </p:cNvSpPr>
-          <p:nvPr/>
-        </p:nvSpPr>
-        <p:spPr>
-          <a:xfrm xmlns:a="http://schemas.openxmlformats.org/drawingml/2006/main">
-            <a:off x="3038475" y="3028950"/>
+              <a:t>3</a:t>
+            </a:r>
+          </a:p>
+        </p:txBody>
+      </p:sp>
+      <p:sp>
+        <p:nvSpPr>
+          <p:cNvPr id="18" name="">
+            <a:extLst xmlns:a="http://schemas.openxmlformats.org/drawingml/2006/main">
+              <a:ext uri="{FF2B5EF4-FFF2-40B4-BE49-F238E27FC236}">
+                <a16:creationId xmlns:a16="http://schemas.microsoft.com/office/drawing/2014/main" id="{D9A5ACB5-D347-499F-88B6-4FE1396677FD}"/>
+              </a:ext>
+            </a:extLst>
+          </p:cNvPr>
+          <p:cNvSpPr>
+            <a:spLocks xmlns:a="http://schemas.openxmlformats.org/drawingml/2006/main" noGrp="1"/>
+          </p:cNvSpPr>
+          <p:nvPr/>
+        </p:nvSpPr>
+        <p:spPr>
+          <a:xfrm xmlns:a="http://schemas.openxmlformats.org/drawingml/2006/main">
+            <a:off x="4991100" y="2781300"/>
             <a:ext cx="952500" cy="247650"/>
           </a:xfrm>
           <a:prstGeom xmlns:a="http://schemas.openxmlformats.org/drawingml/2006/main" prst="rect">
@@ -11134,21 +11300,21 @@
       </p:sp>
       <p:sp>
         <p:nvSpPr>
-          <p:cNvPr id="15" name="">
-            <a:extLst xmlns:a="http://schemas.openxmlformats.org/drawingml/2006/main">
-              <a:ext uri="{FF2B5EF4-FFF2-40B4-BE49-F238E27FC236}">
-                <a16:creationId xmlns:a16="http://schemas.microsoft.com/office/drawing/2014/main" id="{CED7EAA5-47F0-4F1A-B6A8-91254929424C}"/>
-              </a:ext>
-            </a:extLst>
-          </p:cNvPr>
-          <p:cNvSpPr>
-            <a:spLocks xmlns:a="http://schemas.openxmlformats.org/drawingml/2006/main" noGrp="1"/>
-          </p:cNvSpPr>
-          <p:nvPr/>
-        </p:nvSpPr>
-        <p:spPr>
-          <a:xfrm xmlns:a="http://schemas.openxmlformats.org/drawingml/2006/main">
-            <a:off x="4305300" y="2905125"/>
+          <p:cNvPr id="19" name="">
+            <a:extLst xmlns:a="http://schemas.openxmlformats.org/drawingml/2006/main">
+              <a:ext uri="{FF2B5EF4-FFF2-40B4-BE49-F238E27FC236}">
+                <a16:creationId xmlns:a16="http://schemas.microsoft.com/office/drawing/2014/main" id="{330905B9-47D4-4CA8-93BC-767AC85B1682}"/>
+              </a:ext>
+            </a:extLst>
+          </p:cNvPr>
+          <p:cNvSpPr>
+            <a:spLocks xmlns:a="http://schemas.openxmlformats.org/drawingml/2006/main" noGrp="1"/>
+          </p:cNvSpPr>
+          <p:nvPr/>
+        </p:nvSpPr>
+        <p:spPr>
+          <a:xfrm xmlns:a="http://schemas.openxmlformats.org/drawingml/2006/main">
+            <a:off x="6257925" y="2647950"/>
             <a:ext cx="438150" cy="0"/>
           </a:xfrm>
           <a:prstGeom xmlns:a="http://schemas.openxmlformats.org/drawingml/2006/main" prst="line">
@@ -11165,192 +11331,26 @@
       </p:sp>
       <p:sp>
         <p:nvSpPr>
-          <p:cNvPr id="16" name="">
-            <a:extLst xmlns:a="http://schemas.openxmlformats.org/drawingml/2006/main">
-              <a:ext uri="{FF2B5EF4-FFF2-40B4-BE49-F238E27FC236}">
-                <a16:creationId xmlns:a16="http://schemas.microsoft.com/office/drawing/2014/main" id="{C31231BD-025E-4EE1-8C06-ECEE5BAE66CA}"/>
-              </a:ext>
-            </a:extLst>
-          </p:cNvPr>
-          <p:cNvSpPr>
-            <a:spLocks xmlns:a="http://schemas.openxmlformats.org/drawingml/2006/main" noGrp="1"/>
-          </p:cNvSpPr>
-          <p:nvPr/>
-        </p:nvSpPr>
-        <p:spPr>
-          <a:xfrm xmlns:a="http://schemas.openxmlformats.org/drawingml/2006/main">
-            <a:off x="4781550" y="2381250"/>
-            <a:ext cx="1428750" cy="1047750"/>
+          <p:cNvPr id="20" name="">
+            <a:extLst xmlns:a="http://schemas.openxmlformats.org/drawingml/2006/main">
+              <a:ext uri="{FF2B5EF4-FFF2-40B4-BE49-F238E27FC236}">
+                <a16:creationId xmlns:a16="http://schemas.microsoft.com/office/drawing/2014/main" id="{2195BB3D-DAC8-44A2-B561-DBAFFB97153B}"/>
+              </a:ext>
+            </a:extLst>
+          </p:cNvPr>
+          <p:cNvSpPr>
+            <a:spLocks xmlns:a="http://schemas.openxmlformats.org/drawingml/2006/main" noGrp="1"/>
+          </p:cNvSpPr>
+          <p:nvPr/>
+        </p:nvSpPr>
+        <p:spPr>
+          <a:xfrm xmlns:a="http://schemas.openxmlformats.org/drawingml/2006/main">
+            <a:off x="6734175" y="2152650"/>
+            <a:ext cx="1428750" cy="990600"/>
           </a:xfrm>
           <a:prstGeom xmlns:a="http://schemas.openxmlformats.org/drawingml/2006/main" prst="roundRect">
             <a:avLst>
-              <a:gd name="adj" fmla="val 7273"/>
-            </a:avLst>
-          </a:prstGeom>
-          <a:solidFill xmlns:a="http://schemas.openxmlformats.org/drawingml/2006/main">
-            <a:srgbClr val="0D3D2D"/>
-          </a:solidFill>
-          <a:ln xmlns:a="http://schemas.openxmlformats.org/drawingml/2006/main" w="9525">
-            <a:solidFill>
-              <a:srgbClr val="0D3D2D"/>
-            </a:solidFill>
-            <a:prstDash val="solid"/>
-          </a:ln>
-        </p:spPr>
-      </p:sp>
-      <p:sp>
-        <p:nvSpPr>
-          <p:cNvPr id="17" name="">
-            <a:extLst xmlns:a="http://schemas.openxmlformats.org/drawingml/2006/main">
-              <a:ext uri="{FF2B5EF4-FFF2-40B4-BE49-F238E27FC236}">
-                <a16:creationId xmlns:a16="http://schemas.microsoft.com/office/drawing/2014/main" id="{D88AAE40-E956-46E4-B57E-3696A73E87B0}"/>
-              </a:ext>
-            </a:extLst>
-          </p:cNvPr>
-          <p:cNvSpPr>
-            <a:spLocks xmlns:a="http://schemas.openxmlformats.org/drawingml/2006/main" noGrp="1"/>
-          </p:cNvSpPr>
-          <p:nvPr/>
-        </p:nvSpPr>
-        <p:spPr>
-          <a:xfrm xmlns:a="http://schemas.openxmlformats.org/drawingml/2006/main">
-            <a:off x="4991100" y="2590800"/>
-            <a:ext cx="342900" cy="323850"/>
-          </a:xfrm>
-          <a:prstGeom xmlns:a="http://schemas.openxmlformats.org/drawingml/2006/main" prst="rect">
-            <a:avLst/>
-          </a:prstGeom>
-          <a:noFill xmlns:a="http://schemas.openxmlformats.org/drawingml/2006/main"/>
-          <a:ln xmlns:a="http://schemas.openxmlformats.org/drawingml/2006/main" w="0">
-            <a:noFill/>
-            <a:prstDash val="solid"/>
-          </a:ln>
-        </p:spPr>
-        <p:txBody>
-          <a:bodyPr xmlns:a="http://schemas.openxmlformats.org/drawingml/2006/main"/>
-          <a:lstStyle xmlns:a="http://schemas.openxmlformats.org/drawingml/2006/main"/>
-          <a:p xmlns:a="http://schemas.openxmlformats.org/drawingml/2006/main">
-            <a:pPr>
-              <a:defRPr sz="2325" b="1">
-                <a:solidFill>
-                  <a:srgbClr val="C7A044"/>
-                </a:solidFill>
-              </a:defRPr>
-            </a:pPr>
-            <a:r>
-              <a:rPr sz="2325" b="1">
-                <a:solidFill>
-                  <a:srgbClr val="C7A044"/>
-                </a:solidFill>
-              </a:rPr>
-              <a:t>3</a:t>
-            </a:r>
-          </a:p>
-        </p:txBody>
-      </p:sp>
-      <p:sp>
-        <p:nvSpPr>
-          <p:cNvPr id="18" name="">
-            <a:extLst xmlns:a="http://schemas.openxmlformats.org/drawingml/2006/main">
-              <a:ext uri="{FF2B5EF4-FFF2-40B4-BE49-F238E27FC236}">
-                <a16:creationId xmlns:a16="http://schemas.microsoft.com/office/drawing/2014/main" id="{D1FF46B4-654D-4235-B756-D9025C2207E6}"/>
-              </a:ext>
-            </a:extLst>
-          </p:cNvPr>
-          <p:cNvSpPr>
-            <a:spLocks xmlns:a="http://schemas.openxmlformats.org/drawingml/2006/main" noGrp="1"/>
-          </p:cNvSpPr>
-          <p:nvPr/>
-        </p:nvSpPr>
-        <p:spPr>
-          <a:xfrm xmlns:a="http://schemas.openxmlformats.org/drawingml/2006/main">
-            <a:off x="4991100" y="3028950"/>
-            <a:ext cx="952500" cy="247650"/>
-          </a:xfrm>
-          <a:prstGeom xmlns:a="http://schemas.openxmlformats.org/drawingml/2006/main" prst="rect">
-            <a:avLst/>
-          </a:prstGeom>
-          <a:noFill xmlns:a="http://schemas.openxmlformats.org/drawingml/2006/main"/>
-          <a:ln xmlns:a="http://schemas.openxmlformats.org/drawingml/2006/main" w="0">
-            <a:noFill/>
-            <a:prstDash val="solid"/>
-          </a:ln>
-        </p:spPr>
-        <p:txBody>
-          <a:bodyPr xmlns:a="http://schemas.openxmlformats.org/drawingml/2006/main"/>
-          <a:lstStyle xmlns:a="http://schemas.openxmlformats.org/drawingml/2006/main"/>
-          <a:p xmlns:a="http://schemas.openxmlformats.org/drawingml/2006/main">
-            <a:pPr>
-              <a:defRPr sz="1575" b="1">
-                <a:solidFill>
-                  <a:srgbClr val="FFFFFF"/>
-                </a:solidFill>
-              </a:defRPr>
-            </a:pPr>
-            <a:r>
-              <a:rPr sz="1575" b="1">
-                <a:solidFill>
-                  <a:srgbClr val="FFFFFF"/>
-                </a:solidFill>
-              </a:rPr>
-              <a:t>Develop</a:t>
-            </a:r>
-          </a:p>
-        </p:txBody>
-      </p:sp>
-      <p:sp>
-        <p:nvSpPr>
-          <p:cNvPr id="19" name="">
-            <a:extLst xmlns:a="http://schemas.openxmlformats.org/drawingml/2006/main">
-              <a:ext uri="{FF2B5EF4-FFF2-40B4-BE49-F238E27FC236}">
-                <a16:creationId xmlns:a16="http://schemas.microsoft.com/office/drawing/2014/main" id="{A847A976-D751-4DF5-943D-8C2D360982E7}"/>
-              </a:ext>
-            </a:extLst>
-          </p:cNvPr>
-          <p:cNvSpPr>
-            <a:spLocks xmlns:a="http://schemas.openxmlformats.org/drawingml/2006/main" noGrp="1"/>
-          </p:cNvSpPr>
-          <p:nvPr/>
-        </p:nvSpPr>
-        <p:spPr>
-          <a:xfrm xmlns:a="http://schemas.openxmlformats.org/drawingml/2006/main">
-            <a:off x="6257925" y="2905125"/>
-            <a:ext cx="438150" cy="0"/>
-          </a:xfrm>
-          <a:prstGeom xmlns:a="http://schemas.openxmlformats.org/drawingml/2006/main" prst="line">
-            <a:avLst/>
-          </a:prstGeom>
-          <a:noFill xmlns:a="http://schemas.openxmlformats.org/drawingml/2006/main"/>
-          <a:ln xmlns:a="http://schemas.openxmlformats.org/drawingml/2006/main" w="28575">
-            <a:solidFill>
-              <a:srgbClr val="C7A044"/>
-            </a:solidFill>
-            <a:prstDash val="solid"/>
-          </a:ln>
-        </p:spPr>
-      </p:sp>
-      <p:sp>
-        <p:nvSpPr>
-          <p:cNvPr id="20" name="">
-            <a:extLst xmlns:a="http://schemas.openxmlformats.org/drawingml/2006/main">
-              <a:ext uri="{FF2B5EF4-FFF2-40B4-BE49-F238E27FC236}">
-                <a16:creationId xmlns:a16="http://schemas.microsoft.com/office/drawing/2014/main" id="{8F349037-D63C-4174-8785-BF8202011C36}"/>
-              </a:ext>
-            </a:extLst>
-          </p:cNvPr>
-          <p:cNvSpPr>
-            <a:spLocks xmlns:a="http://schemas.openxmlformats.org/drawingml/2006/main" noGrp="1"/>
-          </p:cNvSpPr>
-          <p:nvPr/>
-        </p:nvSpPr>
-        <p:spPr>
-          <a:xfrm xmlns:a="http://schemas.openxmlformats.org/drawingml/2006/main">
-            <a:off x="6734175" y="2381250"/>
-            <a:ext cx="1428750" cy="1047750"/>
-          </a:xfrm>
-          <a:prstGeom xmlns:a="http://schemas.openxmlformats.org/drawingml/2006/main" prst="roundRect">
-            <a:avLst>
-              <a:gd name="adj" fmla="val 7273"/>
+              <a:gd name="adj" fmla="val 7692"/>
             </a:avLst>
           </a:prstGeom>
           <a:solidFill xmlns:a="http://schemas.openxmlformats.org/drawingml/2006/main">
@@ -11369,18 +11369,18 @@
           <p:cNvPr id="21" name="">
             <a:extLst xmlns:a="http://schemas.openxmlformats.org/drawingml/2006/main">
               <a:ext uri="{FF2B5EF4-FFF2-40B4-BE49-F238E27FC236}">
-                <a16:creationId xmlns:a16="http://schemas.microsoft.com/office/drawing/2014/main" id="{EA6EB88B-C029-4DFA-9C9A-41EE74487705}"/>
-              </a:ext>
-            </a:extLst>
-          </p:cNvPr>
-          <p:cNvSpPr>
-            <a:spLocks xmlns:a="http://schemas.openxmlformats.org/drawingml/2006/main" noGrp="1"/>
-          </p:cNvSpPr>
-          <p:nvPr/>
-        </p:nvSpPr>
-        <p:spPr>
-          <a:xfrm xmlns:a="http://schemas.openxmlformats.org/drawingml/2006/main">
-            <a:off x="6943725" y="2590800"/>
+                <a16:creationId xmlns:a16="http://schemas.microsoft.com/office/drawing/2014/main" id="{A507A477-322B-4AD0-B885-C1B6C1F04D7A}"/>
+              </a:ext>
+            </a:extLst>
+          </p:cNvPr>
+          <p:cNvSpPr>
+            <a:spLocks xmlns:a="http://schemas.openxmlformats.org/drawingml/2006/main" noGrp="1"/>
+          </p:cNvSpPr>
+          <p:nvPr/>
+        </p:nvSpPr>
+        <p:spPr>
+          <a:xfrm xmlns:a="http://schemas.openxmlformats.org/drawingml/2006/main">
+            <a:off x="6943725" y="2343150"/>
             <a:ext cx="342900" cy="323850"/>
           </a:xfrm>
           <a:prstGeom xmlns:a="http://schemas.openxmlformats.org/drawingml/2006/main" prst="rect">
@@ -11419,18 +11419,18 @@
           <p:cNvPr id="22" name="">
             <a:extLst xmlns:a="http://schemas.openxmlformats.org/drawingml/2006/main">
               <a:ext uri="{FF2B5EF4-FFF2-40B4-BE49-F238E27FC236}">
-                <a16:creationId xmlns:a16="http://schemas.microsoft.com/office/drawing/2014/main" id="{769CF140-5A4D-4632-B7E1-F2BF259B674B}"/>
-              </a:ext>
-            </a:extLst>
-          </p:cNvPr>
-          <p:cNvSpPr>
-            <a:spLocks xmlns:a="http://schemas.openxmlformats.org/drawingml/2006/main" noGrp="1"/>
-          </p:cNvSpPr>
-          <p:nvPr/>
-        </p:nvSpPr>
-        <p:spPr>
-          <a:xfrm xmlns:a="http://schemas.openxmlformats.org/drawingml/2006/main">
-            <a:off x="6943725" y="3028950"/>
+                <a16:creationId xmlns:a16="http://schemas.microsoft.com/office/drawing/2014/main" id="{4EAD4CEB-1F73-4516-A805-5938DC91C73B}"/>
+              </a:ext>
+            </a:extLst>
+          </p:cNvPr>
+          <p:cNvSpPr>
+            <a:spLocks xmlns:a="http://schemas.openxmlformats.org/drawingml/2006/main" noGrp="1"/>
+          </p:cNvSpPr>
+          <p:nvPr/>
+        </p:nvSpPr>
+        <p:spPr>
+          <a:xfrm xmlns:a="http://schemas.openxmlformats.org/drawingml/2006/main">
+            <a:off x="6943725" y="2781300"/>
             <a:ext cx="952500" cy="247650"/>
           </a:xfrm>
           <a:prstGeom xmlns:a="http://schemas.openxmlformats.org/drawingml/2006/main" prst="rect">
@@ -11459,7 +11459,7 @@
                   <a:srgbClr val="18211F"/>
                 </a:solidFill>
               </a:rPr>
-              <a:t>Test</a:t>
+              <a:t>Develop</a:t>
             </a:r>
           </a:p>
         </p:txBody>
@@ -11469,18 +11469,18 @@
           <p:cNvPr id="23" name="">
             <a:extLst xmlns:a="http://schemas.openxmlformats.org/drawingml/2006/main">
               <a:ext uri="{FF2B5EF4-FFF2-40B4-BE49-F238E27FC236}">
-                <a16:creationId xmlns:a16="http://schemas.microsoft.com/office/drawing/2014/main" id="{8CE2E20F-D2AF-41CD-A994-2EC25B1FEE87}"/>
-              </a:ext>
-            </a:extLst>
-          </p:cNvPr>
-          <p:cNvSpPr>
-            <a:spLocks xmlns:a="http://schemas.openxmlformats.org/drawingml/2006/main" noGrp="1"/>
-          </p:cNvSpPr>
-          <p:nvPr/>
-        </p:nvSpPr>
-        <p:spPr>
-          <a:xfrm xmlns:a="http://schemas.openxmlformats.org/drawingml/2006/main">
-            <a:off x="8210550" y="2905125"/>
+                <a16:creationId xmlns:a16="http://schemas.microsoft.com/office/drawing/2014/main" id="{97E32418-6A0F-4747-8632-01253ED246C6}"/>
+              </a:ext>
+            </a:extLst>
+          </p:cNvPr>
+          <p:cNvSpPr>
+            <a:spLocks xmlns:a="http://schemas.openxmlformats.org/drawingml/2006/main" noGrp="1"/>
+          </p:cNvSpPr>
+          <p:nvPr/>
+        </p:nvSpPr>
+        <p:spPr>
+          <a:xfrm xmlns:a="http://schemas.openxmlformats.org/drawingml/2006/main">
+            <a:off x="8210550" y="2647950"/>
             <a:ext cx="438150" cy="0"/>
           </a:xfrm>
           <a:prstGeom xmlns:a="http://schemas.openxmlformats.org/drawingml/2006/main" prst="line">
@@ -11500,23 +11500,23 @@
           <p:cNvPr id="24" name="">
             <a:extLst xmlns:a="http://schemas.openxmlformats.org/drawingml/2006/main">
               <a:ext uri="{FF2B5EF4-FFF2-40B4-BE49-F238E27FC236}">
-                <a16:creationId xmlns:a16="http://schemas.microsoft.com/office/drawing/2014/main" id="{11C8D66F-2160-4A87-AE82-749143390DB1}"/>
-              </a:ext>
-            </a:extLst>
-          </p:cNvPr>
-          <p:cNvSpPr>
-            <a:spLocks xmlns:a="http://schemas.openxmlformats.org/drawingml/2006/main" noGrp="1"/>
-          </p:cNvSpPr>
-          <p:nvPr/>
-        </p:nvSpPr>
-        <p:spPr>
-          <a:xfrm xmlns:a="http://schemas.openxmlformats.org/drawingml/2006/main">
-            <a:off x="8686800" y="2381250"/>
-            <a:ext cx="1428750" cy="1047750"/>
+                <a16:creationId xmlns:a16="http://schemas.microsoft.com/office/drawing/2014/main" id="{33504CA6-2DE9-4D59-8F9E-331E86BB5489}"/>
+              </a:ext>
+            </a:extLst>
+          </p:cNvPr>
+          <p:cNvSpPr>
+            <a:spLocks xmlns:a="http://schemas.openxmlformats.org/drawingml/2006/main" noGrp="1"/>
+          </p:cNvSpPr>
+          <p:nvPr/>
+        </p:nvSpPr>
+        <p:spPr>
+          <a:xfrm xmlns:a="http://schemas.openxmlformats.org/drawingml/2006/main">
+            <a:off x="8686800" y="2152650"/>
+            <a:ext cx="1428750" cy="990600"/>
           </a:xfrm>
           <a:prstGeom xmlns:a="http://schemas.openxmlformats.org/drawingml/2006/main" prst="roundRect">
             <a:avLst>
-              <a:gd name="adj" fmla="val 7273"/>
+              <a:gd name="adj" fmla="val 7692"/>
             </a:avLst>
           </a:prstGeom>
           <a:solidFill xmlns:a="http://schemas.openxmlformats.org/drawingml/2006/main">
@@ -11535,18 +11535,18 @@
           <p:cNvPr id="25" name="">
             <a:extLst xmlns:a="http://schemas.openxmlformats.org/drawingml/2006/main">
               <a:ext uri="{FF2B5EF4-FFF2-40B4-BE49-F238E27FC236}">
-                <a16:creationId xmlns:a16="http://schemas.microsoft.com/office/drawing/2014/main" id="{8647A2FB-C285-4161-9F35-A2E8927B0583}"/>
-              </a:ext>
-            </a:extLst>
-          </p:cNvPr>
-          <p:cNvSpPr>
-            <a:spLocks xmlns:a="http://schemas.openxmlformats.org/drawingml/2006/main" noGrp="1"/>
-          </p:cNvSpPr>
-          <p:nvPr/>
-        </p:nvSpPr>
-        <p:spPr>
-          <a:xfrm xmlns:a="http://schemas.openxmlformats.org/drawingml/2006/main">
-            <a:off x="8896350" y="2590800"/>
+                <a16:creationId xmlns:a16="http://schemas.microsoft.com/office/drawing/2014/main" id="{A9F366E3-3F6E-4F6D-B0D4-D68AFBCB128E}"/>
+              </a:ext>
+            </a:extLst>
+          </p:cNvPr>
+          <p:cNvSpPr>
+            <a:spLocks xmlns:a="http://schemas.openxmlformats.org/drawingml/2006/main" noGrp="1"/>
+          </p:cNvSpPr>
+          <p:nvPr/>
+        </p:nvSpPr>
+        <p:spPr>
+          <a:xfrm xmlns:a="http://schemas.openxmlformats.org/drawingml/2006/main">
+            <a:off x="8896350" y="2343150"/>
             <a:ext cx="342900" cy="323850"/>
           </a:xfrm>
           <a:prstGeom xmlns:a="http://schemas.openxmlformats.org/drawingml/2006/main" prst="rect">
@@ -11585,18 +11585,18 @@
           <p:cNvPr id="26" name="">
             <a:extLst xmlns:a="http://schemas.openxmlformats.org/drawingml/2006/main">
               <a:ext uri="{FF2B5EF4-FFF2-40B4-BE49-F238E27FC236}">
-                <a16:creationId xmlns:a16="http://schemas.microsoft.com/office/drawing/2014/main" id="{82F951BC-DC17-42B2-B810-80B725FF8FE7}"/>
-              </a:ext>
-            </a:extLst>
-          </p:cNvPr>
-          <p:cNvSpPr>
-            <a:spLocks xmlns:a="http://schemas.openxmlformats.org/drawingml/2006/main" noGrp="1"/>
-          </p:cNvSpPr>
-          <p:nvPr/>
-        </p:nvSpPr>
-        <p:spPr>
-          <a:xfrm xmlns:a="http://schemas.openxmlformats.org/drawingml/2006/main">
-            <a:off x="8896350" y="3028950"/>
+                <a16:creationId xmlns:a16="http://schemas.microsoft.com/office/drawing/2014/main" id="{143B2D50-8005-4915-A9D0-83595A44779F}"/>
+              </a:ext>
+            </a:extLst>
+          </p:cNvPr>
+          <p:cNvSpPr>
+            <a:spLocks xmlns:a="http://schemas.openxmlformats.org/drawingml/2006/main" noGrp="1"/>
+          </p:cNvSpPr>
+          <p:nvPr/>
+        </p:nvSpPr>
+        <p:spPr>
+          <a:xfrm xmlns:a="http://schemas.openxmlformats.org/drawingml/2006/main">
+            <a:off x="8896350" y="2781300"/>
             <a:ext cx="952500" cy="247650"/>
           </a:xfrm>
           <a:prstGeom xmlns:a="http://schemas.openxmlformats.org/drawingml/2006/main" prst="rect">
@@ -11625,7 +11625,7 @@
                   <a:srgbClr val="18211F"/>
                 </a:solidFill>
               </a:rPr>
-              <a:t>Improve</a:t>
+              <a:t>Test</a:t>
             </a:r>
           </a:p>
         </p:txBody>
@@ -11635,42 +11635,212 @@
           <p:cNvPr id="27" name="">
             <a:extLst xmlns:a="http://schemas.openxmlformats.org/drawingml/2006/main">
               <a:ext uri="{FF2B5EF4-FFF2-40B4-BE49-F238E27FC236}">
-                <a16:creationId xmlns:a16="http://schemas.microsoft.com/office/drawing/2014/main" id="{91BF9D92-F8DE-4582-B76C-B7F254DBF275}"/>
-              </a:ext>
-            </a:extLst>
-          </p:cNvPr>
-          <p:cNvSpPr>
-            <a:spLocks xmlns:a="http://schemas.openxmlformats.org/drawingml/2006/main" noGrp="1"/>
-          </p:cNvSpPr>
-          <p:nvPr/>
-        </p:nvSpPr>
-        <p:spPr>
-          <a:xfrm xmlns:a="http://schemas.openxmlformats.org/drawingml/2006/main">
-            <a:off x="895350" y="4343400"/>
-            <a:ext cx="2476500" cy="285750"/>
-          </a:xfrm>
-          <a:prstGeom xmlns:a="http://schemas.openxmlformats.org/drawingml/2006/main" prst="rect">
-            <a:avLst/>
-          </a:prstGeom>
-          <a:noFill xmlns:a="http://schemas.openxmlformats.org/drawingml/2006/main"/>
-          <a:ln xmlns:a="http://schemas.openxmlformats.org/drawingml/2006/main" w="0">
-            <a:noFill/>
-            <a:prstDash val="solid"/>
-          </a:ln>
-        </p:spPr>
-        <p:txBody>
-          <a:bodyPr xmlns:a="http://schemas.openxmlformats.org/drawingml/2006/main"/>
-          <a:lstStyle xmlns:a="http://schemas.openxmlformats.org/drawingml/2006/main"/>
-          <a:p xmlns:a="http://schemas.openxmlformats.org/drawingml/2006/main">
-            <a:pPr>
-              <a:defRPr sz="1800" b="1">
+                <a16:creationId xmlns:a16="http://schemas.microsoft.com/office/drawing/2014/main" id="{759E4605-960D-402C-8891-17C90ACD0AFD}"/>
+              </a:ext>
+            </a:extLst>
+          </p:cNvPr>
+          <p:cNvSpPr>
+            <a:spLocks xmlns:a="http://schemas.openxmlformats.org/drawingml/2006/main" noGrp="1"/>
+          </p:cNvSpPr>
+          <p:nvPr/>
+        </p:nvSpPr>
+        <p:spPr>
+          <a:xfrm xmlns:a="http://schemas.openxmlformats.org/drawingml/2006/main">
+            <a:off x="876300" y="3695700"/>
+            <a:ext cx="4476750" cy="1352550"/>
+          </a:xfrm>
+          <a:prstGeom xmlns:a="http://schemas.openxmlformats.org/drawingml/2006/main" prst="roundRect">
+            <a:avLst>
+              <a:gd name="adj" fmla="val 5634"/>
+            </a:avLst>
+          </a:prstGeom>
+          <a:solidFill xmlns:a="http://schemas.openxmlformats.org/drawingml/2006/main">
+            <a:srgbClr val="EAF4EE"/>
+          </a:solidFill>
+          <a:ln xmlns:a="http://schemas.openxmlformats.org/drawingml/2006/main" w="9525">
+            <a:solidFill>
+              <a:srgbClr val="D5E2DC"/>
+            </a:solidFill>
+            <a:prstDash val="solid"/>
+          </a:ln>
+        </p:spPr>
+      </p:sp>
+      <p:sp>
+        <p:nvSpPr>
+          <p:cNvPr id="28" name="">
+            <a:extLst xmlns:a="http://schemas.openxmlformats.org/drawingml/2006/main">
+              <a:ext uri="{FF2B5EF4-FFF2-40B4-BE49-F238E27FC236}">
+                <a16:creationId xmlns:a16="http://schemas.microsoft.com/office/drawing/2014/main" id="{93EE5795-DA02-415D-BE48-ED649C3DB00D}"/>
+              </a:ext>
+            </a:extLst>
+          </p:cNvPr>
+          <p:cNvSpPr>
+            <a:spLocks xmlns:a="http://schemas.openxmlformats.org/drawingml/2006/main" noGrp="1"/>
+          </p:cNvSpPr>
+          <p:nvPr/>
+        </p:nvSpPr>
+        <p:spPr>
+          <a:xfrm xmlns:a="http://schemas.openxmlformats.org/drawingml/2006/main">
+            <a:off x="1162050" y="3981450"/>
+            <a:ext cx="3143250" cy="247650"/>
+          </a:xfrm>
+          <a:prstGeom xmlns:a="http://schemas.openxmlformats.org/drawingml/2006/main" prst="rect">
+            <a:avLst/>
+          </a:prstGeom>
+          <a:noFill xmlns:a="http://schemas.openxmlformats.org/drawingml/2006/main"/>
+          <a:ln xmlns:a="http://schemas.openxmlformats.org/drawingml/2006/main" w="0">
+            <a:noFill/>
+            <a:prstDash val="solid"/>
+          </a:ln>
+        </p:spPr>
+        <p:txBody>
+          <a:bodyPr xmlns:a="http://schemas.openxmlformats.org/drawingml/2006/main"/>
+          <a:lstStyle xmlns:a="http://schemas.openxmlformats.org/drawingml/2006/main"/>
+          <a:p xmlns:a="http://schemas.openxmlformats.org/drawingml/2006/main">
+            <a:pPr>
+              <a:defRPr sz="1725" b="1">
+                <a:solidFill>
+                  <a:srgbClr val="0D3D2D"/>
+                </a:solidFill>
+              </a:defRPr>
+            </a:pPr>
+            <a:r>
+              <a:rPr sz="1725" b="1">
+                <a:solidFill>
+                  <a:srgbClr val="0D3D2D"/>
+                </a:solidFill>
+              </a:rPr>
+              <a:t>Data collection in Chapter 3</a:t>
+            </a:r>
+          </a:p>
+        </p:txBody>
+      </p:sp>
+      <p:sp>
+        <p:nvSpPr>
+          <p:cNvPr id="29" name="">
+            <a:extLst xmlns:a="http://schemas.openxmlformats.org/drawingml/2006/main">
+              <a:ext uri="{FF2B5EF4-FFF2-40B4-BE49-F238E27FC236}">
+                <a16:creationId xmlns:a16="http://schemas.microsoft.com/office/drawing/2014/main" id="{5A811489-913B-4309-83F6-73C7697F51F5}"/>
+              </a:ext>
+            </a:extLst>
+          </p:cNvPr>
+          <p:cNvSpPr>
+            <a:spLocks xmlns:a="http://schemas.openxmlformats.org/drawingml/2006/main" noGrp="1"/>
+          </p:cNvSpPr>
+          <p:nvPr/>
+        </p:nvSpPr>
+        <p:spPr>
+          <a:xfrm xmlns:a="http://schemas.openxmlformats.org/drawingml/2006/main">
+            <a:off x="1162050" y="4400550"/>
+            <a:ext cx="3695700" cy="438150"/>
+          </a:xfrm>
+          <a:prstGeom xmlns:a="http://schemas.openxmlformats.org/drawingml/2006/main" prst="rect">
+            <a:avLst/>
+          </a:prstGeom>
+          <a:noFill xmlns:a="http://schemas.openxmlformats.org/drawingml/2006/main"/>
+          <a:ln xmlns:a="http://schemas.openxmlformats.org/drawingml/2006/main" w="0">
+            <a:noFill/>
+            <a:prstDash val="solid"/>
+          </a:ln>
+        </p:spPr>
+        <p:txBody>
+          <a:bodyPr xmlns:a="http://schemas.openxmlformats.org/drawingml/2006/main"/>
+          <a:lstStyle xmlns:a="http://schemas.openxmlformats.org/drawingml/2006/main"/>
+          <a:p xmlns:a="http://schemas.openxmlformats.org/drawingml/2006/main">
+            <a:pPr>
+              <a:defRPr sz="1350" b="0">
+                <a:solidFill>
+                  <a:srgbClr val="18211F"/>
+                </a:solidFill>
+              </a:defRPr>
+            </a:pPr>
+            <a:r>
+              <a:rPr sz="1350" b="0">
+                <a:solidFill>
+                  <a:srgbClr val="18211F"/>
+                </a:solidFill>
+              </a:rPr>
+              <a:t>Used for requirements gathering: observation, document review, and user needs. Results belong in Chapter 4 only if real responses were collected.</a:t>
+            </a:r>
+          </a:p>
+        </p:txBody>
+      </p:sp>
+      <p:sp>
+        <p:nvSpPr>
+          <p:cNvPr id="30" name="">
+            <a:extLst xmlns:a="http://schemas.openxmlformats.org/drawingml/2006/main">
+              <a:ext uri="{FF2B5EF4-FFF2-40B4-BE49-F238E27FC236}">
+                <a16:creationId xmlns:a16="http://schemas.microsoft.com/office/drawing/2014/main" id="{4021FDC8-E91C-4DE7-8386-39EDA08E198A}"/>
+              </a:ext>
+            </a:extLst>
+          </p:cNvPr>
+          <p:cNvSpPr>
+            <a:spLocks xmlns:a="http://schemas.openxmlformats.org/drawingml/2006/main" noGrp="1"/>
+          </p:cNvSpPr>
+          <p:nvPr/>
+        </p:nvSpPr>
+        <p:spPr>
+          <a:xfrm xmlns:a="http://schemas.openxmlformats.org/drawingml/2006/main">
+            <a:off x="6191250" y="3695700"/>
+            <a:ext cx="4476750" cy="1352550"/>
+          </a:xfrm>
+          <a:prstGeom xmlns:a="http://schemas.openxmlformats.org/drawingml/2006/main" prst="roundRect">
+            <a:avLst>
+              <a:gd name="adj" fmla="val 5634"/>
+            </a:avLst>
+          </a:prstGeom>
+          <a:solidFill xmlns:a="http://schemas.openxmlformats.org/drawingml/2006/main">
+            <a:srgbClr val="FFFFFF"/>
+          </a:solidFill>
+          <a:ln xmlns:a="http://schemas.openxmlformats.org/drawingml/2006/main" w="9525">
+            <a:solidFill>
+              <a:srgbClr val="D5E2DC"/>
+            </a:solidFill>
+            <a:prstDash val="solid"/>
+          </a:ln>
+        </p:spPr>
+      </p:sp>
+      <p:sp>
+        <p:nvSpPr>
+          <p:cNvPr id="31" name="">
+            <a:extLst xmlns:a="http://schemas.openxmlformats.org/drawingml/2006/main">
+              <a:ext uri="{FF2B5EF4-FFF2-40B4-BE49-F238E27FC236}">
+                <a16:creationId xmlns:a16="http://schemas.microsoft.com/office/drawing/2014/main" id="{B99393BD-2257-4BFD-B071-5FD5F2790FCD}"/>
+              </a:ext>
+            </a:extLst>
+          </p:cNvPr>
+          <p:cNvSpPr>
+            <a:spLocks xmlns:a="http://schemas.openxmlformats.org/drawingml/2006/main" noGrp="1"/>
+          </p:cNvSpPr>
+          <p:nvPr/>
+        </p:nvSpPr>
+        <p:spPr>
+          <a:xfrm xmlns:a="http://schemas.openxmlformats.org/drawingml/2006/main">
+            <a:off x="6477000" y="3981450"/>
+            <a:ext cx="2476500" cy="247650"/>
+          </a:xfrm>
+          <a:prstGeom xmlns:a="http://schemas.openxmlformats.org/drawingml/2006/main" prst="rect">
+            <a:avLst/>
+          </a:prstGeom>
+          <a:noFill xmlns:a="http://schemas.openxmlformats.org/drawingml/2006/main"/>
+          <a:ln xmlns:a="http://schemas.openxmlformats.org/drawingml/2006/main" w="0">
+            <a:noFill/>
+            <a:prstDash val="solid"/>
+          </a:ln>
+        </p:spPr>
+        <p:txBody>
+          <a:bodyPr xmlns:a="http://schemas.openxmlformats.org/drawingml/2006/main"/>
+          <a:lstStyle xmlns:a="http://schemas.openxmlformats.org/drawingml/2006/main"/>
+          <a:p xmlns:a="http://schemas.openxmlformats.org/drawingml/2006/main">
+            <a:pPr>
+              <a:defRPr sz="1725" b="1">
                 <a:solidFill>
                   <a:srgbClr val="A94D43"/>
                 </a:solidFill>
               </a:defRPr>
             </a:pPr>
             <a:r>
-              <a:rPr sz="1800" b="1">
+              <a:rPr sz="1725" b="1">
                 <a:solidFill>
                   <a:srgbClr val="A94D43"/>
                 </a:solidFill>
@@ -11682,50 +11852,50 @@
       </p:sp>
       <p:sp>
         <p:nvSpPr>
-          <p:cNvPr id="28" name="">
-            <a:extLst xmlns:a="http://schemas.openxmlformats.org/drawingml/2006/main">
-              <a:ext uri="{FF2B5EF4-FFF2-40B4-BE49-F238E27FC236}">
-                <a16:creationId xmlns:a16="http://schemas.microsoft.com/office/drawing/2014/main" id="{6C450979-B913-40A2-BE61-4FB6F35B3A62}"/>
-              </a:ext>
-            </a:extLst>
-          </p:cNvPr>
-          <p:cNvSpPr>
-            <a:spLocks xmlns:a="http://schemas.openxmlformats.org/drawingml/2006/main" noGrp="1"/>
-          </p:cNvSpPr>
-          <p:nvPr/>
-        </p:nvSpPr>
-        <p:spPr>
-          <a:xfrm xmlns:a="http://schemas.openxmlformats.org/drawingml/2006/main">
-            <a:off x="895350" y="4743450"/>
-            <a:ext cx="8572500" cy="495300"/>
-          </a:xfrm>
-          <a:prstGeom xmlns:a="http://schemas.openxmlformats.org/drawingml/2006/main" prst="rect">
-            <a:avLst/>
-          </a:prstGeom>
-          <a:noFill xmlns:a="http://schemas.openxmlformats.org/drawingml/2006/main"/>
-          <a:ln xmlns:a="http://schemas.openxmlformats.org/drawingml/2006/main" w="0">
-            <a:noFill/>
-            <a:prstDash val="solid"/>
-          </a:ln>
-        </p:spPr>
-        <p:txBody>
-          <a:bodyPr xmlns:a="http://schemas.openxmlformats.org/drawingml/2006/main"/>
-          <a:lstStyle xmlns:a="http://schemas.openxmlformats.org/drawingml/2006/main"/>
-          <a:p xmlns:a="http://schemas.openxmlformats.org/drawingml/2006/main">
-            <a:pPr>
-              <a:defRPr sz="1500" b="0">
+          <p:cNvPr id="32" name="">
+            <a:extLst xmlns:a="http://schemas.openxmlformats.org/drawingml/2006/main">
+              <a:ext uri="{FF2B5EF4-FFF2-40B4-BE49-F238E27FC236}">
+                <a16:creationId xmlns:a16="http://schemas.microsoft.com/office/drawing/2014/main" id="{64D8E49F-BB01-465D-8C61-1333D24849C3}"/>
+              </a:ext>
+            </a:extLst>
+          </p:cNvPr>
+          <p:cNvSpPr>
+            <a:spLocks xmlns:a="http://schemas.openxmlformats.org/drawingml/2006/main" noGrp="1"/>
+          </p:cNvSpPr>
+          <p:nvPr/>
+        </p:nvSpPr>
+        <p:spPr>
+          <a:xfrm xmlns:a="http://schemas.openxmlformats.org/drawingml/2006/main">
+            <a:off x="6477000" y="4400550"/>
+            <a:ext cx="3714750" cy="438150"/>
+          </a:xfrm>
+          <a:prstGeom xmlns:a="http://schemas.openxmlformats.org/drawingml/2006/main" prst="rect">
+            <a:avLst/>
+          </a:prstGeom>
+          <a:noFill xmlns:a="http://schemas.openxmlformats.org/drawingml/2006/main"/>
+          <a:ln xmlns:a="http://schemas.openxmlformats.org/drawingml/2006/main" w="0">
+            <a:noFill/>
+            <a:prstDash val="solid"/>
+          </a:ln>
+        </p:spPr>
+        <p:txBody>
+          <a:bodyPr xmlns:a="http://schemas.openxmlformats.org/drawingml/2006/main"/>
+          <a:lstStyle xmlns:a="http://schemas.openxmlformats.org/drawingml/2006/main"/>
+          <a:p xmlns:a="http://schemas.openxmlformats.org/drawingml/2006/main">
+            <a:pPr>
+              <a:defRPr sz="1350" b="0">
                 <a:solidFill>
                   <a:srgbClr val="18211F"/>
                 </a:solidFill>
               </a:defRPr>
             </a:pPr>
             <a:r>
-              <a:rPr sz="1500" b="0">
+              <a:rPr sz="1350" b="0">
                 <a:solidFill>
                   <a:srgbClr val="18211F"/>
                 </a:solidFill>
               </a:rPr>
-              <a:t>The documented validation should be system testing and live acceptance testing unless questionnaire/interview results are added as appendices.</a:t>
+              <a:t>System testing and live acceptance testing are the verified results. Do not claim survey results without questionnaire/interview evidence.</a:t>
             </a:r>
           </a:p>
         </p:txBody>
@@ -11733,7 +11903,7 @@
     </p:spTree>
     <p:extLst>
       <p:ext uri="{BB962C8B-B14F-4D97-AF65-F5344CB8AC3E}">
-        <p14:creationId xmlns:p14="http://schemas.microsoft.com/office/powerpoint/2010/main" val="174009506"/>
+        <p14:creationId xmlns:p14="http://schemas.microsoft.com/office/powerpoint/2010/main" val="1692621808"/>
       </p:ext>
     </p:extLst>
   </p:cSld>
@@ -11764,7 +11934,7 @@
           <p:cNvPr id="1" name="">
             <a:extLst xmlns:a="http://schemas.openxmlformats.org/drawingml/2006/main">
               <a:ext uri="{FF2B5EF4-FFF2-40B4-BE49-F238E27FC236}">
-                <a16:creationId xmlns:a16="http://schemas.microsoft.com/office/drawing/2014/main" id="{DA11C064-D715-42C5-A206-70E80E1E99B2}"/>
+                <a16:creationId xmlns:a16="http://schemas.microsoft.com/office/drawing/2014/main" id="{587986E1-E83A-4F75-B12E-B3FE65E57233}"/>
               </a:ext>
             </a:extLst>
           </p:cNvPr>
@@ -11797,7 +11967,7 @@
           <p:cNvPr id="2" name="">
             <a:extLst xmlns:a="http://schemas.openxmlformats.org/drawingml/2006/main">
               <a:ext uri="{FF2B5EF4-FFF2-40B4-BE49-F238E27FC236}">
-                <a16:creationId xmlns:a16="http://schemas.microsoft.com/office/drawing/2014/main" id="{31F35BEF-E823-412C-ACF1-013E0AD8D802}"/>
+                <a16:creationId xmlns:a16="http://schemas.microsoft.com/office/drawing/2014/main" id="{43ED7906-64FC-4E3A-93D2-E9130F275B3B}"/>
               </a:ext>
             </a:extLst>
           </p:cNvPr>
@@ -11830,7 +12000,7 @@
           <p:cNvPr id="3" name="">
             <a:extLst xmlns:a="http://schemas.openxmlformats.org/drawingml/2006/main">
               <a:ext uri="{FF2B5EF4-FFF2-40B4-BE49-F238E27FC236}">
-                <a16:creationId xmlns:a16="http://schemas.microsoft.com/office/drawing/2014/main" id="{0C989340-2A38-467F-BD61-9C0BC57BBC6F}"/>
+                <a16:creationId xmlns:a16="http://schemas.microsoft.com/office/drawing/2014/main" id="{F8A3CCF6-996D-43B9-8B9F-CF5B6343FE7F}"/>
               </a:ext>
             </a:extLst>
           </p:cNvPr>
@@ -11880,7 +12050,7 @@
           <p:cNvPr id="4" name="">
             <a:extLst xmlns:a="http://schemas.openxmlformats.org/drawingml/2006/main">
               <a:ext uri="{FF2B5EF4-FFF2-40B4-BE49-F238E27FC236}">
-                <a16:creationId xmlns:a16="http://schemas.microsoft.com/office/drawing/2014/main" id="{21A3DC5A-2F27-4762-9846-9F63815E9065}"/>
+                <a16:creationId xmlns:a16="http://schemas.microsoft.com/office/drawing/2014/main" id="{44D0FD3F-17C6-4E15-B05E-24141F909F30}"/>
               </a:ext>
             </a:extLst>
           </p:cNvPr>
@@ -11930,7 +12100,7 @@
           <p:cNvPr id="5" name="">
             <a:extLst xmlns:a="http://schemas.openxmlformats.org/drawingml/2006/main">
               <a:ext uri="{FF2B5EF4-FFF2-40B4-BE49-F238E27FC236}">
-                <a16:creationId xmlns:a16="http://schemas.microsoft.com/office/drawing/2014/main" id="{416C480C-6C5D-4148-94D5-90676AA04C69}"/>
+                <a16:creationId xmlns:a16="http://schemas.microsoft.com/office/drawing/2014/main" id="{4B8C2C1B-C0BC-484A-8C6E-E852719DE381}"/>
               </a:ext>
             </a:extLst>
           </p:cNvPr>
@@ -11965,7 +12135,7 @@
           <p:nvPr/>
         </p:nvPicPr>
         <p:blipFill>
-          <a:blip xmlns:r="http://schemas.openxmlformats.org/officeDocument/2006/relationships" xmlns:a="http://schemas.openxmlformats.org/drawingml/2006/main" r:embed="R280e0b96cb424a36"/>
+          <a:blip xmlns:r="http://schemas.openxmlformats.org/officeDocument/2006/relationships" xmlns:a="http://schemas.openxmlformats.org/drawingml/2006/main" r:embed="R3c12c63b30e34030"/>
           <a:stretch xmlns:a="http://schemas.openxmlformats.org/drawingml/2006/main"/>
         </p:blipFill>
         <p:spPr>
@@ -11983,7 +12153,7 @@
           <p:cNvPr id="7" name="">
             <a:extLst xmlns:a="http://schemas.openxmlformats.org/drawingml/2006/main">
               <a:ext uri="{FF2B5EF4-FFF2-40B4-BE49-F238E27FC236}">
-                <a16:creationId xmlns:a16="http://schemas.microsoft.com/office/drawing/2014/main" id="{D5435E09-1113-41C8-8E40-4A72E8F25682}"/>
+                <a16:creationId xmlns:a16="http://schemas.microsoft.com/office/drawing/2014/main" id="{88E0D0D6-238F-485D-BCB1-E974344B3DC7}"/>
               </a:ext>
             </a:extLst>
           </p:cNvPr>
@@ -12016,7 +12186,7 @@
           <p:cNvPr id="8" name="">
             <a:extLst xmlns:a="http://schemas.openxmlformats.org/drawingml/2006/main">
               <a:ext uri="{FF2B5EF4-FFF2-40B4-BE49-F238E27FC236}">
-                <a16:creationId xmlns:a16="http://schemas.microsoft.com/office/drawing/2014/main" id="{499A48D9-8B4A-4E76-B498-D7743F6DBA2C}"/>
+                <a16:creationId xmlns:a16="http://schemas.microsoft.com/office/drawing/2014/main" id="{DF1F2665-6690-43E5-9699-D5EE566B8921}"/>
               </a:ext>
             </a:extLst>
           </p:cNvPr>
@@ -12066,7 +12236,7 @@
           <p:cNvPr id="9" name="">
             <a:extLst xmlns:a="http://schemas.openxmlformats.org/drawingml/2006/main">
               <a:ext uri="{FF2B5EF4-FFF2-40B4-BE49-F238E27FC236}">
-                <a16:creationId xmlns:a16="http://schemas.microsoft.com/office/drawing/2014/main" id="{58AE3A95-3389-4CF5-B3B4-056681C2BE4B}"/>
+                <a16:creationId xmlns:a16="http://schemas.microsoft.com/office/drawing/2014/main" id="{DD3A8246-38D6-4AB2-A97B-0B2B89B07075}"/>
               </a:ext>
             </a:extLst>
           </p:cNvPr>
@@ -12099,7 +12269,7 @@
           <p:cNvPr id="10" name="">
             <a:extLst xmlns:a="http://schemas.openxmlformats.org/drawingml/2006/main">
               <a:ext uri="{FF2B5EF4-FFF2-40B4-BE49-F238E27FC236}">
-                <a16:creationId xmlns:a16="http://schemas.microsoft.com/office/drawing/2014/main" id="{81095831-9628-4A01-8AA3-BCC42ECF0C50}"/>
+                <a16:creationId xmlns:a16="http://schemas.microsoft.com/office/drawing/2014/main" id="{E20B184E-69C7-48E1-961A-0D362381C4C3}"/>
               </a:ext>
             </a:extLst>
           </p:cNvPr>
@@ -12149,7 +12319,7 @@
           <p:cNvPr id="11" name="">
             <a:extLst xmlns:a="http://schemas.openxmlformats.org/drawingml/2006/main">
               <a:ext uri="{FF2B5EF4-FFF2-40B4-BE49-F238E27FC236}">
-                <a16:creationId xmlns:a16="http://schemas.microsoft.com/office/drawing/2014/main" id="{7FE1E453-EB7A-41F5-A024-1999C4711BB5}"/>
+                <a16:creationId xmlns:a16="http://schemas.microsoft.com/office/drawing/2014/main" id="{3427A78D-8611-493D-A27C-159A2F77A0FE}"/>
               </a:ext>
             </a:extLst>
           </p:cNvPr>
@@ -12182,7 +12352,7 @@
           <p:cNvPr id="12" name="">
             <a:extLst xmlns:a="http://schemas.openxmlformats.org/drawingml/2006/main">
               <a:ext uri="{FF2B5EF4-FFF2-40B4-BE49-F238E27FC236}">
-                <a16:creationId xmlns:a16="http://schemas.microsoft.com/office/drawing/2014/main" id="{62FB2D8E-B707-4F8F-939D-07628CD2B0AB}"/>
+                <a16:creationId xmlns:a16="http://schemas.microsoft.com/office/drawing/2014/main" id="{CD0C4CEC-DCD6-4B9E-B7FC-63CF7457381A}"/>
               </a:ext>
             </a:extLst>
           </p:cNvPr>
@@ -12232,7 +12402,7 @@
           <p:cNvPr id="13" name="">
             <a:extLst xmlns:a="http://schemas.openxmlformats.org/drawingml/2006/main">
               <a:ext uri="{FF2B5EF4-FFF2-40B4-BE49-F238E27FC236}">
-                <a16:creationId xmlns:a16="http://schemas.microsoft.com/office/drawing/2014/main" id="{66990577-3127-41E9-B74C-0484DB38DEAE}"/>
+                <a16:creationId xmlns:a16="http://schemas.microsoft.com/office/drawing/2014/main" id="{25A695D5-4E28-4352-AF94-67706E6C3C3F}"/>
               </a:ext>
             </a:extLst>
           </p:cNvPr>
@@ -12265,7 +12435,7 @@
           <p:cNvPr id="14" name="">
             <a:extLst xmlns:a="http://schemas.openxmlformats.org/drawingml/2006/main">
               <a:ext uri="{FF2B5EF4-FFF2-40B4-BE49-F238E27FC236}">
-                <a16:creationId xmlns:a16="http://schemas.microsoft.com/office/drawing/2014/main" id="{C5FD93AD-73DF-4360-9A56-94546C1EC2E8}"/>
+                <a16:creationId xmlns:a16="http://schemas.microsoft.com/office/drawing/2014/main" id="{7896C4E5-37C6-4857-BCC3-7A15E4556D41}"/>
               </a:ext>
             </a:extLst>
           </p:cNvPr>
@@ -12315,7 +12485,7 @@
           <p:cNvPr id="15" name="">
             <a:extLst xmlns:a="http://schemas.openxmlformats.org/drawingml/2006/main">
               <a:ext uri="{FF2B5EF4-FFF2-40B4-BE49-F238E27FC236}">
-                <a16:creationId xmlns:a16="http://schemas.microsoft.com/office/drawing/2014/main" id="{8D2753DB-928B-49F3-BCBD-99B0C3088FBF}"/>
+                <a16:creationId xmlns:a16="http://schemas.microsoft.com/office/drawing/2014/main" id="{54C2DF3D-D248-4C91-9B95-2F7D5E9F1AC3}"/>
               </a:ext>
             </a:extLst>
           </p:cNvPr>
@@ -12348,7 +12518,7 @@
           <p:cNvPr id="16" name="">
             <a:extLst xmlns:a="http://schemas.openxmlformats.org/drawingml/2006/main">
               <a:ext uri="{FF2B5EF4-FFF2-40B4-BE49-F238E27FC236}">
-                <a16:creationId xmlns:a16="http://schemas.microsoft.com/office/drawing/2014/main" id="{4918B13C-8862-4A04-90D3-42B4E86D7B63}"/>
+                <a16:creationId xmlns:a16="http://schemas.microsoft.com/office/drawing/2014/main" id="{5501E9EF-209D-4457-93E0-934AC94E306D}"/>
               </a:ext>
             </a:extLst>
           </p:cNvPr>
@@ -12398,7 +12568,7 @@
           <p:cNvPr id="17" name="">
             <a:extLst xmlns:a="http://schemas.openxmlformats.org/drawingml/2006/main">
               <a:ext uri="{FF2B5EF4-FFF2-40B4-BE49-F238E27FC236}">
-                <a16:creationId xmlns:a16="http://schemas.microsoft.com/office/drawing/2014/main" id="{E8C7BA56-A8DE-4788-A63F-630DCC9F3C2A}"/>
+                <a16:creationId xmlns:a16="http://schemas.microsoft.com/office/drawing/2014/main" id="{982BD62A-B56D-4A9E-AF2A-E3609AC3367B}"/>
               </a:ext>
             </a:extLst>
           </p:cNvPr>
@@ -12433,7 +12603,7 @@
           <p:cNvPr id="18" name="">
             <a:extLst xmlns:a="http://schemas.openxmlformats.org/drawingml/2006/main">
               <a:ext uri="{FF2B5EF4-FFF2-40B4-BE49-F238E27FC236}">
-                <a16:creationId xmlns:a16="http://schemas.microsoft.com/office/drawing/2014/main" id="{56E05323-0D81-42B9-BD11-14340A09B117}"/>
+                <a16:creationId xmlns:a16="http://schemas.microsoft.com/office/drawing/2014/main" id="{1BEEE1E2-ADD1-423B-86B3-B6C43A5B5C45}"/>
               </a:ext>
             </a:extLst>
           </p:cNvPr>
@@ -12483,7 +12653,7 @@
           <p:cNvPr id="19" name="">
             <a:extLst xmlns:a="http://schemas.openxmlformats.org/drawingml/2006/main">
               <a:ext uri="{FF2B5EF4-FFF2-40B4-BE49-F238E27FC236}">
-                <a16:creationId xmlns:a16="http://schemas.microsoft.com/office/drawing/2014/main" id="{4EC21EF7-0F2C-4BC9-98C0-E810FF044592}"/>
+                <a16:creationId xmlns:a16="http://schemas.microsoft.com/office/drawing/2014/main" id="{6479204C-BF30-4488-9BEC-281D9B4F9F4B}"/>
               </a:ext>
             </a:extLst>
           </p:cNvPr>
@@ -12531,7 +12701,7 @@
     </p:spTree>
     <p:extLst>
       <p:ext uri="{BB962C8B-B14F-4D97-AF65-F5344CB8AC3E}">
-        <p14:creationId xmlns:p14="http://schemas.microsoft.com/office/powerpoint/2010/main" val="23015533"/>
+        <p14:creationId xmlns:p14="http://schemas.microsoft.com/office/powerpoint/2010/main" val="1523509706"/>
       </p:ext>
     </p:extLst>
   </p:cSld>
@@ -12562,7 +12732,7 @@
           <p:cNvPr id="1" name="">
             <a:extLst xmlns:a="http://schemas.openxmlformats.org/drawingml/2006/main">
               <a:ext uri="{FF2B5EF4-FFF2-40B4-BE49-F238E27FC236}">
-                <a16:creationId xmlns:a16="http://schemas.microsoft.com/office/drawing/2014/main" id="{8E485FAF-780D-480E-B747-4DF764ACDE28}"/>
+                <a16:creationId xmlns:a16="http://schemas.microsoft.com/office/drawing/2014/main" id="{813DCC1B-BFDF-4BCC-9BC4-5C6BDDC2E3CE}"/>
               </a:ext>
             </a:extLst>
           </p:cNvPr>
@@ -12595,7 +12765,7 @@
           <p:cNvPr id="2" name="">
             <a:extLst xmlns:a="http://schemas.openxmlformats.org/drawingml/2006/main">
               <a:ext uri="{FF2B5EF4-FFF2-40B4-BE49-F238E27FC236}">
-                <a16:creationId xmlns:a16="http://schemas.microsoft.com/office/drawing/2014/main" id="{353CCD51-9E6E-4E50-AD49-468F38999F77}"/>
+                <a16:creationId xmlns:a16="http://schemas.microsoft.com/office/drawing/2014/main" id="{E9C27208-7256-4C71-B183-6F9A31988A3D}"/>
               </a:ext>
             </a:extLst>
           </p:cNvPr>
@@ -12628,7 +12798,7 @@
           <p:cNvPr id="3" name="">
             <a:extLst xmlns:a="http://schemas.openxmlformats.org/drawingml/2006/main">
               <a:ext uri="{FF2B5EF4-FFF2-40B4-BE49-F238E27FC236}">
-                <a16:creationId xmlns:a16="http://schemas.microsoft.com/office/drawing/2014/main" id="{5D6201A7-A131-440D-88EE-38C049430B6F}"/>
+                <a16:creationId xmlns:a16="http://schemas.microsoft.com/office/drawing/2014/main" id="{CBD20F2C-C8C8-4D20-8DC9-1626FE00BDB6}"/>
               </a:ext>
             </a:extLst>
           </p:cNvPr>
@@ -12678,7 +12848,7 @@
           <p:cNvPr id="4" name="">
             <a:extLst xmlns:a="http://schemas.openxmlformats.org/drawingml/2006/main">
               <a:ext uri="{FF2B5EF4-FFF2-40B4-BE49-F238E27FC236}">
-                <a16:creationId xmlns:a16="http://schemas.microsoft.com/office/drawing/2014/main" id="{58E06EDC-B27F-4428-9637-4EC3E9E768CC}"/>
+                <a16:creationId xmlns:a16="http://schemas.microsoft.com/office/drawing/2014/main" id="{ACD050F8-197F-44C0-AF24-BBE56CB7B1B8}"/>
               </a:ext>
             </a:extLst>
           </p:cNvPr>
@@ -12728,7 +12898,7 @@
           <p:cNvPr id="5" name="">
             <a:extLst xmlns:a="http://schemas.openxmlformats.org/drawingml/2006/main">
               <a:ext uri="{FF2B5EF4-FFF2-40B4-BE49-F238E27FC236}">
-                <a16:creationId xmlns:a16="http://schemas.microsoft.com/office/drawing/2014/main" id="{27A6D4FC-D682-4BD6-8B34-C69F96955296}"/>
+                <a16:creationId xmlns:a16="http://schemas.microsoft.com/office/drawing/2014/main" id="{04A7A3C3-27BD-4CD1-ABA0-C68A6D31827B}"/>
               </a:ext>
             </a:extLst>
           </p:cNvPr>
@@ -12763,7 +12933,7 @@
           <p:nvPr/>
         </p:nvPicPr>
         <p:blipFill>
-          <a:blip xmlns:r="http://schemas.openxmlformats.org/officeDocument/2006/relationships" xmlns:a="http://schemas.openxmlformats.org/drawingml/2006/main" r:embed="R026013f6129443ad"/>
+          <a:blip xmlns:r="http://schemas.openxmlformats.org/officeDocument/2006/relationships" xmlns:a="http://schemas.openxmlformats.org/drawingml/2006/main" r:embed="Rb10bd321834f47eb"/>
           <a:stretch xmlns:a="http://schemas.openxmlformats.org/drawingml/2006/main"/>
         </p:blipFill>
         <p:spPr>
@@ -12781,7 +12951,7 @@
           <p:cNvPr id="7" name="">
             <a:extLst xmlns:a="http://schemas.openxmlformats.org/drawingml/2006/main">
               <a:ext uri="{FF2B5EF4-FFF2-40B4-BE49-F238E27FC236}">
-                <a16:creationId xmlns:a16="http://schemas.microsoft.com/office/drawing/2014/main" id="{3500F6A5-ED30-4606-8327-C5A67BA0D340}"/>
+                <a16:creationId xmlns:a16="http://schemas.microsoft.com/office/drawing/2014/main" id="{F00403AF-756D-4031-B919-2FD92A78246E}"/>
               </a:ext>
             </a:extLst>
           </p:cNvPr>
@@ -12816,7 +12986,7 @@
           <p:cNvPr id="8" name="">
             <a:extLst xmlns:a="http://schemas.openxmlformats.org/drawingml/2006/main">
               <a:ext uri="{FF2B5EF4-FFF2-40B4-BE49-F238E27FC236}">
-                <a16:creationId xmlns:a16="http://schemas.microsoft.com/office/drawing/2014/main" id="{D6F9D275-4979-4001-91FB-05ABD33A51A6}"/>
+                <a16:creationId xmlns:a16="http://schemas.microsoft.com/office/drawing/2014/main" id="{8F520FE8-4B1F-4966-8208-FF1F2A0F2D3F}"/>
               </a:ext>
             </a:extLst>
           </p:cNvPr>
@@ -12866,7 +13036,7 @@
           <p:cNvPr id="9" name="">
             <a:extLst xmlns:a="http://schemas.openxmlformats.org/drawingml/2006/main">
               <a:ext uri="{FF2B5EF4-FFF2-40B4-BE49-F238E27FC236}">
-                <a16:creationId xmlns:a16="http://schemas.microsoft.com/office/drawing/2014/main" id="{31F57949-D9E4-4A57-B354-09D72AD136E0}"/>
+                <a16:creationId xmlns:a16="http://schemas.microsoft.com/office/drawing/2014/main" id="{81B420FC-F854-4AC7-B893-91894A120D2F}"/>
               </a:ext>
             </a:extLst>
           </p:cNvPr>
@@ -12916,7 +13086,7 @@
           <p:cNvPr id="10" name="">
             <a:extLst xmlns:a="http://schemas.openxmlformats.org/drawingml/2006/main">
               <a:ext uri="{FF2B5EF4-FFF2-40B4-BE49-F238E27FC236}">
-                <a16:creationId xmlns:a16="http://schemas.microsoft.com/office/drawing/2014/main" id="{75A8178B-E988-400E-B1AC-0105FBA57426}"/>
+                <a16:creationId xmlns:a16="http://schemas.microsoft.com/office/drawing/2014/main" id="{60E5C2D8-14EA-4248-9394-51A1EE67A096}"/>
               </a:ext>
             </a:extLst>
           </p:cNvPr>
@@ -12947,7 +13117,7 @@
           <p:cNvPr id="11" name="">
             <a:extLst xmlns:a="http://schemas.openxmlformats.org/drawingml/2006/main">
               <a:ext uri="{FF2B5EF4-FFF2-40B4-BE49-F238E27FC236}">
-                <a16:creationId xmlns:a16="http://schemas.microsoft.com/office/drawing/2014/main" id="{69A20975-3CFF-47A8-B976-CEEC7F56D640}"/>
+                <a16:creationId xmlns:a16="http://schemas.microsoft.com/office/drawing/2014/main" id="{99974BBD-035A-4B33-A738-DFEEAE5C5D33}"/>
               </a:ext>
             </a:extLst>
           </p:cNvPr>
@@ -12982,7 +13152,7 @@
           <p:cNvPr id="12" name="">
             <a:extLst xmlns:a="http://schemas.openxmlformats.org/drawingml/2006/main">
               <a:ext uri="{FF2B5EF4-FFF2-40B4-BE49-F238E27FC236}">
-                <a16:creationId xmlns:a16="http://schemas.microsoft.com/office/drawing/2014/main" id="{A8544DAA-4A0A-4622-A26D-29CD82254974}"/>
+                <a16:creationId xmlns:a16="http://schemas.microsoft.com/office/drawing/2014/main" id="{8EA16EB7-E7BC-42BF-9839-91115BE09E06}"/>
               </a:ext>
             </a:extLst>
           </p:cNvPr>
@@ -13032,7 +13202,7 @@
           <p:cNvPr id="13" name="">
             <a:extLst xmlns:a="http://schemas.openxmlformats.org/drawingml/2006/main">
               <a:ext uri="{FF2B5EF4-FFF2-40B4-BE49-F238E27FC236}">
-                <a16:creationId xmlns:a16="http://schemas.microsoft.com/office/drawing/2014/main" id="{645FBFFE-F897-4846-9ACE-666053F6E2C2}"/>
+                <a16:creationId xmlns:a16="http://schemas.microsoft.com/office/drawing/2014/main" id="{F36B737E-63C9-4DD5-8BA1-E69896B69B2A}"/>
               </a:ext>
             </a:extLst>
           </p:cNvPr>
@@ -13082,7 +13252,7 @@
           <p:cNvPr id="14" name="">
             <a:extLst xmlns:a="http://schemas.openxmlformats.org/drawingml/2006/main">
               <a:ext uri="{FF2B5EF4-FFF2-40B4-BE49-F238E27FC236}">
-                <a16:creationId xmlns:a16="http://schemas.microsoft.com/office/drawing/2014/main" id="{5A11F6E9-D500-4B34-BF5C-B0E9199933CD}"/>
+                <a16:creationId xmlns:a16="http://schemas.microsoft.com/office/drawing/2014/main" id="{E8F9622F-C50E-4DDB-84E6-03315066A629}"/>
               </a:ext>
             </a:extLst>
           </p:cNvPr>
@@ -13113,7 +13283,7 @@
           <p:cNvPr id="15" name="">
             <a:extLst xmlns:a="http://schemas.openxmlformats.org/drawingml/2006/main">
               <a:ext uri="{FF2B5EF4-FFF2-40B4-BE49-F238E27FC236}">
-                <a16:creationId xmlns:a16="http://schemas.microsoft.com/office/drawing/2014/main" id="{3C03D2CE-0C40-4AE8-A870-8F01150C1E74}"/>
+                <a16:creationId xmlns:a16="http://schemas.microsoft.com/office/drawing/2014/main" id="{EA44A390-99F4-4E8A-86B4-3D27852F3000}"/>
               </a:ext>
             </a:extLst>
           </p:cNvPr>
@@ -13148,7 +13318,7 @@
           <p:cNvPr id="16" name="">
             <a:extLst xmlns:a="http://schemas.openxmlformats.org/drawingml/2006/main">
               <a:ext uri="{FF2B5EF4-FFF2-40B4-BE49-F238E27FC236}">
-                <a16:creationId xmlns:a16="http://schemas.microsoft.com/office/drawing/2014/main" id="{8AC7C5C6-6175-4967-8CAA-FA28ADD0113B}"/>
+                <a16:creationId xmlns:a16="http://schemas.microsoft.com/office/drawing/2014/main" id="{EC61F069-4F69-4193-BCA5-DA8B00761171}"/>
               </a:ext>
             </a:extLst>
           </p:cNvPr>
@@ -13198,7 +13368,7 @@
           <p:cNvPr id="17" name="">
             <a:extLst xmlns:a="http://schemas.openxmlformats.org/drawingml/2006/main">
               <a:ext uri="{FF2B5EF4-FFF2-40B4-BE49-F238E27FC236}">
-                <a16:creationId xmlns:a16="http://schemas.microsoft.com/office/drawing/2014/main" id="{AF5B467D-0A34-4061-AF7A-8C83B180C633}"/>
+                <a16:creationId xmlns:a16="http://schemas.microsoft.com/office/drawing/2014/main" id="{F8241C2D-905A-41BE-8941-A24E660A59B3}"/>
               </a:ext>
             </a:extLst>
           </p:cNvPr>
@@ -13248,7 +13418,7 @@
           <p:cNvPr id="18" name="">
             <a:extLst xmlns:a="http://schemas.openxmlformats.org/drawingml/2006/main">
               <a:ext uri="{FF2B5EF4-FFF2-40B4-BE49-F238E27FC236}">
-                <a16:creationId xmlns:a16="http://schemas.microsoft.com/office/drawing/2014/main" id="{453183F3-E23F-4259-9A2B-55FAC4FF0354}"/>
+                <a16:creationId xmlns:a16="http://schemas.microsoft.com/office/drawing/2014/main" id="{8565EEF4-76A0-4A25-B364-D7754FEA5848}"/>
               </a:ext>
             </a:extLst>
           </p:cNvPr>
@@ -13279,7 +13449,7 @@
           <p:cNvPr id="19" name="">
             <a:extLst xmlns:a="http://schemas.openxmlformats.org/drawingml/2006/main">
               <a:ext uri="{FF2B5EF4-FFF2-40B4-BE49-F238E27FC236}">
-                <a16:creationId xmlns:a16="http://schemas.microsoft.com/office/drawing/2014/main" id="{26115274-0603-4ACB-BBF0-782DC3BFC4EA}"/>
+                <a16:creationId xmlns:a16="http://schemas.microsoft.com/office/drawing/2014/main" id="{D2555205-1960-4717-8F81-CBFEEA3AEF10}"/>
               </a:ext>
             </a:extLst>
           </p:cNvPr>
@@ -13314,7 +13484,7 @@
           <p:cNvPr id="20" name="">
             <a:extLst xmlns:a="http://schemas.openxmlformats.org/drawingml/2006/main">
               <a:ext uri="{FF2B5EF4-FFF2-40B4-BE49-F238E27FC236}">
-                <a16:creationId xmlns:a16="http://schemas.microsoft.com/office/drawing/2014/main" id="{5F6032B0-C216-4994-8881-43B084512660}"/>
+                <a16:creationId xmlns:a16="http://schemas.microsoft.com/office/drawing/2014/main" id="{3D4CDEE4-93CD-4B08-879F-B425D6D7D4CF}"/>
               </a:ext>
             </a:extLst>
           </p:cNvPr>
@@ -13364,7 +13534,7 @@
           <p:cNvPr id="21" name="">
             <a:extLst xmlns:a="http://schemas.openxmlformats.org/drawingml/2006/main">
               <a:ext uri="{FF2B5EF4-FFF2-40B4-BE49-F238E27FC236}">
-                <a16:creationId xmlns:a16="http://schemas.microsoft.com/office/drawing/2014/main" id="{0321481D-EB22-44F8-B7F1-CF5A0A7A5495}"/>
+                <a16:creationId xmlns:a16="http://schemas.microsoft.com/office/drawing/2014/main" id="{001E5862-22AB-4A3D-8FF6-6A3CDED4220D}"/>
               </a:ext>
             </a:extLst>
           </p:cNvPr>
@@ -13414,7 +13584,7 @@
           <p:cNvPr id="22" name="">
             <a:extLst xmlns:a="http://schemas.openxmlformats.org/drawingml/2006/main">
               <a:ext uri="{FF2B5EF4-FFF2-40B4-BE49-F238E27FC236}">
-                <a16:creationId xmlns:a16="http://schemas.microsoft.com/office/drawing/2014/main" id="{EFA724BF-055F-40DC-9C11-EDA45EFB5AC9}"/>
+                <a16:creationId xmlns:a16="http://schemas.microsoft.com/office/drawing/2014/main" id="{9C336667-A7BD-4D51-B9AA-6054B2AFBF2F}"/>
               </a:ext>
             </a:extLst>
           </p:cNvPr>
@@ -13445,7 +13615,7 @@
           <p:cNvPr id="23" name="">
             <a:extLst xmlns:a="http://schemas.openxmlformats.org/drawingml/2006/main">
               <a:ext uri="{FF2B5EF4-FFF2-40B4-BE49-F238E27FC236}">
-                <a16:creationId xmlns:a16="http://schemas.microsoft.com/office/drawing/2014/main" id="{8287A5C1-6F27-47A4-93EA-8505A1280579}"/>
+                <a16:creationId xmlns:a16="http://schemas.microsoft.com/office/drawing/2014/main" id="{E14F77A9-339B-4A19-8B4D-9DE613EF7CC8}"/>
               </a:ext>
             </a:extLst>
           </p:cNvPr>
@@ -13480,7 +13650,7 @@
           <p:cNvPr id="24" name="">
             <a:extLst xmlns:a="http://schemas.openxmlformats.org/drawingml/2006/main">
               <a:ext uri="{FF2B5EF4-FFF2-40B4-BE49-F238E27FC236}">
-                <a16:creationId xmlns:a16="http://schemas.microsoft.com/office/drawing/2014/main" id="{AE241D24-8369-46B9-AAB3-24B53BDA2E8F}"/>
+                <a16:creationId xmlns:a16="http://schemas.microsoft.com/office/drawing/2014/main" id="{7904D221-D96B-42C7-B02F-804BA96F46A5}"/>
               </a:ext>
             </a:extLst>
           </p:cNvPr>
@@ -13530,7 +13700,7 @@
           <p:cNvPr id="25" name="">
             <a:extLst xmlns:a="http://schemas.openxmlformats.org/drawingml/2006/main">
               <a:ext uri="{FF2B5EF4-FFF2-40B4-BE49-F238E27FC236}">
-                <a16:creationId xmlns:a16="http://schemas.microsoft.com/office/drawing/2014/main" id="{0D189D02-D1BE-4168-A8CC-ED6EB21AC424}"/>
+                <a16:creationId xmlns:a16="http://schemas.microsoft.com/office/drawing/2014/main" id="{4F8D6E3F-8D57-4C99-A6C7-CBED38E35A94}"/>
               </a:ext>
             </a:extLst>
           </p:cNvPr>
@@ -13580,7 +13750,7 @@
           <p:cNvPr id="26" name="">
             <a:extLst xmlns:a="http://schemas.openxmlformats.org/drawingml/2006/main">
               <a:ext uri="{FF2B5EF4-FFF2-40B4-BE49-F238E27FC236}">
-                <a16:creationId xmlns:a16="http://schemas.microsoft.com/office/drawing/2014/main" id="{A0F28009-F5DE-471A-A615-9E7F3D4A72CF}"/>
+                <a16:creationId xmlns:a16="http://schemas.microsoft.com/office/drawing/2014/main" id="{61C8B659-5F69-4FE0-9DF9-5FA61AFAF7FC}"/>
               </a:ext>
             </a:extLst>
           </p:cNvPr>
@@ -13628,7 +13798,7 @@
     </p:spTree>
     <p:extLst>
       <p:ext uri="{BB962C8B-B14F-4D97-AF65-F5344CB8AC3E}">
-        <p14:creationId xmlns:p14="http://schemas.microsoft.com/office/powerpoint/2010/main" val="1148553630"/>
+        <p14:creationId xmlns:p14="http://schemas.microsoft.com/office/powerpoint/2010/main" val="721858345"/>
       </p:ext>
     </p:extLst>
   </p:cSld>

</xml_diff>